<commit_message>
Poster: headline accuracy from the 30-day-block test, with the time split shown
Figure 3 now plots error vs mission day with trained (0-30, 60-90, 120-140) and withheld (30-60, 90-120)
periods shaded; tile and takeaway use the block result (median 0.026%, 95% within 0.1%); random-10%
number (0.015%) kept in the caption. poster/data_blocks.jl tabulates block / random / chronological tests.

Co-Authored-By: Claude Opus 5.5 <noreply@anthropic.com>
Claude-Session: https://claude.ai/code/session_012rGthNAyzBgnDfYXWSYd8K
</commit_message>
<xml_diff>
--- a/poster/poster_dark.pptx
+++ b/poster/poster_dark.pptx
@@ -527,7 +527,22 @@
           </a:p>
           <a:p>
             <a:r>
-              <a:t>- Accuracy: emulator v2 (9 inputs, 64-64-32-16, 5-network ensemble) on the random 10% held-out pointings (poster/data_accuracy.jl).</a:t>
+              <a:t>- Accuracy (poster/data_accuracy.jl, data_blocks.jl): 9 inputs (n.S n.z n.E n.vS n.vE n.x_E n.y_E sin/cos of Earth's longitude), 64-64-32-16 gelu, 5-network ensemble.</a:t>
+            </a:r>
+          </a:p>
+          <a:p>
+            <a:r>
+              <a:t>  Main number: trained on days 0-30, 60-90, 120-140; tested on days 30-60, 90-120 (180,166 pointings, 43%): median 0.026%, p95 0.10%, 94.8% within 0.1%.</a:t>
+            </a:r>
+          </a:p>
+          <a:p>
+            <a:r>
+              <a:t>  Random 10% withheld (= packaged emulator v2): median 0.015%, p95 0.064%. Harder: last 20% of the mission (days 111-140, older season inputs): median 0.10%, p95 0.67%.</a:t>
+            </a:r>
+          </a:p>
+          <a:p>
+            <a:r>
+              <a:t>  Errors are relative to ZodiPy (the Kelsall model), not the real sky.</a:t>
             </a:r>
           </a:p>
           <a:p>
@@ -3867,7 +3882,7 @@
                 </a:solidFill>
                 <a:latin typeface="Arial"/>
               </a:rPr>
-              <a:t>A small neural network reproduces a physics model of the Solar System's dust glow to within 0.015%, up to ~2,000× faster per pointing, and can be extended to every wavelength SPHEREx observes.</a:t>
+              <a:t>A small neural network reproduces a physics model of the Solar System's dust glow to ~0.03% on months it never saw, up to ~2,000× faster per pointing, and can be extended to every wavelength SPHEREx observes.</a:t>
             </a:r>
           </a:p>
         </p:txBody>
@@ -5590,7 +5605,7 @@
                 </a:solidFill>
                 <a:latin typeface="Arial"/>
               </a:rPr>
-              <a:t>0.015%</a:t>
+              <a:t>0.026%</a:t>
             </a:r>
           </a:p>
         </p:txBody>
@@ -5632,7 +5647,7 @@
                 </a:solidFill>
                 <a:latin typeface="Arial"/>
               </a:rPr>
-              <a:t>median error on</a:t>
+              <a:t>median error on 2 months</a:t>
             </a:r>
           </a:p>
           <a:p>
@@ -5651,7 +5666,7 @@
                 </a:solidFill>
                 <a:latin typeface="Arial"/>
               </a:rPr>
-              <a:t>unseen pointings</a:t>
+              <a:t>withheld from training</a:t>
             </a:r>
           </a:p>
         </p:txBody>
@@ -5971,7 +5986,7 @@
         <p:spPr>
           <a:xfrm>
             <a:off x="17236440" y="11841480"/>
-            <a:ext cx="14538960" cy="6906006"/>
+            <a:ext cx="14538960" cy="7269480"/>
           </a:xfrm>
           <a:prstGeom prst="rect">
             <a:avLst/>
@@ -5986,8 +6001,8 @@
         </p:nvSpPr>
         <p:spPr>
           <a:xfrm>
-            <a:off x="17236440" y="18747485"/>
-            <a:ext cx="14538960" cy="914400"/>
+            <a:off x="17236440" y="19110960"/>
+            <a:ext cx="14538960" cy="1371600"/>
           </a:xfrm>
           <a:prstGeom prst="rect">
             <a:avLst/>
@@ -6024,7 +6039,7 @@
                 </a:solidFill>
                 <a:latin typeface="Arial"/>
               </a:rPr>
-              <a:t>The neural network vs. ZodiPy on 42,361 pointings it never saw in training. Left: every point lies on the 1:1 line. Right: half of the errors are smaller than 0.015%, and 98% are under 0.1%.</a:t>
+              <a:t>Neural network vs. ZodiPy. The network was trained on mission days 0–30, 60–90 and 120–140, then tested on the two 30-day blocks it never saw (days 30–60 and 90–120; 180,166 pointings). Half of the errors are below 0.026% and 95% are below 0.1%. (With a random 10% of pointings withheld instead, the median is 0.015%.)</a:t>
             </a:r>
           </a:p>
         </p:txBody>
@@ -6045,8 +6060,8 @@
         </p:blipFill>
         <p:spPr>
           <a:xfrm>
-            <a:off x="19271894" y="19707606"/>
-            <a:ext cx="10468051" cy="5192153"/>
+            <a:off x="19708063" y="20482560"/>
+            <a:ext cx="9595713" cy="4759473"/>
           </a:xfrm>
           <a:prstGeom prst="rect">
             <a:avLst/>
@@ -6061,7 +6076,7 @@
         </p:nvSpPr>
         <p:spPr>
           <a:xfrm>
-            <a:off x="17236440" y="24899759"/>
+            <a:off x="17236440" y="25242033"/>
             <a:ext cx="14538960" cy="914400"/>
           </a:xfrm>
           <a:prstGeom prst="rect">
@@ -6112,7 +6127,7 @@
         </p:nvSpPr>
         <p:spPr>
           <a:xfrm>
-            <a:off x="17236440" y="25905599"/>
+            <a:off x="17236440" y="26247873"/>
             <a:ext cx="14538960" cy="54864"/>
           </a:xfrm>
           <a:prstGeom prst="rect">
@@ -6156,7 +6171,7 @@
         </p:nvSpPr>
         <p:spPr>
           <a:xfrm>
-            <a:off x="17236440" y="26134199"/>
+            <a:off x="17236440" y="26476473"/>
             <a:ext cx="14538960" cy="1645920"/>
           </a:xfrm>
           <a:prstGeom prst="rect">
@@ -6194,7 +6209,7 @@
                 </a:solidFill>
                 <a:latin typeface="Arial"/>
               </a:rPr>
-              <a:t>Real SPHEREx images cover many wavelengths, so wavelength becomes one more input. A first version covering 1.25–5 μm already reaches ~0.1% median error.</a:t>
+              <a:t>Real SPHEREx images cover many wavelengths, so wavelength becomes one more input. A first version covering 1.25–5 μm already reaches ~0.1% median error on the same withheld months.</a:t>
             </a:r>
           </a:p>
         </p:txBody>
@@ -6215,8 +6230,8 @@
         </p:blipFill>
         <p:spPr>
           <a:xfrm>
-            <a:off x="19212029" y="27642959"/>
-            <a:ext cx="10587780" cy="7058520"/>
+            <a:off x="19468735" y="27985233"/>
+            <a:ext cx="10074369" cy="6716246"/>
           </a:xfrm>
           <a:prstGeom prst="rect">
             <a:avLst/>

</xml_diff>

<commit_message>
Poster v2 after mentor feedback: geometric-constraint framing, no speed claims
- Speed tile/figure/claims removed; banner and objective reframed (geometrically constrained model that should
  ultimately outperform the Kelsall model; this poster = validation on ZodiPy simulations)
- Intro: "range of infrared wavelengths" (no channel count); zodiacal light "bright enough to be confused with the
  background" instead of "brightest thing"
- Methods expanded: what "geometrically constrained" means, the 9 inputs, new Fig. 2 (Sun, Earth, SPHEREx, Moon,
  Jupiter, n.S / E / v / lambda_E / z)
- Next Steps moved to a vertical roadmap; references in two columns; NSF logo in the acknowledgements

Co-Authored-By: Claude Opus 5.5 <noreply@anthropic.com>
Claude-Session: https://claude.ai/code/session_012rGthNAyzBgnDfYXWSYd8K
</commit_message>
<xml_diff>
--- a/poster/poster_dark.pptx
+++ b/poster/poster_dark.pptx
@@ -507,12 +507,12 @@
           </a:p>
           <a:p>
             <a:r>
-              <a:t>- The problem statement: is 'compared with real data / fitting' the right reason the emulator is needed?</a:t>
-            </a:r>
-          </a:p>
-          <a:p>
-            <a:r>
-              <a:t>- Acknowledgment: exact name of the URS grant/program.</a:t>
+              <a:t>- Problem statement: 'physics models such as Kelsall's were fit to older data and leave errors behind' -- right framing?</a:t>
+            </a:r>
+          </a:p>
+          <a:p>
+            <a:r>
+              <a:t>- Acknowledgment: exact name of the URS grant/program and the NSF award number (if one should be listed).</a:t>
             </a:r>
           </a:p>
           <a:p>
@@ -522,22 +522,22 @@
           </a:p>
           <a:p>
             <a:r>
-              <a:t>- Speed: measured on this laptop (poster/bench_zodipy.py, poster/bench_emulator.jl): ZodiPy 21.6 ms vs network 11 us per single pointing; 32 vs 7.7 us per pointing in batches of 20,000.</a:t>
-            </a:r>
-          </a:p>
-          <a:p>
-            <a:r>
-              <a:t>- Accuracy (poster/data_accuracy.jl, data_blocks.jl): 9 inputs (n.S n.z n.E n.vS n.vE n.x_E n.y_E sin/cos of Earth's longitude), 64-64-32-16 gelu, 5-network ensemble.</a:t>
-            </a:r>
-          </a:p>
-          <a:p>
-            <a:r>
-              <a:t>  Main number: trained on days 0-30, 60-90, 120-140; tested on days 30-60, 90-120 (180,166 pointings, 43%): median 0.026%, p95 0.10%, 94.8% within 0.1%.</a:t>
-            </a:r>
-          </a:p>
-          <a:p>
-            <a:r>
-              <a:t>  Random 10% withheld (= packaged emulator v2): median 0.015%, p95 0.064%. Harder: last 20% of the mission (days 111-140, older season inputs): median 0.10%, p95 0.67%.</a:t>
+              <a:t>- Fig. 2: Jupiter and the Moon are drawn for context; the poster's model inputs are n.S n.z n.E n.vS n.vE n.x_E n.y_E sin/cos(lambda_E) (no Jupiter, no Moon).</a:t>
+            </a:r>
+          </a:p>
+          <a:p>
+            <a:r>
+              <a:t>Numbers (poster/data_accuracy.jl, data_blocks.jl): 5-network ensemble, 64-64-32-16 gelu.</a:t>
+            </a:r>
+          </a:p>
+          <a:p>
+            <a:r>
+              <a:t>  Trained on days 0-30, 60-90, 120-140; tested on days 30-60, 90-120 (180,166 pointings, 43%): median 0.026%, p95 0.10%, 94.8% within 0.1%, RMS 0.058%.</a:t>
+            </a:r>
+          </a:p>
+          <a:p>
+            <a:r>
+              <a:t>  Random 10% withheld: median 0.015%. Last 20% of the mission (days 111-140, older season inputs): median 0.10%, p95 0.67%.</a:t>
             </a:r>
           </a:p>
           <a:p>
@@ -3727,13 +3727,13 @@
               </a:spcAft>
             </a:pPr>
             <a:r>
-              <a:rPr sz="4400" b="0">
+              <a:rPr sz="4000" b="0">
                 <a:solidFill>
                   <a:srgbClr val="FFD27A"/>
                 </a:solidFill>
                 <a:latin typeface="Arial"/>
               </a:rPr>
-              <a:t>A fast zodiacal-light emulator for NASA's SPHEREx mission</a:t>
+              <a:t>A geometrically constrained model of zodiacal light for NASA's SPHEREx mission</a:t>
             </a:r>
           </a:p>
         </p:txBody>
@@ -3808,7 +3808,7 @@
         <p:spPr>
           <a:xfrm>
             <a:off x="731520" y="5486400"/>
-            <a:ext cx="31455360" cy="1600200"/>
+            <a:ext cx="31455360" cy="1371600"/>
           </a:xfrm>
           <a:prstGeom prst="roundRect">
             <a:avLst>
@@ -3854,7 +3854,7 @@
         <p:spPr>
           <a:xfrm>
             <a:off x="1280160" y="5486400"/>
-            <a:ext cx="30358079" cy="1600200"/>
+            <a:ext cx="30358079" cy="1371600"/>
           </a:xfrm>
           <a:prstGeom prst="rect">
             <a:avLst/>
@@ -3872,7 +3872,7 @@
                 <a:spcPct val="100000"/>
               </a:lnSpc>
               <a:spcAft>
-                <a:spcPts val="1000"/>
+                <a:spcPts val="0"/>
               </a:spcAft>
             </a:pPr>
             <a:r>
@@ -3882,7 +3882,7 @@
                 </a:solidFill>
                 <a:latin typeface="Arial"/>
               </a:rPr>
-              <a:t>A small neural network reproduces a physics model of the Solar System's dust glow to ~0.03% on months it never saw, up to ~2,000× faster per pointing, and can be extended to every wavelength SPHEREx observes.</a:t>
+              <a:t>A geometrically constrained neural network learns the zodiacal light from viewing geometry alone, reaching ~0.03% median error on months it never saw.</a:t>
             </a:r>
           </a:p>
         </p:txBody>
@@ -3895,8 +3895,8 @@
         </p:nvSpPr>
         <p:spPr>
           <a:xfrm>
-            <a:off x="731520" y="7498079"/>
-            <a:ext cx="15361920" cy="16824960"/>
+            <a:off x="731520" y="7223760"/>
+            <a:ext cx="15361920" cy="10561319"/>
           </a:xfrm>
           <a:prstGeom prst="rect">
             <a:avLst/>
@@ -3941,7 +3941,7 @@
         </p:nvSpPr>
         <p:spPr>
           <a:xfrm>
-            <a:off x="731520" y="7498079"/>
+            <a:off x="731520" y="7223760"/>
             <a:ext cx="15361920" cy="1051560"/>
           </a:xfrm>
           <a:prstGeom prst="rect">
@@ -3985,7 +3985,7 @@
         </p:nvSpPr>
         <p:spPr>
           <a:xfrm>
-            <a:off x="731520" y="7498079"/>
+            <a:off x="731520" y="7223760"/>
             <a:ext cx="15361920" cy="1051560"/>
           </a:xfrm>
           <a:prstGeom prst="rect">
@@ -4027,8 +4027,8 @@
         </p:nvSpPr>
         <p:spPr>
           <a:xfrm>
-            <a:off x="1143000" y="8869680"/>
-            <a:ext cx="14538960" cy="2377440"/>
+            <a:off x="1143000" y="8595360"/>
+            <a:ext cx="14538960" cy="2011680"/>
           </a:xfrm>
           <a:prstGeom prst="rect">
             <a:avLst/>
@@ -4074,7 +4074,7 @@
                 </a:solidFill>
                 <a:latin typeface="Arial"/>
               </a:rPr>
-              <a:t>entire sky in 102 infrared colors</a:t>
+              <a:t>entire sky across a range of infrared wavelengths</a:t>
             </a:r>
             <a:r>
               <a:rPr sz="2800" b="0">
@@ -4083,7 +4083,7 @@
                 </a:solidFill>
                 <a:latin typeface="Arial"/>
               </a:rPr>
-              <a:t> (0.75–5 μm) every six months. Its maps will help explain how the universe began, how galaxies formed, and where water and other ingredients for life are found.</a:t>
+              <a:t> (0.75–5 μm). Its maps will help explain how the universe began, how galaxies formed, and where water and other ingredients for life are found.</a:t>
             </a:r>
           </a:p>
         </p:txBody>
@@ -4096,8 +4096,8 @@
         </p:nvSpPr>
         <p:spPr>
           <a:xfrm>
-            <a:off x="1143000" y="11155680"/>
-            <a:ext cx="6542532" cy="6035040"/>
+            <a:off x="1143000" y="10652760"/>
+            <a:ext cx="6833311" cy="6949439"/>
           </a:xfrm>
           <a:prstGeom prst="rect">
             <a:avLst/>
@@ -4112,14 +4112,14 @@
           <a:p>
             <a:pPr algn="l">
               <a:lnSpc>
-                <a:spcPct val="112000"/>
+                <a:spcPct val="108000"/>
               </a:lnSpc>
               <a:spcAft>
-                <a:spcPts val="1000"/>
+                <a:spcPts val="800"/>
               </a:spcAft>
             </a:pPr>
             <a:r>
-              <a:rPr sz="2700" b="1">
+              <a:rPr sz="2500" b="1">
                 <a:solidFill>
                   <a:srgbClr val="EEF3F8"/>
                 </a:solidFill>
@@ -4128,38 +4128,66 @@
               <a:t>Zodiacal light. </a:t>
             </a:r>
             <a:r>
-              <a:rPr sz="2700" b="0">
+              <a:rPr sz="2500" b="0">
                 <a:solidFill>
                   <a:srgbClr val="EEF3F8"/>
                 </a:solidFill>
                 <a:latin typeface="Arial"/>
               </a:rPr>
-              <a:t>The Solar System is filled with a thin cloud of dust from comets and asteroids. Sunlight scattered by this dust, plus the dust's own heat glow, is the </a:t>
-            </a:r>
-            <a:r>
-              <a:rPr sz="2700" b="1">
+              <a:t>The Solar System is filled with a thin cloud of dust from comets and asteroids. Sunlight scattered by this dust, plus the dust's own heat glow, adds a smooth glow across every SPHEREx image (Fig. 1). It is bright enough to be confused with the faint background light from distant galaxies, and it changes with where the telescope looks and where Earth is in its orbit, so it must be carefully modeled and removed.</a:t>
+            </a:r>
+          </a:p>
+          <a:p>
+            <a:pPr algn="l">
+              <a:lnSpc>
+                <a:spcPct val="108000"/>
+              </a:lnSpc>
+              <a:spcAft>
+                <a:spcPts val="800"/>
+              </a:spcAft>
+            </a:pPr>
+            <a:r>
+              <a:rPr sz="2500" b="1">
                 <a:solidFill>
                   <a:srgbClr val="EEF3F8"/>
                 </a:solidFill>
                 <a:latin typeface="Arial"/>
               </a:rPr>
-              <a:t>brightest thing in almost every SPHEREx image</a:t>
-            </a:r>
-            <a:r>
-              <a:rPr sz="2700" b="0">
+              <a:t>The Kelsall model. </a:t>
+            </a:r>
+            <a:r>
+              <a:rPr sz="2500" b="0">
                 <a:solidFill>
                   <a:srgbClr val="EEF3F8"/>
                 </a:solidFill>
                 <a:latin typeface="Arial"/>
               </a:rPr>
-              <a:t> (Fig. 1). It changes with where the telescope looks and where Earth is in its orbit, so it must be modeled and removed before faint, distant galaxies can be studied.</a:t>
+              <a:t>Kelsall et al. (1998) built the standard model of this dust from NASA's COBE satellite: a smooth cloud, three dust bands, a ring around the Sun and a clump trailing Earth. The software </a:t>
+            </a:r>
+            <a:r>
+              <a:rPr sz="2500" b="1">
+                <a:solidFill>
+                  <a:srgbClr val="EEF3F8"/>
+                </a:solidFill>
+                <a:latin typeface="Arial"/>
+              </a:rPr>
+              <a:t>ZodiPy</a:t>
+            </a:r>
+            <a:r>
+              <a:rPr sz="2500" b="0">
+                <a:solidFill>
+                  <a:srgbClr val="EEF3F8"/>
+                </a:solidFill>
+                <a:latin typeface="Arial"/>
+              </a:rPr>
+              <a:t> computes what a telescope would see from it; we use it to simulate SPHEREx data.</a:t>
             </a:r>
           </a:p>
         </p:txBody>
       </p:sp>
       <p:pic>
         <p:nvPicPr>
-          <p:cNvPr id="15" name="Picture 14" descr="schematic_dark.png"/>
+          <p:cNvPr id="15" name="Picture 14" descr="sky_dark.png"/>
           <p:cNvPicPr>
             <a:picLocks noChangeAspect="1"/>
           </p:cNvPicPr>
@@ -4173,8 +4201,8 @@
         </p:blipFill>
         <p:spPr>
           <a:xfrm>
-            <a:off x="8005572" y="11155680"/>
-            <a:ext cx="7676388" cy="5526999"/>
+            <a:off x="8296351" y="10835640"/>
+            <a:ext cx="7385608" cy="4431365"/>
           </a:xfrm>
           <a:prstGeom prst="rect">
             <a:avLst/>
@@ -4189,8 +4217,8 @@
         </p:nvSpPr>
         <p:spPr>
           <a:xfrm>
-            <a:off x="8005572" y="16728399"/>
-            <a:ext cx="7676388" cy="822960"/>
+            <a:off x="8296351" y="15358445"/>
+            <a:ext cx="7385608" cy="1463040"/>
           </a:xfrm>
           <a:prstGeom prst="rect">
             <a:avLst/>
@@ -4227,150 +4255,6 @@
                 </a:solidFill>
                 <a:latin typeface="Arial"/>
               </a:rPr>
-              <a:t>SPHEREx looks out through the Sun's dust cloud (top view, not to scale).</a:t>
-            </a:r>
-          </a:p>
-        </p:txBody>
-      </p:sp>
-      <p:sp>
-        <p:nvSpPr>
-          <p:cNvPr id="17" name="TextBox 16"/>
-          <p:cNvSpPr txBox="1"/>
-          <p:nvPr/>
-        </p:nvSpPr>
-        <p:spPr>
-          <a:xfrm>
-            <a:off x="1143000" y="17642799"/>
-            <a:ext cx="6542532" cy="4937760"/>
-          </a:xfrm>
-          <a:prstGeom prst="rect">
-            <a:avLst/>
-          </a:prstGeom>
-          <a:noFill/>
-        </p:spPr>
-        <p:txBody>
-          <a:bodyPr wrap="square" anchor="t" lIns="45720" rIns="45720" tIns="18288" bIns="18288">
-            <a:spAutoFit/>
-          </a:bodyPr>
-          <a:lstStyle/>
-          <a:p>
-            <a:pPr algn="l">
-              <a:lnSpc>
-                <a:spcPct val="112000"/>
-              </a:lnSpc>
-              <a:spcAft>
-                <a:spcPts val="1000"/>
-              </a:spcAft>
-            </a:pPr>
-            <a:r>
-              <a:rPr sz="2700" b="1">
-                <a:solidFill>
-                  <a:srgbClr val="EEF3F8"/>
-                </a:solidFill>
-                <a:latin typeface="Arial"/>
-              </a:rPr>
-              <a:t>The Kelsall model. </a:t>
-            </a:r>
-            <a:r>
-              <a:rPr sz="2700" b="0">
-                <a:solidFill>
-                  <a:srgbClr val="EEF3F8"/>
-                </a:solidFill>
-                <a:latin typeface="Arial"/>
-              </a:rPr>
-              <a:t>Kelsall et al. (1998) built the standard model of this dust from NASA's COBE satellite: a smooth cloud, three dust bands, a ring of dust around the Sun, and a clump that trails Earth. The software </a:t>
-            </a:r>
-            <a:r>
-              <a:rPr sz="2700" b="1">
-                <a:solidFill>
-                  <a:srgbClr val="EEF3F8"/>
-                </a:solidFill>
-                <a:latin typeface="Arial"/>
-              </a:rPr>
-              <a:t>ZodiPy</a:t>
-            </a:r>
-            <a:r>
-              <a:rPr sz="2700" b="0">
-                <a:solidFill>
-                  <a:srgbClr val="EEF3F8"/>
-                </a:solidFill>
-                <a:latin typeface="Arial"/>
-              </a:rPr>
-              <a:t> adds up the glow along each line of sight to predict what a telescope sees (Fig. 2).</a:t>
-            </a:r>
-          </a:p>
-        </p:txBody>
-      </p:sp>
-      <p:pic>
-        <p:nvPicPr>
-          <p:cNvPr id="18" name="Picture 17" descr="sky_dark.png"/>
-          <p:cNvPicPr>
-            <a:picLocks noChangeAspect="1"/>
-          </p:cNvPicPr>
-          <p:nvPr/>
-        </p:nvPicPr>
-        <p:blipFill>
-          <a:blip r:embed="rId5"/>
-          <a:stretch>
-            <a:fillRect/>
-          </a:stretch>
-        </p:blipFill>
-        <p:spPr>
-          <a:xfrm>
-            <a:off x="8005572" y="17734239"/>
-            <a:ext cx="7676388" cy="4605832"/>
-          </a:xfrm>
-          <a:prstGeom prst="rect">
-            <a:avLst/>
-          </a:prstGeom>
-        </p:spPr>
-      </p:pic>
-      <p:sp>
-        <p:nvSpPr>
-          <p:cNvPr id="19" name="TextBox 18"/>
-          <p:cNvSpPr txBox="1"/>
-          <p:nvPr/>
-        </p:nvSpPr>
-        <p:spPr>
-          <a:xfrm>
-            <a:off x="8005572" y="22385792"/>
-            <a:ext cx="7676388" cy="1280160"/>
-          </a:xfrm>
-          <a:prstGeom prst="rect">
-            <a:avLst/>
-          </a:prstGeom>
-          <a:noFill/>
-        </p:spPr>
-        <p:txBody>
-          <a:bodyPr wrap="square" anchor="t" lIns="45720" rIns="45720" tIns="18288" bIns="18288">
-            <a:spAutoFit/>
-          </a:bodyPr>
-          <a:lstStyle/>
-          <a:p>
-            <a:pPr algn="l">
-              <a:lnSpc>
-                <a:spcPct val="105000"/>
-              </a:lnSpc>
-              <a:spcAft>
-                <a:spcPts val="1000"/>
-              </a:spcAft>
-            </a:pPr>
-            <a:r>
-              <a:rPr sz="2200" b="1">
-                <a:solidFill>
-                  <a:srgbClr val="A9B6C6"/>
-                </a:solidFill>
-                <a:latin typeface="Arial"/>
-              </a:rPr>
-              <a:t>Figure 2. </a:t>
-            </a:r>
-            <a:r>
-              <a:rPr sz="2200" b="0">
-                <a:solidFill>
-                  <a:srgbClr val="A9B6C6"/>
-                </a:solidFill>
-                <a:latin typeface="Arial"/>
-              </a:rPr>
               <a:t>The whole sky at 5 μm as seen from SPHEREx (ZodiPy). The glow is brightest toward the Sun and along the plane of the planets. Grey: too close to the Sun to observe.</a:t>
             </a:r>
           </a:p>
@@ -4378,14 +4262,14 @@
       </p:sp>
       <p:sp>
         <p:nvSpPr>
-          <p:cNvPr id="20" name="Rectangle 19"/>
+          <p:cNvPr id="17" name="Rectangle 16"/>
           <p:cNvSpPr/>
           <p:nvPr/>
         </p:nvSpPr>
         <p:spPr>
           <a:xfrm>
-            <a:off x="731520" y="24734520"/>
-            <a:ext cx="15361920" cy="3794759"/>
+            <a:off x="731520" y="18196560"/>
+            <a:ext cx="15361920" cy="3063240"/>
           </a:xfrm>
           <a:prstGeom prst="rect">
             <a:avLst/>
@@ -4424,14 +4308,14 @@
       </p:sp>
       <p:sp>
         <p:nvSpPr>
-          <p:cNvPr id="21" name="TextBox 20"/>
+          <p:cNvPr id="18" name="TextBox 17"/>
           <p:cNvSpPr txBox="1"/>
           <p:nvPr/>
         </p:nvSpPr>
         <p:spPr>
           <a:xfrm>
-            <a:off x="1143000" y="25008840"/>
-            <a:ext cx="14538960" cy="3337559"/>
+            <a:off x="1143000" y="18425160"/>
+            <a:ext cx="14538960" cy="2697480"/>
           </a:xfrm>
           <a:prstGeom prst="rect">
             <a:avLst/>
@@ -4449,11 +4333,11 @@
                 <a:spcPct val="112000"/>
               </a:lnSpc>
               <a:spcAft>
-                <a:spcPts val="1400"/>
+                <a:spcPts val="1200"/>
               </a:spcAft>
             </a:pPr>
             <a:r>
-              <a:rPr sz="2900" b="1">
+              <a:rPr sz="2800" b="1">
                 <a:solidFill>
                   <a:srgbClr val="EEF3F8"/>
                 </a:solidFill>
@@ -4462,13 +4346,13 @@
               <a:t>The problem: </a:t>
             </a:r>
             <a:r>
-              <a:rPr sz="2900" b="0">
+              <a:rPr sz="2800" b="0">
                 <a:solidFill>
                   <a:srgbClr val="EEF3F8"/>
                 </a:solidFill>
                 <a:latin typeface="Arial"/>
               </a:rPr>
-              <a:t>computing the model means adding up dust glow along every line of sight, for millions of SPHEREx pointings, at many wavelengths, again and again as the model is compared with real data.</a:t>
+              <a:t>zodiacal light must be removed from every SPHEREx image, but physics models such as Kelsall's were fit to older data and leave errors behind.</a:t>
             </a:r>
           </a:p>
           <a:p>
@@ -4477,11 +4361,11 @@
                 <a:spcPct val="112000"/>
               </a:lnSpc>
               <a:spcAft>
-                <a:spcPts val="1400"/>
+                <a:spcPts val="1200"/>
               </a:spcAft>
             </a:pPr>
             <a:r>
-              <a:rPr sz="2900" b="1">
+              <a:rPr sz="2800" b="1">
                 <a:solidFill>
                   <a:srgbClr val="EEF3F8"/>
                 </a:solidFill>
@@ -4490,45 +4374,63 @@
               <a:t>Research objective: </a:t>
             </a:r>
             <a:r>
-              <a:rPr sz="2900" b="0">
+              <a:rPr sz="2800" b="0">
                 <a:solidFill>
                   <a:srgbClr val="EEF3F8"/>
                 </a:solidFill>
                 <a:latin typeface="Arial"/>
               </a:rPr>
-              <a:t>to build and test a neural-network </a:t>
-            </a:r>
-            <a:r>
-              <a:rPr sz="2900" b="1">
+              <a:t>build a </a:t>
+            </a:r>
+            <a:r>
+              <a:rPr sz="2800" b="1">
                 <a:solidFill>
                   <a:srgbClr val="EEF3F8"/>
                 </a:solidFill>
                 <a:latin typeface="Arial"/>
               </a:rPr>
-              <a:t>“emulator”</a:t>
-            </a:r>
-            <a:r>
-              <a:rPr sz="2900" b="0">
+              <a:t>geometrically constrained</a:t>
+            </a:r>
+            <a:r>
+              <a:rPr sz="2800" b="0">
                 <a:solidFill>
                   <a:srgbClr val="EEF3F8"/>
                 </a:solidFill>
                 <a:latin typeface="Arial"/>
               </a:rPr>
-              <a:t> that reproduces ZodiPy's zodiacal light accurately (well under 1% error) while running much faster, ready for real SPHEREx data.</a:t>
-            </a:r>
-          </a:p>
-        </p:txBody>
-      </p:sp>
-      <p:sp>
-        <p:nvSpPr>
-          <p:cNvPr id="22" name="Rectangle 21"/>
+              <a:t> neural network that learns the zodiacal light directly from SPHEREx data and </a:t>
+            </a:r>
+            <a:r>
+              <a:rPr sz="2800" b="1">
+                <a:solidFill>
+                  <a:srgbClr val="EEF3F8"/>
+                </a:solidFill>
+                <a:latin typeface="Arial"/>
+              </a:rPr>
+              <a:t>outperforms the Kelsall model</a:t>
+            </a:r>
+            <a:r>
+              <a:rPr sz="2800" b="0">
+                <a:solidFill>
+                  <a:srgbClr val="EEF3F8"/>
+                </a:solidFill>
+                <a:latin typeface="Arial"/>
+              </a:rPr>
+              <a:t>. First step (this poster): show that it can learn ZodiPy's simulated sky from geometry alone.</a:t>
+            </a:r>
+          </a:p>
+        </p:txBody>
+      </p:sp>
+      <p:sp>
+        <p:nvSpPr>
+          <p:cNvPr id="19" name="Rectangle 18"/>
           <p:cNvSpPr/>
           <p:nvPr/>
         </p:nvSpPr>
         <p:spPr>
           <a:xfrm>
-            <a:off x="731520" y="28940760"/>
-            <a:ext cx="15361920" cy="6812280"/>
+            <a:off x="731520" y="21671280"/>
+            <a:ext cx="15361920" cy="18562320"/>
           </a:xfrm>
           <a:prstGeom prst="rect">
             <a:avLst/>
@@ -4567,13 +4469,13 @@
       </p:sp>
       <p:sp>
         <p:nvSpPr>
-          <p:cNvPr id="23" name="Rectangle 22"/>
+          <p:cNvPr id="20" name="Rectangle 19"/>
           <p:cNvSpPr/>
           <p:nvPr/>
         </p:nvSpPr>
         <p:spPr>
           <a:xfrm>
-            <a:off x="731520" y="28940760"/>
+            <a:off x="731520" y="21671280"/>
             <a:ext cx="15361920" cy="1051560"/>
           </a:xfrm>
           <a:prstGeom prst="rect">
@@ -4611,13 +4513,13 @@
       </p:sp>
       <p:sp>
         <p:nvSpPr>
-          <p:cNvPr id="24" name="TextBox 23"/>
+          <p:cNvPr id="21" name="TextBox 20"/>
           <p:cNvSpPr txBox="1"/>
           <p:nvPr/>
         </p:nvSpPr>
         <p:spPr>
           <a:xfrm>
-            <a:off x="731520" y="28940760"/>
+            <a:off x="731520" y="21671280"/>
             <a:ext cx="15361920" cy="1051560"/>
           </a:xfrm>
           <a:prstGeom prst="rect">
@@ -4653,26 +4555,691 @@
       </p:sp>
       <p:sp>
         <p:nvSpPr>
-          <p:cNvPr id="25" name="Rounded Rectangle 24"/>
+          <p:cNvPr id="22" name="TextBox 21"/>
+          <p:cNvSpPr txBox="1"/>
+          <p:nvPr/>
+        </p:nvSpPr>
+        <p:spPr>
+          <a:xfrm>
+            <a:off x="1143000" y="23042880"/>
+            <a:ext cx="14538960" cy="2377440"/>
+          </a:xfrm>
+          <a:prstGeom prst="rect">
+            <a:avLst/>
+          </a:prstGeom>
+          <a:noFill/>
+        </p:spPr>
+        <p:txBody>
+          <a:bodyPr wrap="square" anchor="t" lIns="45720" rIns="45720" tIns="18288" bIns="18288">
+            <a:spAutoFit/>
+          </a:bodyPr>
+          <a:lstStyle/>
+          <a:p>
+            <a:pPr algn="l">
+              <a:lnSpc>
+                <a:spcPct val="112000"/>
+              </a:lnSpc>
+              <a:spcAft>
+                <a:spcPts val="1000"/>
+              </a:spcAft>
+            </a:pPr>
+            <a:r>
+              <a:rPr sz="2700" b="1">
+                <a:solidFill>
+                  <a:srgbClr val="EEF3F8"/>
+                </a:solidFill>
+                <a:latin typeface="Arial"/>
+              </a:rPr>
+              <a:t>A geometrically constrained model. </a:t>
+            </a:r>
+            <a:r>
+              <a:rPr sz="2700" b="0">
+                <a:solidFill>
+                  <a:srgbClr val="EEF3F8"/>
+                </a:solidFill>
+                <a:latin typeface="Arial"/>
+              </a:rPr>
+              <a:t>The network never sees a date or a position on a sky map. Its only inputs are 9 numbers describing the viewing geometry (Fig. 2): dot products of SPHEREx's look direction n with the directions that shape the zodiacal light, plus Earth's place in its orbit. It must learn how the brightness depends on geometry, just as the physics does, instead of memorizing when and where SPHEREx looked.</a:t>
+            </a:r>
+          </a:p>
+        </p:txBody>
+      </p:sp>
+      <p:pic>
+        <p:nvPicPr>
+          <p:cNvPr id="23" name="Picture 22" descr="geometry_dark.png"/>
+          <p:cNvPicPr>
+            <a:picLocks noChangeAspect="1"/>
+          </p:cNvPicPr>
+          <p:nvPr/>
+        </p:nvPicPr>
+        <p:blipFill>
+          <a:blip r:embed="rId5"/>
+          <a:stretch>
+            <a:fillRect/>
+          </a:stretch>
+        </p:blipFill>
+        <p:spPr>
+          <a:xfrm>
+            <a:off x="2596896" y="25466039"/>
+            <a:ext cx="11631168" cy="7909194"/>
+          </a:xfrm>
+          <a:prstGeom prst="rect">
+            <a:avLst/>
+          </a:prstGeom>
+        </p:spPr>
+      </p:pic>
+      <p:sp>
+        <p:nvSpPr>
+          <p:cNvPr id="24" name="TextBox 23"/>
+          <p:cNvSpPr txBox="1"/>
+          <p:nvPr/>
+        </p:nvSpPr>
+        <p:spPr>
+          <a:xfrm>
+            <a:off x="1143000" y="33420954"/>
+            <a:ext cx="14538960" cy="1188720"/>
+          </a:xfrm>
+          <a:prstGeom prst="rect">
+            <a:avLst/>
+          </a:prstGeom>
+          <a:noFill/>
+        </p:spPr>
+        <p:txBody>
+          <a:bodyPr wrap="square" anchor="t" lIns="45720" rIns="45720" tIns="18288" bIns="18288">
+            <a:spAutoFit/>
+          </a:bodyPr>
+          <a:lstStyle/>
+          <a:p>
+            <a:pPr algn="l">
+              <a:lnSpc>
+                <a:spcPct val="105000"/>
+              </a:lnSpc>
+              <a:spcAft>
+                <a:spcPts val="1000"/>
+              </a:spcAft>
+            </a:pPr>
+            <a:r>
+              <a:rPr sz="2200" b="1">
+                <a:solidFill>
+                  <a:srgbClr val="A9B6C6"/>
+                </a:solidFill>
+                <a:latin typeface="Arial"/>
+              </a:rPr>
+              <a:t>Figure 2. </a:t>
+            </a:r>
+            <a:r>
+              <a:rPr sz="2200" b="0">
+                <a:solidFill>
+                  <a:srgbClr val="A9B6C6"/>
+                </a:solidFill>
+                <a:latin typeface="Arial"/>
+              </a:rPr>
+              <a:t>The geometry the network sees (top view, not to scale). n is where SPHEREx looks; S and E point from the Sun to SPHEREx and Earth; v is the orbital motion; λ⊕ is Earth's angle around its orbit. Jupiter and the Moon are shown for context: the final model uses only the Sun–Earth–SPHEREx geometry and the time of year.</a:t>
+            </a:r>
+          </a:p>
+        </p:txBody>
+      </p:sp>
+      <p:sp>
+        <p:nvSpPr>
+          <p:cNvPr id="25" name="TextBox 24"/>
+          <p:cNvSpPr txBox="1"/>
+          <p:nvPr/>
+        </p:nvSpPr>
+        <p:spPr>
+          <a:xfrm>
+            <a:off x="1143000" y="34701114"/>
+            <a:ext cx="14538960" cy="548640"/>
+          </a:xfrm>
+          <a:prstGeom prst="rect">
+            <a:avLst/>
+          </a:prstGeom>
+          <a:noFill/>
+        </p:spPr>
+        <p:txBody>
+          <a:bodyPr wrap="square" anchor="t" lIns="45720" rIns="45720" tIns="18288" bIns="18288">
+            <a:spAutoFit/>
+          </a:bodyPr>
+          <a:lstStyle/>
+          <a:p>
+            <a:pPr algn="l">
+              <a:lnSpc>
+                <a:spcPct val="112000"/>
+              </a:lnSpc>
+              <a:spcAft>
+                <a:spcPts val="0"/>
+              </a:spcAft>
+            </a:pPr>
+            <a:r>
+              <a:rPr sz="2800" b="1">
+                <a:solidFill>
+                  <a:srgbClr val="5FB0FF"/>
+                </a:solidFill>
+                <a:latin typeface="Arial"/>
+              </a:rPr>
+              <a:t>The 9 inputs</a:t>
+            </a:r>
+          </a:p>
+        </p:txBody>
+      </p:sp>
+      <p:sp>
+        <p:nvSpPr>
+          <p:cNvPr id="26" name="TextBox 25"/>
+          <p:cNvSpPr txBox="1"/>
+          <p:nvPr/>
+        </p:nvSpPr>
+        <p:spPr>
+          <a:xfrm>
+            <a:off x="1325880" y="35249754"/>
+            <a:ext cx="3291840" cy="457200"/>
+          </a:xfrm>
+          <a:prstGeom prst="rect">
+            <a:avLst/>
+          </a:prstGeom>
+          <a:noFill/>
+        </p:spPr>
+        <p:txBody>
+          <a:bodyPr wrap="square" anchor="t" lIns="45720" rIns="45720" tIns="18288" bIns="18288">
+            <a:spAutoFit/>
+          </a:bodyPr>
+          <a:lstStyle/>
+          <a:p>
+            <a:pPr algn="l">
+              <a:lnSpc>
+                <a:spcPct val="112000"/>
+              </a:lnSpc>
+              <a:spcAft>
+                <a:spcPts val="0"/>
+              </a:spcAft>
+            </a:pPr>
+            <a:r>
+              <a:rPr sz="2400" b="1">
+                <a:solidFill>
+                  <a:srgbClr val="5FB0FF"/>
+                </a:solidFill>
+                <a:latin typeface="Arial"/>
+              </a:rPr>
+              <a:t>n·S, n·E</a:t>
+            </a:r>
+          </a:p>
+        </p:txBody>
+      </p:sp>
+      <p:sp>
+        <p:nvSpPr>
+          <p:cNvPr id="27" name="TextBox 26"/>
+          <p:cNvSpPr txBox="1"/>
+          <p:nvPr/>
+        </p:nvSpPr>
+        <p:spPr>
+          <a:xfrm>
+            <a:off x="4617720" y="35249754"/>
+            <a:ext cx="11064240" cy="457200"/>
+          </a:xfrm>
+          <a:prstGeom prst="rect">
+            <a:avLst/>
+          </a:prstGeom>
+          <a:noFill/>
+        </p:spPr>
+        <p:txBody>
+          <a:bodyPr wrap="square" anchor="t" lIns="45720" rIns="45720" tIns="18288" bIns="18288">
+            <a:spAutoFit/>
+          </a:bodyPr>
+          <a:lstStyle/>
+          <a:p>
+            <a:pPr algn="l">
+              <a:lnSpc>
+                <a:spcPct val="112000"/>
+              </a:lnSpc>
+              <a:spcAft>
+                <a:spcPts val="0"/>
+              </a:spcAft>
+            </a:pPr>
+            <a:r>
+              <a:rPr sz="2400" b="0">
+                <a:solidFill>
+                  <a:srgbClr val="EEF3F8"/>
+                </a:solidFill>
+                <a:latin typeface="Arial"/>
+              </a:rPr>
+              <a:t>toward or away from the Sun (seen from SPHEREx and from Earth)</a:t>
+            </a:r>
+          </a:p>
+        </p:txBody>
+      </p:sp>
+      <p:sp>
+        <p:nvSpPr>
+          <p:cNvPr id="28" name="TextBox 27"/>
+          <p:cNvSpPr txBox="1"/>
+          <p:nvPr/>
+        </p:nvSpPr>
+        <p:spPr>
+          <a:xfrm>
+            <a:off x="1325880" y="35679522"/>
+            <a:ext cx="3291840" cy="457200"/>
+          </a:xfrm>
+          <a:prstGeom prst="rect">
+            <a:avLst/>
+          </a:prstGeom>
+          <a:noFill/>
+        </p:spPr>
+        <p:txBody>
+          <a:bodyPr wrap="square" anchor="t" lIns="45720" rIns="45720" tIns="18288" bIns="18288">
+            <a:spAutoFit/>
+          </a:bodyPr>
+          <a:lstStyle/>
+          <a:p>
+            <a:pPr algn="l">
+              <a:lnSpc>
+                <a:spcPct val="112000"/>
+              </a:lnSpc>
+              <a:spcAft>
+                <a:spcPts val="0"/>
+              </a:spcAft>
+            </a:pPr>
+            <a:r>
+              <a:rPr sz="2400" b="1">
+                <a:solidFill>
+                  <a:srgbClr val="5FB0FF"/>
+                </a:solidFill>
+                <a:latin typeface="Arial"/>
+              </a:rPr>
+              <a:t>n·z</a:t>
+            </a:r>
+          </a:p>
+        </p:txBody>
+      </p:sp>
+      <p:sp>
+        <p:nvSpPr>
+          <p:cNvPr id="29" name="TextBox 28"/>
+          <p:cNvSpPr txBox="1"/>
+          <p:nvPr/>
+        </p:nvSpPr>
+        <p:spPr>
+          <a:xfrm>
+            <a:off x="4617720" y="35679522"/>
+            <a:ext cx="11064240" cy="457200"/>
+          </a:xfrm>
+          <a:prstGeom prst="rect">
+            <a:avLst/>
+          </a:prstGeom>
+          <a:noFill/>
+        </p:spPr>
+        <p:txBody>
+          <a:bodyPr wrap="square" anchor="t" lIns="45720" rIns="45720" tIns="18288" bIns="18288">
+            <a:spAutoFit/>
+          </a:bodyPr>
+          <a:lstStyle/>
+          <a:p>
+            <a:pPr algn="l">
+              <a:lnSpc>
+                <a:spcPct val="112000"/>
+              </a:lnSpc>
+              <a:spcAft>
+                <a:spcPts val="0"/>
+              </a:spcAft>
+            </a:pPr>
+            <a:r>
+              <a:rPr sz="2400" b="0">
+                <a:solidFill>
+                  <a:srgbClr val="EEF3F8"/>
+                </a:solidFill>
+                <a:latin typeface="Arial"/>
+              </a:rPr>
+              <a:t>how far above or below the plane of the planets</a:t>
+            </a:r>
+          </a:p>
+        </p:txBody>
+      </p:sp>
+      <p:sp>
+        <p:nvSpPr>
+          <p:cNvPr id="30" name="TextBox 29"/>
+          <p:cNvSpPr txBox="1"/>
+          <p:nvPr/>
+        </p:nvSpPr>
+        <p:spPr>
+          <a:xfrm>
+            <a:off x="1325880" y="36109290"/>
+            <a:ext cx="3291840" cy="457200"/>
+          </a:xfrm>
+          <a:prstGeom prst="rect">
+            <a:avLst/>
+          </a:prstGeom>
+          <a:noFill/>
+        </p:spPr>
+        <p:txBody>
+          <a:bodyPr wrap="square" anchor="t" lIns="45720" rIns="45720" tIns="18288" bIns="18288">
+            <a:spAutoFit/>
+          </a:bodyPr>
+          <a:lstStyle/>
+          <a:p>
+            <a:pPr algn="l">
+              <a:lnSpc>
+                <a:spcPct val="112000"/>
+              </a:lnSpc>
+              <a:spcAft>
+                <a:spcPts val="0"/>
+              </a:spcAft>
+            </a:pPr>
+            <a:r>
+              <a:rPr sz="2400" b="1">
+                <a:solidFill>
+                  <a:srgbClr val="5FB0FF"/>
+                </a:solidFill>
+                <a:latin typeface="Arial"/>
+              </a:rPr>
+              <a:t>n·vS, n·vE</a:t>
+            </a:r>
+          </a:p>
+        </p:txBody>
+      </p:sp>
+      <p:sp>
+        <p:nvSpPr>
+          <p:cNvPr id="31" name="TextBox 30"/>
+          <p:cNvSpPr txBox="1"/>
+          <p:nvPr/>
+        </p:nvSpPr>
+        <p:spPr>
+          <a:xfrm>
+            <a:off x="4617720" y="36109290"/>
+            <a:ext cx="11064240" cy="457200"/>
+          </a:xfrm>
+          <a:prstGeom prst="rect">
+            <a:avLst/>
+          </a:prstGeom>
+          <a:noFill/>
+        </p:spPr>
+        <p:txBody>
+          <a:bodyPr wrap="square" anchor="t" lIns="45720" rIns="45720" tIns="18288" bIns="18288">
+            <a:spAutoFit/>
+          </a:bodyPr>
+          <a:lstStyle/>
+          <a:p>
+            <a:pPr algn="l">
+              <a:lnSpc>
+                <a:spcPct val="112000"/>
+              </a:lnSpc>
+              <a:spcAft>
+                <a:spcPts val="0"/>
+              </a:spcAft>
+            </a:pPr>
+            <a:r>
+              <a:rPr sz="2400" b="0">
+                <a:solidFill>
+                  <a:srgbClr val="EEF3F8"/>
+                </a:solidFill>
+                <a:latin typeface="Arial"/>
+              </a:rPr>
+              <a:t>ahead of or behind the orbital motion (SPHEREx, Earth)</a:t>
+            </a:r>
+          </a:p>
+        </p:txBody>
+      </p:sp>
+      <p:sp>
+        <p:nvSpPr>
+          <p:cNvPr id="32" name="TextBox 31"/>
+          <p:cNvSpPr txBox="1"/>
+          <p:nvPr/>
+        </p:nvSpPr>
+        <p:spPr>
+          <a:xfrm>
+            <a:off x="1325880" y="36539058"/>
+            <a:ext cx="3291840" cy="457200"/>
+          </a:xfrm>
+          <a:prstGeom prst="rect">
+            <a:avLst/>
+          </a:prstGeom>
+          <a:noFill/>
+        </p:spPr>
+        <p:txBody>
+          <a:bodyPr wrap="square" anchor="t" lIns="45720" rIns="45720" tIns="18288" bIns="18288">
+            <a:spAutoFit/>
+          </a:bodyPr>
+          <a:lstStyle/>
+          <a:p>
+            <a:pPr algn="l">
+              <a:lnSpc>
+                <a:spcPct val="112000"/>
+              </a:lnSpc>
+              <a:spcAft>
+                <a:spcPts val="0"/>
+              </a:spcAft>
+            </a:pPr>
+            <a:r>
+              <a:rPr sz="2400" b="1">
+                <a:solidFill>
+                  <a:srgbClr val="5FB0FF"/>
+                </a:solidFill>
+                <a:latin typeface="Arial"/>
+              </a:rPr>
+              <a:t>n·x⊕, n·y⊕</a:t>
+            </a:r>
+          </a:p>
+        </p:txBody>
+      </p:sp>
+      <p:sp>
+        <p:nvSpPr>
+          <p:cNvPr id="33" name="TextBox 32"/>
+          <p:cNvSpPr txBox="1"/>
+          <p:nvPr/>
+        </p:nvSpPr>
+        <p:spPr>
+          <a:xfrm>
+            <a:off x="4617720" y="36539058"/>
+            <a:ext cx="11064240" cy="457200"/>
+          </a:xfrm>
+          <a:prstGeom prst="rect">
+            <a:avLst/>
+          </a:prstGeom>
+          <a:noFill/>
+        </p:spPr>
+        <p:txBody>
+          <a:bodyPr wrap="square" anchor="t" lIns="45720" rIns="45720" tIns="18288" bIns="18288">
+            <a:spAutoFit/>
+          </a:bodyPr>
+          <a:lstStyle/>
+          <a:p>
+            <a:pPr algn="l">
+              <a:lnSpc>
+                <a:spcPct val="112000"/>
+              </a:lnSpc>
+              <a:spcAft>
+                <a:spcPts val="0"/>
+              </a:spcAft>
+            </a:pPr>
+            <a:r>
+              <a:rPr sz="2400" b="0">
+                <a:solidFill>
+                  <a:srgbClr val="EEF3F8"/>
+                </a:solidFill>
+                <a:latin typeface="Arial"/>
+              </a:rPr>
+              <a:t>look direction in a frame that turns with Earth (x⊕ = Sun → Earth)</a:t>
+            </a:r>
+          </a:p>
+        </p:txBody>
+      </p:sp>
+      <p:sp>
+        <p:nvSpPr>
+          <p:cNvPr id="34" name="TextBox 33"/>
+          <p:cNvSpPr txBox="1"/>
+          <p:nvPr/>
+        </p:nvSpPr>
+        <p:spPr>
+          <a:xfrm>
+            <a:off x="1325880" y="36968826"/>
+            <a:ext cx="3291840" cy="457200"/>
+          </a:xfrm>
+          <a:prstGeom prst="rect">
+            <a:avLst/>
+          </a:prstGeom>
+          <a:noFill/>
+        </p:spPr>
+        <p:txBody>
+          <a:bodyPr wrap="square" anchor="t" lIns="45720" rIns="45720" tIns="18288" bIns="18288">
+            <a:spAutoFit/>
+          </a:bodyPr>
+          <a:lstStyle/>
+          <a:p>
+            <a:pPr algn="l">
+              <a:lnSpc>
+                <a:spcPct val="112000"/>
+              </a:lnSpc>
+              <a:spcAft>
+                <a:spcPts val="0"/>
+              </a:spcAft>
+            </a:pPr>
+            <a:r>
+              <a:rPr sz="2400" b="1">
+                <a:solidFill>
+                  <a:srgbClr val="5FB0FF"/>
+                </a:solidFill>
+                <a:latin typeface="Arial"/>
+              </a:rPr>
+              <a:t>sin λ⊕, cos λ⊕</a:t>
+            </a:r>
+          </a:p>
+        </p:txBody>
+      </p:sp>
+      <p:sp>
+        <p:nvSpPr>
+          <p:cNvPr id="35" name="TextBox 34"/>
+          <p:cNvSpPr txBox="1"/>
+          <p:nvPr/>
+        </p:nvSpPr>
+        <p:spPr>
+          <a:xfrm>
+            <a:off x="4617720" y="36968826"/>
+            <a:ext cx="11064240" cy="457200"/>
+          </a:xfrm>
+          <a:prstGeom prst="rect">
+            <a:avLst/>
+          </a:prstGeom>
+          <a:noFill/>
+        </p:spPr>
+        <p:txBody>
+          <a:bodyPr wrap="square" anchor="t" lIns="45720" rIns="45720" tIns="18288" bIns="18288">
+            <a:spAutoFit/>
+          </a:bodyPr>
+          <a:lstStyle/>
+          <a:p>
+            <a:pPr algn="l">
+              <a:lnSpc>
+                <a:spcPct val="112000"/>
+              </a:lnSpc>
+              <a:spcAft>
+                <a:spcPts val="0"/>
+              </a:spcAft>
+            </a:pPr>
+            <a:r>
+              <a:rPr sz="2400" b="0">
+                <a:solidFill>
+                  <a:srgbClr val="EEF3F8"/>
+                </a:solidFill>
+                <a:latin typeface="Arial"/>
+              </a:rPr>
+              <a:t>Earth's position in its orbit: the time of year</a:t>
+            </a:r>
+          </a:p>
+        </p:txBody>
+      </p:sp>
+      <p:sp>
+        <p:nvSpPr>
+          <p:cNvPr id="36" name="TextBox 35"/>
+          <p:cNvSpPr txBox="1"/>
+          <p:nvPr/>
+        </p:nvSpPr>
+        <p:spPr>
+          <a:xfrm>
+            <a:off x="1143000" y="37627194"/>
+            <a:ext cx="14538960" cy="2469245"/>
+          </a:xfrm>
+          <a:prstGeom prst="rect">
+            <a:avLst/>
+          </a:prstGeom>
+          <a:noFill/>
+        </p:spPr>
+        <p:txBody>
+          <a:bodyPr wrap="square" anchor="t" lIns="45720" rIns="45720" tIns="18288" bIns="18288">
+            <a:spAutoFit/>
+          </a:bodyPr>
+          <a:lstStyle/>
+          <a:p>
+            <a:pPr algn="l">
+              <a:lnSpc>
+                <a:spcPct val="108000"/>
+              </a:lnSpc>
+              <a:spcAft>
+                <a:spcPts val="800"/>
+              </a:spcAft>
+            </a:pPr>
+            <a:r>
+              <a:rPr sz="2500" b="1">
+                <a:solidFill>
+                  <a:srgbClr val="EEF3F8"/>
+                </a:solidFill>
+                <a:latin typeface="Arial"/>
+              </a:rPr>
+              <a:t>Training and testing. </a:t>
+            </a:r>
+            <a:r>
+              <a:rPr sz="2500" b="0">
+                <a:solidFill>
+                  <a:srgbClr val="EEF3F8"/>
+                </a:solidFill>
+                <a:latin typeface="Arial"/>
+              </a:rPr>
+              <a:t>ZodiPy simulates 423,607 SPHEREx pointings (140 days, 5 μm). Five small networks (4 hidden layers, 64 → 16 neurons; Flux.jl in Julia) learn brightness from the 9 inputs and are averaged, then tested on whole months and sky regions they never saw.</a:t>
+            </a:r>
+          </a:p>
+          <a:p>
+            <a:pPr algn="l">
+              <a:lnSpc>
+                <a:spcPct val="108000"/>
+              </a:lnSpc>
+              <a:spcAft>
+                <a:spcPts val="800"/>
+              </a:spcAft>
+            </a:pPr>
+            <a:r>
+              <a:rPr sz="2500" b="1">
+                <a:solidFill>
+                  <a:srgbClr val="EEF3F8"/>
+                </a:solidFill>
+                <a:latin typeface="Arial"/>
+              </a:rPr>
+              <a:t>Lesson: </a:t>
+            </a:r>
+            <a:r>
+              <a:rPr sz="2500" b="0">
+                <a:solidFill>
+                  <a:srgbClr val="EEF3F8"/>
+                </a:solidFill>
+                <a:latin typeface="Arial"/>
+              </a:rPr>
+              <a:t>adding the time of year (sin λ⊕, cos λ⊕) cut the errors about 40–65×.</a:t>
+            </a:r>
+          </a:p>
+        </p:txBody>
+      </p:sp>
+      <p:sp>
+        <p:nvSpPr>
+          <p:cNvPr id="37" name="Rectangle 36"/>
           <p:cNvSpPr/>
           <p:nvPr/>
         </p:nvSpPr>
         <p:spPr>
           <a:xfrm>
-            <a:off x="1143000" y="30312360"/>
-            <a:ext cx="3257550" cy="3246120"/>
-          </a:xfrm>
-          <a:prstGeom prst="roundRect">
-            <a:avLst>
-              <a:gd name="adj" fmla="val 8000"/>
-            </a:avLst>
+            <a:off x="16824960" y="7223760"/>
+            <a:ext cx="15361920" cy="24505920"/>
+          </a:xfrm>
+          <a:prstGeom prst="rect">
+            <a:avLst/>
           </a:prstGeom>
           <a:solidFill>
-            <a:srgbClr val="16304F"/>
+            <a:srgbClr val="0F2036"/>
           </a:solidFill>
           <a:ln w="38100">
             <a:solidFill>
-              <a:srgbClr val="5FB0FF"/>
+              <a:srgbClr val="2D5A94"/>
             </a:solidFill>
           </a:ln>
           <a:effectLst/>
@@ -4701,104 +5268,20 @@
       </p:sp>
       <p:sp>
         <p:nvSpPr>
-          <p:cNvPr id="26" name="TextBox 25"/>
-          <p:cNvSpPr txBox="1"/>
-          <p:nvPr/>
-        </p:nvSpPr>
-        <p:spPr>
-          <a:xfrm>
-            <a:off x="1234440" y="30422087"/>
-            <a:ext cx="3074670" cy="548640"/>
-          </a:xfrm>
-          <a:prstGeom prst="rect">
-            <a:avLst/>
-          </a:prstGeom>
-          <a:noFill/>
-        </p:spPr>
-        <p:txBody>
-          <a:bodyPr wrap="square" anchor="t" lIns="45720" rIns="45720" tIns="18288" bIns="18288">
-            <a:spAutoFit/>
-          </a:bodyPr>
-          <a:lstStyle/>
-          <a:p>
-            <a:pPr algn="ctr">
-              <a:lnSpc>
-                <a:spcPct val="112000"/>
-              </a:lnSpc>
-              <a:spcAft>
-                <a:spcPts val="1000"/>
-              </a:spcAft>
-            </a:pPr>
-            <a:r>
-              <a:rPr sz="3000" b="1">
-                <a:solidFill>
-                  <a:srgbClr val="5FB0FF"/>
-                </a:solidFill>
-                <a:latin typeface="Arial"/>
-              </a:rPr>
-              <a:t>1. Simulate</a:t>
-            </a:r>
-          </a:p>
-        </p:txBody>
-      </p:sp>
-      <p:sp>
-        <p:nvSpPr>
-          <p:cNvPr id="27" name="TextBox 26"/>
-          <p:cNvSpPr txBox="1"/>
-          <p:nvPr/>
-        </p:nvSpPr>
-        <p:spPr>
-          <a:xfrm>
-            <a:off x="1280160" y="31043879"/>
-            <a:ext cx="2983230" cy="2423160"/>
-          </a:xfrm>
-          <a:prstGeom prst="rect">
-            <a:avLst/>
-          </a:prstGeom>
-          <a:noFill/>
-        </p:spPr>
-        <p:txBody>
-          <a:bodyPr wrap="square" anchor="t" lIns="45720" rIns="45720" tIns="18288" bIns="18288">
-            <a:spAutoFit/>
-          </a:bodyPr>
-          <a:lstStyle/>
-          <a:p>
-            <a:pPr algn="ctr">
-              <a:lnSpc>
-                <a:spcPct val="102000"/>
-              </a:lnSpc>
-              <a:spcAft>
-                <a:spcPts val="1000"/>
-              </a:spcAft>
-            </a:pPr>
-            <a:r>
-              <a:rPr sz="2100" b="0">
-                <a:solidFill>
-                  <a:srgbClr val="EEF3F8"/>
-                </a:solidFill>
-                <a:latin typeface="Arial"/>
-              </a:rPr>
-              <a:t>ZodiPy computes the zodiacal light for 423,607 SPHEREx pointings (140 days, 5 μm)</a:t>
-            </a:r>
-          </a:p>
-        </p:txBody>
-      </p:sp>
-      <p:sp>
-        <p:nvSpPr>
-          <p:cNvPr id="28" name="Right Arrow 27"/>
+          <p:cNvPr id="38" name="Rectangle 37"/>
           <p:cNvSpPr/>
           <p:nvPr/>
         </p:nvSpPr>
         <p:spPr>
           <a:xfrm>
-            <a:off x="4473702" y="31661100"/>
-            <a:ext cx="356616" cy="548640"/>
-          </a:xfrm>
-          <a:prstGeom prst="rightArrow">
+            <a:off x="16824960" y="7223760"/>
+            <a:ext cx="15361920" cy="1051560"/>
+          </a:xfrm>
+          <a:prstGeom prst="rect">
             <a:avLst/>
           </a:prstGeom>
           <a:solidFill>
-            <a:srgbClr val="FF6F91"/>
+            <a:srgbClr val="1E3557"/>
           </a:solidFill>
           <a:ln>
             <a:noFill/>
@@ -4829,27 +5312,67 @@
       </p:sp>
       <p:sp>
         <p:nvSpPr>
-          <p:cNvPr id="29" name="Rounded Rectangle 28"/>
+          <p:cNvPr id="39" name="TextBox 38"/>
+          <p:cNvSpPr txBox="1"/>
+          <p:nvPr/>
+        </p:nvSpPr>
+        <p:spPr>
+          <a:xfrm>
+            <a:off x="16824960" y="7223760"/>
+            <a:ext cx="15361920" cy="1051560"/>
+          </a:xfrm>
+          <a:prstGeom prst="rect">
+            <a:avLst/>
+          </a:prstGeom>
+          <a:noFill/>
+        </p:spPr>
+        <p:txBody>
+          <a:bodyPr wrap="square" anchor="ctr" lIns="45720" rIns="45720" tIns="18288" bIns="18288">
+            <a:spAutoFit/>
+          </a:bodyPr>
+          <a:lstStyle/>
+          <a:p>
+            <a:pPr algn="ctr">
+              <a:lnSpc>
+                <a:spcPct val="112000"/>
+              </a:lnSpc>
+              <a:spcAft>
+                <a:spcPts val="0"/>
+              </a:spcAft>
+            </a:pPr>
+            <a:r>
+              <a:rPr sz="5000" b="1">
+                <a:solidFill>
+                  <a:srgbClr val="FFFFFF"/>
+                </a:solidFill>
+                <a:latin typeface="Arial"/>
+              </a:rPr>
+              <a:t>Results</a:t>
+            </a:r>
+          </a:p>
+        </p:txBody>
+      </p:sp>
+      <p:sp>
+        <p:nvSpPr>
+          <p:cNvPr id="40" name="Rounded Rectangle 39"/>
           <p:cNvSpPr/>
           <p:nvPr/>
         </p:nvSpPr>
         <p:spPr>
           <a:xfrm>
-            <a:off x="4903470" y="30312360"/>
-            <a:ext cx="3257550" cy="3246120"/>
+            <a:off x="17236440" y="8595360"/>
+            <a:ext cx="4632960" cy="2651760"/>
           </a:xfrm>
           <a:prstGeom prst="roundRect">
             <a:avLst>
-              <a:gd name="adj" fmla="val 8000"/>
+              <a:gd name="adj" fmla="val 10000"/>
             </a:avLst>
           </a:prstGeom>
           <a:solidFill>
             <a:srgbClr val="16304F"/>
           </a:solidFill>
-          <a:ln w="38100">
-            <a:solidFill>
-              <a:srgbClr val="5FB0FF"/>
-            </a:solidFill>
+          <a:ln>
+            <a:noFill/>
           </a:ln>
           <a:effectLst/>
         </p:spPr>
@@ -4877,14 +5400,14 @@
       </p:sp>
       <p:sp>
         <p:nvSpPr>
-          <p:cNvPr id="30" name="TextBox 29"/>
+          <p:cNvPr id="41" name="TextBox 40"/>
           <p:cNvSpPr txBox="1"/>
           <p:nvPr/>
         </p:nvSpPr>
         <p:spPr>
           <a:xfrm>
-            <a:off x="4994909" y="30422087"/>
-            <a:ext cx="3074670" cy="548640"/>
+            <a:off x="17236440" y="8686800"/>
+            <a:ext cx="4632960" cy="1325880"/>
           </a:xfrm>
           <a:prstGeom prst="rect">
             <a:avLst/>
@@ -4892,7 +5415,7 @@
           <a:noFill/>
         </p:spPr>
         <p:txBody>
-          <a:bodyPr wrap="square" anchor="t" lIns="45720" rIns="45720" tIns="18288" bIns="18288">
+          <a:bodyPr wrap="square" anchor="ctr" lIns="45720" rIns="45720" tIns="18288" bIns="18288">
             <a:spAutoFit/>
           </a:bodyPr>
           <a:lstStyle/>
@@ -4906,27 +5429,27 @@
               </a:spcAft>
             </a:pPr>
             <a:r>
-              <a:rPr sz="3000" b="1">
+              <a:rPr sz="8000" b="1">
                 <a:solidFill>
                   <a:srgbClr val="5FB0FF"/>
                 </a:solidFill>
                 <a:latin typeface="Arial"/>
               </a:rPr>
-              <a:t>2. Describe</a:t>
-            </a:r>
-          </a:p>
-        </p:txBody>
-      </p:sp>
-      <p:sp>
-        <p:nvSpPr>
-          <p:cNvPr id="31" name="TextBox 30"/>
+              <a:t>0.026%</a:t>
+            </a:r>
+          </a:p>
+        </p:txBody>
+      </p:sp>
+      <p:sp>
+        <p:nvSpPr>
+          <p:cNvPr id="42" name="TextBox 41"/>
           <p:cNvSpPr txBox="1"/>
           <p:nvPr/>
         </p:nvSpPr>
         <p:spPr>
           <a:xfrm>
-            <a:off x="5040630" y="31043879"/>
-            <a:ext cx="2983230" cy="2423160"/>
+            <a:off x="17236440" y="10012680"/>
+            <a:ext cx="4632960" cy="1143000"/>
           </a:xfrm>
           <a:prstGeom prst="rect">
             <a:avLst/>
@@ -4941,40 +5464,61 @@
           <a:p>
             <a:pPr algn="ctr">
               <a:lnSpc>
-                <a:spcPct val="102000"/>
+                <a:spcPct val="100000"/>
               </a:lnSpc>
               <a:spcAft>
-                <a:spcPts val="1000"/>
+                <a:spcPts val="0"/>
               </a:spcAft>
             </a:pPr>
             <a:r>
-              <a:rPr sz="2100" b="0">
+              <a:rPr sz="2400" b="0">
                 <a:solidFill>
                   <a:srgbClr val="EEF3F8"/>
                 </a:solidFill>
                 <a:latin typeface="Arial"/>
               </a:rPr>
-              <a:t>9 numbers per pointing: where the telescope looks relative to the Sun and Earth, plus the time of year</a:t>
-            </a:r>
-          </a:p>
-        </p:txBody>
-      </p:sp>
-      <p:sp>
-        <p:nvSpPr>
-          <p:cNvPr id="32" name="Right Arrow 31"/>
+              <a:t>median error on months</a:t>
+            </a:r>
+          </a:p>
+          <a:p>
+            <a:pPr algn="ctr">
+              <a:lnSpc>
+                <a:spcPct val="100000"/>
+              </a:lnSpc>
+              <a:spcAft>
+                <a:spcPts val="0"/>
+              </a:spcAft>
+            </a:pPr>
+            <a:r>
+              <a:rPr sz="2400" b="0">
+                <a:solidFill>
+                  <a:srgbClr val="EEF3F8"/>
+                </a:solidFill>
+                <a:latin typeface="Arial"/>
+              </a:rPr>
+              <a:t>withheld from training</a:t>
+            </a:r>
+          </a:p>
+        </p:txBody>
+      </p:sp>
+      <p:sp>
+        <p:nvSpPr>
+          <p:cNvPr id="43" name="Rounded Rectangle 42"/>
           <p:cNvSpPr/>
           <p:nvPr/>
         </p:nvSpPr>
         <p:spPr>
           <a:xfrm>
-            <a:off x="8234172" y="31661100"/>
-            <a:ext cx="356616" cy="548640"/>
-          </a:xfrm>
-          <a:prstGeom prst="rightArrow">
-            <a:avLst/>
+            <a:off x="22189440" y="8595360"/>
+            <a:ext cx="4632960" cy="2651760"/>
+          </a:xfrm>
+          <a:prstGeom prst="roundRect">
+            <a:avLst>
+              <a:gd name="adj" fmla="val 10000"/>
+            </a:avLst>
           </a:prstGeom>
           <a:solidFill>
-            <a:srgbClr val="FF6F91"/>
+            <a:srgbClr val="16304F"/>
           </a:solidFill>
           <a:ln>
             <a:noFill/>
@@ -5005,27 +5549,128 @@
       </p:sp>
       <p:sp>
         <p:nvSpPr>
-          <p:cNvPr id="33" name="Rounded Rectangle 32"/>
+          <p:cNvPr id="44" name="TextBox 43"/>
+          <p:cNvSpPr txBox="1"/>
+          <p:nvPr/>
+        </p:nvSpPr>
+        <p:spPr>
+          <a:xfrm>
+            <a:off x="22189440" y="8686800"/>
+            <a:ext cx="4632960" cy="1325880"/>
+          </a:xfrm>
+          <a:prstGeom prst="rect">
+            <a:avLst/>
+          </a:prstGeom>
+          <a:noFill/>
+        </p:spPr>
+        <p:txBody>
+          <a:bodyPr wrap="square" anchor="ctr" lIns="45720" rIns="45720" tIns="18288" bIns="18288">
+            <a:spAutoFit/>
+          </a:bodyPr>
+          <a:lstStyle/>
+          <a:p>
+            <a:pPr algn="ctr">
+              <a:lnSpc>
+                <a:spcPct val="112000"/>
+              </a:lnSpc>
+              <a:spcAft>
+                <a:spcPts val="1000"/>
+              </a:spcAft>
+            </a:pPr>
+            <a:r>
+              <a:rPr sz="8000" b="1">
+                <a:solidFill>
+                  <a:srgbClr val="5FB0FF"/>
+                </a:solidFill>
+                <a:latin typeface="Arial"/>
+              </a:rPr>
+              <a:t>95%</a:t>
+            </a:r>
+          </a:p>
+        </p:txBody>
+      </p:sp>
+      <p:sp>
+        <p:nvSpPr>
+          <p:cNvPr id="45" name="TextBox 44"/>
+          <p:cNvSpPr txBox="1"/>
+          <p:nvPr/>
+        </p:nvSpPr>
+        <p:spPr>
+          <a:xfrm>
+            <a:off x="22189440" y="10012680"/>
+            <a:ext cx="4632960" cy="1143000"/>
+          </a:xfrm>
+          <a:prstGeom prst="rect">
+            <a:avLst/>
+          </a:prstGeom>
+          <a:noFill/>
+        </p:spPr>
+        <p:txBody>
+          <a:bodyPr wrap="square" anchor="t" lIns="45720" rIns="45720" tIns="18288" bIns="18288">
+            <a:spAutoFit/>
+          </a:bodyPr>
+          <a:lstStyle/>
+          <a:p>
+            <a:pPr algn="ctr">
+              <a:lnSpc>
+                <a:spcPct val="100000"/>
+              </a:lnSpc>
+              <a:spcAft>
+                <a:spcPts val="0"/>
+              </a:spcAft>
+            </a:pPr>
+            <a:r>
+              <a:rPr sz="2400" b="0">
+                <a:solidFill>
+                  <a:srgbClr val="EEF3F8"/>
+                </a:solidFill>
+                <a:latin typeface="Arial"/>
+              </a:rPr>
+              <a:t>of pointings within</a:t>
+            </a:r>
+          </a:p>
+          <a:p>
+            <a:pPr algn="ctr">
+              <a:lnSpc>
+                <a:spcPct val="100000"/>
+              </a:lnSpc>
+              <a:spcAft>
+                <a:spcPts val="0"/>
+              </a:spcAft>
+            </a:pPr>
+            <a:r>
+              <a:rPr sz="2400" b="0">
+                <a:solidFill>
+                  <a:srgbClr val="EEF3F8"/>
+                </a:solidFill>
+                <a:latin typeface="Arial"/>
+              </a:rPr>
+              <a:t>0.1% of ZodiPy</a:t>
+            </a:r>
+          </a:p>
+        </p:txBody>
+      </p:sp>
+      <p:sp>
+        <p:nvSpPr>
+          <p:cNvPr id="46" name="Rounded Rectangle 45"/>
           <p:cNvSpPr/>
           <p:nvPr/>
         </p:nvSpPr>
         <p:spPr>
           <a:xfrm>
-            <a:off x="8663940" y="30312360"/>
-            <a:ext cx="3257550" cy="3246120"/>
+            <a:off x="27142440" y="8595360"/>
+            <a:ext cx="4632960" cy="2651760"/>
           </a:xfrm>
           <a:prstGeom prst="roundRect">
             <a:avLst>
-              <a:gd name="adj" fmla="val 8000"/>
+              <a:gd name="adj" fmla="val 10000"/>
             </a:avLst>
           </a:prstGeom>
           <a:solidFill>
             <a:srgbClr val="16304F"/>
           </a:solidFill>
-          <a:ln w="38100">
-            <a:solidFill>
-              <a:srgbClr val="5FB0FF"/>
-            </a:solidFill>
+          <a:ln>
+            <a:noFill/>
           </a:ln>
           <a:effectLst/>
         </p:spPr>
@@ -5053,14 +5698,14 @@
       </p:sp>
       <p:sp>
         <p:nvSpPr>
-          <p:cNvPr id="34" name="TextBox 33"/>
+          <p:cNvPr id="47" name="TextBox 46"/>
           <p:cNvSpPr txBox="1"/>
           <p:nvPr/>
         </p:nvSpPr>
         <p:spPr>
           <a:xfrm>
-            <a:off x="8755380" y="30422087"/>
-            <a:ext cx="3074670" cy="548640"/>
+            <a:off x="27142440" y="8686800"/>
+            <a:ext cx="4632960" cy="1325880"/>
           </a:xfrm>
           <a:prstGeom prst="rect">
             <a:avLst/>
@@ -5068,7 +5713,7 @@
           <a:noFill/>
         </p:spPr>
         <p:txBody>
-          <a:bodyPr wrap="square" anchor="t" lIns="45720" rIns="45720" tIns="18288" bIns="18288">
+          <a:bodyPr wrap="square" anchor="ctr" lIns="45720" rIns="45720" tIns="18288" bIns="18288">
             <a:spAutoFit/>
           </a:bodyPr>
           <a:lstStyle/>
@@ -5082,27 +5727,27 @@
               </a:spcAft>
             </a:pPr>
             <a:r>
-              <a:rPr sz="3000" b="1">
+              <a:rPr sz="8000" b="1">
                 <a:solidFill>
                   <a:srgbClr val="5FB0FF"/>
                 </a:solidFill>
                 <a:latin typeface="Arial"/>
               </a:rPr>
-              <a:t>3. Train</a:t>
-            </a:r>
-          </a:p>
-        </p:txBody>
-      </p:sp>
-      <p:sp>
-        <p:nvSpPr>
-          <p:cNvPr id="35" name="TextBox 34"/>
+              <a:t>64</a:t>
+            </a:r>
+          </a:p>
+        </p:txBody>
+      </p:sp>
+      <p:sp>
+        <p:nvSpPr>
+          <p:cNvPr id="48" name="TextBox 47"/>
           <p:cNvSpPr txBox="1"/>
           <p:nvPr/>
         </p:nvSpPr>
         <p:spPr>
           <a:xfrm>
-            <a:off x="8801100" y="31043879"/>
-            <a:ext cx="2983230" cy="2423160"/>
+            <a:off x="27142440" y="10012680"/>
+            <a:ext cx="4632960" cy="1143000"/>
           </a:xfrm>
           <a:prstGeom prst="rect">
             <a:avLst/>
@@ -5117,40 +5762,134 @@
           <a:p>
             <a:pPr algn="ctr">
               <a:lnSpc>
-                <a:spcPct val="102000"/>
+                <a:spcPct val="100000"/>
+              </a:lnSpc>
+              <a:spcAft>
+                <a:spcPts val="0"/>
+              </a:spcAft>
+            </a:pPr>
+            <a:r>
+              <a:rPr sz="2400" b="0">
+                <a:solidFill>
+                  <a:srgbClr val="EEF3F8"/>
+                </a:solidFill>
+                <a:latin typeface="Arial"/>
+              </a:rPr>
+              <a:t>wavelengths in</a:t>
+            </a:r>
+          </a:p>
+          <a:p>
+            <a:pPr algn="ctr">
+              <a:lnSpc>
+                <a:spcPct val="100000"/>
+              </a:lnSpc>
+              <a:spcAft>
+                <a:spcPts val="0"/>
+              </a:spcAft>
+            </a:pPr>
+            <a:r>
+              <a:rPr sz="2400" b="0">
+                <a:solidFill>
+                  <a:srgbClr val="EEF3F8"/>
+                </a:solidFill>
+                <a:latin typeface="Arial"/>
+              </a:rPr>
+              <a:t>one network</a:t>
+            </a:r>
+          </a:p>
+        </p:txBody>
+      </p:sp>
+      <p:pic>
+        <p:nvPicPr>
+          <p:cNvPr id="49" name="Picture 48" descr="accuracy_dark.png"/>
+          <p:cNvPicPr>
+            <a:picLocks noChangeAspect="1"/>
+          </p:cNvPicPr>
+          <p:nvPr/>
+        </p:nvPicPr>
+        <p:blipFill>
+          <a:blip r:embed="rId6"/>
+          <a:stretch>
+            <a:fillRect/>
+          </a:stretch>
+        </p:blipFill>
+        <p:spPr>
+          <a:xfrm>
+            <a:off x="17236440" y="11567160"/>
+            <a:ext cx="14538960" cy="7269480"/>
+          </a:xfrm>
+          <a:prstGeom prst="rect">
+            <a:avLst/>
+          </a:prstGeom>
+        </p:spPr>
+      </p:pic>
+      <p:sp>
+        <p:nvSpPr>
+          <p:cNvPr id="50" name="TextBox 49"/>
+          <p:cNvSpPr txBox="1"/>
+          <p:nvPr/>
+        </p:nvSpPr>
+        <p:spPr>
+          <a:xfrm>
+            <a:off x="17236440" y="18836640"/>
+            <a:ext cx="14538960" cy="1371600"/>
+          </a:xfrm>
+          <a:prstGeom prst="rect">
+            <a:avLst/>
+          </a:prstGeom>
+          <a:noFill/>
+        </p:spPr>
+        <p:txBody>
+          <a:bodyPr wrap="square" anchor="t" lIns="45720" rIns="45720" tIns="18288" bIns="18288">
+            <a:spAutoFit/>
+          </a:bodyPr>
+          <a:lstStyle/>
+          <a:p>
+            <a:pPr algn="l">
+              <a:lnSpc>
+                <a:spcPct val="105000"/>
               </a:lnSpc>
               <a:spcAft>
                 <a:spcPts val="1000"/>
               </a:spcAft>
             </a:pPr>
             <a:r>
-              <a:rPr sz="2100" b="0">
-                <a:solidFill>
-                  <a:srgbClr val="EEF3F8"/>
-                </a:solidFill>
-                <a:latin typeface="Arial"/>
-              </a:rPr>
-              <a:t>A neural network (Flux.jl in Julia) learns brightness from geometry; 5 networks are averaged</a:t>
-            </a:r>
-          </a:p>
-        </p:txBody>
-      </p:sp>
-      <p:sp>
-        <p:nvSpPr>
-          <p:cNvPr id="36" name="Right Arrow 35"/>
+              <a:rPr sz="2200" b="1">
+                <a:solidFill>
+                  <a:srgbClr val="A9B6C6"/>
+                </a:solidFill>
+                <a:latin typeface="Arial"/>
+              </a:rPr>
+              <a:t>Figure 3. </a:t>
+            </a:r>
+            <a:r>
+              <a:rPr sz="2200" b="0">
+                <a:solidFill>
+                  <a:srgbClr val="A9B6C6"/>
+                </a:solidFill>
+                <a:latin typeface="Arial"/>
+              </a:rPr>
+              <a:t>Neural network vs. ZodiPy. The network was trained on mission days 0–30, 60–90 and 120–140, then tested on the two 30-day blocks it never saw (days 30–60 and 90–120; 180,166 pointings). Half of the errors are below 0.026% and 95% are below 0.1%. (With a random 10% of pointings withheld instead, the median is 0.015%.)</a:t>
+            </a:r>
+          </a:p>
+        </p:txBody>
+      </p:sp>
+      <p:sp>
+        <p:nvSpPr>
+          <p:cNvPr id="51" name="Rectangle 50"/>
           <p:cNvSpPr/>
           <p:nvPr/>
         </p:nvSpPr>
         <p:spPr>
           <a:xfrm>
-            <a:off x="11994642" y="31661100"/>
-            <a:ext cx="356616" cy="548640"/>
-          </a:xfrm>
-          <a:prstGeom prst="rightArrow">
+            <a:off x="17236440" y="20253960"/>
+            <a:ext cx="14538960" cy="54864"/>
+          </a:xfrm>
+          <a:prstGeom prst="rect">
             <a:avLst/>
           </a:prstGeom>
           <a:solidFill>
-            <a:srgbClr val="FF6F91"/>
+            <a:srgbClr val="2D5A94"/>
           </a:solidFill>
           <a:ln>
             <a:noFill/>
@@ -5181,26 +5920,150 @@
       </p:sp>
       <p:sp>
         <p:nvSpPr>
-          <p:cNvPr id="37" name="Rounded Rectangle 36"/>
+          <p:cNvPr id="52" name="TextBox 51"/>
+          <p:cNvSpPr txBox="1"/>
+          <p:nvPr/>
+        </p:nvSpPr>
+        <p:spPr>
+          <a:xfrm>
+            <a:off x="17236440" y="20482560"/>
+            <a:ext cx="14538960" cy="1645920"/>
+          </a:xfrm>
+          <a:prstGeom prst="rect">
+            <a:avLst/>
+          </a:prstGeom>
+          <a:noFill/>
+        </p:spPr>
+        <p:txBody>
+          <a:bodyPr wrap="square" anchor="t" lIns="45720" rIns="45720" tIns="18288" bIns="18288">
+            <a:spAutoFit/>
+          </a:bodyPr>
+          <a:lstStyle/>
+          <a:p>
+            <a:pPr algn="l">
+              <a:lnSpc>
+                <a:spcPct val="112000"/>
+              </a:lnSpc>
+              <a:spcAft>
+                <a:spcPts val="1000"/>
+              </a:spcAft>
+            </a:pPr>
+            <a:r>
+              <a:rPr sz="2800" b="1">
+                <a:solidFill>
+                  <a:srgbClr val="EEF3F8"/>
+                </a:solidFill>
+                <a:latin typeface="Arial"/>
+              </a:rPr>
+              <a:t>Looking forward: every SPHEREx wavelength. </a:t>
+            </a:r>
+            <a:r>
+              <a:rPr sz="2800" b="0">
+                <a:solidFill>
+                  <a:srgbClr val="EEF3F8"/>
+                </a:solidFill>
+                <a:latin typeface="Arial"/>
+              </a:rPr>
+              <a:t>Real SPHEREx images cover many wavelengths, so wavelength becomes one more input. A first version covering 1.25–5 μm already reaches ~0.1% median error on the same withheld months.</a:t>
+            </a:r>
+          </a:p>
+        </p:txBody>
+      </p:sp>
+      <p:pic>
+        <p:nvPicPr>
+          <p:cNvPr id="53" name="Picture 52" descr="spectra_dark.png"/>
+          <p:cNvPicPr>
+            <a:picLocks noChangeAspect="1"/>
+          </p:cNvPicPr>
+          <p:nvPr/>
+        </p:nvPicPr>
+        <p:blipFill>
+          <a:blip r:embed="rId7"/>
+          <a:stretch>
+            <a:fillRect/>
+          </a:stretch>
+        </p:blipFill>
+        <p:spPr>
+          <a:xfrm>
+            <a:off x="18093690" y="22037040"/>
+            <a:ext cx="12824460" cy="8549640"/>
+          </a:xfrm>
+          <a:prstGeom prst="rect">
+            <a:avLst/>
+          </a:prstGeom>
+        </p:spPr>
+      </p:pic>
+      <p:sp>
+        <p:nvSpPr>
+          <p:cNvPr id="54" name="TextBox 53"/>
+          <p:cNvSpPr txBox="1"/>
+          <p:nvPr/>
+        </p:nvSpPr>
+        <p:spPr>
+          <a:xfrm>
+            <a:off x="17236440" y="30586680"/>
+            <a:ext cx="14538960" cy="914400"/>
+          </a:xfrm>
+          <a:prstGeom prst="rect">
+            <a:avLst/>
+          </a:prstGeom>
+          <a:noFill/>
+        </p:spPr>
+        <p:txBody>
+          <a:bodyPr wrap="square" anchor="t" lIns="45720" rIns="45720" tIns="18288" bIns="18288">
+            <a:spAutoFit/>
+          </a:bodyPr>
+          <a:lstStyle/>
+          <a:p>
+            <a:pPr algn="l">
+              <a:lnSpc>
+                <a:spcPct val="105000"/>
+              </a:lnSpc>
+              <a:spcAft>
+                <a:spcPts val="1000"/>
+              </a:spcAft>
+            </a:pPr>
+            <a:r>
+              <a:rPr sz="2200" b="1">
+                <a:solidFill>
+                  <a:srgbClr val="A9B6C6"/>
+                </a:solidFill>
+                <a:latin typeface="Arial"/>
+              </a:rPr>
+              <a:t>Figure 4. </a:t>
+            </a:r>
+            <a:r>
+              <a:rPr sz="2200" b="0">
+                <a:solidFill>
+                  <a:srgbClr val="A9B6C6"/>
+                </a:solidFill>
+                <a:latin typeface="Arial"/>
+              </a:rPr>
+              <a:t>Brightness vs. wavelength for three pointings: ZodiPy (solid) and the network (dashed). Below 3 μm we see scattered sunlight; above, the dust's heat. Bottom: the differences stay under 1%.</a:t>
+            </a:r>
+          </a:p>
+        </p:txBody>
+      </p:sp>
+      <p:sp>
+        <p:nvSpPr>
+          <p:cNvPr id="55" name="Rectangle 54"/>
           <p:cNvSpPr/>
           <p:nvPr/>
         </p:nvSpPr>
         <p:spPr>
           <a:xfrm>
-            <a:off x="12424409" y="30312360"/>
-            <a:ext cx="3257550" cy="3246120"/>
-          </a:xfrm>
-          <a:prstGeom prst="roundRect">
-            <a:avLst>
-              <a:gd name="adj" fmla="val 8000"/>
-            </a:avLst>
+            <a:off x="16824960" y="32141160"/>
+            <a:ext cx="15361920" cy="8092439"/>
+          </a:xfrm>
+          <a:prstGeom prst="rect">
+            <a:avLst/>
           </a:prstGeom>
           <a:solidFill>
-            <a:srgbClr val="16304F"/>
+            <a:srgbClr val="0F2036"/>
           </a:solidFill>
           <a:ln w="38100">
             <a:solidFill>
-              <a:srgbClr val="5FB0FF"/>
+              <a:srgbClr val="2D5A94"/>
             </a:solidFill>
           </a:ln>
           <a:effectLst/>
@@ -5229,188 +6092,23 @@
       </p:sp>
       <p:sp>
         <p:nvSpPr>
-          <p:cNvPr id="38" name="TextBox 37"/>
-          <p:cNvSpPr txBox="1"/>
-          <p:nvPr/>
-        </p:nvSpPr>
-        <p:spPr>
-          <a:xfrm>
-            <a:off x="12515849" y="30422087"/>
-            <a:ext cx="3074670" cy="548640"/>
-          </a:xfrm>
-          <a:prstGeom prst="rect">
-            <a:avLst/>
-          </a:prstGeom>
-          <a:noFill/>
-        </p:spPr>
-        <p:txBody>
-          <a:bodyPr wrap="square" anchor="t" lIns="45720" rIns="45720" tIns="18288" bIns="18288">
-            <a:spAutoFit/>
-          </a:bodyPr>
-          <a:lstStyle/>
-          <a:p>
-            <a:pPr algn="ctr">
-              <a:lnSpc>
-                <a:spcPct val="112000"/>
-              </a:lnSpc>
-              <a:spcAft>
-                <a:spcPts val="1000"/>
-              </a:spcAft>
-            </a:pPr>
-            <a:r>
-              <a:rPr sz="3000" b="1">
-                <a:solidFill>
-                  <a:srgbClr val="5FB0FF"/>
-                </a:solidFill>
-                <a:latin typeface="Arial"/>
-              </a:rPr>
-              <a:t>4. Test</a:t>
-            </a:r>
-          </a:p>
-        </p:txBody>
-      </p:sp>
-      <p:sp>
-        <p:nvSpPr>
-          <p:cNvPr id="39" name="TextBox 38"/>
-          <p:cNvSpPr txBox="1"/>
-          <p:nvPr/>
-        </p:nvSpPr>
-        <p:spPr>
-          <a:xfrm>
-            <a:off x="12561569" y="31043879"/>
-            <a:ext cx="2983230" cy="2423160"/>
-          </a:xfrm>
-          <a:prstGeom prst="rect">
-            <a:avLst/>
-          </a:prstGeom>
-          <a:noFill/>
-        </p:spPr>
-        <p:txBody>
-          <a:bodyPr wrap="square" anchor="t" lIns="45720" rIns="45720" tIns="18288" bIns="18288">
-            <a:spAutoFit/>
-          </a:bodyPr>
-          <a:lstStyle/>
-          <a:p>
-            <a:pPr algn="ctr">
-              <a:lnSpc>
-                <a:spcPct val="102000"/>
-              </a:lnSpc>
-              <a:spcAft>
-                <a:spcPts val="1000"/>
-              </a:spcAft>
-            </a:pPr>
-            <a:r>
-              <a:rPr sz="2100" b="0">
-                <a:solidFill>
-                  <a:srgbClr val="EEF3F8"/>
-                </a:solidFill>
-                <a:latin typeface="Arial"/>
-              </a:rPr>
-              <a:t>Compare with ZodiPy on pointings the network never saw: random, unseen months, unseen sky</a:t>
-            </a:r>
-          </a:p>
-        </p:txBody>
-      </p:sp>
-      <p:sp>
-        <p:nvSpPr>
-          <p:cNvPr id="40" name="TextBox 39"/>
-          <p:cNvSpPr txBox="1"/>
-          <p:nvPr/>
-        </p:nvSpPr>
-        <p:spPr>
-          <a:xfrm>
-            <a:off x="1143000" y="33878520"/>
-            <a:ext cx="14538960" cy="1691640"/>
-          </a:xfrm>
-          <a:prstGeom prst="rect">
-            <a:avLst/>
-          </a:prstGeom>
-          <a:noFill/>
-        </p:spPr>
-        <p:txBody>
-          <a:bodyPr wrap="square" anchor="t" lIns="45720" rIns="45720" tIns="18288" bIns="18288">
-            <a:spAutoFit/>
-          </a:bodyPr>
-          <a:lstStyle/>
-          <a:p>
-            <a:pPr algn="l">
-              <a:lnSpc>
-                <a:spcPct val="112000"/>
-              </a:lnSpc>
-              <a:spcAft>
-                <a:spcPts val="800"/>
-              </a:spcAft>
-            </a:pPr>
-            <a:r>
-              <a:rPr sz="2600" b="1">
-                <a:solidFill>
-                  <a:srgbClr val="EEF3F8"/>
-                </a:solidFill>
-                <a:latin typeface="Arial"/>
-              </a:rPr>
-              <a:t>Give the network the right physics. </a:t>
-            </a:r>
-            <a:r>
-              <a:rPr sz="2600" b="0">
-                <a:solidFill>
-                  <a:srgbClr val="EEF3F8"/>
-                </a:solidFill>
-                <a:latin typeface="Arial"/>
-              </a:rPr>
-              <a:t>Telling it where Earth is in its orbit (the “season”) cut errors about 40–65×.</a:t>
-            </a:r>
-          </a:p>
-          <a:p>
-            <a:pPr algn="l">
-              <a:lnSpc>
-                <a:spcPct val="112000"/>
-              </a:lnSpc>
-              <a:spcAft>
-                <a:spcPts val="800"/>
-              </a:spcAft>
-            </a:pPr>
-            <a:r>
-              <a:rPr sz="2600" b="1">
-                <a:solidFill>
-                  <a:srgbClr val="EEF3F8"/>
-                </a:solidFill>
-                <a:latin typeface="Arial"/>
-              </a:rPr>
-              <a:t>Test honestly. </a:t>
-            </a:r>
-            <a:r>
-              <a:rPr sz="2600" b="0">
-                <a:solidFill>
-                  <a:srgbClr val="EEF3F8"/>
-                </a:solidFill>
-                <a:latin typeface="Arial"/>
-              </a:rPr>
-              <a:t>Data were split by time, by sky region and at random, and many network sizes and training schedules were compared.</a:t>
-            </a:r>
-          </a:p>
-        </p:txBody>
-      </p:sp>
-      <p:sp>
-        <p:nvSpPr>
-          <p:cNvPr id="41" name="Rectangle 40"/>
+          <p:cNvPr id="56" name="Rectangle 55"/>
           <p:cNvSpPr/>
           <p:nvPr/>
         </p:nvSpPr>
         <p:spPr>
           <a:xfrm>
-            <a:off x="16824960" y="7498079"/>
-            <a:ext cx="15361920" cy="28254960"/>
+            <a:off x="16824960" y="32141160"/>
+            <a:ext cx="15361920" cy="1051560"/>
           </a:xfrm>
           <a:prstGeom prst="rect">
             <a:avLst/>
           </a:prstGeom>
           <a:solidFill>
-            <a:srgbClr val="0F2036"/>
+            <a:srgbClr val="1E3557"/>
           </a:solidFill>
-          <a:ln w="38100">
-            <a:solidFill>
-              <a:srgbClr val="2D5A94"/>
-            </a:solidFill>
+          <a:ln>
+            <a:noFill/>
           </a:ln>
           <a:effectLst/>
         </p:spPr>
@@ -5438,23 +6136,69 @@
       </p:sp>
       <p:sp>
         <p:nvSpPr>
-          <p:cNvPr id="42" name="Rectangle 41"/>
+          <p:cNvPr id="57" name="TextBox 56"/>
+          <p:cNvSpPr txBox="1"/>
+          <p:nvPr/>
+        </p:nvSpPr>
+        <p:spPr>
+          <a:xfrm>
+            <a:off x="16824960" y="32141160"/>
+            <a:ext cx="15361920" cy="1051560"/>
+          </a:xfrm>
+          <a:prstGeom prst="rect">
+            <a:avLst/>
+          </a:prstGeom>
+          <a:noFill/>
+        </p:spPr>
+        <p:txBody>
+          <a:bodyPr wrap="square" anchor="ctr" lIns="45720" rIns="45720" tIns="18288" bIns="18288">
+            <a:spAutoFit/>
+          </a:bodyPr>
+          <a:lstStyle/>
+          <a:p>
+            <a:pPr algn="ctr">
+              <a:lnSpc>
+                <a:spcPct val="112000"/>
+              </a:lnSpc>
+              <a:spcAft>
+                <a:spcPts val="0"/>
+              </a:spcAft>
+            </a:pPr>
+            <a:r>
+              <a:rPr sz="5000" b="1">
+                <a:solidFill>
+                  <a:srgbClr val="FFFFFF"/>
+                </a:solidFill>
+                <a:latin typeface="Arial"/>
+              </a:rPr>
+              <a:t>Next Steps</a:t>
+            </a:r>
+          </a:p>
+        </p:txBody>
+      </p:sp>
+      <p:sp>
+        <p:nvSpPr>
+          <p:cNvPr id="58" name="Rounded Rectangle 57"/>
           <p:cNvSpPr/>
           <p:nvPr/>
         </p:nvSpPr>
         <p:spPr>
           <a:xfrm>
-            <a:off x="16824960" y="7498079"/>
-            <a:ext cx="15361920" cy="1051560"/>
-          </a:xfrm>
-          <a:prstGeom prst="rect">
-            <a:avLst/>
+            <a:off x="17236440" y="33512760"/>
+            <a:ext cx="14538960" cy="1234440"/>
+          </a:xfrm>
+          <a:prstGeom prst="roundRect">
+            <a:avLst>
+              <a:gd name="adj" fmla="val 15000"/>
+            </a:avLst>
           </a:prstGeom>
           <a:solidFill>
-            <a:srgbClr val="1E3557"/>
+            <a:srgbClr val="16304F"/>
           </a:solidFill>
-          <a:ln>
-            <a:noFill/>
+          <a:ln w="63500">
+            <a:solidFill>
+              <a:srgbClr val="66BB6A"/>
+            </a:solidFill>
           </a:ln>
           <a:effectLst/>
         </p:spPr>
@@ -5482,14 +6226,14 @@
       </p:sp>
       <p:sp>
         <p:nvSpPr>
-          <p:cNvPr id="43" name="TextBox 42"/>
+          <p:cNvPr id="59" name="TextBox 58"/>
           <p:cNvSpPr txBox="1"/>
           <p:nvPr/>
         </p:nvSpPr>
         <p:spPr>
           <a:xfrm>
-            <a:off x="16824960" y="7498079"/>
-            <a:ext cx="15361920" cy="1051560"/>
+            <a:off x="17465040" y="33512760"/>
+            <a:ext cx="3931920" cy="1234440"/>
           </a:xfrm>
           <a:prstGeom prst="rect">
             <a:avLst/>
@@ -5502,44 +6246,103 @@
           </a:bodyPr>
           <a:lstStyle/>
           <a:p>
-            <a:pPr algn="ctr">
+            <a:pPr algn="l">
               <a:lnSpc>
-                <a:spcPct val="112000"/>
+                <a:spcPct val="100000"/>
               </a:lnSpc>
               <a:spcAft>
                 <a:spcPts val="0"/>
               </a:spcAft>
             </a:pPr>
             <a:r>
-              <a:rPr sz="5000" b="1">
-                <a:solidFill>
-                  <a:srgbClr val="FFFFFF"/>
-                </a:solidFill>
-                <a:latin typeface="Arial"/>
-              </a:rPr>
-              <a:t>Results</a:t>
-            </a:r>
-          </a:p>
-        </p:txBody>
-      </p:sp>
-      <p:sp>
-        <p:nvSpPr>
-          <p:cNvPr id="44" name="Rounded Rectangle 43"/>
+              <a:rPr sz="2400" b="1">
+                <a:solidFill>
+                  <a:srgbClr val="66BB6A"/>
+                </a:solidFill>
+                <a:latin typeface="Arial"/>
+              </a:rPr>
+              <a:t>✓ DONE</a:t>
+            </a:r>
+          </a:p>
+          <a:p>
+            <a:pPr algn="l">
+              <a:lnSpc>
+                <a:spcPct val="100000"/>
+              </a:lnSpc>
+              <a:spcAft>
+                <a:spcPts val="0"/>
+              </a:spcAft>
+            </a:pPr>
+            <a:r>
+              <a:rPr sz="2400" b="1">
+                <a:solidFill>
+                  <a:srgbClr val="66BB6A"/>
+                </a:solidFill>
+                <a:latin typeface="Arial"/>
+              </a:rPr>
+              <a:t>Validate</a:t>
+            </a:r>
+          </a:p>
+        </p:txBody>
+      </p:sp>
+      <p:sp>
+        <p:nvSpPr>
+          <p:cNvPr id="60" name="TextBox 59"/>
+          <p:cNvSpPr txBox="1"/>
+          <p:nvPr/>
+        </p:nvSpPr>
+        <p:spPr>
+          <a:xfrm>
+            <a:off x="21442680" y="33512760"/>
+            <a:ext cx="10104120" cy="1234440"/>
+          </a:xfrm>
+          <a:prstGeom prst="rect">
+            <a:avLst/>
+          </a:prstGeom>
+          <a:noFill/>
+        </p:spPr>
+        <p:txBody>
+          <a:bodyPr wrap="square" anchor="ctr" lIns="45720" rIns="45720" tIns="18288" bIns="18288">
+            <a:spAutoFit/>
+          </a:bodyPr>
+          <a:lstStyle/>
+          <a:p>
+            <a:pPr algn="l">
+              <a:lnSpc>
+                <a:spcPct val="102000"/>
+              </a:lnSpc>
+              <a:spcAft>
+                <a:spcPts val="0"/>
+              </a:spcAft>
+            </a:pPr>
+            <a:r>
+              <a:rPr sz="2500" b="0">
+                <a:solidFill>
+                  <a:srgbClr val="EEF3F8"/>
+                </a:solidFill>
+                <a:latin typeface="Arial"/>
+              </a:rPr>
+              <a:t>Learn ZodiPy's simulated sky from geometry alone; test on unseen months and sky regions</a:t>
+            </a:r>
+          </a:p>
+        </p:txBody>
+      </p:sp>
+      <p:sp>
+        <p:nvSpPr>
+          <p:cNvPr id="61" name="Down Arrow 60"/>
           <p:cNvSpPr/>
           <p:nvPr/>
         </p:nvSpPr>
         <p:spPr>
           <a:xfrm>
-            <a:off x="17236440" y="8869680"/>
-            <a:ext cx="4632960" cy="2651760"/>
-          </a:xfrm>
-          <a:prstGeom prst="roundRect">
-            <a:avLst>
-              <a:gd name="adj" fmla="val 10000"/>
-            </a:avLst>
+            <a:off x="24231600" y="34774632"/>
+            <a:ext cx="548640" cy="237744"/>
+          </a:xfrm>
+          <a:prstGeom prst="downArrow">
+            <a:avLst/>
           </a:prstGeom>
           <a:solidFill>
-            <a:srgbClr val="16304F"/>
+            <a:srgbClr val="FF6F91"/>
           </a:solidFill>
           <a:ln>
             <a:noFill/>
@@ -5570,128 +6373,27 @@
       </p:sp>
       <p:sp>
         <p:nvSpPr>
-          <p:cNvPr id="45" name="TextBox 44"/>
-          <p:cNvSpPr txBox="1"/>
-          <p:nvPr/>
-        </p:nvSpPr>
-        <p:spPr>
-          <a:xfrm>
-            <a:off x="17236440" y="8961119"/>
-            <a:ext cx="4632960" cy="1325880"/>
-          </a:xfrm>
-          <a:prstGeom prst="rect">
-            <a:avLst/>
-          </a:prstGeom>
-          <a:noFill/>
-        </p:spPr>
-        <p:txBody>
-          <a:bodyPr wrap="square" anchor="ctr" lIns="45720" rIns="45720" tIns="18288" bIns="18288">
-            <a:spAutoFit/>
-          </a:bodyPr>
-          <a:lstStyle/>
-          <a:p>
-            <a:pPr algn="ctr">
-              <a:lnSpc>
-                <a:spcPct val="112000"/>
-              </a:lnSpc>
-              <a:spcAft>
-                <a:spcPts val="1000"/>
-              </a:spcAft>
-            </a:pPr>
-            <a:r>
-              <a:rPr sz="8000" b="1">
-                <a:solidFill>
-                  <a:srgbClr val="5FB0FF"/>
-                </a:solidFill>
-                <a:latin typeface="Arial"/>
-              </a:rPr>
-              <a:t>0.026%</a:t>
-            </a:r>
-          </a:p>
-        </p:txBody>
-      </p:sp>
-      <p:sp>
-        <p:nvSpPr>
-          <p:cNvPr id="46" name="TextBox 45"/>
-          <p:cNvSpPr txBox="1"/>
-          <p:nvPr/>
-        </p:nvSpPr>
-        <p:spPr>
-          <a:xfrm>
-            <a:off x="17236440" y="10287000"/>
-            <a:ext cx="4632960" cy="1143000"/>
-          </a:xfrm>
-          <a:prstGeom prst="rect">
-            <a:avLst/>
-          </a:prstGeom>
-          <a:noFill/>
-        </p:spPr>
-        <p:txBody>
-          <a:bodyPr wrap="square" anchor="t" lIns="45720" rIns="45720" tIns="18288" bIns="18288">
-            <a:spAutoFit/>
-          </a:bodyPr>
-          <a:lstStyle/>
-          <a:p>
-            <a:pPr algn="ctr">
-              <a:lnSpc>
-                <a:spcPct val="100000"/>
-              </a:lnSpc>
-              <a:spcAft>
-                <a:spcPts val="0"/>
-              </a:spcAft>
-            </a:pPr>
-            <a:r>
-              <a:rPr sz="2400" b="0">
-                <a:solidFill>
-                  <a:srgbClr val="EEF3F8"/>
-                </a:solidFill>
-                <a:latin typeface="Arial"/>
-              </a:rPr>
-              <a:t>median error on 2 months</a:t>
-            </a:r>
-          </a:p>
-          <a:p>
-            <a:pPr algn="ctr">
-              <a:lnSpc>
-                <a:spcPct val="100000"/>
-              </a:lnSpc>
-              <a:spcAft>
-                <a:spcPts val="0"/>
-              </a:spcAft>
-            </a:pPr>
-            <a:r>
-              <a:rPr sz="2400" b="0">
-                <a:solidFill>
-                  <a:srgbClr val="EEF3F8"/>
-                </a:solidFill>
-                <a:latin typeface="Arial"/>
-              </a:rPr>
-              <a:t>withheld from training</a:t>
-            </a:r>
-          </a:p>
-        </p:txBody>
-      </p:sp>
-      <p:sp>
-        <p:nvSpPr>
-          <p:cNvPr id="47" name="Rounded Rectangle 46"/>
+          <p:cNvPr id="62" name="Rounded Rectangle 61"/>
           <p:cNvSpPr/>
           <p:nvPr/>
         </p:nvSpPr>
         <p:spPr>
           <a:xfrm>
-            <a:off x="22189440" y="8869680"/>
-            <a:ext cx="4632960" cy="2651760"/>
+            <a:off x="17236440" y="35039808"/>
+            <a:ext cx="14538960" cy="1234440"/>
           </a:xfrm>
           <a:prstGeom prst="roundRect">
             <a:avLst>
-              <a:gd name="adj" fmla="val 10000"/>
+              <a:gd name="adj" fmla="val 15000"/>
             </a:avLst>
           </a:prstGeom>
           <a:solidFill>
             <a:srgbClr val="16304F"/>
           </a:solidFill>
-          <a:ln>
-            <a:noFill/>
+          <a:ln w="63500">
+            <a:solidFill>
+              <a:srgbClr val="FFB000"/>
+            </a:solidFill>
           </a:ln>
           <a:effectLst/>
         </p:spPr>
@@ -5719,14 +6421,14 @@
       </p:sp>
       <p:sp>
         <p:nvSpPr>
-          <p:cNvPr id="48" name="TextBox 47"/>
+          <p:cNvPr id="63" name="TextBox 62"/>
           <p:cNvSpPr txBox="1"/>
           <p:nvPr/>
         </p:nvSpPr>
         <p:spPr>
           <a:xfrm>
-            <a:off x="22189440" y="8961119"/>
-            <a:ext cx="4632960" cy="1325880"/>
+            <a:off x="17465040" y="35039808"/>
+            <a:ext cx="3931920" cy="1234440"/>
           </a:xfrm>
           <a:prstGeom prst="rect">
             <a:avLst/>
@@ -5739,49 +6441,7 @@
           </a:bodyPr>
           <a:lstStyle/>
           <a:p>
-            <a:pPr algn="ctr">
-              <a:lnSpc>
-                <a:spcPct val="112000"/>
-              </a:lnSpc>
-              <a:spcAft>
-                <a:spcPts val="1000"/>
-              </a:spcAft>
-            </a:pPr>
-            <a:r>
-              <a:rPr sz="8000" b="1">
-                <a:solidFill>
-                  <a:srgbClr val="5FB0FF"/>
-                </a:solidFill>
-                <a:latin typeface="Arial"/>
-              </a:rPr>
-              <a:t>~2,000×</a:t>
-            </a:r>
-          </a:p>
-        </p:txBody>
-      </p:sp>
-      <p:sp>
-        <p:nvSpPr>
-          <p:cNvPr id="49" name="TextBox 48"/>
-          <p:cNvSpPr txBox="1"/>
-          <p:nvPr/>
-        </p:nvSpPr>
-        <p:spPr>
-          <a:xfrm>
-            <a:off x="22189440" y="10287000"/>
-            <a:ext cx="4632960" cy="1143000"/>
-          </a:xfrm>
-          <a:prstGeom prst="rect">
-            <a:avLst/>
-          </a:prstGeom>
-          <a:noFill/>
-        </p:spPr>
-        <p:txBody>
-          <a:bodyPr wrap="square" anchor="t" lIns="45720" rIns="45720" tIns="18288" bIns="18288">
-            <a:spAutoFit/>
-          </a:bodyPr>
-          <a:lstStyle/>
-          <a:p>
-            <a:pPr algn="ctr">
+            <a:pPr algn="l">
               <a:lnSpc>
                 <a:spcPct val="100000"/>
               </a:lnSpc>
@@ -5790,17 +6450,17 @@
               </a:spcAft>
             </a:pPr>
             <a:r>
-              <a:rPr sz="2400" b="0">
-                <a:solidFill>
-                  <a:srgbClr val="EEF3F8"/>
-                </a:solidFill>
-                <a:latin typeface="Arial"/>
-              </a:rPr>
-              <a:t>faster per pointing</a:t>
-            </a:r>
-          </a:p>
-          <a:p>
-            <a:pPr algn="ctr">
+              <a:rPr sz="2400" b="1">
+                <a:solidFill>
+                  <a:srgbClr val="FFB000"/>
+                </a:solidFill>
+                <a:latin typeface="Arial"/>
+              </a:rPr>
+              <a:t>IN PROGRESS</a:t>
+            </a:r>
+          </a:p>
+          <a:p>
+            <a:pPr algn="l">
               <a:lnSpc>
                 <a:spcPct val="100000"/>
               </a:lnSpc>
@@ -5809,35 +6469,75 @@
               </a:spcAft>
             </a:pPr>
             <a:r>
-              <a:rPr sz="2400" b="0">
+              <a:rPr sz="2400" b="1">
+                <a:solidFill>
+                  <a:srgbClr val="FFB000"/>
+                </a:solidFill>
+                <a:latin typeface="Arial"/>
+              </a:rPr>
+              <a:t>Refine</a:t>
+            </a:r>
+          </a:p>
+        </p:txBody>
+      </p:sp>
+      <p:sp>
+        <p:nvSpPr>
+          <p:cNvPr id="64" name="TextBox 63"/>
+          <p:cNvSpPr txBox="1"/>
+          <p:nvPr/>
+        </p:nvSpPr>
+        <p:spPr>
+          <a:xfrm>
+            <a:off x="21442680" y="35039808"/>
+            <a:ext cx="10104120" cy="1234440"/>
+          </a:xfrm>
+          <a:prstGeom prst="rect">
+            <a:avLst/>
+          </a:prstGeom>
+          <a:noFill/>
+        </p:spPr>
+        <p:txBody>
+          <a:bodyPr wrap="square" anchor="ctr" lIns="45720" rIns="45720" tIns="18288" bIns="18288">
+            <a:spAutoFit/>
+          </a:bodyPr>
+          <a:lstStyle/>
+          <a:p>
+            <a:pPr algn="l">
+              <a:lnSpc>
+                <a:spcPct val="102000"/>
+              </a:lnSpc>
+              <a:spcAft>
+                <a:spcPts val="0"/>
+              </a:spcAft>
+            </a:pPr>
+            <a:r>
+              <a:rPr sz="2500" b="0">
                 <a:solidFill>
                   <a:srgbClr val="EEF3F8"/>
                 </a:solidFill>
                 <a:latin typeface="Arial"/>
               </a:rPr>
-              <a:t>than ZodiPy</a:t>
-            </a:r>
-          </a:p>
-        </p:txBody>
-      </p:sp>
-      <p:sp>
-        <p:nvSpPr>
-          <p:cNvPr id="50" name="Rounded Rectangle 49"/>
+              <a:t>Longer training; all SPHEREx wavelengths (0.75–5 μm)</a:t>
+            </a:r>
+          </a:p>
+        </p:txBody>
+      </p:sp>
+      <p:sp>
+        <p:nvSpPr>
+          <p:cNvPr id="65" name="Down Arrow 64"/>
           <p:cNvSpPr/>
           <p:nvPr/>
         </p:nvSpPr>
         <p:spPr>
           <a:xfrm>
-            <a:off x="27142440" y="8869680"/>
-            <a:ext cx="4632960" cy="2651760"/>
-          </a:xfrm>
-          <a:prstGeom prst="roundRect">
-            <a:avLst>
-              <a:gd name="adj" fmla="val 10000"/>
-            </a:avLst>
+            <a:off x="24231600" y="36301680"/>
+            <a:ext cx="548640" cy="237744"/>
+          </a:xfrm>
+          <a:prstGeom prst="downArrow">
+            <a:avLst/>
           </a:prstGeom>
           <a:solidFill>
-            <a:srgbClr val="16304F"/>
+            <a:srgbClr val="FF6F91"/>
           </a:solidFill>
           <a:ln>
             <a:noFill/>
@@ -5868,276 +6568,27 @@
       </p:sp>
       <p:sp>
         <p:nvSpPr>
-          <p:cNvPr id="51" name="TextBox 50"/>
-          <p:cNvSpPr txBox="1"/>
-          <p:nvPr/>
-        </p:nvSpPr>
-        <p:spPr>
-          <a:xfrm>
-            <a:off x="27142440" y="8961119"/>
-            <a:ext cx="4632960" cy="1325880"/>
-          </a:xfrm>
-          <a:prstGeom prst="rect">
-            <a:avLst/>
-          </a:prstGeom>
-          <a:noFill/>
-        </p:spPr>
-        <p:txBody>
-          <a:bodyPr wrap="square" anchor="ctr" lIns="45720" rIns="45720" tIns="18288" bIns="18288">
-            <a:spAutoFit/>
-          </a:bodyPr>
-          <a:lstStyle/>
-          <a:p>
-            <a:pPr algn="ctr">
-              <a:lnSpc>
-                <a:spcPct val="112000"/>
-              </a:lnSpc>
-              <a:spcAft>
-                <a:spcPts val="1000"/>
-              </a:spcAft>
-            </a:pPr>
-            <a:r>
-              <a:rPr sz="8000" b="1">
-                <a:solidFill>
-                  <a:srgbClr val="5FB0FF"/>
-                </a:solidFill>
-                <a:latin typeface="Arial"/>
-              </a:rPr>
-              <a:t>64</a:t>
-            </a:r>
-          </a:p>
-        </p:txBody>
-      </p:sp>
-      <p:sp>
-        <p:nvSpPr>
-          <p:cNvPr id="52" name="TextBox 51"/>
-          <p:cNvSpPr txBox="1"/>
-          <p:nvPr/>
-        </p:nvSpPr>
-        <p:spPr>
-          <a:xfrm>
-            <a:off x="27142440" y="10287000"/>
-            <a:ext cx="4632960" cy="1143000"/>
-          </a:xfrm>
-          <a:prstGeom prst="rect">
-            <a:avLst/>
-          </a:prstGeom>
-          <a:noFill/>
-        </p:spPr>
-        <p:txBody>
-          <a:bodyPr wrap="square" anchor="t" lIns="45720" rIns="45720" tIns="18288" bIns="18288">
-            <a:spAutoFit/>
-          </a:bodyPr>
-          <a:lstStyle/>
-          <a:p>
-            <a:pPr algn="ctr">
-              <a:lnSpc>
-                <a:spcPct val="100000"/>
-              </a:lnSpc>
-              <a:spcAft>
-                <a:spcPts val="0"/>
-              </a:spcAft>
-            </a:pPr>
-            <a:r>
-              <a:rPr sz="2400" b="0">
-                <a:solidFill>
-                  <a:srgbClr val="EEF3F8"/>
-                </a:solidFill>
-                <a:latin typeface="Arial"/>
-              </a:rPr>
-              <a:t>wavelengths in</a:t>
-            </a:r>
-          </a:p>
-          <a:p>
-            <a:pPr algn="ctr">
-              <a:lnSpc>
-                <a:spcPct val="100000"/>
-              </a:lnSpc>
-              <a:spcAft>
-                <a:spcPts val="0"/>
-              </a:spcAft>
-            </a:pPr>
-            <a:r>
-              <a:rPr sz="2400" b="0">
-                <a:solidFill>
-                  <a:srgbClr val="EEF3F8"/>
-                </a:solidFill>
-                <a:latin typeface="Arial"/>
-              </a:rPr>
-              <a:t>one network</a:t>
-            </a:r>
-          </a:p>
-        </p:txBody>
-      </p:sp>
-      <p:pic>
-        <p:nvPicPr>
-          <p:cNvPr id="53" name="Picture 52" descr="accuracy_dark.png"/>
-          <p:cNvPicPr>
-            <a:picLocks noChangeAspect="1"/>
-          </p:cNvPicPr>
-          <p:nvPr/>
-        </p:nvPicPr>
-        <p:blipFill>
-          <a:blip r:embed="rId6"/>
-          <a:stretch>
-            <a:fillRect/>
-          </a:stretch>
-        </p:blipFill>
-        <p:spPr>
-          <a:xfrm>
-            <a:off x="17236440" y="11841480"/>
-            <a:ext cx="14538960" cy="7269480"/>
-          </a:xfrm>
-          <a:prstGeom prst="rect">
-            <a:avLst/>
-          </a:prstGeom>
-        </p:spPr>
-      </p:pic>
-      <p:sp>
-        <p:nvSpPr>
-          <p:cNvPr id="54" name="TextBox 53"/>
-          <p:cNvSpPr txBox="1"/>
-          <p:nvPr/>
-        </p:nvSpPr>
-        <p:spPr>
-          <a:xfrm>
-            <a:off x="17236440" y="19110960"/>
-            <a:ext cx="14538960" cy="1371600"/>
-          </a:xfrm>
-          <a:prstGeom prst="rect">
-            <a:avLst/>
-          </a:prstGeom>
-          <a:noFill/>
-        </p:spPr>
-        <p:txBody>
-          <a:bodyPr wrap="square" anchor="t" lIns="45720" rIns="45720" tIns="18288" bIns="18288">
-            <a:spAutoFit/>
-          </a:bodyPr>
-          <a:lstStyle/>
-          <a:p>
-            <a:pPr algn="l">
-              <a:lnSpc>
-                <a:spcPct val="105000"/>
-              </a:lnSpc>
-              <a:spcAft>
-                <a:spcPts val="1000"/>
-              </a:spcAft>
-            </a:pPr>
-            <a:r>
-              <a:rPr sz="2200" b="1">
-                <a:solidFill>
-                  <a:srgbClr val="A9B6C6"/>
-                </a:solidFill>
-                <a:latin typeface="Arial"/>
-              </a:rPr>
-              <a:t>Figure 3. </a:t>
-            </a:r>
-            <a:r>
-              <a:rPr sz="2200" b="0">
-                <a:solidFill>
-                  <a:srgbClr val="A9B6C6"/>
-                </a:solidFill>
-                <a:latin typeface="Arial"/>
-              </a:rPr>
-              <a:t>Neural network vs. ZodiPy. The network was trained on mission days 0–30, 60–90 and 120–140, then tested on the two 30-day blocks it never saw (days 30–60 and 90–120; 180,166 pointings). Half of the errors are below 0.026% and 95% are below 0.1%. (With a random 10% of pointings withheld instead, the median is 0.015%.)</a:t>
-            </a:r>
-          </a:p>
-        </p:txBody>
-      </p:sp>
-      <p:pic>
-        <p:nvPicPr>
-          <p:cNvPr id="55" name="Picture 54" descr="speed_dark.png"/>
-          <p:cNvPicPr>
-            <a:picLocks noChangeAspect="1"/>
-          </p:cNvPicPr>
-          <p:nvPr/>
-        </p:nvPicPr>
-        <p:blipFill>
-          <a:blip r:embed="rId7"/>
-          <a:stretch>
-            <a:fillRect/>
-          </a:stretch>
-        </p:blipFill>
-        <p:spPr>
-          <a:xfrm>
-            <a:off x="19708063" y="20482560"/>
-            <a:ext cx="9595713" cy="4759473"/>
-          </a:xfrm>
-          <a:prstGeom prst="rect">
-            <a:avLst/>
-          </a:prstGeom>
-        </p:spPr>
-      </p:pic>
-      <p:sp>
-        <p:nvSpPr>
-          <p:cNvPr id="56" name="TextBox 55"/>
-          <p:cNvSpPr txBox="1"/>
-          <p:nvPr/>
-        </p:nvSpPr>
-        <p:spPr>
-          <a:xfrm>
-            <a:off x="17236440" y="25242033"/>
-            <a:ext cx="14538960" cy="914400"/>
-          </a:xfrm>
-          <a:prstGeom prst="rect">
-            <a:avLst/>
-          </a:prstGeom>
-          <a:noFill/>
-        </p:spPr>
-        <p:txBody>
-          <a:bodyPr wrap="square" anchor="t" lIns="45720" rIns="45720" tIns="18288" bIns="18288">
-            <a:spAutoFit/>
-          </a:bodyPr>
-          <a:lstStyle/>
-          <a:p>
-            <a:pPr algn="l">
-              <a:lnSpc>
-                <a:spcPct val="105000"/>
-              </a:lnSpc>
-              <a:spcAft>
-                <a:spcPts val="1000"/>
-              </a:spcAft>
-            </a:pPr>
-            <a:r>
-              <a:rPr sz="2200" b="1">
-                <a:solidFill>
-                  <a:srgbClr val="A9B6C6"/>
-                </a:solidFill>
-                <a:latin typeface="Arial"/>
-              </a:rPr>
-              <a:t>Figure 4. </a:t>
-            </a:r>
-            <a:r>
-              <a:rPr sz="2200" b="0">
-                <a:solidFill>
-                  <a:srgbClr val="A9B6C6"/>
-                </a:solidFill>
-                <a:latin typeface="Arial"/>
-              </a:rPr>
-              <a:t>Time per pointing on a laptop (one CPU core, the same 20,000 pointings). One at a time, the network is ~2,000× faster; in large batches, where ZodiPy is efficient, it is ~4× faster.</a:t>
-            </a:r>
-          </a:p>
-        </p:txBody>
-      </p:sp>
-      <p:sp>
-        <p:nvSpPr>
-          <p:cNvPr id="57" name="Rectangle 56"/>
+          <p:cNvPr id="66" name="Rounded Rectangle 65"/>
           <p:cNvSpPr/>
           <p:nvPr/>
         </p:nvSpPr>
         <p:spPr>
           <a:xfrm>
-            <a:off x="17236440" y="26247873"/>
-            <a:ext cx="14538960" cy="54864"/>
-          </a:xfrm>
-          <a:prstGeom prst="rect">
-            <a:avLst/>
+            <a:off x="17236440" y="36566856"/>
+            <a:ext cx="14538960" cy="1234440"/>
+          </a:xfrm>
+          <a:prstGeom prst="roundRect">
+            <a:avLst>
+              <a:gd name="adj" fmla="val 15000"/>
+            </a:avLst>
           </a:prstGeom>
           <a:solidFill>
-            <a:srgbClr val="2D5A94"/>
+            <a:srgbClr val="16304F"/>
           </a:solidFill>
-          <a:ln>
-            <a:noFill/>
+          <a:ln w="63500">
+            <a:solidFill>
+              <a:srgbClr val="A9B6C6"/>
+            </a:solidFill>
           </a:ln>
           <a:effectLst/>
         </p:spPr>
@@ -6165,14 +6616,14 @@
       </p:sp>
       <p:sp>
         <p:nvSpPr>
-          <p:cNvPr id="58" name="TextBox 57"/>
+          <p:cNvPr id="67" name="TextBox 66"/>
           <p:cNvSpPr txBox="1"/>
           <p:nvPr/>
         </p:nvSpPr>
         <p:spPr>
           <a:xfrm>
-            <a:off x="17236440" y="26476473"/>
-            <a:ext cx="14538960" cy="1645920"/>
+            <a:off x="17465040" y="36566856"/>
+            <a:ext cx="3931920" cy="1234440"/>
           </a:xfrm>
           <a:prstGeom prst="rect">
             <a:avLst/>
@@ -6180,74 +6631,60 @@
           <a:noFill/>
         </p:spPr>
         <p:txBody>
-          <a:bodyPr wrap="square" anchor="t" lIns="45720" rIns="45720" tIns="18288" bIns="18288">
+          <a:bodyPr wrap="square" anchor="ctr" lIns="45720" rIns="45720" tIns="18288" bIns="18288">
             <a:spAutoFit/>
           </a:bodyPr>
           <a:lstStyle/>
           <a:p>
             <a:pPr algn="l">
               <a:lnSpc>
-                <a:spcPct val="112000"/>
+                <a:spcPct val="100000"/>
               </a:lnSpc>
               <a:spcAft>
-                <a:spcPts val="1000"/>
+                <a:spcPts val="0"/>
               </a:spcAft>
             </a:pPr>
             <a:r>
-              <a:rPr sz="2800" b="1">
-                <a:solidFill>
-                  <a:srgbClr val="EEF3F8"/>
-                </a:solidFill>
-                <a:latin typeface="Arial"/>
-              </a:rPr>
-              <a:t>Looking forward: every SPHEREx wavelength. </a:t>
-            </a:r>
-            <a:r>
-              <a:rPr sz="2800" b="0">
-                <a:solidFill>
-                  <a:srgbClr val="EEF3F8"/>
-                </a:solidFill>
-                <a:latin typeface="Arial"/>
-              </a:rPr>
-              <a:t>Real SPHEREx images cover many wavelengths, so wavelength becomes one more input. A first version covering 1.25–5 μm already reaches ~0.1% median error on the same withheld months.</a:t>
-            </a:r>
-          </a:p>
-        </p:txBody>
-      </p:sp>
-      <p:pic>
-        <p:nvPicPr>
-          <p:cNvPr id="59" name="Picture 58" descr="spectra_dark.png"/>
-          <p:cNvPicPr>
-            <a:picLocks noChangeAspect="1"/>
-          </p:cNvPicPr>
-          <p:nvPr/>
-        </p:nvPicPr>
-        <p:blipFill>
-          <a:blip r:embed="rId8"/>
-          <a:stretch>
-            <a:fillRect/>
-          </a:stretch>
-        </p:blipFill>
-        <p:spPr>
-          <a:xfrm>
-            <a:off x="19468735" y="27985233"/>
-            <a:ext cx="10074369" cy="6716246"/>
-          </a:xfrm>
-          <a:prstGeom prst="rect">
-            <a:avLst/>
-          </a:prstGeom>
-        </p:spPr>
-      </p:pic>
-      <p:sp>
-        <p:nvSpPr>
-          <p:cNvPr id="60" name="TextBox 59"/>
+              <a:rPr sz="2400" b="1">
+                <a:solidFill>
+                  <a:srgbClr val="A9B6C6"/>
+                </a:solidFill>
+                <a:latin typeface="Arial"/>
+              </a:rPr>
+              <a:t>NEXT</a:t>
+            </a:r>
+          </a:p>
+          <a:p>
+            <a:pPr algn="l">
+              <a:lnSpc>
+                <a:spcPct val="100000"/>
+              </a:lnSpc>
+              <a:spcAft>
+                <a:spcPts val="0"/>
+              </a:spcAft>
+            </a:pPr>
+            <a:r>
+              <a:rPr sz="2400" b="1">
+                <a:solidFill>
+                  <a:srgbClr val="A9B6C6"/>
+                </a:solidFill>
+                <a:latin typeface="Arial"/>
+              </a:rPr>
+              <a:t>Scale up</a:t>
+            </a:r>
+          </a:p>
+        </p:txBody>
+      </p:sp>
+      <p:sp>
+        <p:nvSpPr>
+          <p:cNvPr id="68" name="TextBox 67"/>
           <p:cNvSpPr txBox="1"/>
           <p:nvPr/>
         </p:nvSpPr>
         <p:spPr>
           <a:xfrm>
-            <a:off x="17236440" y="34701480"/>
-            <a:ext cx="14538960" cy="914400"/>
+            <a:off x="21442680" y="36566856"/>
+            <a:ext cx="10104120" cy="1234440"/>
           </a:xfrm>
           <a:prstGeom prst="rect">
             <a:avLst/>
@@ -6255,61 +6692,50 @@
           <a:noFill/>
         </p:spPr>
         <p:txBody>
-          <a:bodyPr wrap="square" anchor="t" lIns="45720" rIns="45720" tIns="18288" bIns="18288">
+          <a:bodyPr wrap="square" anchor="ctr" lIns="45720" rIns="45720" tIns="18288" bIns="18288">
             <a:spAutoFit/>
           </a:bodyPr>
           <a:lstStyle/>
           <a:p>
             <a:pPr algn="l">
               <a:lnSpc>
-                <a:spcPct val="105000"/>
+                <a:spcPct val="102000"/>
               </a:lnSpc>
               <a:spcAft>
-                <a:spcPts val="1000"/>
+                <a:spcPts val="0"/>
               </a:spcAft>
             </a:pPr>
             <a:r>
-              <a:rPr sz="2200" b="1">
-                <a:solidFill>
-                  <a:srgbClr val="A9B6C6"/>
-                </a:solidFill>
-                <a:latin typeface="Arial"/>
-              </a:rPr>
-              <a:t>Figure 5. </a:t>
-            </a:r>
-            <a:r>
-              <a:rPr sz="2200" b="0">
-                <a:solidFill>
-                  <a:srgbClr val="A9B6C6"/>
-                </a:solidFill>
-                <a:latin typeface="Arial"/>
-              </a:rPr>
-              <a:t>Brightness vs. wavelength for three pointings: ZodiPy (solid) and the network (dashed). Below 3 μm we see scattered sunlight; above, the dust's heat. Bottom: the differences stay under 1%.</a:t>
-            </a:r>
-          </a:p>
-        </p:txBody>
-      </p:sp>
-      <p:sp>
-        <p:nvSpPr>
-          <p:cNvPr id="61" name="Rectangle 60"/>
+              <a:rPr sz="2500" b="0">
+                <a:solidFill>
+                  <a:srgbClr val="EEF3F8"/>
+                </a:solidFill>
+                <a:latin typeface="Arial"/>
+              </a:rPr>
+              <a:t>Move training to a computing cluster</a:t>
+            </a:r>
+          </a:p>
+        </p:txBody>
+      </p:sp>
+      <p:sp>
+        <p:nvSpPr>
+          <p:cNvPr id="69" name="Down Arrow 68"/>
           <p:cNvSpPr/>
           <p:nvPr/>
         </p:nvSpPr>
         <p:spPr>
           <a:xfrm>
-            <a:off x="731520" y="36164520"/>
-            <a:ext cx="31455360" cy="4343399"/>
-          </a:xfrm>
-          <a:prstGeom prst="rect">
+            <a:off x="24231600" y="37828728"/>
+            <a:ext cx="548640" cy="237744"/>
+          </a:xfrm>
+          <a:prstGeom prst="downArrow">
             <a:avLst/>
           </a:prstGeom>
           <a:solidFill>
-            <a:srgbClr val="0F2036"/>
+            <a:srgbClr val="FF6F91"/>
           </a:solidFill>
-          <a:ln w="38100">
-            <a:solidFill>
-              <a:srgbClr val="2D5A94"/>
-            </a:solidFill>
+          <a:ln>
+            <a:noFill/>
           </a:ln>
           <a:effectLst/>
         </p:spPr>
@@ -6337,23 +6763,27 @@
       </p:sp>
       <p:sp>
         <p:nvSpPr>
-          <p:cNvPr id="62" name="Rectangle 61"/>
+          <p:cNvPr id="70" name="Rounded Rectangle 69"/>
           <p:cNvSpPr/>
           <p:nvPr/>
         </p:nvSpPr>
         <p:spPr>
           <a:xfrm>
-            <a:off x="731520" y="36164520"/>
-            <a:ext cx="31455360" cy="1051560"/>
-          </a:xfrm>
-          <a:prstGeom prst="rect">
-            <a:avLst/>
+            <a:off x="17236440" y="38093904"/>
+            <a:ext cx="14538960" cy="1234440"/>
+          </a:xfrm>
+          <a:prstGeom prst="roundRect">
+            <a:avLst>
+              <a:gd name="adj" fmla="val 15000"/>
+            </a:avLst>
           </a:prstGeom>
           <a:solidFill>
-            <a:srgbClr val="1E3557"/>
+            <a:srgbClr val="16304F"/>
           </a:solidFill>
-          <a:ln>
-            <a:noFill/>
+          <a:ln w="63500">
+            <a:solidFill>
+              <a:srgbClr val="A9B6C6"/>
+            </a:solidFill>
           </a:ln>
           <a:effectLst/>
         </p:spPr>
@@ -6381,14 +6811,14 @@
       </p:sp>
       <p:sp>
         <p:nvSpPr>
-          <p:cNvPr id="63" name="TextBox 62"/>
+          <p:cNvPr id="71" name="TextBox 70"/>
           <p:cNvSpPr txBox="1"/>
           <p:nvPr/>
         </p:nvSpPr>
         <p:spPr>
           <a:xfrm>
-            <a:off x="731520" y="36164520"/>
-            <a:ext cx="31455360" cy="1051560"/>
+            <a:off x="17465040" y="38093904"/>
+            <a:ext cx="3931920" cy="1234440"/>
           </a:xfrm>
           <a:prstGeom prst="rect">
             <a:avLst/>
@@ -6397,6 +6827,109 @@
         </p:spPr>
         <p:txBody>
           <a:bodyPr wrap="square" anchor="ctr" lIns="45720" rIns="45720" tIns="18288" bIns="18288">
+            <a:spAutoFit/>
+          </a:bodyPr>
+          <a:lstStyle/>
+          <a:p>
+            <a:pPr algn="l">
+              <a:lnSpc>
+                <a:spcPct val="100000"/>
+              </a:lnSpc>
+              <a:spcAft>
+                <a:spcPts val="0"/>
+              </a:spcAft>
+            </a:pPr>
+            <a:r>
+              <a:rPr sz="2400" b="1">
+                <a:solidFill>
+                  <a:srgbClr val="A9B6C6"/>
+                </a:solidFill>
+                <a:latin typeface="Arial"/>
+              </a:rPr>
+              <a:t>NEXT</a:t>
+            </a:r>
+          </a:p>
+          <a:p>
+            <a:pPr algn="l">
+              <a:lnSpc>
+                <a:spcPct val="100000"/>
+              </a:lnSpc>
+              <a:spcAft>
+                <a:spcPts val="0"/>
+              </a:spcAft>
+            </a:pPr>
+            <a:r>
+              <a:rPr sz="2400" b="1">
+                <a:solidFill>
+                  <a:srgbClr val="A9B6C6"/>
+                </a:solidFill>
+                <a:latin typeface="Arial"/>
+              </a:rPr>
+              <a:t>Real data</a:t>
+            </a:r>
+          </a:p>
+        </p:txBody>
+      </p:sp>
+      <p:sp>
+        <p:nvSpPr>
+          <p:cNvPr id="72" name="TextBox 71"/>
+          <p:cNvSpPr txBox="1"/>
+          <p:nvPr/>
+        </p:nvSpPr>
+        <p:spPr>
+          <a:xfrm>
+            <a:off x="21442680" y="38093904"/>
+            <a:ext cx="10104120" cy="1234440"/>
+          </a:xfrm>
+          <a:prstGeom prst="rect">
+            <a:avLst/>
+          </a:prstGeom>
+          <a:noFill/>
+        </p:spPr>
+        <p:txBody>
+          <a:bodyPr wrap="square" anchor="ctr" lIns="45720" rIns="45720" tIns="18288" bIns="18288">
+            <a:spAutoFit/>
+          </a:bodyPr>
+          <a:lstStyle/>
+          <a:p>
+            <a:pPr algn="l">
+              <a:lnSpc>
+                <a:spcPct val="102000"/>
+              </a:lnSpc>
+              <a:spcAft>
+                <a:spcPts val="0"/>
+              </a:spcAft>
+            </a:pPr>
+            <a:r>
+              <a:rPr sz="2500" b="0">
+                <a:solidFill>
+                  <a:srgbClr val="EEF3F8"/>
+                </a:solidFill>
+                <a:latin typeface="Arial"/>
+              </a:rPr>
+              <a:t>Train on real SPHEREx images and compare with the Kelsall model</a:t>
+            </a:r>
+          </a:p>
+        </p:txBody>
+      </p:sp>
+      <p:sp>
+        <p:nvSpPr>
+          <p:cNvPr id="73" name="TextBox 72"/>
+          <p:cNvSpPr txBox="1"/>
+          <p:nvPr/>
+        </p:nvSpPr>
+        <p:spPr>
+          <a:xfrm>
+            <a:off x="17236440" y="39465504"/>
+            <a:ext cx="14538960" cy="548640"/>
+          </a:xfrm>
+          <a:prstGeom prst="rect">
+            <a:avLst/>
+          </a:prstGeom>
+          <a:noFill/>
+        </p:spPr>
+        <p:txBody>
+          <a:bodyPr wrap="square" anchor="t" lIns="45720" rIns="45720" tIns="18288" bIns="18288">
             <a:spAutoFit/>
           </a:bodyPr>
           <a:lstStyle/>
@@ -6406,43 +6939,41 @@
                 <a:spcPct val="112000"/>
               </a:lnSpc>
               <a:spcAft>
-                <a:spcPts val="0"/>
+                <a:spcPts val="1000"/>
               </a:spcAft>
             </a:pPr>
             <a:r>
-              <a:rPr sz="5000" b="1">
-                <a:solidFill>
-                  <a:srgbClr val="FFFFFF"/>
-                </a:solidFill>
-                <a:latin typeface="Arial"/>
-              </a:rPr>
-              <a:t>Next Steps</a:t>
-            </a:r>
-          </a:p>
-        </p:txBody>
-      </p:sp>
-      <p:sp>
-        <p:nvSpPr>
-          <p:cNvPr id="64" name="Rounded Rectangle 63"/>
+              <a:rPr sz="2300" b="0">
+                <a:solidFill>
+                  <a:srgbClr val="A9B6C6"/>
+                </a:solidFill>
+                <a:latin typeface="Arial"/>
+              </a:rPr>
+              <a:t>All results so far are preliminary and use simulated data.</a:t>
+            </a:r>
+          </a:p>
+        </p:txBody>
+      </p:sp>
+      <p:sp>
+        <p:nvSpPr>
+          <p:cNvPr id="74" name="Rectangle 73"/>
           <p:cNvSpPr/>
           <p:nvPr/>
         </p:nvSpPr>
         <p:spPr>
           <a:xfrm>
-            <a:off x="1143000" y="37536120"/>
-            <a:ext cx="7178040" cy="2011680"/>
-          </a:xfrm>
-          <a:prstGeom prst="roundRect">
-            <a:avLst>
-              <a:gd name="adj" fmla="val 10000"/>
-            </a:avLst>
+            <a:off x="731520" y="40599360"/>
+            <a:ext cx="15361920" cy="2834640"/>
+          </a:xfrm>
+          <a:prstGeom prst="rect">
+            <a:avLst/>
           </a:prstGeom>
           <a:solidFill>
-            <a:srgbClr val="16304F"/>
+            <a:srgbClr val="0F2036"/>
           </a:solidFill>
-          <a:ln w="63500">
+          <a:ln w="38100">
             <a:solidFill>
-              <a:srgbClr val="66BB6A"/>
+              <a:srgbClr val="2D5A94"/>
             </a:solidFill>
           </a:ln>
           <a:effectLst/>
@@ -6471,113 +7002,20 @@
       </p:sp>
       <p:sp>
         <p:nvSpPr>
-          <p:cNvPr id="65" name="TextBox 64"/>
-          <p:cNvSpPr txBox="1"/>
-          <p:nvPr/>
-        </p:nvSpPr>
-        <p:spPr>
-          <a:xfrm>
-            <a:off x="1325880" y="37645848"/>
-            <a:ext cx="6812279" cy="548640"/>
-          </a:xfrm>
-          <a:prstGeom prst="rect">
-            <a:avLst/>
-          </a:prstGeom>
-          <a:noFill/>
-        </p:spPr>
-        <p:txBody>
-          <a:bodyPr wrap="square" anchor="t" lIns="45720" rIns="45720" tIns="18288" bIns="18288">
-            <a:spAutoFit/>
-          </a:bodyPr>
-          <a:lstStyle/>
-          <a:p>
-            <a:pPr algn="l">
-              <a:lnSpc>
-                <a:spcPct val="112000"/>
-              </a:lnSpc>
-              <a:spcAft>
-                <a:spcPts val="1000"/>
-              </a:spcAft>
-            </a:pPr>
-            <a:r>
-              <a:rPr sz="2800" b="1">
-                <a:solidFill>
-                  <a:srgbClr val="66BB6A"/>
-                </a:solidFill>
-                <a:latin typeface="Arial"/>
-              </a:rPr>
-              <a:t>✓ DONE   </a:t>
-            </a:r>
-            <a:r>
-              <a:rPr sz="2800" b="1">
-                <a:solidFill>
-                  <a:srgbClr val="66BB6A"/>
-                </a:solidFill>
-                <a:latin typeface="Arial"/>
-              </a:rPr>
-              <a:t>Validate</a:t>
-            </a:r>
-          </a:p>
-        </p:txBody>
-      </p:sp>
-      <p:sp>
-        <p:nvSpPr>
-          <p:cNvPr id="66" name="TextBox 65"/>
-          <p:cNvSpPr txBox="1"/>
-          <p:nvPr/>
-        </p:nvSpPr>
-        <p:spPr>
-          <a:xfrm>
-            <a:off x="1325880" y="38267640"/>
-            <a:ext cx="6812279" cy="1188720"/>
-          </a:xfrm>
-          <a:prstGeom prst="rect">
-            <a:avLst/>
-          </a:prstGeom>
-          <a:noFill/>
-        </p:spPr>
-        <p:txBody>
-          <a:bodyPr wrap="square" anchor="t" lIns="45720" rIns="45720" tIns="18288" bIns="18288">
-            <a:spAutoFit/>
-          </a:bodyPr>
-          <a:lstStyle/>
-          <a:p>
-            <a:pPr algn="l">
-              <a:lnSpc>
-                <a:spcPct val="102000"/>
-              </a:lnSpc>
-              <a:spcAft>
-                <a:spcPts val="1000"/>
-              </a:spcAft>
-            </a:pPr>
-            <a:r>
-              <a:rPr sz="2400" b="0">
-                <a:solidFill>
-                  <a:srgbClr val="EEF3F8"/>
-                </a:solidFill>
-                <a:latin typeface="Arial"/>
-              </a:rPr>
-              <a:t>Accuracy, speed, unseen months and sky regions, all on simulated data</a:t>
-            </a:r>
-          </a:p>
-        </p:txBody>
-      </p:sp>
-      <p:sp>
-        <p:nvSpPr>
-          <p:cNvPr id="67" name="Right Arrow 66"/>
+          <p:cNvPr id="75" name="Rectangle 74"/>
           <p:cNvSpPr/>
           <p:nvPr/>
         </p:nvSpPr>
         <p:spPr>
           <a:xfrm>
-            <a:off x="8412480" y="38221920"/>
-            <a:ext cx="457199" cy="640080"/>
-          </a:xfrm>
-          <a:prstGeom prst="rightArrow">
+            <a:off x="731520" y="40599360"/>
+            <a:ext cx="15361920" cy="777240"/>
+          </a:xfrm>
+          <a:prstGeom prst="rect">
             <a:avLst/>
           </a:prstGeom>
           <a:solidFill>
-            <a:srgbClr val="FF6F91"/>
+            <a:srgbClr val="1E3557"/>
           </a:solidFill>
           <a:ln>
             <a:noFill/>
@@ -6608,26 +7046,132 @@
       </p:sp>
       <p:sp>
         <p:nvSpPr>
-          <p:cNvPr id="68" name="Rounded Rectangle 67"/>
+          <p:cNvPr id="76" name="TextBox 75"/>
+          <p:cNvSpPr txBox="1"/>
+          <p:nvPr/>
+        </p:nvSpPr>
+        <p:spPr>
+          <a:xfrm>
+            <a:off x="731520" y="40599360"/>
+            <a:ext cx="15361920" cy="777240"/>
+          </a:xfrm>
+          <a:prstGeom prst="rect">
+            <a:avLst/>
+          </a:prstGeom>
+          <a:noFill/>
+        </p:spPr>
+        <p:txBody>
+          <a:bodyPr wrap="square" anchor="ctr" lIns="45720" rIns="45720" tIns="18288" bIns="18288">
+            <a:spAutoFit/>
+          </a:bodyPr>
+          <a:lstStyle/>
+          <a:p>
+            <a:pPr algn="ctr">
+              <a:lnSpc>
+                <a:spcPct val="112000"/>
+              </a:lnSpc>
+              <a:spcAft>
+                <a:spcPts val="0"/>
+              </a:spcAft>
+            </a:pPr>
+            <a:r>
+              <a:rPr sz="4000" b="1">
+                <a:solidFill>
+                  <a:srgbClr val="FFFFFF"/>
+                </a:solidFill>
+                <a:latin typeface="Arial"/>
+              </a:rPr>
+              <a:t>Acknowledgements</a:t>
+            </a:r>
+          </a:p>
+        </p:txBody>
+      </p:sp>
+      <p:pic>
+        <p:nvPicPr>
+          <p:cNvPr id="77" name="Picture 76" descr="logo_nsf.png"/>
+          <p:cNvPicPr>
+            <a:picLocks noChangeAspect="1"/>
+          </p:cNvPicPr>
+          <p:nvPr/>
+        </p:nvPicPr>
+        <p:blipFill>
+          <a:blip r:embed="rId8"/>
+          <a:stretch>
+            <a:fillRect/>
+          </a:stretch>
+        </p:blipFill>
+        <p:spPr>
+          <a:xfrm>
+            <a:off x="14036040" y="41559480"/>
+            <a:ext cx="1640792" cy="1645919"/>
+          </a:xfrm>
+          <a:prstGeom prst="rect">
+            <a:avLst/>
+          </a:prstGeom>
+        </p:spPr>
+      </p:pic>
+      <p:sp>
+        <p:nvSpPr>
+          <p:cNvPr id="78" name="TextBox 77"/>
+          <p:cNvSpPr txBox="1"/>
+          <p:nvPr/>
+        </p:nvSpPr>
+        <p:spPr>
+          <a:xfrm>
+            <a:off x="1143000" y="41513760"/>
+            <a:ext cx="12618720" cy="1828799"/>
+          </a:xfrm>
+          <a:prstGeom prst="rect">
+            <a:avLst/>
+          </a:prstGeom>
+          <a:noFill/>
+        </p:spPr>
+        <p:txBody>
+          <a:bodyPr wrap="square" anchor="t" lIns="45720" rIns="45720" tIns="18288" bIns="18288">
+            <a:spAutoFit/>
+          </a:bodyPr>
+          <a:lstStyle/>
+          <a:p>
+            <a:pPr algn="l">
+              <a:lnSpc>
+                <a:spcPct val="105000"/>
+              </a:lnSpc>
+              <a:spcAft>
+                <a:spcPts val="1000"/>
+              </a:spcAft>
+            </a:pPr>
+            <a:r>
+              <a:rPr sz="2200" b="0">
+                <a:solidFill>
+                  <a:srgbClr val="EEF3F8"/>
+                </a:solidFill>
+                <a:latin typeface="Arial"/>
+              </a:rPr>
+              <a:t>This research is supported by a URS grant at New Mexico State University, funded by the National Science Foundation (NSF). Thank you to Dr. Andrew Saydjari for mentorship, and to the developers of ZodiPy and Flux.jl.</a:t>
+            </a:r>
+          </a:p>
+        </p:txBody>
+      </p:sp>
+      <p:sp>
+        <p:nvSpPr>
+          <p:cNvPr id="79" name="Rectangle 78"/>
           <p:cNvSpPr/>
           <p:nvPr/>
         </p:nvSpPr>
         <p:spPr>
           <a:xfrm>
-            <a:off x="8961119" y="37536120"/>
-            <a:ext cx="7178040" cy="2011680"/>
-          </a:xfrm>
-          <a:prstGeom prst="roundRect">
-            <a:avLst>
-              <a:gd name="adj" fmla="val 10000"/>
-            </a:avLst>
+            <a:off x="16824960" y="40599360"/>
+            <a:ext cx="15361920" cy="2834640"/>
+          </a:xfrm>
+          <a:prstGeom prst="rect">
+            <a:avLst/>
           </a:prstGeom>
           <a:solidFill>
-            <a:srgbClr val="16304F"/>
+            <a:srgbClr val="0F2036"/>
           </a:solidFill>
-          <a:ln w="63500">
+          <a:ln w="38100">
             <a:solidFill>
-              <a:srgbClr val="FFB000"/>
+              <a:srgbClr val="2D5A94"/>
             </a:solidFill>
           </a:ln>
           <a:effectLst/>
@@ -6656,113 +7200,20 @@
       </p:sp>
       <p:sp>
         <p:nvSpPr>
-          <p:cNvPr id="69" name="TextBox 68"/>
-          <p:cNvSpPr txBox="1"/>
-          <p:nvPr/>
-        </p:nvSpPr>
-        <p:spPr>
-          <a:xfrm>
-            <a:off x="9143999" y="37645848"/>
-            <a:ext cx="6812279" cy="548640"/>
-          </a:xfrm>
-          <a:prstGeom prst="rect">
-            <a:avLst/>
-          </a:prstGeom>
-          <a:noFill/>
-        </p:spPr>
-        <p:txBody>
-          <a:bodyPr wrap="square" anchor="t" lIns="45720" rIns="45720" tIns="18288" bIns="18288">
-            <a:spAutoFit/>
-          </a:bodyPr>
-          <a:lstStyle/>
-          <a:p>
-            <a:pPr algn="l">
-              <a:lnSpc>
-                <a:spcPct val="112000"/>
-              </a:lnSpc>
-              <a:spcAft>
-                <a:spcPts val="1000"/>
-              </a:spcAft>
-            </a:pPr>
-            <a:r>
-              <a:rPr sz="2800" b="1">
-                <a:solidFill>
-                  <a:srgbClr val="FFB000"/>
-                </a:solidFill>
-                <a:latin typeface="Arial"/>
-              </a:rPr>
-              <a:t>IN PROGRESS   </a:t>
-            </a:r>
-            <a:r>
-              <a:rPr sz="2800" b="1">
-                <a:solidFill>
-                  <a:srgbClr val="FFB000"/>
-                </a:solidFill>
-                <a:latin typeface="Arial"/>
-              </a:rPr>
-              <a:t>Refine</a:t>
-            </a:r>
-          </a:p>
-        </p:txBody>
-      </p:sp>
-      <p:sp>
-        <p:nvSpPr>
-          <p:cNvPr id="70" name="TextBox 69"/>
-          <p:cNvSpPr txBox="1"/>
-          <p:nvPr/>
-        </p:nvSpPr>
-        <p:spPr>
-          <a:xfrm>
-            <a:off x="9143999" y="38267640"/>
-            <a:ext cx="6812279" cy="1188720"/>
-          </a:xfrm>
-          <a:prstGeom prst="rect">
-            <a:avLst/>
-          </a:prstGeom>
-          <a:noFill/>
-        </p:spPr>
-        <p:txBody>
-          <a:bodyPr wrap="square" anchor="t" lIns="45720" rIns="45720" tIns="18288" bIns="18288">
-            <a:spAutoFit/>
-          </a:bodyPr>
-          <a:lstStyle/>
-          <a:p>
-            <a:pPr algn="l">
-              <a:lnSpc>
-                <a:spcPct val="102000"/>
-              </a:lnSpc>
-              <a:spcAft>
-                <a:spcPts val="1000"/>
-              </a:spcAft>
-            </a:pPr>
-            <a:r>
-              <a:rPr sz="2400" b="0">
-                <a:solidFill>
-                  <a:srgbClr val="EEF3F8"/>
-                </a:solidFill>
-                <a:latin typeface="Arial"/>
-              </a:rPr>
-              <a:t>Longer training; all SPHEREx wavelengths (0.75–5 μm)</a:t>
-            </a:r>
-          </a:p>
-        </p:txBody>
-      </p:sp>
-      <p:sp>
-        <p:nvSpPr>
-          <p:cNvPr id="71" name="Right Arrow 70"/>
+          <p:cNvPr id="80" name="Rectangle 79"/>
           <p:cNvSpPr/>
           <p:nvPr/>
         </p:nvSpPr>
         <p:spPr>
           <a:xfrm>
-            <a:off x="16230600" y="38221920"/>
-            <a:ext cx="457199" cy="640080"/>
-          </a:xfrm>
-          <a:prstGeom prst="rightArrow">
+            <a:off x="16824960" y="40599360"/>
+            <a:ext cx="15361920" cy="777240"/>
+          </a:xfrm>
+          <a:prstGeom prst="rect">
             <a:avLst/>
           </a:prstGeom>
           <a:solidFill>
-            <a:srgbClr val="FF6F91"/>
+            <a:srgbClr val="1E3557"/>
           </a:solidFill>
           <a:ln>
             <a:noFill/>
@@ -6793,471 +7244,13 @@
       </p:sp>
       <p:sp>
         <p:nvSpPr>
-          <p:cNvPr id="72" name="Rounded Rectangle 71"/>
-          <p:cNvSpPr/>
-          <p:nvPr/>
-        </p:nvSpPr>
-        <p:spPr>
-          <a:xfrm>
-            <a:off x="16779239" y="37536120"/>
-            <a:ext cx="7178040" cy="2011680"/>
-          </a:xfrm>
-          <a:prstGeom prst="roundRect">
-            <a:avLst>
-              <a:gd name="adj" fmla="val 10000"/>
-            </a:avLst>
-          </a:prstGeom>
-          <a:solidFill>
-            <a:srgbClr val="16304F"/>
-          </a:solidFill>
-          <a:ln w="63500">
-            <a:solidFill>
-              <a:srgbClr val="A9B6C6"/>
-            </a:solidFill>
-          </a:ln>
-          <a:effectLst/>
-        </p:spPr>
-        <p:style>
-          <a:lnRef idx="1">
-            <a:schemeClr val="accent1"/>
-          </a:lnRef>
-          <a:fillRef idx="3">
-            <a:schemeClr val="accent1"/>
-          </a:fillRef>
-          <a:effectRef idx="2">
-            <a:schemeClr val="accent1"/>
-          </a:effectRef>
-          <a:fontRef idx="minor">
-            <a:schemeClr val="lt1"/>
-          </a:fontRef>
-        </p:style>
-        <p:txBody>
-          <a:bodyPr rtlCol="0" anchor="ctr"/>
-          <a:lstStyle/>
-          <a:p>
-            <a:pPr algn="ctr"/>
-          </a:p>
-        </p:txBody>
-      </p:sp>
-      <p:sp>
-        <p:nvSpPr>
-          <p:cNvPr id="73" name="TextBox 72"/>
+          <p:cNvPr id="81" name="TextBox 80"/>
           <p:cNvSpPr txBox="1"/>
           <p:nvPr/>
         </p:nvSpPr>
         <p:spPr>
           <a:xfrm>
-            <a:off x="16962119" y="37645848"/>
-            <a:ext cx="6812279" cy="548640"/>
-          </a:xfrm>
-          <a:prstGeom prst="rect">
-            <a:avLst/>
-          </a:prstGeom>
-          <a:noFill/>
-        </p:spPr>
-        <p:txBody>
-          <a:bodyPr wrap="square" anchor="t" lIns="45720" rIns="45720" tIns="18288" bIns="18288">
-            <a:spAutoFit/>
-          </a:bodyPr>
-          <a:lstStyle/>
-          <a:p>
-            <a:pPr algn="l">
-              <a:lnSpc>
-                <a:spcPct val="112000"/>
-              </a:lnSpc>
-              <a:spcAft>
-                <a:spcPts val="1000"/>
-              </a:spcAft>
-            </a:pPr>
-            <a:r>
-              <a:rPr sz="2800" b="1">
-                <a:solidFill>
-                  <a:srgbClr val="A9B6C6"/>
-                </a:solidFill>
-                <a:latin typeface="Arial"/>
-              </a:rPr>
-              <a:t>NEXT   </a:t>
-            </a:r>
-            <a:r>
-              <a:rPr sz="2800" b="1">
-                <a:solidFill>
-                  <a:srgbClr val="A9B6C6"/>
-                </a:solidFill>
-                <a:latin typeface="Arial"/>
-              </a:rPr>
-              <a:t>Scale up</a:t>
-            </a:r>
-          </a:p>
-        </p:txBody>
-      </p:sp>
-      <p:sp>
-        <p:nvSpPr>
-          <p:cNvPr id="74" name="TextBox 73"/>
-          <p:cNvSpPr txBox="1"/>
-          <p:nvPr/>
-        </p:nvSpPr>
-        <p:spPr>
-          <a:xfrm>
-            <a:off x="16962119" y="38267640"/>
-            <a:ext cx="6812279" cy="1188720"/>
-          </a:xfrm>
-          <a:prstGeom prst="rect">
-            <a:avLst/>
-          </a:prstGeom>
-          <a:noFill/>
-        </p:spPr>
-        <p:txBody>
-          <a:bodyPr wrap="square" anchor="t" lIns="45720" rIns="45720" tIns="18288" bIns="18288">
-            <a:spAutoFit/>
-          </a:bodyPr>
-          <a:lstStyle/>
-          <a:p>
-            <a:pPr algn="l">
-              <a:lnSpc>
-                <a:spcPct val="102000"/>
-              </a:lnSpc>
-              <a:spcAft>
-                <a:spcPts val="1000"/>
-              </a:spcAft>
-            </a:pPr>
-            <a:r>
-              <a:rPr sz="2400" b="0">
-                <a:solidFill>
-                  <a:srgbClr val="EEF3F8"/>
-                </a:solidFill>
-                <a:latin typeface="Arial"/>
-              </a:rPr>
-              <a:t>Move training to a computing cluster</a:t>
-            </a:r>
-          </a:p>
-        </p:txBody>
-      </p:sp>
-      <p:sp>
-        <p:nvSpPr>
-          <p:cNvPr id="75" name="Right Arrow 74"/>
-          <p:cNvSpPr/>
-          <p:nvPr/>
-        </p:nvSpPr>
-        <p:spPr>
-          <a:xfrm>
-            <a:off x="24048719" y="38221920"/>
-            <a:ext cx="457199" cy="640080"/>
-          </a:xfrm>
-          <a:prstGeom prst="rightArrow">
-            <a:avLst/>
-          </a:prstGeom>
-          <a:solidFill>
-            <a:srgbClr val="FF6F91"/>
-          </a:solidFill>
-          <a:ln>
-            <a:noFill/>
-          </a:ln>
-          <a:effectLst/>
-        </p:spPr>
-        <p:style>
-          <a:lnRef idx="1">
-            <a:schemeClr val="accent1"/>
-          </a:lnRef>
-          <a:fillRef idx="3">
-            <a:schemeClr val="accent1"/>
-          </a:fillRef>
-          <a:effectRef idx="2">
-            <a:schemeClr val="accent1"/>
-          </a:effectRef>
-          <a:fontRef idx="minor">
-            <a:schemeClr val="lt1"/>
-          </a:fontRef>
-        </p:style>
-        <p:txBody>
-          <a:bodyPr rtlCol="0" anchor="ctr"/>
-          <a:lstStyle/>
-          <a:p>
-            <a:pPr algn="ctr"/>
-          </a:p>
-        </p:txBody>
-      </p:sp>
-      <p:sp>
-        <p:nvSpPr>
-          <p:cNvPr id="76" name="Rounded Rectangle 75"/>
-          <p:cNvSpPr/>
-          <p:nvPr/>
-        </p:nvSpPr>
-        <p:spPr>
-          <a:xfrm>
-            <a:off x="24597360" y="37536120"/>
-            <a:ext cx="7178040" cy="2011680"/>
-          </a:xfrm>
-          <a:prstGeom prst="roundRect">
-            <a:avLst>
-              <a:gd name="adj" fmla="val 10000"/>
-            </a:avLst>
-          </a:prstGeom>
-          <a:solidFill>
-            <a:srgbClr val="16304F"/>
-          </a:solidFill>
-          <a:ln w="63500">
-            <a:solidFill>
-              <a:srgbClr val="A9B6C6"/>
-            </a:solidFill>
-          </a:ln>
-          <a:effectLst/>
-        </p:spPr>
-        <p:style>
-          <a:lnRef idx="1">
-            <a:schemeClr val="accent1"/>
-          </a:lnRef>
-          <a:fillRef idx="3">
-            <a:schemeClr val="accent1"/>
-          </a:fillRef>
-          <a:effectRef idx="2">
-            <a:schemeClr val="accent1"/>
-          </a:effectRef>
-          <a:fontRef idx="minor">
-            <a:schemeClr val="lt1"/>
-          </a:fontRef>
-        </p:style>
-        <p:txBody>
-          <a:bodyPr rtlCol="0" anchor="ctr"/>
-          <a:lstStyle/>
-          <a:p>
-            <a:pPr algn="ctr"/>
-          </a:p>
-        </p:txBody>
-      </p:sp>
-      <p:sp>
-        <p:nvSpPr>
-          <p:cNvPr id="77" name="TextBox 76"/>
-          <p:cNvSpPr txBox="1"/>
-          <p:nvPr/>
-        </p:nvSpPr>
-        <p:spPr>
-          <a:xfrm>
-            <a:off x="24780239" y="37645848"/>
-            <a:ext cx="6812279" cy="548640"/>
-          </a:xfrm>
-          <a:prstGeom prst="rect">
-            <a:avLst/>
-          </a:prstGeom>
-          <a:noFill/>
-        </p:spPr>
-        <p:txBody>
-          <a:bodyPr wrap="square" anchor="t" lIns="45720" rIns="45720" tIns="18288" bIns="18288">
-            <a:spAutoFit/>
-          </a:bodyPr>
-          <a:lstStyle/>
-          <a:p>
-            <a:pPr algn="l">
-              <a:lnSpc>
-                <a:spcPct val="112000"/>
-              </a:lnSpc>
-              <a:spcAft>
-                <a:spcPts val="1000"/>
-              </a:spcAft>
-            </a:pPr>
-            <a:r>
-              <a:rPr sz="2800" b="1">
-                <a:solidFill>
-                  <a:srgbClr val="A9B6C6"/>
-                </a:solidFill>
-                <a:latin typeface="Arial"/>
-              </a:rPr>
-              <a:t>NEXT   </a:t>
-            </a:r>
-            <a:r>
-              <a:rPr sz="2800" b="1">
-                <a:solidFill>
-                  <a:srgbClr val="A9B6C6"/>
-                </a:solidFill>
-                <a:latin typeface="Arial"/>
-              </a:rPr>
-              <a:t>Real data</a:t>
-            </a:r>
-          </a:p>
-        </p:txBody>
-      </p:sp>
-      <p:sp>
-        <p:nvSpPr>
-          <p:cNvPr id="78" name="TextBox 77"/>
-          <p:cNvSpPr txBox="1"/>
-          <p:nvPr/>
-        </p:nvSpPr>
-        <p:spPr>
-          <a:xfrm>
-            <a:off x="24780239" y="38267640"/>
-            <a:ext cx="6812279" cy="1188720"/>
-          </a:xfrm>
-          <a:prstGeom prst="rect">
-            <a:avLst/>
-          </a:prstGeom>
-          <a:noFill/>
-        </p:spPr>
-        <p:txBody>
-          <a:bodyPr wrap="square" anchor="t" lIns="45720" rIns="45720" tIns="18288" bIns="18288">
-            <a:spAutoFit/>
-          </a:bodyPr>
-          <a:lstStyle/>
-          <a:p>
-            <a:pPr algn="l">
-              <a:lnSpc>
-                <a:spcPct val="102000"/>
-              </a:lnSpc>
-              <a:spcAft>
-                <a:spcPts val="1000"/>
-              </a:spcAft>
-            </a:pPr>
-            <a:r>
-              <a:rPr sz="2400" b="0">
-                <a:solidFill>
-                  <a:srgbClr val="EEF3F8"/>
-                </a:solidFill>
-                <a:latin typeface="Arial"/>
-              </a:rPr>
-              <a:t>Apply the emulator to real SPHEREx images</a:t>
-            </a:r>
-          </a:p>
-        </p:txBody>
-      </p:sp>
-      <p:sp>
-        <p:nvSpPr>
-          <p:cNvPr id="79" name="TextBox 78"/>
-          <p:cNvSpPr txBox="1"/>
-          <p:nvPr/>
-        </p:nvSpPr>
-        <p:spPr>
-          <a:xfrm>
-            <a:off x="1143000" y="39684960"/>
-            <a:ext cx="30632400" cy="548640"/>
-          </a:xfrm>
-          <a:prstGeom prst="rect">
-            <a:avLst/>
-          </a:prstGeom>
-          <a:noFill/>
-        </p:spPr>
-        <p:txBody>
-          <a:bodyPr wrap="square" anchor="t" lIns="45720" rIns="45720" tIns="18288" bIns="18288">
-            <a:spAutoFit/>
-          </a:bodyPr>
-          <a:lstStyle/>
-          <a:p>
-            <a:pPr algn="ctr">
-              <a:lnSpc>
-                <a:spcPct val="112000"/>
-              </a:lnSpc>
-              <a:spcAft>
-                <a:spcPts val="1000"/>
-              </a:spcAft>
-            </a:pPr>
-            <a:r>
-              <a:rPr sz="2300" b="0">
-                <a:solidFill>
-                  <a:srgbClr val="A9B6C6"/>
-                </a:solidFill>
-                <a:latin typeface="Arial"/>
-              </a:rPr>
-              <a:t>All results so far are preliminary and use simulated data. Next, the model is fully validated and then applied to real SPHEREx data.</a:t>
-            </a:r>
-          </a:p>
-        </p:txBody>
-      </p:sp>
-      <p:sp>
-        <p:nvSpPr>
-          <p:cNvPr id="80" name="Rectangle 79"/>
-          <p:cNvSpPr/>
-          <p:nvPr/>
-        </p:nvSpPr>
-        <p:spPr>
-          <a:xfrm>
-            <a:off x="731520" y="40873679"/>
-            <a:ext cx="15361920" cy="2560320"/>
-          </a:xfrm>
-          <a:prstGeom prst="rect">
-            <a:avLst/>
-          </a:prstGeom>
-          <a:solidFill>
-            <a:srgbClr val="0F2036"/>
-          </a:solidFill>
-          <a:ln w="38100">
-            <a:solidFill>
-              <a:srgbClr val="2D5A94"/>
-            </a:solidFill>
-          </a:ln>
-          <a:effectLst/>
-        </p:spPr>
-        <p:style>
-          <a:lnRef idx="1">
-            <a:schemeClr val="accent1"/>
-          </a:lnRef>
-          <a:fillRef idx="3">
-            <a:schemeClr val="accent1"/>
-          </a:fillRef>
-          <a:effectRef idx="2">
-            <a:schemeClr val="accent1"/>
-          </a:effectRef>
-          <a:fontRef idx="minor">
-            <a:schemeClr val="lt1"/>
-          </a:fontRef>
-        </p:style>
-        <p:txBody>
-          <a:bodyPr rtlCol="0" anchor="ctr"/>
-          <a:lstStyle/>
-          <a:p>
-            <a:pPr algn="ctr"/>
-          </a:p>
-        </p:txBody>
-      </p:sp>
-      <p:sp>
-        <p:nvSpPr>
-          <p:cNvPr id="81" name="Rectangle 80"/>
-          <p:cNvSpPr/>
-          <p:nvPr/>
-        </p:nvSpPr>
-        <p:spPr>
-          <a:xfrm>
-            <a:off x="731520" y="40873679"/>
-            <a:ext cx="15361920" cy="777240"/>
-          </a:xfrm>
-          <a:prstGeom prst="rect">
-            <a:avLst/>
-          </a:prstGeom>
-          <a:solidFill>
-            <a:srgbClr val="1E3557"/>
-          </a:solidFill>
-          <a:ln>
-            <a:noFill/>
-          </a:ln>
-          <a:effectLst/>
-        </p:spPr>
-        <p:style>
-          <a:lnRef idx="1">
-            <a:schemeClr val="accent1"/>
-          </a:lnRef>
-          <a:fillRef idx="3">
-            <a:schemeClr val="accent1"/>
-          </a:fillRef>
-          <a:effectRef idx="2">
-            <a:schemeClr val="accent1"/>
-          </a:effectRef>
-          <a:fontRef idx="minor">
-            <a:schemeClr val="lt1"/>
-          </a:fontRef>
-        </p:style>
-        <p:txBody>
-          <a:bodyPr rtlCol="0" anchor="ctr"/>
-          <a:lstStyle/>
-          <a:p>
-            <a:pPr algn="ctr"/>
-          </a:p>
-        </p:txBody>
-      </p:sp>
-      <p:sp>
-        <p:nvSpPr>
-          <p:cNvPr id="82" name="TextBox 81"/>
-          <p:cNvSpPr txBox="1"/>
-          <p:nvPr/>
-        </p:nvSpPr>
-        <p:spPr>
-          <a:xfrm>
-            <a:off x="731520" y="40873679"/>
+            <a:off x="16824960" y="40599360"/>
             <a:ext cx="15361920" cy="777240"/>
           </a:xfrm>
           <a:prstGeom prst="rect">
@@ -7286,195 +7279,21 @@
                 </a:solidFill>
                 <a:latin typeface="Arial"/>
               </a:rPr>
-              <a:t>Acknowledgements</a:t>
-            </a:r>
-          </a:p>
-        </p:txBody>
-      </p:sp>
-      <p:sp>
-        <p:nvSpPr>
-          <p:cNvPr id="83" name="TextBox 82"/>
+              <a:t>References</a:t>
+            </a:r>
+          </a:p>
+        </p:txBody>
+      </p:sp>
+      <p:sp>
+        <p:nvSpPr>
+          <p:cNvPr id="82" name="TextBox 81"/>
           <p:cNvSpPr txBox="1"/>
           <p:nvPr/>
         </p:nvSpPr>
         <p:spPr>
           <a:xfrm>
-            <a:off x="1143000" y="41788079"/>
-            <a:ext cx="14538960" cy="1463040"/>
-          </a:xfrm>
-          <a:prstGeom prst="rect">
-            <a:avLst/>
-          </a:prstGeom>
-          <a:noFill/>
-        </p:spPr>
-        <p:txBody>
-          <a:bodyPr wrap="square" anchor="t" lIns="45720" rIns="45720" tIns="18288" bIns="18288">
-            <a:spAutoFit/>
-          </a:bodyPr>
-          <a:lstStyle/>
-          <a:p>
-            <a:pPr algn="l">
-              <a:lnSpc>
-                <a:spcPct val="105000"/>
-              </a:lnSpc>
-              <a:spcAft>
-                <a:spcPts val="1000"/>
-              </a:spcAft>
-            </a:pPr>
-            <a:r>
-              <a:rPr sz="2200" b="0">
-                <a:solidFill>
-                  <a:srgbClr val="EEF3F8"/>
-                </a:solidFill>
-                <a:latin typeface="Arial"/>
-              </a:rPr>
-              <a:t>This research is supported by a URS grant at New Mexico State University. Thank you to Dr. Andrew Saydjari for mentorship, and to the developers of ZodiPy and Flux.jl.</a:t>
-            </a:r>
-          </a:p>
-        </p:txBody>
-      </p:sp>
-      <p:sp>
-        <p:nvSpPr>
-          <p:cNvPr id="84" name="Rectangle 83"/>
-          <p:cNvSpPr/>
-          <p:nvPr/>
-        </p:nvSpPr>
-        <p:spPr>
-          <a:xfrm>
-            <a:off x="16824960" y="40873679"/>
-            <a:ext cx="15361920" cy="2560320"/>
-          </a:xfrm>
-          <a:prstGeom prst="rect">
-            <a:avLst/>
-          </a:prstGeom>
-          <a:solidFill>
-            <a:srgbClr val="0F2036"/>
-          </a:solidFill>
-          <a:ln w="38100">
-            <a:solidFill>
-              <a:srgbClr val="2D5A94"/>
-            </a:solidFill>
-          </a:ln>
-          <a:effectLst/>
-        </p:spPr>
-        <p:style>
-          <a:lnRef idx="1">
-            <a:schemeClr val="accent1"/>
-          </a:lnRef>
-          <a:fillRef idx="3">
-            <a:schemeClr val="accent1"/>
-          </a:fillRef>
-          <a:effectRef idx="2">
-            <a:schemeClr val="accent1"/>
-          </a:effectRef>
-          <a:fontRef idx="minor">
-            <a:schemeClr val="lt1"/>
-          </a:fontRef>
-        </p:style>
-        <p:txBody>
-          <a:bodyPr rtlCol="0" anchor="ctr"/>
-          <a:lstStyle/>
-          <a:p>
-            <a:pPr algn="ctr"/>
-          </a:p>
-        </p:txBody>
-      </p:sp>
-      <p:sp>
-        <p:nvSpPr>
-          <p:cNvPr id="85" name="Rectangle 84"/>
-          <p:cNvSpPr/>
-          <p:nvPr/>
-        </p:nvSpPr>
-        <p:spPr>
-          <a:xfrm>
-            <a:off x="16824960" y="40873679"/>
-            <a:ext cx="15361920" cy="777240"/>
-          </a:xfrm>
-          <a:prstGeom prst="rect">
-            <a:avLst/>
-          </a:prstGeom>
-          <a:solidFill>
-            <a:srgbClr val="1E3557"/>
-          </a:solidFill>
-          <a:ln>
-            <a:noFill/>
-          </a:ln>
-          <a:effectLst/>
-        </p:spPr>
-        <p:style>
-          <a:lnRef idx="1">
-            <a:schemeClr val="accent1"/>
-          </a:lnRef>
-          <a:fillRef idx="3">
-            <a:schemeClr val="accent1"/>
-          </a:fillRef>
-          <a:effectRef idx="2">
-            <a:schemeClr val="accent1"/>
-          </a:effectRef>
-          <a:fontRef idx="minor">
-            <a:schemeClr val="lt1"/>
-          </a:fontRef>
-        </p:style>
-        <p:txBody>
-          <a:bodyPr rtlCol="0" anchor="ctr"/>
-          <a:lstStyle/>
-          <a:p>
-            <a:pPr algn="ctr"/>
-          </a:p>
-        </p:txBody>
-      </p:sp>
-      <p:sp>
-        <p:nvSpPr>
-          <p:cNvPr id="86" name="TextBox 85"/>
-          <p:cNvSpPr txBox="1"/>
-          <p:nvPr/>
-        </p:nvSpPr>
-        <p:spPr>
-          <a:xfrm>
-            <a:off x="16824960" y="40873679"/>
-            <a:ext cx="15361920" cy="777240"/>
-          </a:xfrm>
-          <a:prstGeom prst="rect">
-            <a:avLst/>
-          </a:prstGeom>
-          <a:noFill/>
-        </p:spPr>
-        <p:txBody>
-          <a:bodyPr wrap="square" anchor="ctr" lIns="45720" rIns="45720" tIns="18288" bIns="18288">
-            <a:spAutoFit/>
-          </a:bodyPr>
-          <a:lstStyle/>
-          <a:p>
-            <a:pPr algn="ctr">
-              <a:lnSpc>
-                <a:spcPct val="112000"/>
-              </a:lnSpc>
-              <a:spcAft>
-                <a:spcPts val="0"/>
-              </a:spcAft>
-            </a:pPr>
-            <a:r>
-              <a:rPr sz="4000" b="1">
-                <a:solidFill>
-                  <a:srgbClr val="FFFFFF"/>
-                </a:solidFill>
-                <a:latin typeface="Arial"/>
-              </a:rPr>
-              <a:t>References</a:t>
-            </a:r>
-          </a:p>
-        </p:txBody>
-      </p:sp>
-      <p:sp>
-        <p:nvSpPr>
-          <p:cNvPr id="87" name="TextBox 86"/>
-          <p:cNvSpPr txBox="1"/>
-          <p:nvPr/>
-        </p:nvSpPr>
-        <p:spPr>
-          <a:xfrm>
-            <a:off x="17236440" y="41742360"/>
-            <a:ext cx="14538960" cy="1645920"/>
+            <a:off x="17236440" y="41513760"/>
+            <a:ext cx="7086600" cy="1737359"/>
           </a:xfrm>
           <a:prstGeom prst="rect">
             <a:avLst/>
@@ -7492,11 +7311,11 @@
                 <a:spcPct val="100000"/>
               </a:lnSpc>
               <a:spcAft>
-                <a:spcPts val="0"/>
+                <a:spcPts val="600"/>
               </a:spcAft>
             </a:pPr>
             <a:r>
-              <a:rPr sz="1900" b="0">
+              <a:rPr sz="2100" b="0">
                 <a:solidFill>
                   <a:srgbClr val="EEF3F8"/>
                 </a:solidFill>
@@ -7511,11 +7330,11 @@
                 <a:spcPct val="100000"/>
               </a:lnSpc>
               <a:spcAft>
-                <a:spcPts val="0"/>
+                <a:spcPts val="600"/>
               </a:spcAft>
             </a:pPr>
             <a:r>
-              <a:rPr sz="1900" b="0">
+              <a:rPr sz="2100" b="0">
                 <a:solidFill>
                   <a:srgbClr val="EEF3F8"/>
                 </a:solidFill>
@@ -7524,17 +7343,40 @@
               <a:t>San, M., et al. 2022, JOSS, 7, 4602 (ZodiPy)</a:t>
             </a:r>
           </a:p>
+        </p:txBody>
+      </p:sp>
+      <p:sp>
+        <p:nvSpPr>
+          <p:cNvPr id="83" name="TextBox 82"/>
+          <p:cNvSpPr txBox="1"/>
+          <p:nvPr/>
+        </p:nvSpPr>
+        <p:spPr>
+          <a:xfrm>
+            <a:off x="24688800" y="41513760"/>
+            <a:ext cx="7086600" cy="1737359"/>
+          </a:xfrm>
+          <a:prstGeom prst="rect">
+            <a:avLst/>
+          </a:prstGeom>
+          <a:noFill/>
+        </p:spPr>
+        <p:txBody>
+          <a:bodyPr wrap="square" anchor="t" lIns="45720" rIns="45720" tIns="18288" bIns="18288">
+            <a:spAutoFit/>
+          </a:bodyPr>
+          <a:lstStyle/>
           <a:p>
             <a:pPr algn="l">
               <a:lnSpc>
                 <a:spcPct val="100000"/>
               </a:lnSpc>
               <a:spcAft>
-                <a:spcPts val="0"/>
+                <a:spcPts val="600"/>
               </a:spcAft>
             </a:pPr>
             <a:r>
-              <a:rPr sz="1900" b="0">
+              <a:rPr sz="2100" b="0">
                 <a:solidFill>
                   <a:srgbClr val="EEF3F8"/>
                 </a:solidFill>
@@ -7549,11 +7391,11 @@
                 <a:spcPct val="100000"/>
               </a:lnSpc>
               <a:spcAft>
-                <a:spcPts val="0"/>
+                <a:spcPts val="600"/>
               </a:spcAft>
             </a:pPr>
             <a:r>
-              <a:rPr sz="1900" b="0">
+              <a:rPr sz="2100" b="0">
                 <a:solidFill>
                   <a:srgbClr val="EEF3F8"/>
                 </a:solidFill>

</xml_diff>

<commit_message>
Poster v3: sky map of the out-of-sample error replaces the spectra figure; explain map stripes (10152026)
- Thin pole-to-pole grey stripes in the round-16 sky maps are gaps between SPHEREx scan circles (boresight-only
  pointing; e.g. nothing at lon 357-3 deg), not missing days: no time gaps, same columns empty in the whole mission.
- footprint_stat / sky_footprint_fig (shift_helpers.jl): each boresight spread over a 1.75 deg disc (~half a 3.5 deg
  SPHEREx field) on a 1 deg grid; added to 10152026.ipynb (16 cells, runs top to bottom in 2.3 min).
- Poster: Fig. 4 = that map (poster/data_skyerror.jl, interior windows, 364,797 pointings), new text (0.023-0.037%
  for every shift; 0.09% on the ecliptic vs 0.016% near the poles); tile 3 = "<=0.04% for every choice of withheld
  months"; multi-wavelength result moved into the Refine step.

Co-Authored-By: Claude Opus 5.5 <noreply@anthropic.com>
Claude-Session: https://claude.ai/code/session_012rGthNAyzBgnDfYXWSYd8K
</commit_message>
<xml_diff>
--- a/poster/poster_dark.pptx
+++ b/poster/poster_dark.pptx
@@ -547,7 +547,32 @@
           </a:p>
           <a:p>
             <a:r>
-              <a:t>- Multi-wavelength: round-15 'ep300' ensemble, 30-day blocks, 1.25-5.0 um (poster/data_spectra.jl).</a:t>
+              <a:t>- Multi-wavelength (Refine step): round-15 'ep300' ensemble, 30-day blocks, 1.25-5.0 um, ~0.1% median (poster/data_spectra.jl).</a:t>
+            </a:r>
+          </a:p>
+          <a:p>
+            <a:r>
+              <a:t>- Fig. 4 / sky text (poster/data_skyerror.jl, round 16, 10152026 notebook): 30-day split slid by 0,10,...,50 days, 5 seeds each;</a:t>
+            </a:r>
+          </a:p>
+          <a:p>
+            <a:r>
+              <a:t>  interior withheld windows only (training data before and after; 364,797 pointings = 86%), each pointing averaged over the</a:t>
+            </a:r>
+          </a:p>
+          <a:p>
+            <a:r>
+              <a:t>  versions that withheld it. Per-version interior medians 0.023-0.037%. Within 2 deg of the ecliptic 0.094%, above 60 deg 0.016%.</a:t>
+            </a:r>
+          </a:p>
+          <a:p>
+            <a:r>
+              <a:t>  Map: each boresight spread over a 1.75-deg-radius disc on a 1-deg grid (the boresights lie on scan circles a few degrees</a:t>
+            </a:r>
+          </a:p>
+          <a:p>
+            <a:r>
+              <a:t>  apart; without spreading, thin pole-to-pole gaps appear). Windows at the mission's start/end (extrapolation) are excluded.</a:t>
             </a:r>
           </a:p>
           <a:p/>
@@ -5733,7 +5758,7 @@
                 </a:solidFill>
                 <a:latin typeface="Arial"/>
               </a:rPr>
-              <a:t>64</a:t>
+              <a:t>≤0.04%</a:t>
             </a:r>
           </a:p>
         </p:txBody>
@@ -5775,7 +5800,7 @@
                 </a:solidFill>
                 <a:latin typeface="Arial"/>
               </a:rPr>
-              <a:t>wavelengths in</a:t>
+              <a:t>median error for every</a:t>
             </a:r>
           </a:p>
           <a:p>
@@ -5794,7 +5819,7 @@
                 </a:solidFill>
                 <a:latin typeface="Arial"/>
               </a:rPr>
-              <a:t>one network</a:t>
+              <a:t>choice of withheld months</a:t>
             </a:r>
           </a:p>
         </p:txBody>
@@ -5927,7 +5952,7 @@
         <p:spPr>
           <a:xfrm>
             <a:off x="17236440" y="20482560"/>
-            <a:ext cx="14538960" cy="1645920"/>
+            <a:ext cx="14538960" cy="2194560"/>
           </a:xfrm>
           <a:prstGeom prst="rect">
             <a:avLst/>
@@ -5949,29 +5974,29 @@
               </a:spcAft>
             </a:pPr>
             <a:r>
-              <a:rPr sz="2800" b="1">
+              <a:rPr sz="2700" b="1">
                 <a:solidFill>
                   <a:srgbClr val="EEF3F8"/>
                 </a:solidFill>
                 <a:latin typeface="Arial"/>
               </a:rPr>
-              <a:t>Looking forward: every SPHEREx wavelength. </a:t>
-            </a:r>
-            <a:r>
-              <a:rPr sz="2800" b="0">
+              <a:t>Where on the sky are the errors? </a:t>
+            </a:r>
+            <a:r>
+              <a:rPr sz="2700" b="0">
                 <a:solidFill>
                   <a:srgbClr val="EEF3F8"/>
                 </a:solidFill>
                 <a:latin typeface="Arial"/>
               </a:rPr>
-              <a:t>Real SPHEREx images cover many wavelengths, so wavelength becomes one more input. A first version covering 1.25–5 μm already reaches ~0.1% median error on the same withheld months.</a:t>
+              <a:t>We repeated the test six times, sliding which months were withheld, so almost every pointing was tested by networks that never saw it. Every version reached 0.023–0.037% median error. The errors are largest along the plane of the planets, where the dust bands are (0.09%), and smallest toward the poles (0.016%).</a:t>
             </a:r>
           </a:p>
         </p:txBody>
       </p:sp>
       <p:pic>
         <p:nvPicPr>
-          <p:cNvPr id="53" name="Picture 52" descr="spectra_dark.png"/>
+          <p:cNvPr id="53" name="Picture 52" descr="skyerror_dark.png"/>
           <p:cNvPicPr>
             <a:picLocks noChangeAspect="1"/>
           </p:cNvPicPr>
@@ -5985,8 +6010,8 @@
         </p:blipFill>
         <p:spPr>
           <a:xfrm>
-            <a:off x="18093690" y="22037040"/>
-            <a:ext cx="12824460" cy="8549640"/>
+            <a:off x="17236440" y="22677120"/>
+            <a:ext cx="14538960" cy="7366406"/>
           </a:xfrm>
           <a:prstGeom prst="rect">
             <a:avLst/>
@@ -6001,8 +6026,8 @@
         </p:nvSpPr>
         <p:spPr>
           <a:xfrm>
-            <a:off x="17236440" y="30586680"/>
-            <a:ext cx="14538960" cy="914400"/>
+            <a:off x="17236440" y="30043526"/>
+            <a:ext cx="14538960" cy="1188720"/>
           </a:xfrm>
           <a:prstGeom prst="rect">
             <a:avLst/>
@@ -6039,7 +6064,7 @@
                 </a:solidFill>
                 <a:latin typeface="Arial"/>
               </a:rPr>
-              <a:t>Brightness vs. wavelength for three pointings: ZodiPy (solid) and the network (dashed). Below 3 μm we see scattered sunlight; above, the dust's heat. Bottom: the differences stay under 1%.</a:t>
+              <a:t>The network's error on pointings it never saw, across the whole sky (plane of the planets across the middle). Each pointing is drawn as a 3.5°-wide patch, about the width of SPHEREx's view. Grey: not observed in the 140 days, or only at the very start or end of the mission.</a:t>
             </a:r>
           </a:p>
         </p:txBody>
@@ -6517,7 +6542,7 @@
                 </a:solidFill>
                 <a:latin typeface="Arial"/>
               </a:rPr>
-              <a:t>Longer training; all SPHEREx wavelengths (0.75–5 μm)</a:t>
+              <a:t>Longer training; all SPHEREx wavelengths (a first 1.25–5 μm version: ~0.1% error)</a:t>
             </a:r>
           </a:p>
         </p:txBody>

</xml_diff>

<commit_message>
Poster v4: bullet-point text, two new figures (train/test MSE, shifted windows), author line
- All section text as short bullets (H/B helpers in build_poster.py); captions shortened; the 9-input list and
  the banner unchanged. Authors: "Mark Burch and Andrew Saydjari".
- New Fig. 3 (poster/data_training.jl): per-epoch train and test MSE of the 5 networks, whole months withheld.
- New Fig. 5: the six shifted 30-day splits (round 16) with median error between training months / at the ends.
- Layout: Fig. 2 beside the geometry bullets, Fig. 3 beside the training bullets; results figures sized to fit.

Co-Authored-By: Claude Opus 5.5 <noreply@anthropic.com>
Claude-Session: https://claude.ai/code/session_012rGthNAyzBgnDfYXWSYd8K
</commit_message>
<xml_diff>
--- a/poster/poster_dark.pptx
+++ b/poster/poster_dark.pptx
@@ -517,11 +517,6 @@
           </a:p>
           <a:p>
             <a:r>
-              <a:t>- Author line: middle initial / 'Dr.' style for the mentor.</a:t>
-            </a:r>
-          </a:p>
-          <a:p>
-            <a:r>
               <a:t>- Fig. 2: Jupiter and the Moon are drawn for context; the poster's model inputs are n.S n.z n.E n.vS n.vE n.x_E n.y_E sin/cos(lambda_E) (no Jupiter, no Moon).</a:t>
             </a:r>
           </a:p>
@@ -537,42 +532,57 @@
           </a:p>
           <a:p>
             <a:r>
-              <a:t>  Random 10% withheld: median 0.015%. Last 20% of the mission (days 111-140, older season inputs): median 0.10%, p95 0.67%.</a:t>
-            </a:r>
-          </a:p>
-          <a:p>
-            <a:r>
-              <a:t>  Errors are relative to ZodiPy (the Kelsall model), not the real sky.</a:t>
+              <a:t>  Random 10% withheld: median 0.015%. Errors are relative to ZodiPy (the Kelsall model), not the real sky.</a:t>
+            </a:r>
+          </a:p>
+          <a:p>
+            <a:r>
+              <a:t>- Fig. 3 (poster/data_training.jl): per-epoch MSE of each network on its training data and on the withheld data; final mean</a:t>
+            </a:r>
+          </a:p>
+          <a:p>
+            <a:r>
+              <a:t>  train/test MSE 1.2e-7 / 2.3e-7 (MJy/sr)^2 for the 30-day split, 6.2e-8 / 5.9e-8 for the random 10%.</a:t>
+            </a:r>
+          </a:p>
+          <a:p>
+            <a:r>
+              <a:t>- Fig. 5 (round 16, 10152026 notebook): the 30-day split slid by 0, 10, ..., 50 days, 5 seeds each. Red = withheld windows</a:t>
+            </a:r>
+          </a:p>
+          <a:p>
+            <a:r>
+              <a:t>  with training data before and after (interpolation): 0.023-0.037%. Orange = withheld windows at the mission's start/end</a:t>
+            </a:r>
+          </a:p>
+          <a:p>
+            <a:r>
+              <a:t>  (extrapolation in time): 10 days 0.03-0.04%, 20-30 days 0.11-0.22% median.</a:t>
+            </a:r>
+          </a:p>
+          <a:p>
+            <a:r>
+              <a:t>- Fig. 6 (poster/data_skyerror.jl): red (interior) windows only, 364,797 pointings (86%), each averaged over the versions</a:t>
+            </a:r>
+          </a:p>
+          <a:p>
+            <a:r>
+              <a:t>  that withheld it. Within 2 deg of the ecliptic 0.094%, above 60 deg 0.016%. Map: each boresight spread over a</a:t>
+            </a:r>
+          </a:p>
+          <a:p>
+            <a:r>
+              <a:t>  1.75-deg-radius disc on a 1-deg grid (boresights lie on scan circles a few degrees apart; without spreading, thin</a:t>
+            </a:r>
+          </a:p>
+          <a:p>
+            <a:r>
+              <a:t>  pole-to-pole gaps appear).</a:t>
             </a:r>
           </a:p>
           <a:p>
             <a:r>
               <a:t>- Multi-wavelength (Refine step): round-15 'ep300' ensemble, 30-day blocks, 1.25-5.0 um, ~0.1% median (poster/data_spectra.jl).</a:t>
-            </a:r>
-          </a:p>
-          <a:p>
-            <a:r>
-              <a:t>- Fig. 4 / sky text (poster/data_skyerror.jl, round 16, 10152026 notebook): 30-day split slid by 0,10,...,50 days, 5 seeds each;</a:t>
-            </a:r>
-          </a:p>
-          <a:p>
-            <a:r>
-              <a:t>  interior withheld windows only (training data before and after; 364,797 pointings = 86%), each pointing averaged over the</a:t>
-            </a:r>
-          </a:p>
-          <a:p>
-            <a:r>
-              <a:t>  versions that withheld it. Per-version interior medians 0.023-0.037%. Within 2 deg of the ecliptic 0.094%, above 60 deg 0.016%.</a:t>
-            </a:r>
-          </a:p>
-          <a:p>
-            <a:r>
-              <a:t>  Map: each boresight spread over a 1.75-deg-radius disc on a 1-deg grid (the boresights lie on scan circles a few degrees</a:t>
-            </a:r>
-          </a:p>
-          <a:p>
-            <a:r>
-              <a:t>  apart; without spreading, thin pole-to-pole gaps appear). Windows at the mission's start/end (extrapolation) are excluded.</a:t>
             </a:r>
           </a:p>
           <a:p/>
@@ -3800,7 +3810,7 @@
                 </a:solidFill>
                 <a:latin typeface="Arial"/>
               </a:rPr>
-              <a:t>Mark A. Burch and Dr. Andrew Saydjari</a:t>
+              <a:t>Mark Burch and Andrew Saydjari</a:t>
             </a:r>
           </a:p>
           <a:p>
@@ -3921,7 +3931,7 @@
         <p:spPr>
           <a:xfrm>
             <a:off x="731520" y="7223760"/>
-            <a:ext cx="15361920" cy="10561319"/>
+            <a:ext cx="15361920" cy="9966301"/>
           </a:xfrm>
           <a:prstGeom prst="rect">
             <a:avLst/>
@@ -4053,7 +4063,7 @@
         <p:spPr>
           <a:xfrm>
             <a:off x="1143000" y="8595360"/>
-            <a:ext cx="14538960" cy="2011680"/>
+            <a:ext cx="14538960" cy="1986076"/>
           </a:xfrm>
           <a:prstGeom prst="rect">
             <a:avLst/>
@@ -4066,49 +4076,111 @@
           </a:bodyPr>
           <a:lstStyle/>
           <a:p>
-            <a:pPr algn="l">
+            <a:pPr algn="l" marL="384048" indent="-384048">
               <a:lnSpc>
-                <a:spcPct val="112000"/>
+                <a:spcPct val="108000"/>
               </a:lnSpc>
               <a:spcAft>
-                <a:spcPts val="1000"/>
+                <a:spcPts val="600"/>
               </a:spcAft>
+              <a:buClr>
+                <a:srgbClr val="FF6F91"/>
+              </a:buClr>
+              <a:buFont typeface="Arial"/>
+              <a:buChar char="•"/>
             </a:pPr>
             <a:r>
-              <a:rPr sz="2800" b="1">
+              <a:rPr sz="2600" b="1">
                 <a:solidFill>
                   <a:srgbClr val="EEF3F8"/>
                 </a:solidFill>
                 <a:latin typeface="Arial"/>
               </a:rPr>
-              <a:t>SPHEREx</a:t>
-            </a:r>
-            <a:r>
-              <a:rPr sz="2800" b="0">
+              <a:t>SPHEREx: </a:t>
+            </a:r>
+            <a:r>
+              <a:rPr sz="2600" b="0">
                 <a:solidFill>
                   <a:srgbClr val="EEF3F8"/>
                 </a:solidFill>
                 <a:latin typeface="Arial"/>
               </a:rPr>
-              <a:t> is a NASA space telescope, launched in March 2025, that maps the </a:t>
-            </a:r>
-            <a:r>
-              <a:rPr sz="2800" b="1">
+              <a:t>NASA space telescope, launched in March 2025</a:t>
+            </a:r>
+          </a:p>
+          <a:p>
+            <a:pPr algn="l" marL="384048" indent="-384048">
+              <a:lnSpc>
+                <a:spcPct val="108000"/>
+              </a:lnSpc>
+              <a:spcAft>
+                <a:spcPts val="600"/>
+              </a:spcAft>
+              <a:buClr>
+                <a:srgbClr val="FF6F91"/>
+              </a:buClr>
+              <a:buFont typeface="Arial"/>
+              <a:buChar char="•"/>
+            </a:pPr>
+            <a:r>
+              <a:rPr sz="2600" b="0">
                 <a:solidFill>
                   <a:srgbClr val="EEF3F8"/>
                 </a:solidFill>
                 <a:latin typeface="Arial"/>
               </a:rPr>
+              <a:t>Maps the </a:t>
+            </a:r>
+            <a:r>
+              <a:rPr sz="2600" b="1">
+                <a:solidFill>
+                  <a:srgbClr val="EEF3F8"/>
+                </a:solidFill>
+                <a:latin typeface="Arial"/>
+              </a:rPr>
               <a:t>entire sky across a range of infrared wavelengths</a:t>
             </a:r>
             <a:r>
-              <a:rPr sz="2800" b="0">
+              <a:rPr sz="2600" b="0">
                 <a:solidFill>
                   <a:srgbClr val="EEF3F8"/>
                 </a:solidFill>
                 <a:latin typeface="Arial"/>
               </a:rPr>
-              <a:t> (0.75–5 μm). Its maps will help explain how the universe began, how galaxies formed, and where water and other ingredients for life are found.</a:t>
+              <a:t> (0.75–5 μm)</a:t>
+            </a:r>
+          </a:p>
+          <a:p>
+            <a:pPr algn="l" marL="384048" indent="-384048">
+              <a:lnSpc>
+                <a:spcPct val="108000"/>
+              </a:lnSpc>
+              <a:spcAft>
+                <a:spcPts val="600"/>
+              </a:spcAft>
+              <a:buClr>
+                <a:srgbClr val="FF6F91"/>
+              </a:buClr>
+              <a:buFont typeface="Arial"/>
+              <a:buChar char="•"/>
+            </a:pPr>
+            <a:r>
+              <a:rPr sz="2600" b="1">
+                <a:solidFill>
+                  <a:srgbClr val="EEF3F8"/>
+                </a:solidFill>
+                <a:latin typeface="Arial"/>
+              </a:rPr>
+              <a:t>Science: </a:t>
+            </a:r>
+            <a:r>
+              <a:rPr sz="2600" b="0">
+                <a:solidFill>
+                  <a:srgbClr val="EEF3F8"/>
+                </a:solidFill>
+                <a:latin typeface="Arial"/>
+              </a:rPr>
+              <a:t>how the universe began, how galaxies formed, and where water and other ingredients for life are found</a:t>
             </a:r>
           </a:p>
         </p:txBody>
@@ -4121,8 +4193,8 @@
         </p:nvSpPr>
         <p:spPr>
           <a:xfrm>
-            <a:off x="1143000" y="10652760"/>
-            <a:ext cx="6833311" cy="6949439"/>
+            <a:off x="1143000" y="10672876"/>
+            <a:ext cx="7705648" cy="5932627"/>
           </a:xfrm>
           <a:prstGeom prst="rect">
             <a:avLst/>
@@ -4139,27 +4211,102 @@
               <a:lnSpc>
                 <a:spcPct val="108000"/>
               </a:lnSpc>
+              <a:spcBef>
+                <a:spcPts val="0"/>
+              </a:spcBef>
               <a:spcAft>
-                <a:spcPts val="800"/>
+                <a:spcPts val="600"/>
               </a:spcAft>
             </a:pPr>
             <a:r>
-              <a:rPr sz="2500" b="1">
+              <a:rPr sz="2600" b="1">
+                <a:solidFill>
+                  <a:srgbClr val="5FB0FF"/>
+                </a:solidFill>
+                <a:latin typeface="Arial"/>
+              </a:rPr>
+              <a:t>Zodiacal light</a:t>
+            </a:r>
+          </a:p>
+          <a:p>
+            <a:pPr algn="l" marL="384048" indent="-384048">
+              <a:lnSpc>
+                <a:spcPct val="108000"/>
+              </a:lnSpc>
+              <a:spcAft>
+                <a:spcPts val="600"/>
+              </a:spcAft>
+              <a:buClr>
+                <a:srgbClr val="FF6F91"/>
+              </a:buClr>
+              <a:buFont typeface="Arial"/>
+              <a:buChar char="•"/>
+            </a:pPr>
+            <a:r>
+              <a:rPr sz="2400" b="0">
                 <a:solidFill>
                   <a:srgbClr val="EEF3F8"/>
                 </a:solidFill>
                 <a:latin typeface="Arial"/>
               </a:rPr>
-              <a:t>Zodiacal light. </a:t>
-            </a:r>
-            <a:r>
-              <a:rPr sz="2500" b="0">
+              <a:t>Sunlight scattered by dust from comets and asteroids, plus the dust's heat glow (Fig. 1)</a:t>
+            </a:r>
+          </a:p>
+          <a:p>
+            <a:pPr algn="l" marL="384048" indent="-384048">
+              <a:lnSpc>
+                <a:spcPct val="108000"/>
+              </a:lnSpc>
+              <a:spcAft>
+                <a:spcPts val="600"/>
+              </a:spcAft>
+              <a:buClr>
+                <a:srgbClr val="FF6F91"/>
+              </a:buClr>
+              <a:buFont typeface="Arial"/>
+              <a:buChar char="•"/>
+            </a:pPr>
+            <a:r>
+              <a:rPr sz="2400" b="0">
                 <a:solidFill>
                   <a:srgbClr val="EEF3F8"/>
                 </a:solidFill>
                 <a:latin typeface="Arial"/>
               </a:rPr>
-              <a:t>The Solar System is filled with a thin cloud of dust from comets and asteroids. Sunlight scattered by this dust, plus the dust's own heat glow, adds a smooth glow across every SPHEREx image (Fig. 1). It is bright enough to be confused with the faint background light from distant galaxies, and it changes with where the telescope looks and where Earth is in its orbit, so it must be carefully modeled and removed.</a:t>
+              <a:t>Bright enough to be confused with faint light from distant galaxies</a:t>
+            </a:r>
+          </a:p>
+          <a:p>
+            <a:pPr algn="l" marL="384048" indent="-384048">
+              <a:lnSpc>
+                <a:spcPct val="108000"/>
+              </a:lnSpc>
+              <a:spcAft>
+                <a:spcPts val="600"/>
+              </a:spcAft>
+              <a:buClr>
+                <a:srgbClr val="FF6F91"/>
+              </a:buClr>
+              <a:buFont typeface="Arial"/>
+              <a:buChar char="•"/>
+            </a:pPr>
+            <a:r>
+              <a:rPr sz="2400" b="0">
+                <a:solidFill>
+                  <a:srgbClr val="EEF3F8"/>
+                </a:solidFill>
+                <a:latin typeface="Arial"/>
+              </a:rPr>
+              <a:t>Changes with look direction and Earth's place in orbit → </a:t>
+            </a:r>
+            <a:r>
+              <a:rPr sz="2400" b="1">
+                <a:solidFill>
+                  <a:srgbClr val="EEF3F8"/>
+                </a:solidFill>
+                <a:latin typeface="Arial"/>
+              </a:rPr>
+              <a:t>must be modeled and removed</a:t>
             </a:r>
           </a:p>
           <a:p>
@@ -4167,45 +4314,78 @@
               <a:lnSpc>
                 <a:spcPct val="108000"/>
               </a:lnSpc>
+              <a:spcBef>
+                <a:spcPts val="600"/>
+              </a:spcBef>
               <a:spcAft>
-                <a:spcPts val="800"/>
+                <a:spcPts val="600"/>
               </a:spcAft>
             </a:pPr>
             <a:r>
-              <a:rPr sz="2500" b="1">
+              <a:rPr sz="2600" b="1">
+                <a:solidFill>
+                  <a:srgbClr val="5FB0FF"/>
+                </a:solidFill>
+                <a:latin typeface="Arial"/>
+              </a:rPr>
+              <a:t>The Kelsall model</a:t>
+            </a:r>
+          </a:p>
+          <a:p>
+            <a:pPr algn="l" marL="384048" indent="-384048">
+              <a:lnSpc>
+                <a:spcPct val="108000"/>
+              </a:lnSpc>
+              <a:spcAft>
+                <a:spcPts val="600"/>
+              </a:spcAft>
+              <a:buClr>
+                <a:srgbClr val="FF6F91"/>
+              </a:buClr>
+              <a:buFont typeface="Arial"/>
+              <a:buChar char="•"/>
+            </a:pPr>
+            <a:r>
+              <a:rPr sz="2400" b="0">
                 <a:solidFill>
                   <a:srgbClr val="EEF3F8"/>
                 </a:solidFill>
                 <a:latin typeface="Arial"/>
               </a:rPr>
-              <a:t>The Kelsall model. </a:t>
-            </a:r>
-            <a:r>
-              <a:rPr sz="2500" b="0">
+              <a:t>Standard dust model (Kelsall et al. 1998, NASA's COBE): smooth cloud, three dust bands, a ring around the Sun, a clump trailing Earth</a:t>
+            </a:r>
+          </a:p>
+          <a:p>
+            <a:pPr algn="l" marL="384048" indent="-384048">
+              <a:lnSpc>
+                <a:spcPct val="108000"/>
+              </a:lnSpc>
+              <a:spcAft>
+                <a:spcPts val="600"/>
+              </a:spcAft>
+              <a:buClr>
+                <a:srgbClr val="FF6F91"/>
+              </a:buClr>
+              <a:buFont typeface="Arial"/>
+              <a:buChar char="•"/>
+            </a:pPr>
+            <a:r>
+              <a:rPr sz="2400" b="1">
                 <a:solidFill>
                   <a:srgbClr val="EEF3F8"/>
                 </a:solidFill>
                 <a:latin typeface="Arial"/>
               </a:rPr>
-              <a:t>Kelsall et al. (1998) built the standard model of this dust from NASA's COBE satellite: a smooth cloud, three dust bands, a ring around the Sun and a clump trailing Earth. The software </a:t>
-            </a:r>
-            <a:r>
-              <a:rPr sz="2500" b="1">
+              <a:t>ZodiPy</a:t>
+            </a:r>
+            <a:r>
+              <a:rPr sz="2400" b="0">
                 <a:solidFill>
                   <a:srgbClr val="EEF3F8"/>
                 </a:solidFill>
                 <a:latin typeface="Arial"/>
               </a:rPr>
-              <a:t>ZodiPy</a:t>
-            </a:r>
-            <a:r>
-              <a:rPr sz="2500" b="0">
-                <a:solidFill>
-                  <a:srgbClr val="EEF3F8"/>
-                </a:solidFill>
-                <a:latin typeface="Arial"/>
-              </a:rPr>
-              <a:t> computes what a telescope would see from it; we use it to simulate SPHEREx data.</a:t>
+              <a:t> computes what a telescope sees; we use it to simulate SPHEREx data</a:t>
             </a:r>
           </a:p>
         </p:txBody>
@@ -4226,8 +4406,8 @@
         </p:blipFill>
         <p:spPr>
           <a:xfrm>
-            <a:off x="8296351" y="10835640"/>
-            <a:ext cx="7385608" cy="4431365"/>
+            <a:off x="9122968" y="10947196"/>
+            <a:ext cx="6558991" cy="3935394"/>
           </a:xfrm>
           <a:prstGeom prst="rect">
             <a:avLst/>
@@ -4242,8 +4422,8 @@
         </p:nvSpPr>
         <p:spPr>
           <a:xfrm>
-            <a:off x="8296351" y="15358445"/>
-            <a:ext cx="7385608" cy="1463040"/>
+            <a:off x="9122968" y="14974031"/>
+            <a:ext cx="6558991" cy="1453896"/>
           </a:xfrm>
           <a:prstGeom prst="rect">
             <a:avLst/>
@@ -4261,7 +4441,7 @@
                 <a:spcPct val="105000"/>
               </a:lnSpc>
               <a:spcAft>
-                <a:spcPts val="1000"/>
+                <a:spcPts val="0"/>
               </a:spcAft>
             </a:pPr>
             <a:r>
@@ -4280,7 +4460,7 @@
                 </a:solidFill>
                 <a:latin typeface="Arial"/>
               </a:rPr>
-              <a:t>The whole sky at 5 μm as seen from SPHEREx (ZodiPy). The glow is brightest toward the Sun and along the plane of the planets. Grey: too close to the Sun to observe.</a:t>
+              <a:t>The whole sky at 5 μm from SPHEREx (ZodiPy): brightest toward the Sun and along the plane of the planets. Grey: too close to the Sun to observe.</a:t>
             </a:r>
           </a:p>
         </p:txBody>
@@ -4293,8 +4473,8 @@
         </p:nvSpPr>
         <p:spPr>
           <a:xfrm>
-            <a:off x="731520" y="18196560"/>
-            <a:ext cx="15361920" cy="3063240"/>
+            <a:off x="731520" y="17601541"/>
+            <a:ext cx="15361920" cy="3480657"/>
           </a:xfrm>
           <a:prstGeom prst="rect">
             <a:avLst/>
@@ -4339,8 +4519,8 @@
         </p:nvSpPr>
         <p:spPr>
           <a:xfrm>
-            <a:off x="1143000" y="18425160"/>
-            <a:ext cx="14538960" cy="2697480"/>
+            <a:off x="1143000" y="17802709"/>
+            <a:ext cx="7040880" cy="2440838"/>
           </a:xfrm>
           <a:prstGeom prst="rect">
             <a:avLst/>
@@ -4355,107 +4535,205 @@
           <a:p>
             <a:pPr algn="l">
               <a:lnSpc>
-                <a:spcPct val="112000"/>
+                <a:spcPct val="108000"/>
+              </a:lnSpc>
+              <a:spcBef>
+                <a:spcPts val="0"/>
+              </a:spcBef>
+              <a:spcAft>
+                <a:spcPts val="600"/>
+              </a:spcAft>
+            </a:pPr>
+            <a:r>
+              <a:rPr sz="2700" b="1">
+                <a:solidFill>
+                  <a:srgbClr val="5FB0FF"/>
+                </a:solidFill>
+                <a:latin typeface="Arial"/>
+              </a:rPr>
+              <a:t>The problem</a:t>
+            </a:r>
+          </a:p>
+          <a:p>
+            <a:pPr algn="l" marL="384048" indent="-384048">
+              <a:lnSpc>
+                <a:spcPct val="108000"/>
               </a:lnSpc>
               <a:spcAft>
-                <a:spcPts val="1200"/>
+                <a:spcPts val="600"/>
+              </a:spcAft>
+              <a:buClr>
+                <a:srgbClr val="FF6F91"/>
+              </a:buClr>
+              <a:buFont typeface="Arial"/>
+              <a:buChar char="•"/>
+            </a:pPr>
+            <a:r>
+              <a:rPr sz="2500" b="0">
+                <a:solidFill>
+                  <a:srgbClr val="EEF3F8"/>
+                </a:solidFill>
+                <a:latin typeface="Arial"/>
+              </a:rPr>
+              <a:t>Zodiacal light must be removed from every SPHEREx image</a:t>
+            </a:r>
+          </a:p>
+          <a:p>
+            <a:pPr algn="l" marL="384048" indent="-384048">
+              <a:lnSpc>
+                <a:spcPct val="108000"/>
+              </a:lnSpc>
+              <a:spcAft>
+                <a:spcPts val="600"/>
+              </a:spcAft>
+              <a:buClr>
+                <a:srgbClr val="FF6F91"/>
+              </a:buClr>
+              <a:buFont typeface="Arial"/>
+              <a:buChar char="•"/>
+            </a:pPr>
+            <a:r>
+              <a:rPr sz="2500" b="0">
+                <a:solidFill>
+                  <a:srgbClr val="EEF3F8"/>
+                </a:solidFill>
+                <a:latin typeface="Arial"/>
+              </a:rPr>
+              <a:t>Physics models such as Kelsall's were fit to older data and leave errors behind</a:t>
+            </a:r>
+          </a:p>
+        </p:txBody>
+      </p:sp>
+      <p:sp>
+        <p:nvSpPr>
+          <p:cNvPr id="19" name="TextBox 18"/>
+          <p:cNvSpPr txBox="1"/>
+          <p:nvPr/>
+        </p:nvSpPr>
+        <p:spPr>
+          <a:xfrm>
+            <a:off x="8641080" y="17802709"/>
+            <a:ext cx="7040880" cy="2852318"/>
+          </a:xfrm>
+          <a:prstGeom prst="rect">
+            <a:avLst/>
+          </a:prstGeom>
+          <a:noFill/>
+        </p:spPr>
+        <p:txBody>
+          <a:bodyPr wrap="square" anchor="t" lIns="45720" rIns="45720" tIns="18288" bIns="18288">
+            <a:spAutoFit/>
+          </a:bodyPr>
+          <a:lstStyle/>
+          <a:p>
+            <a:pPr algn="l">
+              <a:lnSpc>
+                <a:spcPct val="108000"/>
+              </a:lnSpc>
+              <a:spcBef>
+                <a:spcPts val="0"/>
+              </a:spcBef>
+              <a:spcAft>
+                <a:spcPts val="600"/>
               </a:spcAft>
             </a:pPr>
             <a:r>
-              <a:rPr sz="2800" b="1">
-                <a:solidFill>
-                  <a:srgbClr val="EEF3F8"/>
-                </a:solidFill>
-                <a:latin typeface="Arial"/>
-              </a:rPr>
-              <a:t>The problem: </a:t>
-            </a:r>
-            <a:r>
-              <a:rPr sz="2800" b="0">
-                <a:solidFill>
-                  <a:srgbClr val="EEF3F8"/>
-                </a:solidFill>
-                <a:latin typeface="Arial"/>
-              </a:rPr>
-              <a:t>zodiacal light must be removed from every SPHEREx image, but physics models such as Kelsall's were fit to older data and leave errors behind.</a:t>
-            </a:r>
-          </a:p>
-          <a:p>
-            <a:pPr algn="l">
+              <a:rPr sz="2700" b="1">
+                <a:solidFill>
+                  <a:srgbClr val="5FB0FF"/>
+                </a:solidFill>
+                <a:latin typeface="Arial"/>
+              </a:rPr>
+              <a:t>Research objective</a:t>
+            </a:r>
+          </a:p>
+          <a:p>
+            <a:pPr algn="l" marL="384048" indent="-384048">
               <a:lnSpc>
-                <a:spcPct val="112000"/>
+                <a:spcPct val="108000"/>
               </a:lnSpc>
               <a:spcAft>
-                <a:spcPts val="1200"/>
+                <a:spcPts val="600"/>
               </a:spcAft>
+              <a:buClr>
+                <a:srgbClr val="FF6F91"/>
+              </a:buClr>
+              <a:buFont typeface="Arial"/>
+              <a:buChar char="•"/>
             </a:pPr>
             <a:r>
-              <a:rPr sz="2800" b="1">
+              <a:rPr sz="2500" b="0">
                 <a:solidFill>
                   <a:srgbClr val="EEF3F8"/>
                 </a:solidFill>
                 <a:latin typeface="Arial"/>
               </a:rPr>
-              <a:t>Research objective: </a:t>
-            </a:r>
-            <a:r>
-              <a:rPr sz="2800" b="0">
+              <a:t>Build a </a:t>
+            </a:r>
+            <a:r>
+              <a:rPr sz="2500" b="1">
                 <a:solidFill>
                   <a:srgbClr val="EEF3F8"/>
                 </a:solidFill>
                 <a:latin typeface="Arial"/>
               </a:rPr>
-              <a:t>build a </a:t>
-            </a:r>
-            <a:r>
-              <a:rPr sz="2800" b="1">
+              <a:t>geometrically constrained</a:t>
+            </a:r>
+            <a:r>
+              <a:rPr sz="2500" b="0">
                 <a:solidFill>
                   <a:srgbClr val="EEF3F8"/>
                 </a:solidFill>
                 <a:latin typeface="Arial"/>
               </a:rPr>
-              <a:t>geometrically constrained</a:t>
-            </a:r>
-            <a:r>
-              <a:rPr sz="2800" b="0">
+              <a:t> neural network that learns zodiacal light from SPHEREx data and </a:t>
+            </a:r>
+            <a:r>
+              <a:rPr sz="2500" b="1">
                 <a:solidFill>
                   <a:srgbClr val="EEF3F8"/>
                 </a:solidFill>
                 <a:latin typeface="Arial"/>
               </a:rPr>
-              <a:t> neural network that learns the zodiacal light directly from SPHEREx data and </a:t>
-            </a:r>
-            <a:r>
-              <a:rPr sz="2800" b="1">
+              <a:t>outperforms the Kelsall model</a:t>
+            </a:r>
+          </a:p>
+          <a:p>
+            <a:pPr algn="l" marL="384048" indent="-384048">
+              <a:lnSpc>
+                <a:spcPct val="108000"/>
+              </a:lnSpc>
+              <a:spcAft>
+                <a:spcPts val="600"/>
+              </a:spcAft>
+              <a:buClr>
+                <a:srgbClr val="FF6F91"/>
+              </a:buClr>
+              <a:buFont typeface="Arial"/>
+              <a:buChar char="•"/>
+            </a:pPr>
+            <a:r>
+              <a:rPr sz="2500" b="0">
                 <a:solidFill>
                   <a:srgbClr val="EEF3F8"/>
                 </a:solidFill>
                 <a:latin typeface="Arial"/>
               </a:rPr>
-              <a:t>outperforms the Kelsall model</a:t>
-            </a:r>
-            <a:r>
-              <a:rPr sz="2800" b="0">
-                <a:solidFill>
-                  <a:srgbClr val="EEF3F8"/>
-                </a:solidFill>
-                <a:latin typeface="Arial"/>
-              </a:rPr>
-              <a:t>. First step (this poster): show that it can learn ZodiPy's simulated sky from geometry alone.</a:t>
-            </a:r>
-          </a:p>
-        </p:txBody>
-      </p:sp>
-      <p:sp>
-        <p:nvSpPr>
-          <p:cNvPr id="19" name="Rectangle 18"/>
+              <a:t>First step (this poster): learn ZodiPy's simulated sky from geometry alone</a:t>
+            </a:r>
+          </a:p>
+        </p:txBody>
+      </p:sp>
+      <p:sp>
+        <p:nvSpPr>
+          <p:cNvPr id="20" name="Rectangle 19"/>
           <p:cNvSpPr/>
           <p:nvPr/>
         </p:nvSpPr>
         <p:spPr>
           <a:xfrm>
-            <a:off x="731520" y="21671280"/>
-            <a:ext cx="15361920" cy="18562320"/>
+            <a:off x="731520" y="21493679"/>
+            <a:ext cx="15361920" cy="18739920"/>
           </a:xfrm>
           <a:prstGeom prst="rect">
             <a:avLst/>
@@ -4494,13 +4772,13 @@
       </p:sp>
       <p:sp>
         <p:nvSpPr>
-          <p:cNvPr id="20" name="Rectangle 19"/>
+          <p:cNvPr id="21" name="Rectangle 20"/>
           <p:cNvSpPr/>
           <p:nvPr/>
         </p:nvSpPr>
         <p:spPr>
           <a:xfrm>
-            <a:off x="731520" y="21671280"/>
+            <a:off x="731520" y="21493679"/>
             <a:ext cx="15361920" cy="1051560"/>
           </a:xfrm>
           <a:prstGeom prst="rect">
@@ -4538,13 +4816,13 @@
       </p:sp>
       <p:sp>
         <p:nvSpPr>
-          <p:cNvPr id="21" name="TextBox 20"/>
+          <p:cNvPr id="22" name="TextBox 21"/>
           <p:cNvSpPr txBox="1"/>
           <p:nvPr/>
         </p:nvSpPr>
         <p:spPr>
           <a:xfrm>
-            <a:off x="731520" y="21671280"/>
+            <a:off x="731520" y="21493679"/>
             <a:ext cx="15361920" cy="1051560"/>
           </a:xfrm>
           <a:prstGeom prst="rect">
@@ -4580,14 +4858,14 @@
       </p:sp>
       <p:sp>
         <p:nvSpPr>
-          <p:cNvPr id="22" name="TextBox 21"/>
+          <p:cNvPr id="23" name="TextBox 22"/>
           <p:cNvSpPr txBox="1"/>
           <p:nvPr/>
         </p:nvSpPr>
         <p:spPr>
           <a:xfrm>
-            <a:off x="1143000" y="23042880"/>
-            <a:ext cx="14538960" cy="2377440"/>
+            <a:off x="1143000" y="23479725"/>
+            <a:ext cx="6268212" cy="4574438"/>
           </a:xfrm>
           <a:prstGeom prst="rect">
             <a:avLst/>
@@ -4602,36 +4880,120 @@
           <a:p>
             <a:pPr algn="l">
               <a:lnSpc>
-                <a:spcPct val="112000"/>
+                <a:spcPct val="108000"/>
+              </a:lnSpc>
+              <a:spcBef>
+                <a:spcPts val="0"/>
+              </a:spcBef>
+              <a:spcAft>
+                <a:spcPts val="600"/>
+              </a:spcAft>
+            </a:pPr>
+            <a:r>
+              <a:rPr sz="2700" b="1">
+                <a:solidFill>
+                  <a:srgbClr val="5FB0FF"/>
+                </a:solidFill>
+                <a:latin typeface="Arial"/>
+              </a:rPr>
+              <a:t>A geometrically constrained model</a:t>
+            </a:r>
+          </a:p>
+          <a:p>
+            <a:pPr algn="l" marL="384048" indent="-384048">
+              <a:lnSpc>
+                <a:spcPct val="108000"/>
               </a:lnSpc>
               <a:spcAft>
-                <a:spcPts val="1000"/>
+                <a:spcPts val="600"/>
               </a:spcAft>
+              <a:buClr>
+                <a:srgbClr val="FF6F91"/>
+              </a:buClr>
+              <a:buFont typeface="Arial"/>
+              <a:buChar char="•"/>
             </a:pPr>
             <a:r>
-              <a:rPr sz="2700" b="1">
+              <a:rPr sz="2500" b="0">
                 <a:solidFill>
                   <a:srgbClr val="EEF3F8"/>
                 </a:solidFill>
                 <a:latin typeface="Arial"/>
               </a:rPr>
-              <a:t>A geometrically constrained model. </a:t>
-            </a:r>
-            <a:r>
-              <a:rPr sz="2700" b="0">
+              <a:t>No dates and no sky-map positions as inputs</a:t>
+            </a:r>
+          </a:p>
+          <a:p>
+            <a:pPr algn="l" marL="384048" indent="-384048">
+              <a:lnSpc>
+                <a:spcPct val="108000"/>
+              </a:lnSpc>
+              <a:spcAft>
+                <a:spcPts val="600"/>
+              </a:spcAft>
+              <a:buClr>
+                <a:srgbClr val="FF6F91"/>
+              </a:buClr>
+              <a:buFont typeface="Arial"/>
+              <a:buChar char="•"/>
+            </a:pPr>
+            <a:r>
+              <a:rPr sz="2500" b="0">
                 <a:solidFill>
                   <a:srgbClr val="EEF3F8"/>
                 </a:solidFill>
                 <a:latin typeface="Arial"/>
               </a:rPr>
-              <a:t>The network never sees a date or a position on a sky map. Its only inputs are 9 numbers describing the viewing geometry (Fig. 2): dot products of SPHEREx's look direction n with the directions that shape the zodiacal light, plus Earth's place in its orbit. It must learn how the brightness depends on geometry, just as the physics does, instead of memorizing when and where SPHEREx looked.</a:t>
+              <a:t>Only </a:t>
+            </a:r>
+            <a:r>
+              <a:rPr sz="2500" b="1">
+                <a:solidFill>
+                  <a:srgbClr val="EEF3F8"/>
+                </a:solidFill>
+                <a:latin typeface="Arial"/>
+              </a:rPr>
+              <a:t>9 numbers describing the viewing geometry</a:t>
+            </a:r>
+            <a:r>
+              <a:rPr sz="2500" b="0">
+                <a:solidFill>
+                  <a:srgbClr val="EEF3F8"/>
+                </a:solidFill>
+                <a:latin typeface="Arial"/>
+              </a:rPr>
+              <a:t> (Fig. 2): dot products of the look direction n, plus Earth's place in its orbit</a:t>
+            </a:r>
+          </a:p>
+          <a:p>
+            <a:pPr algn="l" marL="384048" indent="-384048">
+              <a:lnSpc>
+                <a:spcPct val="108000"/>
+              </a:lnSpc>
+              <a:spcAft>
+                <a:spcPts val="600"/>
+              </a:spcAft>
+              <a:buClr>
+                <a:srgbClr val="FF6F91"/>
+              </a:buClr>
+              <a:buFont typeface="Arial"/>
+              <a:buChar char="•"/>
+            </a:pPr>
+            <a:r>
+              <a:rPr sz="2500" b="0">
+                <a:solidFill>
+                  <a:srgbClr val="EEF3F8"/>
+                </a:solidFill>
+                <a:latin typeface="Arial"/>
+              </a:rPr>
+              <a:t>Must learn how brightness depends on geometry, as the physics does, not memorize when and where SPHEREx looked</a:t>
             </a:r>
           </a:p>
         </p:txBody>
       </p:sp>
       <p:pic>
         <p:nvPicPr>
-          <p:cNvPr id="23" name="Picture 22" descr="geometry_dark.png"/>
+          <p:cNvPr id="24" name="Picture 23" descr="geometry_dark.png"/>
           <p:cNvPicPr>
             <a:picLocks noChangeAspect="1"/>
           </p:cNvPicPr>
@@ -4645,8 +5007,8 @@
         </p:blipFill>
         <p:spPr>
           <a:xfrm>
-            <a:off x="2596896" y="25466039"/>
-            <a:ext cx="11631168" cy="7909194"/>
+            <a:off x="7685532" y="23048159"/>
+            <a:ext cx="7996428" cy="5437571"/>
           </a:xfrm>
           <a:prstGeom prst="rect">
             <a:avLst/>
@@ -4655,14 +5017,14 @@
       </p:pic>
       <p:sp>
         <p:nvSpPr>
-          <p:cNvPr id="24" name="TextBox 23"/>
+          <p:cNvPr id="25" name="TextBox 24"/>
           <p:cNvSpPr txBox="1"/>
           <p:nvPr/>
         </p:nvSpPr>
         <p:spPr>
           <a:xfrm>
-            <a:off x="1143000" y="33420954"/>
-            <a:ext cx="14538960" cy="1188720"/>
+            <a:off x="1143000" y="28577170"/>
+            <a:ext cx="14538960" cy="749808"/>
           </a:xfrm>
           <a:prstGeom prst="rect">
             <a:avLst/>
@@ -4680,7 +5042,7 @@
                 <a:spcPct val="105000"/>
               </a:lnSpc>
               <a:spcAft>
-                <a:spcPts val="1000"/>
+                <a:spcPts val="0"/>
               </a:spcAft>
             </a:pPr>
             <a:r>
@@ -4699,20 +5061,20 @@
                 </a:solidFill>
                 <a:latin typeface="Arial"/>
               </a:rPr>
-              <a:t>The geometry the network sees (top view, not to scale). n is where SPHEREx looks; S and E point from the Sun to SPHEREx and Earth; v is the orbital motion; λ⊕ is Earth's angle around its orbit. Jupiter and the Moon are shown for context: the final model uses only the Sun–Earth–SPHEREx geometry and the time of year.</a:t>
-            </a:r>
-          </a:p>
-        </p:txBody>
-      </p:sp>
-      <p:sp>
-        <p:nvSpPr>
-          <p:cNvPr id="25" name="TextBox 24"/>
+              <a:t>The geometry the network sees (top view, not to scale): n = where SPHEREx looks; S, E = Sun → SPHEREx, Earth; v = orbital motion; λ⊕ = Earth's angle around its orbit. Jupiter and the Moon: context only.</a:t>
+            </a:r>
+          </a:p>
+        </p:txBody>
+      </p:sp>
+      <p:sp>
+        <p:nvSpPr>
+          <p:cNvPr id="26" name="TextBox 25"/>
           <p:cNvSpPr txBox="1"/>
           <p:nvPr/>
         </p:nvSpPr>
         <p:spPr>
           <a:xfrm>
-            <a:off x="1143000" y="34701114"/>
+            <a:off x="1143000" y="30009209"/>
             <a:ext cx="14538960" cy="548640"/>
           </a:xfrm>
           <a:prstGeom prst="rect">
@@ -4748,13 +5110,13 @@
       </p:sp>
       <p:sp>
         <p:nvSpPr>
-          <p:cNvPr id="26" name="TextBox 25"/>
+          <p:cNvPr id="27" name="TextBox 26"/>
           <p:cNvSpPr txBox="1"/>
           <p:nvPr/>
         </p:nvSpPr>
         <p:spPr>
           <a:xfrm>
-            <a:off x="1325880" y="35249754"/>
+            <a:off x="1325880" y="30557849"/>
             <a:ext cx="3291840" cy="457200"/>
           </a:xfrm>
           <a:prstGeom prst="rect">
@@ -4790,13 +5152,13 @@
       </p:sp>
       <p:sp>
         <p:nvSpPr>
-          <p:cNvPr id="27" name="TextBox 26"/>
+          <p:cNvPr id="28" name="TextBox 27"/>
           <p:cNvSpPr txBox="1"/>
           <p:nvPr/>
         </p:nvSpPr>
         <p:spPr>
           <a:xfrm>
-            <a:off x="4617720" y="35249754"/>
+            <a:off x="4617720" y="30557849"/>
             <a:ext cx="11064240" cy="457200"/>
           </a:xfrm>
           <a:prstGeom prst="rect">
@@ -4832,13 +5194,13 @@
       </p:sp>
       <p:sp>
         <p:nvSpPr>
-          <p:cNvPr id="28" name="TextBox 27"/>
+          <p:cNvPr id="29" name="TextBox 28"/>
           <p:cNvSpPr txBox="1"/>
           <p:nvPr/>
         </p:nvSpPr>
         <p:spPr>
           <a:xfrm>
-            <a:off x="1325880" y="35679522"/>
+            <a:off x="1325880" y="30987617"/>
             <a:ext cx="3291840" cy="457200"/>
           </a:xfrm>
           <a:prstGeom prst="rect">
@@ -4874,13 +5236,13 @@
       </p:sp>
       <p:sp>
         <p:nvSpPr>
-          <p:cNvPr id="29" name="TextBox 28"/>
+          <p:cNvPr id="30" name="TextBox 29"/>
           <p:cNvSpPr txBox="1"/>
           <p:nvPr/>
         </p:nvSpPr>
         <p:spPr>
           <a:xfrm>
-            <a:off x="4617720" y="35679522"/>
+            <a:off x="4617720" y="30987617"/>
             <a:ext cx="11064240" cy="457200"/>
           </a:xfrm>
           <a:prstGeom prst="rect">
@@ -4916,13 +5278,13 @@
       </p:sp>
       <p:sp>
         <p:nvSpPr>
-          <p:cNvPr id="30" name="TextBox 29"/>
+          <p:cNvPr id="31" name="TextBox 30"/>
           <p:cNvSpPr txBox="1"/>
           <p:nvPr/>
         </p:nvSpPr>
         <p:spPr>
           <a:xfrm>
-            <a:off x="1325880" y="36109290"/>
+            <a:off x="1325880" y="31417385"/>
             <a:ext cx="3291840" cy="457200"/>
           </a:xfrm>
           <a:prstGeom prst="rect">
@@ -4958,13 +5320,13 @@
       </p:sp>
       <p:sp>
         <p:nvSpPr>
-          <p:cNvPr id="31" name="TextBox 30"/>
+          <p:cNvPr id="32" name="TextBox 31"/>
           <p:cNvSpPr txBox="1"/>
           <p:nvPr/>
         </p:nvSpPr>
         <p:spPr>
           <a:xfrm>
-            <a:off x="4617720" y="36109290"/>
+            <a:off x="4617720" y="31417385"/>
             <a:ext cx="11064240" cy="457200"/>
           </a:xfrm>
           <a:prstGeom prst="rect">
@@ -5000,13 +5362,13 @@
       </p:sp>
       <p:sp>
         <p:nvSpPr>
-          <p:cNvPr id="32" name="TextBox 31"/>
+          <p:cNvPr id="33" name="TextBox 32"/>
           <p:cNvSpPr txBox="1"/>
           <p:nvPr/>
         </p:nvSpPr>
         <p:spPr>
           <a:xfrm>
-            <a:off x="1325880" y="36539058"/>
+            <a:off x="1325880" y="31847153"/>
             <a:ext cx="3291840" cy="457200"/>
           </a:xfrm>
           <a:prstGeom prst="rect">
@@ -5042,13 +5404,13 @@
       </p:sp>
       <p:sp>
         <p:nvSpPr>
-          <p:cNvPr id="33" name="TextBox 32"/>
+          <p:cNvPr id="34" name="TextBox 33"/>
           <p:cNvSpPr txBox="1"/>
           <p:nvPr/>
         </p:nvSpPr>
         <p:spPr>
           <a:xfrm>
-            <a:off x="4617720" y="36539058"/>
+            <a:off x="4617720" y="31847153"/>
             <a:ext cx="11064240" cy="457200"/>
           </a:xfrm>
           <a:prstGeom prst="rect">
@@ -5084,13 +5446,13 @@
       </p:sp>
       <p:sp>
         <p:nvSpPr>
-          <p:cNvPr id="34" name="TextBox 33"/>
+          <p:cNvPr id="35" name="TextBox 34"/>
           <p:cNvSpPr txBox="1"/>
           <p:nvPr/>
         </p:nvSpPr>
         <p:spPr>
           <a:xfrm>
-            <a:off x="1325880" y="36968826"/>
+            <a:off x="1325880" y="32276921"/>
             <a:ext cx="3291840" cy="457200"/>
           </a:xfrm>
           <a:prstGeom prst="rect">
@@ -5126,13 +5488,13 @@
       </p:sp>
       <p:sp>
         <p:nvSpPr>
-          <p:cNvPr id="35" name="TextBox 34"/>
+          <p:cNvPr id="36" name="TextBox 35"/>
           <p:cNvSpPr txBox="1"/>
           <p:nvPr/>
         </p:nvSpPr>
         <p:spPr>
           <a:xfrm>
-            <a:off x="4617720" y="36968826"/>
+            <a:off x="4617720" y="32276921"/>
             <a:ext cx="11064240" cy="457200"/>
           </a:xfrm>
           <a:prstGeom prst="rect">
@@ -5168,14 +5530,14 @@
       </p:sp>
       <p:sp>
         <p:nvSpPr>
-          <p:cNvPr id="36" name="TextBox 35"/>
+          <p:cNvPr id="37" name="TextBox 36"/>
           <p:cNvSpPr txBox="1"/>
           <p:nvPr/>
         </p:nvSpPr>
         <p:spPr>
           <a:xfrm>
-            <a:off x="1143000" y="37627194"/>
-            <a:ext cx="14538960" cy="2469245"/>
+            <a:off x="1143000" y="33388921"/>
+            <a:ext cx="7867497" cy="5138318"/>
           </a:xfrm>
           <a:prstGeom prst="rect">
             <a:avLst/>
@@ -5192,69 +5554,248 @@
               <a:lnSpc>
                 <a:spcPct val="108000"/>
               </a:lnSpc>
+              <a:spcBef>
+                <a:spcPts val="0"/>
+              </a:spcBef>
               <a:spcAft>
-                <a:spcPts val="800"/>
+                <a:spcPts val="600"/>
               </a:spcAft>
             </a:pPr>
             <a:r>
-              <a:rPr sz="2500" b="1">
-                <a:solidFill>
-                  <a:srgbClr val="EEF3F8"/>
-                </a:solidFill>
-                <a:latin typeface="Arial"/>
-              </a:rPr>
-              <a:t>Training and testing. </a:t>
-            </a:r>
-            <a:r>
-              <a:rPr sz="2500" b="0">
-                <a:solidFill>
-                  <a:srgbClr val="EEF3F8"/>
-                </a:solidFill>
-                <a:latin typeface="Arial"/>
-              </a:rPr>
-              <a:t>ZodiPy simulates 423,607 SPHEREx pointings (140 days, 5 μm). Five small networks (4 hidden layers, 64 → 16 neurons; Flux.jl in Julia) learn brightness from the 9 inputs and are averaged, then tested on whole months and sky regions they never saw.</a:t>
-            </a:r>
-          </a:p>
-          <a:p>
-            <a:pPr algn="l">
+              <a:rPr sz="2700" b="1">
+                <a:solidFill>
+                  <a:srgbClr val="5FB0FF"/>
+                </a:solidFill>
+                <a:latin typeface="Arial"/>
+              </a:rPr>
+              <a:t>Training and testing</a:t>
+            </a:r>
+          </a:p>
+          <a:p>
+            <a:pPr algn="l" marL="384048" indent="-384048">
               <a:lnSpc>
                 <a:spcPct val="108000"/>
               </a:lnSpc>
               <a:spcAft>
-                <a:spcPts val="800"/>
+                <a:spcPts val="600"/>
+              </a:spcAft>
+              <a:buClr>
+                <a:srgbClr val="FF6F91"/>
+              </a:buClr>
+              <a:buFont typeface="Arial"/>
+              <a:buChar char="•"/>
+            </a:pPr>
+            <a:r>
+              <a:rPr sz="2500" b="0">
+                <a:solidFill>
+                  <a:srgbClr val="EEF3F8"/>
+                </a:solidFill>
+                <a:latin typeface="Arial"/>
+              </a:rPr>
+              <a:t>423,607 simulated SPHEREx pointings from ZodiPy (140 days, 5 μm)</a:t>
+            </a:r>
+          </a:p>
+          <a:p>
+            <a:pPr algn="l" marL="384048" indent="-384048">
+              <a:lnSpc>
+                <a:spcPct val="108000"/>
+              </a:lnSpc>
+              <a:spcAft>
+                <a:spcPts val="600"/>
+              </a:spcAft>
+              <a:buClr>
+                <a:srgbClr val="FF6F91"/>
+              </a:buClr>
+              <a:buFont typeface="Arial"/>
+              <a:buChar char="•"/>
+            </a:pPr>
+            <a:r>
+              <a:rPr sz="2500" b="0">
+                <a:solidFill>
+                  <a:srgbClr val="EEF3F8"/>
+                </a:solidFill>
+                <a:latin typeface="Arial"/>
+              </a:rPr>
+              <a:t>Five small networks (4 hidden layers, 64 → 16 neurons; Flux.jl in Julia), averaged</a:t>
+            </a:r>
+          </a:p>
+          <a:p>
+            <a:pPr algn="l" marL="384048" indent="-384048">
+              <a:lnSpc>
+                <a:spcPct val="108000"/>
+              </a:lnSpc>
+              <a:spcAft>
+                <a:spcPts val="600"/>
+              </a:spcAft>
+              <a:buClr>
+                <a:srgbClr val="FF6F91"/>
+              </a:buClr>
+              <a:buFont typeface="Arial"/>
+              <a:buChar char="•"/>
+            </a:pPr>
+            <a:r>
+              <a:rPr sz="2500" b="0">
+                <a:solidFill>
+                  <a:srgbClr val="EEF3F8"/>
+                </a:solidFill>
+                <a:latin typeface="Arial"/>
+              </a:rPr>
+              <a:t>Tested on whole months and sky regions they never saw</a:t>
+            </a:r>
+          </a:p>
+          <a:p>
+            <a:pPr algn="l" marL="384048" indent="-384048">
+              <a:lnSpc>
+                <a:spcPct val="108000"/>
+              </a:lnSpc>
+              <a:spcAft>
+                <a:spcPts val="600"/>
+              </a:spcAft>
+              <a:buClr>
+                <a:srgbClr val="FF6F91"/>
+              </a:buClr>
+              <a:buFont typeface="Arial"/>
+              <a:buChar char="•"/>
+            </a:pPr>
+            <a:r>
+              <a:rPr sz="2500" b="1">
+                <a:solidFill>
+                  <a:srgbClr val="EEF3F8"/>
+                </a:solidFill>
+                <a:latin typeface="Arial"/>
+              </a:rPr>
+              <a:t>Lesson: </a:t>
+            </a:r>
+            <a:r>
+              <a:rPr sz="2500" b="0">
+                <a:solidFill>
+                  <a:srgbClr val="EEF3F8"/>
+                </a:solidFill>
+                <a:latin typeface="Arial"/>
+              </a:rPr>
+              <a:t>adding the time of year (sin λ⊕, cos λ⊕) cut the errors ~40–65×</a:t>
+            </a:r>
+          </a:p>
+          <a:p>
+            <a:pPr algn="l" marL="384048" indent="-384048">
+              <a:lnSpc>
+                <a:spcPct val="108000"/>
+              </a:lnSpc>
+              <a:spcAft>
+                <a:spcPts val="600"/>
+              </a:spcAft>
+              <a:buClr>
+                <a:srgbClr val="FF6F91"/>
+              </a:buClr>
+              <a:buFont typeface="Arial"/>
+              <a:buChar char="•"/>
+            </a:pPr>
+            <a:r>
+              <a:rPr sz="2500" b="1">
+                <a:solidFill>
+                  <a:srgbClr val="EEF3F8"/>
+                </a:solidFill>
+                <a:latin typeface="Arial"/>
+              </a:rPr>
+              <a:t>No overfitting: </a:t>
+            </a:r>
+            <a:r>
+              <a:rPr sz="2500" b="0">
+                <a:solidFill>
+                  <a:srgbClr val="EEF3F8"/>
+                </a:solidFill>
+                <a:latin typeface="Arial"/>
+              </a:rPr>
+              <a:t>error on withheld data levels off and never rises (Fig. 3)</a:t>
+            </a:r>
+          </a:p>
+        </p:txBody>
+      </p:sp>
+      <p:pic>
+        <p:nvPicPr>
+          <p:cNvPr id="38" name="Picture 37" descr="training_dark.png"/>
+          <p:cNvPicPr>
+            <a:picLocks noChangeAspect="1"/>
+          </p:cNvPicPr>
+          <p:nvPr/>
+        </p:nvPicPr>
+        <p:blipFill>
+          <a:blip r:embed="rId6"/>
+          <a:stretch>
+            <a:fillRect/>
+          </a:stretch>
+        </p:blipFill>
+        <p:spPr>
+          <a:xfrm>
+            <a:off x="9284817" y="33388921"/>
+            <a:ext cx="6397142" cy="5117713"/>
+          </a:xfrm>
+          <a:prstGeom prst="rect">
+            <a:avLst/>
+          </a:prstGeom>
+        </p:spPr>
+      </p:pic>
+      <p:sp>
+        <p:nvSpPr>
+          <p:cNvPr id="39" name="TextBox 38"/>
+          <p:cNvSpPr txBox="1"/>
+          <p:nvPr/>
+        </p:nvSpPr>
+        <p:spPr>
+          <a:xfrm>
+            <a:off x="1143000" y="38618680"/>
+            <a:ext cx="14538960" cy="749808"/>
+          </a:xfrm>
+          <a:prstGeom prst="rect">
+            <a:avLst/>
+          </a:prstGeom>
+          <a:noFill/>
+        </p:spPr>
+        <p:txBody>
+          <a:bodyPr wrap="square" anchor="t" lIns="45720" rIns="45720" tIns="18288" bIns="18288">
+            <a:spAutoFit/>
+          </a:bodyPr>
+          <a:lstStyle/>
+          <a:p>
+            <a:pPr algn="l">
+              <a:lnSpc>
+                <a:spcPct val="105000"/>
+              </a:lnSpc>
+              <a:spcAft>
+                <a:spcPts val="0"/>
               </a:spcAft>
             </a:pPr>
             <a:r>
-              <a:rPr sz="2500" b="1">
-                <a:solidFill>
-                  <a:srgbClr val="EEF3F8"/>
-                </a:solidFill>
-                <a:latin typeface="Arial"/>
-              </a:rPr>
-              <a:t>Lesson: </a:t>
-            </a:r>
-            <a:r>
-              <a:rPr sz="2500" b="0">
-                <a:solidFill>
-                  <a:srgbClr val="EEF3F8"/>
-                </a:solidFill>
-                <a:latin typeface="Arial"/>
-              </a:rPr>
-              <a:t>adding the time of year (sin λ⊕, cos λ⊕) cut the errors about 40–65×.</a:t>
-            </a:r>
-          </a:p>
-        </p:txBody>
-      </p:sp>
-      <p:sp>
-        <p:nvSpPr>
-          <p:cNvPr id="37" name="Rectangle 36"/>
+              <a:rPr sz="2200" b="1">
+                <a:solidFill>
+                  <a:srgbClr val="A9B6C6"/>
+                </a:solidFill>
+                <a:latin typeface="Arial"/>
+              </a:rPr>
+              <a:t>Figure 3. </a:t>
+            </a:r>
+            <a:r>
+              <a:rPr sz="2200" b="0">
+                <a:solidFill>
+                  <a:srgbClr val="A9B6C6"/>
+                </a:solidFill>
+                <a:latin typeface="Arial"/>
+              </a:rPr>
+              <a:t>Error during training on the training data and the withheld months: 5 networks (thin) and their average (thick). Test error ends ~2× the training error; with a random 10% withheld, the curves overlap.</a:t>
+            </a:r>
+          </a:p>
+        </p:txBody>
+      </p:sp>
+      <p:sp>
+        <p:nvSpPr>
+          <p:cNvPr id="40" name="Rectangle 39"/>
           <p:cNvSpPr/>
           <p:nvPr/>
         </p:nvSpPr>
         <p:spPr>
           <a:xfrm>
             <a:off x="16824960" y="7223760"/>
-            <a:ext cx="15361920" cy="24505920"/>
+            <a:ext cx="15361920" cy="25968960"/>
           </a:xfrm>
           <a:prstGeom prst="rect">
             <a:avLst/>
@@ -5293,7 +5834,7 @@
       </p:sp>
       <p:sp>
         <p:nvSpPr>
-          <p:cNvPr id="38" name="Rectangle 37"/>
+          <p:cNvPr id="41" name="Rectangle 40"/>
           <p:cNvSpPr/>
           <p:nvPr/>
         </p:nvSpPr>
@@ -5337,7 +5878,7 @@
       </p:sp>
       <p:sp>
         <p:nvSpPr>
-          <p:cNvPr id="39" name="TextBox 38"/>
+          <p:cNvPr id="42" name="TextBox 41"/>
           <p:cNvSpPr txBox="1"/>
           <p:nvPr/>
         </p:nvSpPr>
@@ -5379,14 +5920,14 @@
       </p:sp>
       <p:sp>
         <p:nvSpPr>
-          <p:cNvPr id="40" name="Rounded Rectangle 39"/>
+          <p:cNvPr id="43" name="Rounded Rectangle 42"/>
           <p:cNvSpPr/>
           <p:nvPr/>
         </p:nvSpPr>
         <p:spPr>
           <a:xfrm>
             <a:off x="17236440" y="8595360"/>
-            <a:ext cx="4632960" cy="2651760"/>
+            <a:ext cx="4632960" cy="2468880"/>
           </a:xfrm>
           <a:prstGeom prst="roundRect">
             <a:avLst>
@@ -5425,14 +5966,14 @@
       </p:sp>
       <p:sp>
         <p:nvSpPr>
-          <p:cNvPr id="41" name="TextBox 40"/>
+          <p:cNvPr id="44" name="TextBox 43"/>
           <p:cNvSpPr txBox="1"/>
           <p:nvPr/>
         </p:nvSpPr>
         <p:spPr>
           <a:xfrm>
-            <a:off x="17236440" y="8686800"/>
-            <a:ext cx="4632960" cy="1325880"/>
+            <a:off x="17236440" y="8668512"/>
+            <a:ext cx="4632960" cy="1280160"/>
           </a:xfrm>
           <a:prstGeom prst="rect">
             <a:avLst/>
@@ -5454,7 +5995,7 @@
               </a:spcAft>
             </a:pPr>
             <a:r>
-              <a:rPr sz="8000" b="1">
+              <a:rPr sz="7600" b="1">
                 <a:solidFill>
                   <a:srgbClr val="5FB0FF"/>
                 </a:solidFill>
@@ -5467,14 +6008,14 @@
       </p:sp>
       <p:sp>
         <p:nvSpPr>
-          <p:cNvPr id="42" name="TextBox 41"/>
+          <p:cNvPr id="45" name="TextBox 44"/>
           <p:cNvSpPr txBox="1"/>
           <p:nvPr/>
         </p:nvSpPr>
         <p:spPr>
           <a:xfrm>
-            <a:off x="17236440" y="10012680"/>
-            <a:ext cx="4632960" cy="1143000"/>
+            <a:off x="17236440" y="9921240"/>
+            <a:ext cx="4632960" cy="1097280"/>
           </a:xfrm>
           <a:prstGeom prst="rect">
             <a:avLst/>
@@ -5496,7 +6037,7 @@
               </a:spcAft>
             </a:pPr>
             <a:r>
-              <a:rPr sz="2400" b="0">
+              <a:rPr sz="2300" b="0">
                 <a:solidFill>
                   <a:srgbClr val="EEF3F8"/>
                 </a:solidFill>
@@ -5515,7 +6056,7 @@
               </a:spcAft>
             </a:pPr>
             <a:r>
-              <a:rPr sz="2400" b="0">
+              <a:rPr sz="2300" b="0">
                 <a:solidFill>
                   <a:srgbClr val="EEF3F8"/>
                 </a:solidFill>
@@ -5528,14 +6069,14 @@
       </p:sp>
       <p:sp>
         <p:nvSpPr>
-          <p:cNvPr id="43" name="Rounded Rectangle 42"/>
+          <p:cNvPr id="46" name="Rounded Rectangle 45"/>
           <p:cNvSpPr/>
           <p:nvPr/>
         </p:nvSpPr>
         <p:spPr>
           <a:xfrm>
             <a:off x="22189440" y="8595360"/>
-            <a:ext cx="4632960" cy="2651760"/>
+            <a:ext cx="4632960" cy="2468880"/>
           </a:xfrm>
           <a:prstGeom prst="roundRect">
             <a:avLst>
@@ -5574,14 +6115,14 @@
       </p:sp>
       <p:sp>
         <p:nvSpPr>
-          <p:cNvPr id="44" name="TextBox 43"/>
+          <p:cNvPr id="47" name="TextBox 46"/>
           <p:cNvSpPr txBox="1"/>
           <p:nvPr/>
         </p:nvSpPr>
         <p:spPr>
           <a:xfrm>
-            <a:off x="22189440" y="8686800"/>
-            <a:ext cx="4632960" cy="1325880"/>
+            <a:off x="22189440" y="8668512"/>
+            <a:ext cx="4632960" cy="1280160"/>
           </a:xfrm>
           <a:prstGeom prst="rect">
             <a:avLst/>
@@ -5603,7 +6144,7 @@
               </a:spcAft>
             </a:pPr>
             <a:r>
-              <a:rPr sz="8000" b="1">
+              <a:rPr sz="7600" b="1">
                 <a:solidFill>
                   <a:srgbClr val="5FB0FF"/>
                 </a:solidFill>
@@ -5616,14 +6157,14 @@
       </p:sp>
       <p:sp>
         <p:nvSpPr>
-          <p:cNvPr id="45" name="TextBox 44"/>
+          <p:cNvPr id="48" name="TextBox 47"/>
           <p:cNvSpPr txBox="1"/>
           <p:nvPr/>
         </p:nvSpPr>
         <p:spPr>
           <a:xfrm>
-            <a:off x="22189440" y="10012680"/>
-            <a:ext cx="4632960" cy="1143000"/>
+            <a:off x="22189440" y="9921240"/>
+            <a:ext cx="4632960" cy="1097280"/>
           </a:xfrm>
           <a:prstGeom prst="rect">
             <a:avLst/>
@@ -5645,7 +6186,7 @@
               </a:spcAft>
             </a:pPr>
             <a:r>
-              <a:rPr sz="2400" b="0">
+              <a:rPr sz="2300" b="0">
                 <a:solidFill>
                   <a:srgbClr val="EEF3F8"/>
                 </a:solidFill>
@@ -5664,7 +6205,7 @@
               </a:spcAft>
             </a:pPr>
             <a:r>
-              <a:rPr sz="2400" b="0">
+              <a:rPr sz="2300" b="0">
                 <a:solidFill>
                   <a:srgbClr val="EEF3F8"/>
                 </a:solidFill>
@@ -5677,14 +6218,14 @@
       </p:sp>
       <p:sp>
         <p:nvSpPr>
-          <p:cNvPr id="46" name="Rounded Rectangle 45"/>
+          <p:cNvPr id="49" name="Rounded Rectangle 48"/>
           <p:cNvSpPr/>
           <p:nvPr/>
         </p:nvSpPr>
         <p:spPr>
           <a:xfrm>
             <a:off x="27142440" y="8595360"/>
-            <a:ext cx="4632960" cy="2651760"/>
+            <a:ext cx="4632960" cy="2468880"/>
           </a:xfrm>
           <a:prstGeom prst="roundRect">
             <a:avLst>
@@ -5723,14 +6264,14 @@
       </p:sp>
       <p:sp>
         <p:nvSpPr>
-          <p:cNvPr id="47" name="TextBox 46"/>
+          <p:cNvPr id="50" name="TextBox 49"/>
           <p:cNvSpPr txBox="1"/>
           <p:nvPr/>
         </p:nvSpPr>
         <p:spPr>
           <a:xfrm>
-            <a:off x="27142440" y="8686800"/>
-            <a:ext cx="4632960" cy="1325880"/>
+            <a:off x="27142440" y="8668512"/>
+            <a:ext cx="4632960" cy="1280160"/>
           </a:xfrm>
           <a:prstGeom prst="rect">
             <a:avLst/>
@@ -5752,7 +6293,7 @@
               </a:spcAft>
             </a:pPr>
             <a:r>
-              <a:rPr sz="8000" b="1">
+              <a:rPr sz="7600" b="1">
                 <a:solidFill>
                   <a:srgbClr val="5FB0FF"/>
                 </a:solidFill>
@@ -5765,14 +6306,14 @@
       </p:sp>
       <p:sp>
         <p:nvSpPr>
-          <p:cNvPr id="48" name="TextBox 47"/>
+          <p:cNvPr id="51" name="TextBox 50"/>
           <p:cNvSpPr txBox="1"/>
           <p:nvPr/>
         </p:nvSpPr>
         <p:spPr>
           <a:xfrm>
-            <a:off x="27142440" y="10012680"/>
-            <a:ext cx="4632960" cy="1143000"/>
+            <a:off x="27142440" y="9921240"/>
+            <a:ext cx="4632960" cy="1097280"/>
           </a:xfrm>
           <a:prstGeom prst="rect">
             <a:avLst/>
@@ -5794,7 +6335,7 @@
               </a:spcAft>
             </a:pPr>
             <a:r>
-              <a:rPr sz="2400" b="0">
+              <a:rPr sz="2300" b="0">
                 <a:solidFill>
                   <a:srgbClr val="EEF3F8"/>
                 </a:solidFill>
@@ -5813,7 +6354,7 @@
               </a:spcAft>
             </a:pPr>
             <a:r>
-              <a:rPr sz="2400" b="0">
+              <a:rPr sz="2300" b="0">
                 <a:solidFill>
                   <a:srgbClr val="EEF3F8"/>
                 </a:solidFill>
@@ -5826,22 +6367,22 @@
       </p:sp>
       <p:pic>
         <p:nvPicPr>
-          <p:cNvPr id="49" name="Picture 48" descr="accuracy_dark.png"/>
+          <p:cNvPr id="52" name="Picture 51" descr="accuracy_dark.png"/>
           <p:cNvPicPr>
             <a:picLocks noChangeAspect="1"/>
           </p:cNvPicPr>
           <p:nvPr/>
         </p:nvPicPr>
         <p:blipFill>
-          <a:blip r:embed="rId6"/>
+          <a:blip r:embed="rId7"/>
           <a:stretch>
             <a:fillRect/>
           </a:stretch>
         </p:blipFill>
         <p:spPr>
           <a:xfrm>
-            <a:off x="17236440" y="11567160"/>
-            <a:ext cx="14538960" cy="7269480"/>
+            <a:off x="18929544" y="11178540"/>
+            <a:ext cx="11152750" cy="5576375"/>
           </a:xfrm>
           <a:prstGeom prst="rect">
             <a:avLst/>
@@ -5850,14 +6391,14 @@
       </p:pic>
       <p:sp>
         <p:nvSpPr>
-          <p:cNvPr id="50" name="TextBox 49"/>
+          <p:cNvPr id="53" name="TextBox 52"/>
           <p:cNvSpPr txBox="1"/>
           <p:nvPr/>
         </p:nvSpPr>
         <p:spPr>
           <a:xfrm>
-            <a:off x="17236440" y="18836640"/>
-            <a:ext cx="14538960" cy="1371600"/>
+            <a:off x="17236440" y="16846355"/>
+            <a:ext cx="14538960" cy="749808"/>
           </a:xfrm>
           <a:prstGeom prst="rect">
             <a:avLst/>
@@ -5875,7 +6416,7 @@
                 <a:spcPct val="105000"/>
               </a:lnSpc>
               <a:spcAft>
-                <a:spcPts val="1000"/>
+                <a:spcPts val="0"/>
               </a:spcAft>
             </a:pPr>
             <a:r>
@@ -5885,7 +6426,7 @@
                 </a:solidFill>
                 <a:latin typeface="Arial"/>
               </a:rPr>
-              <a:t>Figure 3. </a:t>
+              <a:t>Figure 4. </a:t>
             </a:r>
             <a:r>
               <a:rPr sz="2200" b="0">
@@ -5894,30 +6435,360 @@
                 </a:solidFill>
                 <a:latin typeface="Arial"/>
               </a:rPr>
-              <a:t>Neural network vs. ZodiPy. The network was trained on mission days 0–30, 60–90 and 120–140, then tested on the two 30-day blocks it never saw (days 30–60 and 90–120; 180,166 pointings). Half of the errors are below 0.026% and 95% are below 0.1%. (With a random 10% of pointings withheld instead, the median is 0.015%.)</a:t>
-            </a:r>
-          </a:p>
-        </p:txBody>
-      </p:sp>
-      <p:sp>
-        <p:nvSpPr>
-          <p:cNvPr id="51" name="Rectangle 50"/>
+              <a:t>Network vs. ZodiPy on the two 30-day blocks never used in training (days 30–60 and 90–120; 180,166 pointings). Half of the errors are below 0.026%, 95% below 0.1%.</a:t>
+            </a:r>
+          </a:p>
+        </p:txBody>
+      </p:sp>
+      <p:sp>
+        <p:nvSpPr>
+          <p:cNvPr id="54" name="TextBox 53"/>
+          <p:cNvSpPr txBox="1"/>
+          <p:nvPr/>
+        </p:nvSpPr>
+        <p:spPr>
+          <a:xfrm>
+            <a:off x="17236440" y="17710463"/>
+            <a:ext cx="14538960" cy="1481937"/>
+          </a:xfrm>
+          <a:prstGeom prst="rect">
+            <a:avLst/>
+          </a:prstGeom>
+          <a:noFill/>
+        </p:spPr>
+        <p:txBody>
+          <a:bodyPr wrap="square" anchor="t" lIns="45720" rIns="45720" tIns="18288" bIns="18288">
+            <a:spAutoFit/>
+          </a:bodyPr>
+          <a:lstStyle/>
+          <a:p>
+            <a:pPr algn="l" marL="384048" indent="-384048">
+              <a:lnSpc>
+                <a:spcPct val="108000"/>
+              </a:lnSpc>
+              <a:spcAft>
+                <a:spcPts val="600"/>
+              </a:spcAft>
+              <a:buClr>
+                <a:srgbClr val="FF6F91"/>
+              </a:buClr>
+              <a:buFont typeface="Arial"/>
+              <a:buChar char="•"/>
+            </a:pPr>
+            <a:r>
+              <a:rPr sz="2600" b="1">
+                <a:solidFill>
+                  <a:srgbClr val="EEF3F8"/>
+                </a:solidFill>
+                <a:latin typeface="Arial"/>
+              </a:rPr>
+              <a:t>Robust: </a:t>
+            </a:r>
+            <a:r>
+              <a:rPr sz="2600" b="0">
+                <a:solidFill>
+                  <a:srgbClr val="EEF3F8"/>
+                </a:solidFill>
+                <a:latin typeface="Arial"/>
+              </a:rPr>
+              <a:t>six versions with different withheld months all reach 0.023–0.037% (Fig. 5)</a:t>
+            </a:r>
+          </a:p>
+          <a:p>
+            <a:pPr algn="l" marL="384048" indent="-384048">
+              <a:lnSpc>
+                <a:spcPct val="108000"/>
+              </a:lnSpc>
+              <a:spcAft>
+                <a:spcPts val="600"/>
+              </a:spcAft>
+              <a:buClr>
+                <a:srgbClr val="FF6F91"/>
+              </a:buClr>
+              <a:buFont typeface="Arial"/>
+              <a:buChar char="•"/>
+            </a:pPr>
+            <a:r>
+              <a:rPr sz="2600" b="1">
+                <a:solidFill>
+                  <a:srgbClr val="EEF3F8"/>
+                </a:solidFill>
+                <a:latin typeface="Arial"/>
+              </a:rPr>
+              <a:t>Harder: </a:t>
+            </a:r>
+            <a:r>
+              <a:rPr sz="2600" b="0">
+                <a:solidFill>
+                  <a:srgbClr val="EEF3F8"/>
+                </a:solidFill>
+                <a:latin typeface="Arial"/>
+              </a:rPr>
+              <a:t>predicting past the start or end of the data (orange): fine for ~10 days, then errors grow</a:t>
+            </a:r>
+          </a:p>
+        </p:txBody>
+      </p:sp>
+      <p:pic>
+        <p:nvPicPr>
+          <p:cNvPr id="55" name="Picture 54" descr="shifts_dark.png"/>
+          <p:cNvPicPr>
+            <a:picLocks noChangeAspect="1"/>
+          </p:cNvPicPr>
+          <p:nvPr/>
+        </p:nvPicPr>
+        <p:blipFill>
+          <a:blip r:embed="rId8"/>
+          <a:stretch>
+            <a:fillRect/>
+          </a:stretch>
+        </p:blipFill>
+        <p:spPr>
+          <a:xfrm>
+            <a:off x="18929544" y="19306700"/>
+            <a:ext cx="11152750" cy="5018737"/>
+          </a:xfrm>
+          <a:prstGeom prst="rect">
+            <a:avLst/>
+          </a:prstGeom>
+        </p:spPr>
+      </p:pic>
+      <p:sp>
+        <p:nvSpPr>
+          <p:cNvPr id="56" name="TextBox 55"/>
+          <p:cNvSpPr txBox="1"/>
+          <p:nvPr/>
+        </p:nvSpPr>
+        <p:spPr>
+          <a:xfrm>
+            <a:off x="17236440" y="24416878"/>
+            <a:ext cx="14538960" cy="749808"/>
+          </a:xfrm>
+          <a:prstGeom prst="rect">
+            <a:avLst/>
+          </a:prstGeom>
+          <a:noFill/>
+        </p:spPr>
+        <p:txBody>
+          <a:bodyPr wrap="square" anchor="t" lIns="45720" rIns="45720" tIns="18288" bIns="18288">
+            <a:spAutoFit/>
+          </a:bodyPr>
+          <a:lstStyle/>
+          <a:p>
+            <a:pPr algn="l">
+              <a:lnSpc>
+                <a:spcPct val="105000"/>
+              </a:lnSpc>
+              <a:spcAft>
+                <a:spcPts val="0"/>
+              </a:spcAft>
+            </a:pPr>
+            <a:r>
+              <a:rPr sz="2200" b="1">
+                <a:solidFill>
+                  <a:srgbClr val="A9B6C6"/>
+                </a:solidFill>
+                <a:latin typeface="Arial"/>
+              </a:rPr>
+              <a:t>Figure 5. </a:t>
+            </a:r>
+            <a:r>
+              <a:rPr sz="2200" b="0">
+                <a:solidFill>
+                  <a:srgbClr val="A9B6C6"/>
+                </a:solidFill>
+                <a:latin typeface="Arial"/>
+              </a:rPr>
+              <a:t>Six versions of the test, sliding the withheld months 10 days at a time. Right: median error on the red days (orange: start/end of the mission).</a:t>
+            </a:r>
+          </a:p>
+        </p:txBody>
+      </p:sp>
+      <p:sp>
+        <p:nvSpPr>
+          <p:cNvPr id="57" name="TextBox 56"/>
+          <p:cNvSpPr txBox="1"/>
+          <p:nvPr/>
+        </p:nvSpPr>
+        <p:spPr>
+          <a:xfrm>
+            <a:off x="17236440" y="25280986"/>
+            <a:ext cx="14538960" cy="1053998"/>
+          </a:xfrm>
+          <a:prstGeom prst="rect">
+            <a:avLst/>
+          </a:prstGeom>
+          <a:noFill/>
+        </p:spPr>
+        <p:txBody>
+          <a:bodyPr wrap="square" anchor="t" lIns="45720" rIns="45720" tIns="18288" bIns="18288">
+            <a:spAutoFit/>
+          </a:bodyPr>
+          <a:lstStyle/>
+          <a:p>
+            <a:pPr algn="l" marL="384048" indent="-384048">
+              <a:lnSpc>
+                <a:spcPct val="108000"/>
+              </a:lnSpc>
+              <a:spcAft>
+                <a:spcPts val="600"/>
+              </a:spcAft>
+              <a:buClr>
+                <a:srgbClr val="FF6F91"/>
+              </a:buClr>
+              <a:buFont typeface="Arial"/>
+              <a:buChar char="•"/>
+            </a:pPr>
+            <a:r>
+              <a:rPr sz="2600" b="1">
+                <a:solidFill>
+                  <a:srgbClr val="EEF3F8"/>
+                </a:solidFill>
+                <a:latin typeface="Arial"/>
+              </a:rPr>
+              <a:t>Largest errors: </a:t>
+            </a:r>
+            <a:r>
+              <a:rPr sz="2600" b="0">
+                <a:solidFill>
+                  <a:srgbClr val="EEF3F8"/>
+                </a:solidFill>
+                <a:latin typeface="Arial"/>
+              </a:rPr>
+              <a:t>along the plane of the planets, where the dust bands are (0.09%; Fig. 6)</a:t>
+            </a:r>
+          </a:p>
+          <a:p>
+            <a:pPr algn="l" marL="384048" indent="-384048">
+              <a:lnSpc>
+                <a:spcPct val="108000"/>
+              </a:lnSpc>
+              <a:spcAft>
+                <a:spcPts val="600"/>
+              </a:spcAft>
+              <a:buClr>
+                <a:srgbClr val="FF6F91"/>
+              </a:buClr>
+              <a:buFont typeface="Arial"/>
+              <a:buChar char="•"/>
+            </a:pPr>
+            <a:r>
+              <a:rPr sz="2600" b="1">
+                <a:solidFill>
+                  <a:srgbClr val="EEF3F8"/>
+                </a:solidFill>
+                <a:latin typeface="Arial"/>
+              </a:rPr>
+              <a:t>Smallest: </a:t>
+            </a:r>
+            <a:r>
+              <a:rPr sz="2600" b="0">
+                <a:solidFill>
+                  <a:srgbClr val="EEF3F8"/>
+                </a:solidFill>
+                <a:latin typeface="Arial"/>
+              </a:rPr>
+              <a:t>toward the poles (0.016%)</a:t>
+            </a:r>
+          </a:p>
+        </p:txBody>
+      </p:sp>
+      <p:pic>
+        <p:nvPicPr>
+          <p:cNvPr id="58" name="Picture 57" descr="skyerror_dark.png"/>
+          <p:cNvPicPr>
+            <a:picLocks noChangeAspect="1"/>
+          </p:cNvPicPr>
+          <p:nvPr/>
+        </p:nvPicPr>
+        <p:blipFill>
+          <a:blip r:embed="rId9"/>
+          <a:stretch>
+            <a:fillRect/>
+          </a:stretch>
+        </p:blipFill>
+        <p:spPr>
+          <a:xfrm>
+            <a:off x="18929544" y="26449285"/>
+            <a:ext cx="11152750" cy="5650726"/>
+          </a:xfrm>
+          <a:prstGeom prst="rect">
+            <a:avLst/>
+          </a:prstGeom>
+        </p:spPr>
+      </p:pic>
+      <p:sp>
+        <p:nvSpPr>
+          <p:cNvPr id="59" name="TextBox 58"/>
+          <p:cNvSpPr txBox="1"/>
+          <p:nvPr/>
+        </p:nvSpPr>
+        <p:spPr>
+          <a:xfrm>
+            <a:off x="17236440" y="32191452"/>
+            <a:ext cx="14538960" cy="749808"/>
+          </a:xfrm>
+          <a:prstGeom prst="rect">
+            <a:avLst/>
+          </a:prstGeom>
+          <a:noFill/>
+        </p:spPr>
+        <p:txBody>
+          <a:bodyPr wrap="square" anchor="t" lIns="45720" rIns="45720" tIns="18288" bIns="18288">
+            <a:spAutoFit/>
+          </a:bodyPr>
+          <a:lstStyle/>
+          <a:p>
+            <a:pPr algn="l">
+              <a:lnSpc>
+                <a:spcPct val="105000"/>
+              </a:lnSpc>
+              <a:spcAft>
+                <a:spcPts val="0"/>
+              </a:spcAft>
+            </a:pPr>
+            <a:r>
+              <a:rPr sz="2200" b="1">
+                <a:solidFill>
+                  <a:srgbClr val="A9B6C6"/>
+                </a:solidFill>
+                <a:latin typeface="Arial"/>
+              </a:rPr>
+              <a:t>Figure 6. </a:t>
+            </a:r>
+            <a:r>
+              <a:rPr sz="2200" b="0">
+                <a:solidFill>
+                  <a:srgbClr val="A9B6C6"/>
+                </a:solidFill>
+                <a:latin typeface="Arial"/>
+              </a:rPr>
+              <a:t>Error on pointings the network never saw, across the whole sky. Each pointing is drawn 3.5° wide, about SPHEREx's view. Grey: not tested.</a:t>
+            </a:r>
+          </a:p>
+        </p:txBody>
+      </p:sp>
+      <p:sp>
+        <p:nvSpPr>
+          <p:cNvPr id="60" name="Rectangle 59"/>
           <p:cNvSpPr/>
           <p:nvPr/>
         </p:nvSpPr>
         <p:spPr>
           <a:xfrm>
-            <a:off x="17236440" y="20253960"/>
-            <a:ext cx="14538960" cy="54864"/>
+            <a:off x="16824960" y="33604200"/>
+            <a:ext cx="15361920" cy="6629400"/>
           </a:xfrm>
           <a:prstGeom prst="rect">
             <a:avLst/>
           </a:prstGeom>
           <a:solidFill>
-            <a:srgbClr val="2D5A94"/>
+            <a:srgbClr val="0F2036"/>
           </a:solidFill>
-          <a:ln>
-            <a:noFill/>
+          <a:ln w="38100">
+            <a:solidFill>
+              <a:srgbClr val="2D5A94"/>
+            </a:solidFill>
           </a:ln>
           <a:effectLst/>
         </p:spPr>
@@ -5945,151 +6816,23 @@
       </p:sp>
       <p:sp>
         <p:nvSpPr>
-          <p:cNvPr id="52" name="TextBox 51"/>
-          <p:cNvSpPr txBox="1"/>
-          <p:nvPr/>
-        </p:nvSpPr>
-        <p:spPr>
-          <a:xfrm>
-            <a:off x="17236440" y="20482560"/>
-            <a:ext cx="14538960" cy="2194560"/>
-          </a:xfrm>
-          <a:prstGeom prst="rect">
-            <a:avLst/>
-          </a:prstGeom>
-          <a:noFill/>
-        </p:spPr>
-        <p:txBody>
-          <a:bodyPr wrap="square" anchor="t" lIns="45720" rIns="45720" tIns="18288" bIns="18288">
-            <a:spAutoFit/>
-          </a:bodyPr>
-          <a:lstStyle/>
-          <a:p>
-            <a:pPr algn="l">
-              <a:lnSpc>
-                <a:spcPct val="112000"/>
-              </a:lnSpc>
-              <a:spcAft>
-                <a:spcPts val="1000"/>
-              </a:spcAft>
-            </a:pPr>
-            <a:r>
-              <a:rPr sz="2700" b="1">
-                <a:solidFill>
-                  <a:srgbClr val="EEF3F8"/>
-                </a:solidFill>
-                <a:latin typeface="Arial"/>
-              </a:rPr>
-              <a:t>Where on the sky are the errors? </a:t>
-            </a:r>
-            <a:r>
-              <a:rPr sz="2700" b="0">
-                <a:solidFill>
-                  <a:srgbClr val="EEF3F8"/>
-                </a:solidFill>
-                <a:latin typeface="Arial"/>
-              </a:rPr>
-              <a:t>We repeated the test six times, sliding which months were withheld, so almost every pointing was tested by networks that never saw it. Every version reached 0.023–0.037% median error. The errors are largest along the plane of the planets, where the dust bands are (0.09%), and smallest toward the poles (0.016%).</a:t>
-            </a:r>
-          </a:p>
-        </p:txBody>
-      </p:sp>
-      <p:pic>
-        <p:nvPicPr>
-          <p:cNvPr id="53" name="Picture 52" descr="skyerror_dark.png"/>
-          <p:cNvPicPr>
-            <a:picLocks noChangeAspect="1"/>
-          </p:cNvPicPr>
-          <p:nvPr/>
-        </p:nvPicPr>
-        <p:blipFill>
-          <a:blip r:embed="rId7"/>
-          <a:stretch>
-            <a:fillRect/>
-          </a:stretch>
-        </p:blipFill>
-        <p:spPr>
-          <a:xfrm>
-            <a:off x="17236440" y="22677120"/>
-            <a:ext cx="14538960" cy="7366406"/>
-          </a:xfrm>
-          <a:prstGeom prst="rect">
-            <a:avLst/>
-          </a:prstGeom>
-        </p:spPr>
-      </p:pic>
-      <p:sp>
-        <p:nvSpPr>
-          <p:cNvPr id="54" name="TextBox 53"/>
-          <p:cNvSpPr txBox="1"/>
-          <p:nvPr/>
-        </p:nvSpPr>
-        <p:spPr>
-          <a:xfrm>
-            <a:off x="17236440" y="30043526"/>
-            <a:ext cx="14538960" cy="1188720"/>
-          </a:xfrm>
-          <a:prstGeom prst="rect">
-            <a:avLst/>
-          </a:prstGeom>
-          <a:noFill/>
-        </p:spPr>
-        <p:txBody>
-          <a:bodyPr wrap="square" anchor="t" lIns="45720" rIns="45720" tIns="18288" bIns="18288">
-            <a:spAutoFit/>
-          </a:bodyPr>
-          <a:lstStyle/>
-          <a:p>
-            <a:pPr algn="l">
-              <a:lnSpc>
-                <a:spcPct val="105000"/>
-              </a:lnSpc>
-              <a:spcAft>
-                <a:spcPts val="1000"/>
-              </a:spcAft>
-            </a:pPr>
-            <a:r>
-              <a:rPr sz="2200" b="1">
-                <a:solidFill>
-                  <a:srgbClr val="A9B6C6"/>
-                </a:solidFill>
-                <a:latin typeface="Arial"/>
-              </a:rPr>
-              <a:t>Figure 4. </a:t>
-            </a:r>
-            <a:r>
-              <a:rPr sz="2200" b="0">
-                <a:solidFill>
-                  <a:srgbClr val="A9B6C6"/>
-                </a:solidFill>
-                <a:latin typeface="Arial"/>
-              </a:rPr>
-              <a:t>The network's error on pointings it never saw, across the whole sky (plane of the planets across the middle). Each pointing is drawn as a 3.5°-wide patch, about the width of SPHEREx's view. Grey: not observed in the 140 days, or only at the very start or end of the mission.</a:t>
-            </a:r>
-          </a:p>
-        </p:txBody>
-      </p:sp>
-      <p:sp>
-        <p:nvSpPr>
-          <p:cNvPr id="55" name="Rectangle 54"/>
+          <p:cNvPr id="61" name="Rectangle 60"/>
           <p:cNvSpPr/>
           <p:nvPr/>
         </p:nvSpPr>
         <p:spPr>
           <a:xfrm>
-            <a:off x="16824960" y="32141160"/>
-            <a:ext cx="15361920" cy="8092439"/>
+            <a:off x="16824960" y="33604200"/>
+            <a:ext cx="15361920" cy="914400"/>
           </a:xfrm>
           <a:prstGeom prst="rect">
             <a:avLst/>
           </a:prstGeom>
           <a:solidFill>
-            <a:srgbClr val="0F2036"/>
+            <a:srgbClr val="1E3557"/>
           </a:solidFill>
-          <a:ln w="38100">
-            <a:solidFill>
-              <a:srgbClr val="2D5A94"/>
-            </a:solidFill>
+          <a:ln>
+            <a:noFill/>
           </a:ln>
           <a:effectLst/>
         </p:spPr>
@@ -6117,23 +6860,69 @@
       </p:sp>
       <p:sp>
         <p:nvSpPr>
-          <p:cNvPr id="56" name="Rectangle 55"/>
+          <p:cNvPr id="62" name="TextBox 61"/>
+          <p:cNvSpPr txBox="1"/>
+          <p:nvPr/>
+        </p:nvSpPr>
+        <p:spPr>
+          <a:xfrm>
+            <a:off x="16824960" y="33604200"/>
+            <a:ext cx="15361920" cy="914400"/>
+          </a:xfrm>
+          <a:prstGeom prst="rect">
+            <a:avLst/>
+          </a:prstGeom>
+          <a:noFill/>
+        </p:spPr>
+        <p:txBody>
+          <a:bodyPr wrap="square" anchor="ctr" lIns="45720" rIns="45720" tIns="18288" bIns="18288">
+            <a:spAutoFit/>
+          </a:bodyPr>
+          <a:lstStyle/>
+          <a:p>
+            <a:pPr algn="ctr">
+              <a:lnSpc>
+                <a:spcPct val="112000"/>
+              </a:lnSpc>
+              <a:spcAft>
+                <a:spcPts val="0"/>
+              </a:spcAft>
+            </a:pPr>
+            <a:r>
+              <a:rPr sz="4000" b="1">
+                <a:solidFill>
+                  <a:srgbClr val="FFFFFF"/>
+                </a:solidFill>
+                <a:latin typeface="Arial"/>
+              </a:rPr>
+              <a:t>Next Steps</a:t>
+            </a:r>
+          </a:p>
+        </p:txBody>
+      </p:sp>
+      <p:sp>
+        <p:nvSpPr>
+          <p:cNvPr id="63" name="Rounded Rectangle 62"/>
           <p:cNvSpPr/>
           <p:nvPr/>
         </p:nvSpPr>
         <p:spPr>
           <a:xfrm>
-            <a:off x="16824960" y="32141160"/>
-            <a:ext cx="15361920" cy="1051560"/>
-          </a:xfrm>
-          <a:prstGeom prst="rect">
-            <a:avLst/>
+            <a:off x="17236440" y="34838640"/>
+            <a:ext cx="14538960" cy="1024128"/>
+          </a:xfrm>
+          <a:prstGeom prst="roundRect">
+            <a:avLst>
+              <a:gd name="adj" fmla="val 15000"/>
+            </a:avLst>
           </a:prstGeom>
           <a:solidFill>
-            <a:srgbClr val="1E3557"/>
+            <a:srgbClr val="16304F"/>
           </a:solidFill>
-          <a:ln>
-            <a:noFill/>
+          <a:ln w="63500">
+            <a:solidFill>
+              <a:srgbClr val="66BB6A"/>
+            </a:solidFill>
           </a:ln>
           <a:effectLst/>
         </p:spPr>
@@ -6161,14 +6950,14 @@
       </p:sp>
       <p:sp>
         <p:nvSpPr>
-          <p:cNvPr id="57" name="TextBox 56"/>
+          <p:cNvPr id="64" name="TextBox 63"/>
           <p:cNvSpPr txBox="1"/>
           <p:nvPr/>
         </p:nvSpPr>
         <p:spPr>
           <a:xfrm>
-            <a:off x="16824960" y="32141160"/>
-            <a:ext cx="15361920" cy="1051560"/>
+            <a:off x="17465040" y="34838640"/>
+            <a:ext cx="3931920" cy="1024128"/>
           </a:xfrm>
           <a:prstGeom prst="rect">
             <a:avLst/>
@@ -6181,49 +6970,106 @@
           </a:bodyPr>
           <a:lstStyle/>
           <a:p>
-            <a:pPr algn="ctr">
+            <a:pPr algn="l">
               <a:lnSpc>
-                <a:spcPct val="112000"/>
+                <a:spcPct val="100000"/>
               </a:lnSpc>
               <a:spcAft>
                 <a:spcPts val="0"/>
               </a:spcAft>
             </a:pPr>
             <a:r>
-              <a:rPr sz="5000" b="1">
-                <a:solidFill>
-                  <a:srgbClr val="FFFFFF"/>
-                </a:solidFill>
-                <a:latin typeface="Arial"/>
-              </a:rPr>
-              <a:t>Next Steps</a:t>
-            </a:r>
-          </a:p>
-        </p:txBody>
-      </p:sp>
-      <p:sp>
-        <p:nvSpPr>
-          <p:cNvPr id="58" name="Rounded Rectangle 57"/>
+              <a:rPr sz="2200" b="1">
+                <a:solidFill>
+                  <a:srgbClr val="66BB6A"/>
+                </a:solidFill>
+                <a:latin typeface="Arial"/>
+              </a:rPr>
+              <a:t>✓ DONE</a:t>
+            </a:r>
+          </a:p>
+          <a:p>
+            <a:pPr algn="l">
+              <a:lnSpc>
+                <a:spcPct val="100000"/>
+              </a:lnSpc>
+              <a:spcAft>
+                <a:spcPts val="0"/>
+              </a:spcAft>
+            </a:pPr>
+            <a:r>
+              <a:rPr sz="2200" b="1">
+                <a:solidFill>
+                  <a:srgbClr val="66BB6A"/>
+                </a:solidFill>
+                <a:latin typeface="Arial"/>
+              </a:rPr>
+              <a:t>Validate</a:t>
+            </a:r>
+          </a:p>
+        </p:txBody>
+      </p:sp>
+      <p:sp>
+        <p:nvSpPr>
+          <p:cNvPr id="65" name="TextBox 64"/>
+          <p:cNvSpPr txBox="1"/>
+          <p:nvPr/>
+        </p:nvSpPr>
+        <p:spPr>
+          <a:xfrm>
+            <a:off x="21442680" y="34838640"/>
+            <a:ext cx="10104120" cy="1024128"/>
+          </a:xfrm>
+          <a:prstGeom prst="rect">
+            <a:avLst/>
+          </a:prstGeom>
+          <a:noFill/>
+        </p:spPr>
+        <p:txBody>
+          <a:bodyPr wrap="square" anchor="ctr" lIns="45720" rIns="45720" tIns="18288" bIns="18288">
+            <a:spAutoFit/>
+          </a:bodyPr>
+          <a:lstStyle/>
+          <a:p>
+            <a:pPr algn="l">
+              <a:lnSpc>
+                <a:spcPct val="100000"/>
+              </a:lnSpc>
+              <a:spcAft>
+                <a:spcPts val="0"/>
+              </a:spcAft>
+            </a:pPr>
+            <a:r>
+              <a:rPr sz="2300" b="0">
+                <a:solidFill>
+                  <a:srgbClr val="EEF3F8"/>
+                </a:solidFill>
+                <a:latin typeface="Arial"/>
+              </a:rPr>
+              <a:t>Learn ZodiPy's simulated sky from geometry alone; test on unseen months and sky regions</a:t>
+            </a:r>
+          </a:p>
+        </p:txBody>
+      </p:sp>
+      <p:sp>
+        <p:nvSpPr>
+          <p:cNvPr id="66" name="Down Arrow 65"/>
           <p:cNvSpPr/>
           <p:nvPr/>
         </p:nvSpPr>
         <p:spPr>
           <a:xfrm>
-            <a:off x="17236440" y="33512760"/>
-            <a:ext cx="14538960" cy="1234440"/>
-          </a:xfrm>
-          <a:prstGeom prst="roundRect">
-            <a:avLst>
-              <a:gd name="adj" fmla="val 15000"/>
-            </a:avLst>
+            <a:off x="24231600" y="35890200"/>
+            <a:ext cx="548640" cy="182880"/>
+          </a:xfrm>
+          <a:prstGeom prst="downArrow">
+            <a:avLst/>
           </a:prstGeom>
           <a:solidFill>
-            <a:srgbClr val="16304F"/>
+            <a:srgbClr val="FF6F91"/>
           </a:solidFill>
-          <a:ln w="63500">
-            <a:solidFill>
-              <a:srgbClr val="66BB6A"/>
-            </a:solidFill>
+          <a:ln>
+            <a:noFill/>
           </a:ln>
           <a:effectLst/>
         </p:spPr>
@@ -6251,126 +7097,27 @@
       </p:sp>
       <p:sp>
         <p:nvSpPr>
-          <p:cNvPr id="59" name="TextBox 58"/>
-          <p:cNvSpPr txBox="1"/>
-          <p:nvPr/>
-        </p:nvSpPr>
-        <p:spPr>
-          <a:xfrm>
-            <a:off x="17465040" y="33512760"/>
-            <a:ext cx="3931920" cy="1234440"/>
-          </a:xfrm>
-          <a:prstGeom prst="rect">
-            <a:avLst/>
-          </a:prstGeom>
-          <a:noFill/>
-        </p:spPr>
-        <p:txBody>
-          <a:bodyPr wrap="square" anchor="ctr" lIns="45720" rIns="45720" tIns="18288" bIns="18288">
-            <a:spAutoFit/>
-          </a:bodyPr>
-          <a:lstStyle/>
-          <a:p>
-            <a:pPr algn="l">
-              <a:lnSpc>
-                <a:spcPct val="100000"/>
-              </a:lnSpc>
-              <a:spcAft>
-                <a:spcPts val="0"/>
-              </a:spcAft>
-            </a:pPr>
-            <a:r>
-              <a:rPr sz="2400" b="1">
-                <a:solidFill>
-                  <a:srgbClr val="66BB6A"/>
-                </a:solidFill>
-                <a:latin typeface="Arial"/>
-              </a:rPr>
-              <a:t>✓ DONE</a:t>
-            </a:r>
-          </a:p>
-          <a:p>
-            <a:pPr algn="l">
-              <a:lnSpc>
-                <a:spcPct val="100000"/>
-              </a:lnSpc>
-              <a:spcAft>
-                <a:spcPts val="0"/>
-              </a:spcAft>
-            </a:pPr>
-            <a:r>
-              <a:rPr sz="2400" b="1">
-                <a:solidFill>
-                  <a:srgbClr val="66BB6A"/>
-                </a:solidFill>
-                <a:latin typeface="Arial"/>
-              </a:rPr>
-              <a:t>Validate</a:t>
-            </a:r>
-          </a:p>
-        </p:txBody>
-      </p:sp>
-      <p:sp>
-        <p:nvSpPr>
-          <p:cNvPr id="60" name="TextBox 59"/>
-          <p:cNvSpPr txBox="1"/>
-          <p:nvPr/>
-        </p:nvSpPr>
-        <p:spPr>
-          <a:xfrm>
-            <a:off x="21442680" y="33512760"/>
-            <a:ext cx="10104120" cy="1234440"/>
-          </a:xfrm>
-          <a:prstGeom prst="rect">
-            <a:avLst/>
-          </a:prstGeom>
-          <a:noFill/>
-        </p:spPr>
-        <p:txBody>
-          <a:bodyPr wrap="square" anchor="ctr" lIns="45720" rIns="45720" tIns="18288" bIns="18288">
-            <a:spAutoFit/>
-          </a:bodyPr>
-          <a:lstStyle/>
-          <a:p>
-            <a:pPr algn="l">
-              <a:lnSpc>
-                <a:spcPct val="102000"/>
-              </a:lnSpc>
-              <a:spcAft>
-                <a:spcPts val="0"/>
-              </a:spcAft>
-            </a:pPr>
-            <a:r>
-              <a:rPr sz="2500" b="0">
-                <a:solidFill>
-                  <a:srgbClr val="EEF3F8"/>
-                </a:solidFill>
-                <a:latin typeface="Arial"/>
-              </a:rPr>
-              <a:t>Learn ZodiPy's simulated sky from geometry alone; test on unseen months and sky regions</a:t>
-            </a:r>
-          </a:p>
-        </p:txBody>
-      </p:sp>
-      <p:sp>
-        <p:nvSpPr>
-          <p:cNvPr id="61" name="Down Arrow 60"/>
+          <p:cNvPr id="67" name="Rounded Rectangle 66"/>
           <p:cNvSpPr/>
           <p:nvPr/>
         </p:nvSpPr>
         <p:spPr>
           <a:xfrm>
-            <a:off x="24231600" y="34774632"/>
-            <a:ext cx="548640" cy="237744"/>
-          </a:xfrm>
-          <a:prstGeom prst="downArrow">
-            <a:avLst/>
+            <a:off x="17236440" y="36100512"/>
+            <a:ext cx="14538960" cy="1024128"/>
+          </a:xfrm>
+          <a:prstGeom prst="roundRect">
+            <a:avLst>
+              <a:gd name="adj" fmla="val 15000"/>
+            </a:avLst>
           </a:prstGeom>
           <a:solidFill>
-            <a:srgbClr val="FF6F91"/>
+            <a:srgbClr val="16304F"/>
           </a:solidFill>
-          <a:ln>
-            <a:noFill/>
+          <a:ln w="63500">
+            <a:solidFill>
+              <a:srgbClr val="FFB000"/>
+            </a:solidFill>
           </a:ln>
           <a:effectLst/>
         </p:spPr>
@@ -6398,27 +7145,126 @@
       </p:sp>
       <p:sp>
         <p:nvSpPr>
-          <p:cNvPr id="62" name="Rounded Rectangle 61"/>
+          <p:cNvPr id="68" name="TextBox 67"/>
+          <p:cNvSpPr txBox="1"/>
+          <p:nvPr/>
+        </p:nvSpPr>
+        <p:spPr>
+          <a:xfrm>
+            <a:off x="17465040" y="36100512"/>
+            <a:ext cx="3931920" cy="1024128"/>
+          </a:xfrm>
+          <a:prstGeom prst="rect">
+            <a:avLst/>
+          </a:prstGeom>
+          <a:noFill/>
+        </p:spPr>
+        <p:txBody>
+          <a:bodyPr wrap="square" anchor="ctr" lIns="45720" rIns="45720" tIns="18288" bIns="18288">
+            <a:spAutoFit/>
+          </a:bodyPr>
+          <a:lstStyle/>
+          <a:p>
+            <a:pPr algn="l">
+              <a:lnSpc>
+                <a:spcPct val="100000"/>
+              </a:lnSpc>
+              <a:spcAft>
+                <a:spcPts val="0"/>
+              </a:spcAft>
+            </a:pPr>
+            <a:r>
+              <a:rPr sz="2200" b="1">
+                <a:solidFill>
+                  <a:srgbClr val="FFB000"/>
+                </a:solidFill>
+                <a:latin typeface="Arial"/>
+              </a:rPr>
+              <a:t>IN PROGRESS</a:t>
+            </a:r>
+          </a:p>
+          <a:p>
+            <a:pPr algn="l">
+              <a:lnSpc>
+                <a:spcPct val="100000"/>
+              </a:lnSpc>
+              <a:spcAft>
+                <a:spcPts val="0"/>
+              </a:spcAft>
+            </a:pPr>
+            <a:r>
+              <a:rPr sz="2200" b="1">
+                <a:solidFill>
+                  <a:srgbClr val="FFB000"/>
+                </a:solidFill>
+                <a:latin typeface="Arial"/>
+              </a:rPr>
+              <a:t>Refine</a:t>
+            </a:r>
+          </a:p>
+        </p:txBody>
+      </p:sp>
+      <p:sp>
+        <p:nvSpPr>
+          <p:cNvPr id="69" name="TextBox 68"/>
+          <p:cNvSpPr txBox="1"/>
+          <p:nvPr/>
+        </p:nvSpPr>
+        <p:spPr>
+          <a:xfrm>
+            <a:off x="21442680" y="36100512"/>
+            <a:ext cx="10104120" cy="1024128"/>
+          </a:xfrm>
+          <a:prstGeom prst="rect">
+            <a:avLst/>
+          </a:prstGeom>
+          <a:noFill/>
+        </p:spPr>
+        <p:txBody>
+          <a:bodyPr wrap="square" anchor="ctr" lIns="45720" rIns="45720" tIns="18288" bIns="18288">
+            <a:spAutoFit/>
+          </a:bodyPr>
+          <a:lstStyle/>
+          <a:p>
+            <a:pPr algn="l">
+              <a:lnSpc>
+                <a:spcPct val="100000"/>
+              </a:lnSpc>
+              <a:spcAft>
+                <a:spcPts val="0"/>
+              </a:spcAft>
+            </a:pPr>
+            <a:r>
+              <a:rPr sz="2300" b="0">
+                <a:solidFill>
+                  <a:srgbClr val="EEF3F8"/>
+                </a:solidFill>
+                <a:latin typeface="Arial"/>
+              </a:rPr>
+              <a:t>Longer training; all SPHEREx wavelengths (a first 1.25–5 μm version: ~0.1% error)</a:t>
+            </a:r>
+          </a:p>
+        </p:txBody>
+      </p:sp>
+      <p:sp>
+        <p:nvSpPr>
+          <p:cNvPr id="70" name="Down Arrow 69"/>
           <p:cNvSpPr/>
           <p:nvPr/>
         </p:nvSpPr>
         <p:spPr>
           <a:xfrm>
-            <a:off x="17236440" y="35039808"/>
-            <a:ext cx="14538960" cy="1234440"/>
-          </a:xfrm>
-          <a:prstGeom prst="roundRect">
-            <a:avLst>
-              <a:gd name="adj" fmla="val 15000"/>
-            </a:avLst>
+            <a:off x="24231600" y="37152071"/>
+            <a:ext cx="548640" cy="182880"/>
+          </a:xfrm>
+          <a:prstGeom prst="downArrow">
+            <a:avLst/>
           </a:prstGeom>
           <a:solidFill>
-            <a:srgbClr val="16304F"/>
+            <a:srgbClr val="FF6F91"/>
           </a:solidFill>
-          <a:ln w="63500">
-            <a:solidFill>
-              <a:srgbClr val="FFB000"/>
-            </a:solidFill>
+          <a:ln>
+            <a:noFill/>
           </a:ln>
           <a:effectLst/>
         </p:spPr>
@@ -6446,126 +7292,27 @@
       </p:sp>
       <p:sp>
         <p:nvSpPr>
-          <p:cNvPr id="63" name="TextBox 62"/>
-          <p:cNvSpPr txBox="1"/>
-          <p:nvPr/>
-        </p:nvSpPr>
-        <p:spPr>
-          <a:xfrm>
-            <a:off x="17465040" y="35039808"/>
-            <a:ext cx="3931920" cy="1234440"/>
-          </a:xfrm>
-          <a:prstGeom prst="rect">
-            <a:avLst/>
-          </a:prstGeom>
-          <a:noFill/>
-        </p:spPr>
-        <p:txBody>
-          <a:bodyPr wrap="square" anchor="ctr" lIns="45720" rIns="45720" tIns="18288" bIns="18288">
-            <a:spAutoFit/>
-          </a:bodyPr>
-          <a:lstStyle/>
-          <a:p>
-            <a:pPr algn="l">
-              <a:lnSpc>
-                <a:spcPct val="100000"/>
-              </a:lnSpc>
-              <a:spcAft>
-                <a:spcPts val="0"/>
-              </a:spcAft>
-            </a:pPr>
-            <a:r>
-              <a:rPr sz="2400" b="1">
-                <a:solidFill>
-                  <a:srgbClr val="FFB000"/>
-                </a:solidFill>
-                <a:latin typeface="Arial"/>
-              </a:rPr>
-              <a:t>IN PROGRESS</a:t>
-            </a:r>
-          </a:p>
-          <a:p>
-            <a:pPr algn="l">
-              <a:lnSpc>
-                <a:spcPct val="100000"/>
-              </a:lnSpc>
-              <a:spcAft>
-                <a:spcPts val="0"/>
-              </a:spcAft>
-            </a:pPr>
-            <a:r>
-              <a:rPr sz="2400" b="1">
-                <a:solidFill>
-                  <a:srgbClr val="FFB000"/>
-                </a:solidFill>
-                <a:latin typeface="Arial"/>
-              </a:rPr>
-              <a:t>Refine</a:t>
-            </a:r>
-          </a:p>
-        </p:txBody>
-      </p:sp>
-      <p:sp>
-        <p:nvSpPr>
-          <p:cNvPr id="64" name="TextBox 63"/>
-          <p:cNvSpPr txBox="1"/>
-          <p:nvPr/>
-        </p:nvSpPr>
-        <p:spPr>
-          <a:xfrm>
-            <a:off x="21442680" y="35039808"/>
-            <a:ext cx="10104120" cy="1234440"/>
-          </a:xfrm>
-          <a:prstGeom prst="rect">
-            <a:avLst/>
-          </a:prstGeom>
-          <a:noFill/>
-        </p:spPr>
-        <p:txBody>
-          <a:bodyPr wrap="square" anchor="ctr" lIns="45720" rIns="45720" tIns="18288" bIns="18288">
-            <a:spAutoFit/>
-          </a:bodyPr>
-          <a:lstStyle/>
-          <a:p>
-            <a:pPr algn="l">
-              <a:lnSpc>
-                <a:spcPct val="102000"/>
-              </a:lnSpc>
-              <a:spcAft>
-                <a:spcPts val="0"/>
-              </a:spcAft>
-            </a:pPr>
-            <a:r>
-              <a:rPr sz="2500" b="0">
-                <a:solidFill>
-                  <a:srgbClr val="EEF3F8"/>
-                </a:solidFill>
-                <a:latin typeface="Arial"/>
-              </a:rPr>
-              <a:t>Longer training; all SPHEREx wavelengths (a first 1.25–5 μm version: ~0.1% error)</a:t>
-            </a:r>
-          </a:p>
-        </p:txBody>
-      </p:sp>
-      <p:sp>
-        <p:nvSpPr>
-          <p:cNvPr id="65" name="Down Arrow 64"/>
+          <p:cNvPr id="71" name="Rounded Rectangle 70"/>
           <p:cNvSpPr/>
           <p:nvPr/>
         </p:nvSpPr>
         <p:spPr>
           <a:xfrm>
-            <a:off x="24231600" y="36301680"/>
-            <a:ext cx="548640" cy="237744"/>
-          </a:xfrm>
-          <a:prstGeom prst="downArrow">
-            <a:avLst/>
+            <a:off x="17236440" y="37362383"/>
+            <a:ext cx="14538960" cy="1024128"/>
+          </a:xfrm>
+          <a:prstGeom prst="roundRect">
+            <a:avLst>
+              <a:gd name="adj" fmla="val 15000"/>
+            </a:avLst>
           </a:prstGeom>
           <a:solidFill>
-            <a:srgbClr val="FF6F91"/>
+            <a:srgbClr val="16304F"/>
           </a:solidFill>
-          <a:ln>
-            <a:noFill/>
+          <a:ln w="63500">
+            <a:solidFill>
+              <a:srgbClr val="A9B6C6"/>
+            </a:solidFill>
           </a:ln>
           <a:effectLst/>
         </p:spPr>
@@ -6593,27 +7340,126 @@
       </p:sp>
       <p:sp>
         <p:nvSpPr>
-          <p:cNvPr id="66" name="Rounded Rectangle 65"/>
+          <p:cNvPr id="72" name="TextBox 71"/>
+          <p:cNvSpPr txBox="1"/>
+          <p:nvPr/>
+        </p:nvSpPr>
+        <p:spPr>
+          <a:xfrm>
+            <a:off x="17465040" y="37362383"/>
+            <a:ext cx="3931920" cy="1024128"/>
+          </a:xfrm>
+          <a:prstGeom prst="rect">
+            <a:avLst/>
+          </a:prstGeom>
+          <a:noFill/>
+        </p:spPr>
+        <p:txBody>
+          <a:bodyPr wrap="square" anchor="ctr" lIns="45720" rIns="45720" tIns="18288" bIns="18288">
+            <a:spAutoFit/>
+          </a:bodyPr>
+          <a:lstStyle/>
+          <a:p>
+            <a:pPr algn="l">
+              <a:lnSpc>
+                <a:spcPct val="100000"/>
+              </a:lnSpc>
+              <a:spcAft>
+                <a:spcPts val="0"/>
+              </a:spcAft>
+            </a:pPr>
+            <a:r>
+              <a:rPr sz="2200" b="1">
+                <a:solidFill>
+                  <a:srgbClr val="A9B6C6"/>
+                </a:solidFill>
+                <a:latin typeface="Arial"/>
+              </a:rPr>
+              <a:t>NEXT</a:t>
+            </a:r>
+          </a:p>
+          <a:p>
+            <a:pPr algn="l">
+              <a:lnSpc>
+                <a:spcPct val="100000"/>
+              </a:lnSpc>
+              <a:spcAft>
+                <a:spcPts val="0"/>
+              </a:spcAft>
+            </a:pPr>
+            <a:r>
+              <a:rPr sz="2200" b="1">
+                <a:solidFill>
+                  <a:srgbClr val="A9B6C6"/>
+                </a:solidFill>
+                <a:latin typeface="Arial"/>
+              </a:rPr>
+              <a:t>Scale up</a:t>
+            </a:r>
+          </a:p>
+        </p:txBody>
+      </p:sp>
+      <p:sp>
+        <p:nvSpPr>
+          <p:cNvPr id="73" name="TextBox 72"/>
+          <p:cNvSpPr txBox="1"/>
+          <p:nvPr/>
+        </p:nvSpPr>
+        <p:spPr>
+          <a:xfrm>
+            <a:off x="21442680" y="37362383"/>
+            <a:ext cx="10104120" cy="1024128"/>
+          </a:xfrm>
+          <a:prstGeom prst="rect">
+            <a:avLst/>
+          </a:prstGeom>
+          <a:noFill/>
+        </p:spPr>
+        <p:txBody>
+          <a:bodyPr wrap="square" anchor="ctr" lIns="45720" rIns="45720" tIns="18288" bIns="18288">
+            <a:spAutoFit/>
+          </a:bodyPr>
+          <a:lstStyle/>
+          <a:p>
+            <a:pPr algn="l">
+              <a:lnSpc>
+                <a:spcPct val="100000"/>
+              </a:lnSpc>
+              <a:spcAft>
+                <a:spcPts val="0"/>
+              </a:spcAft>
+            </a:pPr>
+            <a:r>
+              <a:rPr sz="2300" b="0">
+                <a:solidFill>
+                  <a:srgbClr val="EEF3F8"/>
+                </a:solidFill>
+                <a:latin typeface="Arial"/>
+              </a:rPr>
+              <a:t>Move training to a computing cluster</a:t>
+            </a:r>
+          </a:p>
+        </p:txBody>
+      </p:sp>
+      <p:sp>
+        <p:nvSpPr>
+          <p:cNvPr id="74" name="Down Arrow 73"/>
           <p:cNvSpPr/>
           <p:nvPr/>
         </p:nvSpPr>
         <p:spPr>
           <a:xfrm>
-            <a:off x="17236440" y="36566856"/>
-            <a:ext cx="14538960" cy="1234440"/>
-          </a:xfrm>
-          <a:prstGeom prst="roundRect">
-            <a:avLst>
-              <a:gd name="adj" fmla="val 15000"/>
-            </a:avLst>
+            <a:off x="24231600" y="38413943"/>
+            <a:ext cx="548640" cy="182880"/>
+          </a:xfrm>
+          <a:prstGeom prst="downArrow">
+            <a:avLst/>
           </a:prstGeom>
           <a:solidFill>
-            <a:srgbClr val="16304F"/>
+            <a:srgbClr val="FF6F91"/>
           </a:solidFill>
-          <a:ln w="63500">
-            <a:solidFill>
-              <a:srgbClr val="A9B6C6"/>
-            </a:solidFill>
+          <a:ln>
+            <a:noFill/>
           </a:ln>
           <a:effectLst/>
         </p:spPr>
@@ -6641,126 +7487,27 @@
       </p:sp>
       <p:sp>
         <p:nvSpPr>
-          <p:cNvPr id="67" name="TextBox 66"/>
-          <p:cNvSpPr txBox="1"/>
-          <p:nvPr/>
-        </p:nvSpPr>
-        <p:spPr>
-          <a:xfrm>
-            <a:off x="17465040" y="36566856"/>
-            <a:ext cx="3931920" cy="1234440"/>
-          </a:xfrm>
-          <a:prstGeom prst="rect">
-            <a:avLst/>
-          </a:prstGeom>
-          <a:noFill/>
-        </p:spPr>
-        <p:txBody>
-          <a:bodyPr wrap="square" anchor="ctr" lIns="45720" rIns="45720" tIns="18288" bIns="18288">
-            <a:spAutoFit/>
-          </a:bodyPr>
-          <a:lstStyle/>
-          <a:p>
-            <a:pPr algn="l">
-              <a:lnSpc>
-                <a:spcPct val="100000"/>
-              </a:lnSpc>
-              <a:spcAft>
-                <a:spcPts val="0"/>
-              </a:spcAft>
-            </a:pPr>
-            <a:r>
-              <a:rPr sz="2400" b="1">
-                <a:solidFill>
-                  <a:srgbClr val="A9B6C6"/>
-                </a:solidFill>
-                <a:latin typeface="Arial"/>
-              </a:rPr>
-              <a:t>NEXT</a:t>
-            </a:r>
-          </a:p>
-          <a:p>
-            <a:pPr algn="l">
-              <a:lnSpc>
-                <a:spcPct val="100000"/>
-              </a:lnSpc>
-              <a:spcAft>
-                <a:spcPts val="0"/>
-              </a:spcAft>
-            </a:pPr>
-            <a:r>
-              <a:rPr sz="2400" b="1">
-                <a:solidFill>
-                  <a:srgbClr val="A9B6C6"/>
-                </a:solidFill>
-                <a:latin typeface="Arial"/>
-              </a:rPr>
-              <a:t>Scale up</a:t>
-            </a:r>
-          </a:p>
-        </p:txBody>
-      </p:sp>
-      <p:sp>
-        <p:nvSpPr>
-          <p:cNvPr id="68" name="TextBox 67"/>
-          <p:cNvSpPr txBox="1"/>
-          <p:nvPr/>
-        </p:nvSpPr>
-        <p:spPr>
-          <a:xfrm>
-            <a:off x="21442680" y="36566856"/>
-            <a:ext cx="10104120" cy="1234440"/>
-          </a:xfrm>
-          <a:prstGeom prst="rect">
-            <a:avLst/>
-          </a:prstGeom>
-          <a:noFill/>
-        </p:spPr>
-        <p:txBody>
-          <a:bodyPr wrap="square" anchor="ctr" lIns="45720" rIns="45720" tIns="18288" bIns="18288">
-            <a:spAutoFit/>
-          </a:bodyPr>
-          <a:lstStyle/>
-          <a:p>
-            <a:pPr algn="l">
-              <a:lnSpc>
-                <a:spcPct val="102000"/>
-              </a:lnSpc>
-              <a:spcAft>
-                <a:spcPts val="0"/>
-              </a:spcAft>
-            </a:pPr>
-            <a:r>
-              <a:rPr sz="2500" b="0">
-                <a:solidFill>
-                  <a:srgbClr val="EEF3F8"/>
-                </a:solidFill>
-                <a:latin typeface="Arial"/>
-              </a:rPr>
-              <a:t>Move training to a computing cluster</a:t>
-            </a:r>
-          </a:p>
-        </p:txBody>
-      </p:sp>
-      <p:sp>
-        <p:nvSpPr>
-          <p:cNvPr id="69" name="Down Arrow 68"/>
+          <p:cNvPr id="75" name="Rounded Rectangle 74"/>
           <p:cNvSpPr/>
           <p:nvPr/>
         </p:nvSpPr>
         <p:spPr>
           <a:xfrm>
-            <a:off x="24231600" y="37828728"/>
-            <a:ext cx="548640" cy="237744"/>
-          </a:xfrm>
-          <a:prstGeom prst="downArrow">
-            <a:avLst/>
+            <a:off x="17236440" y="38624255"/>
+            <a:ext cx="14538960" cy="1024128"/>
+          </a:xfrm>
+          <a:prstGeom prst="roundRect">
+            <a:avLst>
+              <a:gd name="adj" fmla="val 15000"/>
+            </a:avLst>
           </a:prstGeom>
           <a:solidFill>
-            <a:srgbClr val="FF6F91"/>
+            <a:srgbClr val="16304F"/>
           </a:solidFill>
-          <a:ln>
-            <a:noFill/>
+          <a:ln w="63500">
+            <a:solidFill>
+              <a:srgbClr val="A9B6C6"/>
+            </a:solidFill>
           </a:ln>
           <a:effectLst/>
         </p:spPr>
@@ -6788,26 +7535,169 @@
       </p:sp>
       <p:sp>
         <p:nvSpPr>
-          <p:cNvPr id="70" name="Rounded Rectangle 69"/>
+          <p:cNvPr id="76" name="TextBox 75"/>
+          <p:cNvSpPr txBox="1"/>
+          <p:nvPr/>
+        </p:nvSpPr>
+        <p:spPr>
+          <a:xfrm>
+            <a:off x="17465040" y="38624255"/>
+            <a:ext cx="3931920" cy="1024128"/>
+          </a:xfrm>
+          <a:prstGeom prst="rect">
+            <a:avLst/>
+          </a:prstGeom>
+          <a:noFill/>
+        </p:spPr>
+        <p:txBody>
+          <a:bodyPr wrap="square" anchor="ctr" lIns="45720" rIns="45720" tIns="18288" bIns="18288">
+            <a:spAutoFit/>
+          </a:bodyPr>
+          <a:lstStyle/>
+          <a:p>
+            <a:pPr algn="l">
+              <a:lnSpc>
+                <a:spcPct val="100000"/>
+              </a:lnSpc>
+              <a:spcAft>
+                <a:spcPts val="0"/>
+              </a:spcAft>
+            </a:pPr>
+            <a:r>
+              <a:rPr sz="2200" b="1">
+                <a:solidFill>
+                  <a:srgbClr val="A9B6C6"/>
+                </a:solidFill>
+                <a:latin typeface="Arial"/>
+              </a:rPr>
+              <a:t>NEXT</a:t>
+            </a:r>
+          </a:p>
+          <a:p>
+            <a:pPr algn="l">
+              <a:lnSpc>
+                <a:spcPct val="100000"/>
+              </a:lnSpc>
+              <a:spcAft>
+                <a:spcPts val="0"/>
+              </a:spcAft>
+            </a:pPr>
+            <a:r>
+              <a:rPr sz="2200" b="1">
+                <a:solidFill>
+                  <a:srgbClr val="A9B6C6"/>
+                </a:solidFill>
+                <a:latin typeface="Arial"/>
+              </a:rPr>
+              <a:t>Real data</a:t>
+            </a:r>
+          </a:p>
+        </p:txBody>
+      </p:sp>
+      <p:sp>
+        <p:nvSpPr>
+          <p:cNvPr id="77" name="TextBox 76"/>
+          <p:cNvSpPr txBox="1"/>
+          <p:nvPr/>
+        </p:nvSpPr>
+        <p:spPr>
+          <a:xfrm>
+            <a:off x="21442680" y="38624255"/>
+            <a:ext cx="10104120" cy="1024128"/>
+          </a:xfrm>
+          <a:prstGeom prst="rect">
+            <a:avLst/>
+          </a:prstGeom>
+          <a:noFill/>
+        </p:spPr>
+        <p:txBody>
+          <a:bodyPr wrap="square" anchor="ctr" lIns="45720" rIns="45720" tIns="18288" bIns="18288">
+            <a:spAutoFit/>
+          </a:bodyPr>
+          <a:lstStyle/>
+          <a:p>
+            <a:pPr algn="l">
+              <a:lnSpc>
+                <a:spcPct val="100000"/>
+              </a:lnSpc>
+              <a:spcAft>
+                <a:spcPts val="0"/>
+              </a:spcAft>
+            </a:pPr>
+            <a:r>
+              <a:rPr sz="2300" b="0">
+                <a:solidFill>
+                  <a:srgbClr val="EEF3F8"/>
+                </a:solidFill>
+                <a:latin typeface="Arial"/>
+              </a:rPr>
+              <a:t>Train on real SPHEREx images and compare with the Kelsall model</a:t>
+            </a:r>
+          </a:p>
+        </p:txBody>
+      </p:sp>
+      <p:sp>
+        <p:nvSpPr>
+          <p:cNvPr id="78" name="TextBox 77"/>
+          <p:cNvSpPr txBox="1"/>
+          <p:nvPr/>
+        </p:nvSpPr>
+        <p:spPr>
+          <a:xfrm>
+            <a:off x="17236440" y="39721535"/>
+            <a:ext cx="14538960" cy="457200"/>
+          </a:xfrm>
+          <a:prstGeom prst="rect">
+            <a:avLst/>
+          </a:prstGeom>
+          <a:noFill/>
+        </p:spPr>
+        <p:txBody>
+          <a:bodyPr wrap="square" anchor="t" lIns="45720" rIns="45720" tIns="18288" bIns="18288">
+            <a:spAutoFit/>
+          </a:bodyPr>
+          <a:lstStyle/>
+          <a:p>
+            <a:pPr algn="ctr">
+              <a:lnSpc>
+                <a:spcPct val="112000"/>
+              </a:lnSpc>
+              <a:spcAft>
+                <a:spcPts val="0"/>
+              </a:spcAft>
+            </a:pPr>
+            <a:r>
+              <a:rPr sz="2100" b="0">
+                <a:solidFill>
+                  <a:srgbClr val="A9B6C6"/>
+                </a:solidFill>
+                <a:latin typeface="Arial"/>
+              </a:rPr>
+              <a:t>All results so far are preliminary and use simulated data.</a:t>
+            </a:r>
+          </a:p>
+        </p:txBody>
+      </p:sp>
+      <p:sp>
+        <p:nvSpPr>
+          <p:cNvPr id="79" name="Rectangle 78"/>
           <p:cNvSpPr/>
           <p:nvPr/>
         </p:nvSpPr>
         <p:spPr>
           <a:xfrm>
-            <a:off x="17236440" y="38093904"/>
-            <a:ext cx="14538960" cy="1234440"/>
-          </a:xfrm>
-          <a:prstGeom prst="roundRect">
-            <a:avLst>
-              <a:gd name="adj" fmla="val 15000"/>
-            </a:avLst>
+            <a:off x="731520" y="40599360"/>
+            <a:ext cx="15361920" cy="2834640"/>
+          </a:xfrm>
+          <a:prstGeom prst="rect">
+            <a:avLst/>
           </a:prstGeom>
           <a:solidFill>
-            <a:srgbClr val="16304F"/>
+            <a:srgbClr val="0F2036"/>
           </a:solidFill>
-          <a:ln w="63500">
+          <a:ln w="38100">
             <a:solidFill>
-              <a:srgbClr val="A9B6C6"/>
+              <a:srgbClr val="2D5A94"/>
             </a:solidFill>
           </a:ln>
           <a:effectLst/>
@@ -6836,170 +7726,23 @@
       </p:sp>
       <p:sp>
         <p:nvSpPr>
-          <p:cNvPr id="71" name="TextBox 70"/>
-          <p:cNvSpPr txBox="1"/>
-          <p:nvPr/>
-        </p:nvSpPr>
-        <p:spPr>
-          <a:xfrm>
-            <a:off x="17465040" y="38093904"/>
-            <a:ext cx="3931920" cy="1234440"/>
-          </a:xfrm>
-          <a:prstGeom prst="rect">
-            <a:avLst/>
-          </a:prstGeom>
-          <a:noFill/>
-        </p:spPr>
-        <p:txBody>
-          <a:bodyPr wrap="square" anchor="ctr" lIns="45720" rIns="45720" tIns="18288" bIns="18288">
-            <a:spAutoFit/>
-          </a:bodyPr>
-          <a:lstStyle/>
-          <a:p>
-            <a:pPr algn="l">
-              <a:lnSpc>
-                <a:spcPct val="100000"/>
-              </a:lnSpc>
-              <a:spcAft>
-                <a:spcPts val="0"/>
-              </a:spcAft>
-            </a:pPr>
-            <a:r>
-              <a:rPr sz="2400" b="1">
-                <a:solidFill>
-                  <a:srgbClr val="A9B6C6"/>
-                </a:solidFill>
-                <a:latin typeface="Arial"/>
-              </a:rPr>
-              <a:t>NEXT</a:t>
-            </a:r>
-          </a:p>
-          <a:p>
-            <a:pPr algn="l">
-              <a:lnSpc>
-                <a:spcPct val="100000"/>
-              </a:lnSpc>
-              <a:spcAft>
-                <a:spcPts val="0"/>
-              </a:spcAft>
-            </a:pPr>
-            <a:r>
-              <a:rPr sz="2400" b="1">
-                <a:solidFill>
-                  <a:srgbClr val="A9B6C6"/>
-                </a:solidFill>
-                <a:latin typeface="Arial"/>
-              </a:rPr>
-              <a:t>Real data</a:t>
-            </a:r>
-          </a:p>
-        </p:txBody>
-      </p:sp>
-      <p:sp>
-        <p:nvSpPr>
-          <p:cNvPr id="72" name="TextBox 71"/>
-          <p:cNvSpPr txBox="1"/>
-          <p:nvPr/>
-        </p:nvSpPr>
-        <p:spPr>
-          <a:xfrm>
-            <a:off x="21442680" y="38093904"/>
-            <a:ext cx="10104120" cy="1234440"/>
-          </a:xfrm>
-          <a:prstGeom prst="rect">
-            <a:avLst/>
-          </a:prstGeom>
-          <a:noFill/>
-        </p:spPr>
-        <p:txBody>
-          <a:bodyPr wrap="square" anchor="ctr" lIns="45720" rIns="45720" tIns="18288" bIns="18288">
-            <a:spAutoFit/>
-          </a:bodyPr>
-          <a:lstStyle/>
-          <a:p>
-            <a:pPr algn="l">
-              <a:lnSpc>
-                <a:spcPct val="102000"/>
-              </a:lnSpc>
-              <a:spcAft>
-                <a:spcPts val="0"/>
-              </a:spcAft>
-            </a:pPr>
-            <a:r>
-              <a:rPr sz="2500" b="0">
-                <a:solidFill>
-                  <a:srgbClr val="EEF3F8"/>
-                </a:solidFill>
-                <a:latin typeface="Arial"/>
-              </a:rPr>
-              <a:t>Train on real SPHEREx images and compare with the Kelsall model</a:t>
-            </a:r>
-          </a:p>
-        </p:txBody>
-      </p:sp>
-      <p:sp>
-        <p:nvSpPr>
-          <p:cNvPr id="73" name="TextBox 72"/>
-          <p:cNvSpPr txBox="1"/>
-          <p:nvPr/>
-        </p:nvSpPr>
-        <p:spPr>
-          <a:xfrm>
-            <a:off x="17236440" y="39465504"/>
-            <a:ext cx="14538960" cy="548640"/>
-          </a:xfrm>
-          <a:prstGeom prst="rect">
-            <a:avLst/>
-          </a:prstGeom>
-          <a:noFill/>
-        </p:spPr>
-        <p:txBody>
-          <a:bodyPr wrap="square" anchor="t" lIns="45720" rIns="45720" tIns="18288" bIns="18288">
-            <a:spAutoFit/>
-          </a:bodyPr>
-          <a:lstStyle/>
-          <a:p>
-            <a:pPr algn="ctr">
-              <a:lnSpc>
-                <a:spcPct val="112000"/>
-              </a:lnSpc>
-              <a:spcAft>
-                <a:spcPts val="1000"/>
-              </a:spcAft>
-            </a:pPr>
-            <a:r>
-              <a:rPr sz="2300" b="0">
-                <a:solidFill>
-                  <a:srgbClr val="A9B6C6"/>
-                </a:solidFill>
-                <a:latin typeface="Arial"/>
-              </a:rPr>
-              <a:t>All results so far are preliminary and use simulated data.</a:t>
-            </a:r>
-          </a:p>
-        </p:txBody>
-      </p:sp>
-      <p:sp>
-        <p:nvSpPr>
-          <p:cNvPr id="74" name="Rectangle 73"/>
+          <p:cNvPr id="80" name="Rectangle 79"/>
           <p:cNvSpPr/>
           <p:nvPr/>
         </p:nvSpPr>
         <p:spPr>
           <a:xfrm>
             <a:off x="731520" y="40599360"/>
-            <a:ext cx="15361920" cy="2834640"/>
+            <a:ext cx="15361920" cy="777240"/>
           </a:xfrm>
           <a:prstGeom prst="rect">
             <a:avLst/>
           </a:prstGeom>
           <a:solidFill>
-            <a:srgbClr val="0F2036"/>
+            <a:srgbClr val="1E3557"/>
           </a:solidFill>
-          <a:ln w="38100">
-            <a:solidFill>
-              <a:srgbClr val="2D5A94"/>
-            </a:solidFill>
+          <a:ln>
+            <a:noFill/>
           </a:ln>
           <a:effectLst/>
         </p:spPr>
@@ -7027,23 +7770,133 @@
       </p:sp>
       <p:sp>
         <p:nvSpPr>
-          <p:cNvPr id="75" name="Rectangle 74"/>
+          <p:cNvPr id="81" name="TextBox 80"/>
+          <p:cNvSpPr txBox="1"/>
+          <p:nvPr/>
+        </p:nvSpPr>
+        <p:spPr>
+          <a:xfrm>
+            <a:off x="731520" y="40599360"/>
+            <a:ext cx="15361920" cy="777240"/>
+          </a:xfrm>
+          <a:prstGeom prst="rect">
+            <a:avLst/>
+          </a:prstGeom>
+          <a:noFill/>
+        </p:spPr>
+        <p:txBody>
+          <a:bodyPr wrap="square" anchor="ctr" lIns="45720" rIns="45720" tIns="18288" bIns="18288">
+            <a:spAutoFit/>
+          </a:bodyPr>
+          <a:lstStyle/>
+          <a:p>
+            <a:pPr algn="ctr">
+              <a:lnSpc>
+                <a:spcPct val="112000"/>
+              </a:lnSpc>
+              <a:spcAft>
+                <a:spcPts val="0"/>
+              </a:spcAft>
+            </a:pPr>
+            <a:r>
+              <a:rPr sz="4000" b="1">
+                <a:solidFill>
+                  <a:srgbClr val="FFFFFF"/>
+                </a:solidFill>
+                <a:latin typeface="Arial"/>
+              </a:rPr>
+              <a:t>Acknowledgements</a:t>
+            </a:r>
+          </a:p>
+        </p:txBody>
+      </p:sp>
+      <p:pic>
+        <p:nvPicPr>
+          <p:cNvPr id="82" name="Picture 81" descr="logo_nsf.png"/>
+          <p:cNvPicPr>
+            <a:picLocks noChangeAspect="1"/>
+          </p:cNvPicPr>
+          <p:nvPr/>
+        </p:nvPicPr>
+        <p:blipFill>
+          <a:blip r:embed="rId10"/>
+          <a:stretch>
+            <a:fillRect/>
+          </a:stretch>
+        </p:blipFill>
+        <p:spPr>
+          <a:xfrm>
+            <a:off x="14036040" y="41559480"/>
+            <a:ext cx="1640792" cy="1645919"/>
+          </a:xfrm>
+          <a:prstGeom prst="rect">
+            <a:avLst/>
+          </a:prstGeom>
+        </p:spPr>
+      </p:pic>
+      <p:sp>
+        <p:nvSpPr>
+          <p:cNvPr id="83" name="TextBox 82"/>
+          <p:cNvSpPr txBox="1"/>
+          <p:nvPr/>
+        </p:nvSpPr>
+        <p:spPr>
+          <a:xfrm>
+            <a:off x="1143000" y="41513760"/>
+            <a:ext cx="12618720" cy="1828799"/>
+          </a:xfrm>
+          <a:prstGeom prst="rect">
+            <a:avLst/>
+          </a:prstGeom>
+          <a:noFill/>
+        </p:spPr>
+        <p:txBody>
+          <a:bodyPr wrap="square" anchor="t" lIns="45720" rIns="45720" tIns="18288" bIns="18288">
+            <a:spAutoFit/>
+          </a:bodyPr>
+          <a:lstStyle/>
+          <a:p>
+            <a:pPr algn="l">
+              <a:lnSpc>
+                <a:spcPct val="105000"/>
+              </a:lnSpc>
+              <a:spcAft>
+                <a:spcPts val="1000"/>
+              </a:spcAft>
+            </a:pPr>
+            <a:r>
+              <a:rPr sz="2200" b="0">
+                <a:solidFill>
+                  <a:srgbClr val="EEF3F8"/>
+                </a:solidFill>
+                <a:latin typeface="Arial"/>
+              </a:rPr>
+              <a:t>This research is supported by a URS grant at New Mexico State University, funded by the National Science Foundation (NSF). Thank you to Dr. Andrew Saydjari for mentorship, and to the developers of ZodiPy and Flux.jl.</a:t>
+            </a:r>
+          </a:p>
+        </p:txBody>
+      </p:sp>
+      <p:sp>
+        <p:nvSpPr>
+          <p:cNvPr id="84" name="Rectangle 83"/>
           <p:cNvSpPr/>
           <p:nvPr/>
         </p:nvSpPr>
         <p:spPr>
           <a:xfrm>
-            <a:off x="731520" y="40599360"/>
-            <a:ext cx="15361920" cy="777240"/>
+            <a:off x="16824960" y="40599360"/>
+            <a:ext cx="15361920" cy="2834640"/>
           </a:xfrm>
           <a:prstGeom prst="rect">
             <a:avLst/>
           </a:prstGeom>
           <a:solidFill>
-            <a:srgbClr val="1E3557"/>
+            <a:srgbClr val="0F2036"/>
           </a:solidFill>
-          <a:ln>
-            <a:noFill/>
+          <a:ln w="38100">
+            <a:solidFill>
+              <a:srgbClr val="2D5A94"/>
+            </a:solidFill>
           </a:ln>
           <a:effectLst/>
         </p:spPr>
@@ -7071,133 +7924,23 @@
       </p:sp>
       <p:sp>
         <p:nvSpPr>
-          <p:cNvPr id="76" name="TextBox 75"/>
-          <p:cNvSpPr txBox="1"/>
-          <p:nvPr/>
-        </p:nvSpPr>
-        <p:spPr>
-          <a:xfrm>
-            <a:off x="731520" y="40599360"/>
-            <a:ext cx="15361920" cy="777240"/>
-          </a:xfrm>
-          <a:prstGeom prst="rect">
-            <a:avLst/>
-          </a:prstGeom>
-          <a:noFill/>
-        </p:spPr>
-        <p:txBody>
-          <a:bodyPr wrap="square" anchor="ctr" lIns="45720" rIns="45720" tIns="18288" bIns="18288">
-            <a:spAutoFit/>
-          </a:bodyPr>
-          <a:lstStyle/>
-          <a:p>
-            <a:pPr algn="ctr">
-              <a:lnSpc>
-                <a:spcPct val="112000"/>
-              </a:lnSpc>
-              <a:spcAft>
-                <a:spcPts val="0"/>
-              </a:spcAft>
-            </a:pPr>
-            <a:r>
-              <a:rPr sz="4000" b="1">
-                <a:solidFill>
-                  <a:srgbClr val="FFFFFF"/>
-                </a:solidFill>
-                <a:latin typeface="Arial"/>
-              </a:rPr>
-              <a:t>Acknowledgements</a:t>
-            </a:r>
-          </a:p>
-        </p:txBody>
-      </p:sp>
-      <p:pic>
-        <p:nvPicPr>
-          <p:cNvPr id="77" name="Picture 76" descr="logo_nsf.png"/>
-          <p:cNvPicPr>
-            <a:picLocks noChangeAspect="1"/>
-          </p:cNvPicPr>
-          <p:nvPr/>
-        </p:nvPicPr>
-        <p:blipFill>
-          <a:blip r:embed="rId8"/>
-          <a:stretch>
-            <a:fillRect/>
-          </a:stretch>
-        </p:blipFill>
-        <p:spPr>
-          <a:xfrm>
-            <a:off x="14036040" y="41559480"/>
-            <a:ext cx="1640792" cy="1645919"/>
-          </a:xfrm>
-          <a:prstGeom prst="rect">
-            <a:avLst/>
-          </a:prstGeom>
-        </p:spPr>
-      </p:pic>
-      <p:sp>
-        <p:nvSpPr>
-          <p:cNvPr id="78" name="TextBox 77"/>
-          <p:cNvSpPr txBox="1"/>
-          <p:nvPr/>
-        </p:nvSpPr>
-        <p:spPr>
-          <a:xfrm>
-            <a:off x="1143000" y="41513760"/>
-            <a:ext cx="12618720" cy="1828799"/>
-          </a:xfrm>
-          <a:prstGeom prst="rect">
-            <a:avLst/>
-          </a:prstGeom>
-          <a:noFill/>
-        </p:spPr>
-        <p:txBody>
-          <a:bodyPr wrap="square" anchor="t" lIns="45720" rIns="45720" tIns="18288" bIns="18288">
-            <a:spAutoFit/>
-          </a:bodyPr>
-          <a:lstStyle/>
-          <a:p>
-            <a:pPr algn="l">
-              <a:lnSpc>
-                <a:spcPct val="105000"/>
-              </a:lnSpc>
-              <a:spcAft>
-                <a:spcPts val="1000"/>
-              </a:spcAft>
-            </a:pPr>
-            <a:r>
-              <a:rPr sz="2200" b="0">
-                <a:solidFill>
-                  <a:srgbClr val="EEF3F8"/>
-                </a:solidFill>
-                <a:latin typeface="Arial"/>
-              </a:rPr>
-              <a:t>This research is supported by a URS grant at New Mexico State University, funded by the National Science Foundation (NSF). Thank you to Dr. Andrew Saydjari for mentorship, and to the developers of ZodiPy and Flux.jl.</a:t>
-            </a:r>
-          </a:p>
-        </p:txBody>
-      </p:sp>
-      <p:sp>
-        <p:nvSpPr>
-          <p:cNvPr id="79" name="Rectangle 78"/>
+          <p:cNvPr id="85" name="Rectangle 84"/>
           <p:cNvSpPr/>
           <p:nvPr/>
         </p:nvSpPr>
         <p:spPr>
           <a:xfrm>
             <a:off x="16824960" y="40599360"/>
-            <a:ext cx="15361920" cy="2834640"/>
+            <a:ext cx="15361920" cy="777240"/>
           </a:xfrm>
           <a:prstGeom prst="rect">
             <a:avLst/>
           </a:prstGeom>
           <a:solidFill>
-            <a:srgbClr val="0F2036"/>
+            <a:srgbClr val="1E3557"/>
           </a:solidFill>
-          <a:ln w="38100">
-            <a:solidFill>
-              <a:srgbClr val="2D5A94"/>
-            </a:solidFill>
+          <a:ln>
+            <a:noFill/>
           </a:ln>
           <a:effectLst/>
         </p:spPr>
@@ -7225,51 +7968,7 @@
       </p:sp>
       <p:sp>
         <p:nvSpPr>
-          <p:cNvPr id="80" name="Rectangle 79"/>
-          <p:cNvSpPr/>
-          <p:nvPr/>
-        </p:nvSpPr>
-        <p:spPr>
-          <a:xfrm>
-            <a:off x="16824960" y="40599360"/>
-            <a:ext cx="15361920" cy="777240"/>
-          </a:xfrm>
-          <a:prstGeom prst="rect">
-            <a:avLst/>
-          </a:prstGeom>
-          <a:solidFill>
-            <a:srgbClr val="1E3557"/>
-          </a:solidFill>
-          <a:ln>
-            <a:noFill/>
-          </a:ln>
-          <a:effectLst/>
-        </p:spPr>
-        <p:style>
-          <a:lnRef idx="1">
-            <a:schemeClr val="accent1"/>
-          </a:lnRef>
-          <a:fillRef idx="3">
-            <a:schemeClr val="accent1"/>
-          </a:fillRef>
-          <a:effectRef idx="2">
-            <a:schemeClr val="accent1"/>
-          </a:effectRef>
-          <a:fontRef idx="minor">
-            <a:schemeClr val="lt1"/>
-          </a:fontRef>
-        </p:style>
-        <p:txBody>
-          <a:bodyPr rtlCol="0" anchor="ctr"/>
-          <a:lstStyle/>
-          <a:p>
-            <a:pPr algn="ctr"/>
-          </a:p>
-        </p:txBody>
-      </p:sp>
-      <p:sp>
-        <p:nvSpPr>
-          <p:cNvPr id="81" name="TextBox 80"/>
+          <p:cNvPr id="86" name="TextBox 85"/>
           <p:cNvSpPr txBox="1"/>
           <p:nvPr/>
         </p:nvSpPr>
@@ -7311,7 +8010,7 @@
       </p:sp>
       <p:sp>
         <p:nvSpPr>
-          <p:cNvPr id="82" name="TextBox 81"/>
+          <p:cNvPr id="87" name="TextBox 86"/>
           <p:cNvSpPr txBox="1"/>
           <p:nvPr/>
         </p:nvSpPr>
@@ -7372,7 +8071,7 @@
       </p:sp>
       <p:sp>
         <p:nvSpPr>
-          <p:cNvPr id="83" name="TextBox 82"/>
+          <p:cNvPr id="88" name="TextBox 87"/>
           <p:cNvSpPr txBox="1"/>
           <p:nvPr/>
         </p:nvSpPr>

</xml_diff>

<commit_message>
Poster v6: Fig. 7 with 3.5-deg patches as the main version (7-deg blend kept as _7deg); linear-scale loss plots
Co-Authored-By: Claude Opus 5.5 <noreply@anthropic.com>

Claude-Session: https://claude.ai/code/session_012rGthNAyzBgnDfYXWSYd8K
</commit_message>
<xml_diff>
--- a/poster/poster_dark.pptx
+++ b/poster/poster_dark.pptx
@@ -6532,7 +6532,7 @@
       </p:sp>
       <p:pic>
         <p:nvPicPr>
-          <p:cNvPr id="59" name="Picture 58" descr="skyerror7_dark.png"/>
+          <p:cNvPr id="59" name="Picture 58" descr="skyerror_dark.png"/>
           <p:cNvPicPr>
             <a:picLocks noChangeAspect="1"/>
           </p:cNvPicPr>
@@ -6600,7 +6600,7 @@
                 </a:solidFill>
                 <a:latin typeface="Arial"/>
               </a:rPr>
-              <a:t>Error on pointings the network never saw, across the whole sky. Each pointing is blended over a 7° patch to show the large-scale pattern. Grey: not tested.</a:t>
+              <a:t>Error on pointings the network never saw, across the whole sky. Each pointing is drawn 3.5° wide, about SPHEREx's view. Grey: not tested.</a:t>
             </a:r>
           </a:p>
         </p:txBody>

</xml_diff>

<commit_message>
Poster: mentor's wording notes (pointing vector, ZodiPy contribution, Kelsall components, sky coordinates, Jupiter/Moon for real data, EBL)
Co-Authored-By: Claude Opus 5.5 <noreply@anthropic.com>

Claude-Session: https://claude.ai/code/session_012rGthNAyzBgnDfYXWSYd8K
</commit_message>
<xml_diff>
--- a/poster/poster_dark.pptx
+++ b/poster/poster_dark.pptx
@@ -4195,7 +4195,7 @@
         <p:spPr>
           <a:xfrm>
             <a:off x="1143000" y="10596676"/>
-            <a:ext cx="7705648" cy="4671364"/>
+            <a:ext cx="7705648" cy="5066385"/>
           </a:xfrm>
           <a:prstGeom prst="rect">
             <a:avLst/>
@@ -4274,7 +4274,7 @@
                 </a:solidFill>
                 <a:latin typeface="Arial"/>
               </a:rPr>
-              <a:t>Bright enough to be confused with faint light from distant galaxies</a:t>
+              <a:t>Far brighter than the faint glow of distant galaxies SPHEREx aims to measure</a:t>
             </a:r>
           </a:p>
           <a:p>
@@ -4298,7 +4298,7 @@
                 </a:solidFill>
                 <a:latin typeface="Arial"/>
               </a:rPr>
-              <a:t>Changes with look direction and Earth's place in orbit → </a:t>
+              <a:t>Changes with pointing and Earth's place in orbit → </a:t>
             </a:r>
             <a:r>
               <a:rPr sz="2400" b="1">
@@ -4371,7 +4371,7 @@
                 </a:solidFill>
                 <a:latin typeface="Arial"/>
               </a:rPr>
-              <a:t> computes what SPHEREx would see from it</a:t>
+              <a:t> evaluates its prediction of the zodiacal-light contribution to what SPHEREx observes</a:t>
             </a:r>
           </a:p>
         </p:txBody>
@@ -4535,7 +4535,7 @@
         <p:spPr>
           <a:xfrm>
             <a:off x="731520" y="23017337"/>
-            <a:ext cx="15361920" cy="2963716"/>
+            <a:ext cx="15361920" cy="3399885"/>
           </a:xfrm>
           <a:prstGeom prst="rect">
             <a:avLst/>
@@ -4581,7 +4581,7 @@
         <p:spPr>
           <a:xfrm>
             <a:off x="1143000" y="23218505"/>
-            <a:ext cx="7040880" cy="1953158"/>
+            <a:ext cx="7040880" cy="2776118"/>
           </a:xfrm>
           <a:prstGeom prst="rect">
             <a:avLst/>
@@ -4636,7 +4636,7 @@
                 </a:solidFill>
                 <a:latin typeface="Arial"/>
               </a:rPr>
-              <a:t>Zodiacal light must be removed from every SPHEREx image, but models like Kelsall's were fit to older data and leave errors behind</a:t>
+              <a:t>Zodiacal light must be removed from every SPHEREx image, but Kelsall's model uses a finite number of analytic components that don't fully describe the spatial and spectral structure in real data</a:t>
             </a:r>
           </a:p>
         </p:txBody>
@@ -4754,8 +4754,8 @@
         </p:nvSpPr>
         <p:spPr>
           <a:xfrm>
-            <a:off x="731520" y="26392534"/>
-            <a:ext cx="15361920" cy="13841065"/>
+            <a:off x="731520" y="26828703"/>
+            <a:ext cx="15361920" cy="13404896"/>
           </a:xfrm>
           <a:prstGeom prst="rect">
             <a:avLst/>
@@ -4800,7 +4800,7 @@
         </p:nvSpPr>
         <p:spPr>
           <a:xfrm>
-            <a:off x="731520" y="26392534"/>
+            <a:off x="731520" y="26828703"/>
             <a:ext cx="15361920" cy="1051560"/>
           </a:xfrm>
           <a:prstGeom prst="rect">
@@ -4844,7 +4844,7 @@
         </p:nvSpPr>
         <p:spPr>
           <a:xfrm>
-            <a:off x="731520" y="26392534"/>
+            <a:off x="731520" y="26828703"/>
             <a:ext cx="15361920" cy="1051560"/>
           </a:xfrm>
           <a:prstGeom prst="rect">
@@ -4886,8 +4886,8 @@
         </p:nvSpPr>
         <p:spPr>
           <a:xfrm>
-            <a:off x="1143000" y="28838321"/>
-            <a:ext cx="6000695" cy="3675278"/>
+            <a:off x="1143000" y="29082481"/>
+            <a:ext cx="7181258" cy="3263798"/>
           </a:xfrm>
           <a:prstGeom prst="rect">
             <a:avLst/>
@@ -4942,7 +4942,7 @@
                 </a:solidFill>
                 <a:latin typeface="Arial"/>
               </a:rPr>
-              <a:t>No dates or sky-map positions: only </a:t>
+              <a:t>No dates or sky coordinates: only </a:t>
             </a:r>
             <a:r>
               <a:rPr sz="2500" b="1">
@@ -4960,7 +4960,7 @@
                 </a:solidFill>
                 <a:latin typeface="Arial"/>
               </a:rPr>
-              <a:t> (Fig. 3)</a:t>
+              <a:t> (Fig. 3), dot products of the pointing vector n</a:t>
             </a:r>
           </a:p>
           <a:p>
@@ -5005,8 +5005,8 @@
         </p:blipFill>
         <p:spPr>
           <a:xfrm>
-            <a:off x="7418015" y="27866219"/>
-            <a:ext cx="8263944" cy="5619482"/>
+            <a:off x="8598578" y="28306030"/>
+            <a:ext cx="7083381" cy="4816699"/>
           </a:xfrm>
           <a:prstGeom prst="rect">
             <a:avLst/>
@@ -5021,8 +5021,8 @@
         </p:nvSpPr>
         <p:spPr>
           <a:xfrm>
-            <a:off x="1143000" y="33577141"/>
-            <a:ext cx="14538960" cy="749808"/>
+            <a:off x="1143000" y="33214170"/>
+            <a:ext cx="14538960" cy="1101852"/>
           </a:xfrm>
           <a:prstGeom prst="rect">
             <a:avLst/>
@@ -5059,7 +5059,7 @@
                 </a:solidFill>
                 <a:latin typeface="Arial"/>
               </a:rPr>
-              <a:t>The geometry the network sees (top view, not to scale): n = where SPHEREx looks; S, E = Sun → SPHEREx, Earth; v = orbital motion; λ⊕ = Earth's angle around its orbit. Jupiter and the Moon: context only.</a:t>
+              <a:t>The geometry the network sees (top view, not to scale): n = SPHEREx's pointing vector; S, E = SPHEREx, Earth positions; v = orbital motion; λ⊕ = Earth's angle around its orbit. Jupiter and the Moon are tracked for real data: dust clouds leading and trailing Jupiter, and moonlight.</a:t>
             </a:r>
           </a:p>
         </p:txBody>
@@ -5072,7 +5072,7 @@
         </p:nvSpPr>
         <p:spPr>
           <a:xfrm>
-            <a:off x="1143000" y="34611914"/>
+            <a:off x="1143000" y="34604629"/>
             <a:ext cx="14538960" cy="548640"/>
           </a:xfrm>
           <a:prstGeom prst="rect">
@@ -5114,7 +5114,7 @@
         </p:nvSpPr>
         <p:spPr>
           <a:xfrm>
-            <a:off x="1325880" y="35160554"/>
+            <a:off x="1325880" y="35153269"/>
             <a:ext cx="3291840" cy="457200"/>
           </a:xfrm>
           <a:prstGeom prst="rect">
@@ -5156,7 +5156,7 @@
         </p:nvSpPr>
         <p:spPr>
           <a:xfrm>
-            <a:off x="4617720" y="35160554"/>
+            <a:off x="4617720" y="35153269"/>
             <a:ext cx="11064240" cy="457200"/>
           </a:xfrm>
           <a:prstGeom prst="rect">
@@ -5198,7 +5198,7 @@
         </p:nvSpPr>
         <p:spPr>
           <a:xfrm>
-            <a:off x="1325880" y="35590322"/>
+            <a:off x="1325880" y="35583037"/>
             <a:ext cx="3291840" cy="457200"/>
           </a:xfrm>
           <a:prstGeom prst="rect">
@@ -5240,7 +5240,7 @@
         </p:nvSpPr>
         <p:spPr>
           <a:xfrm>
-            <a:off x="4617720" y="35590322"/>
+            <a:off x="4617720" y="35583037"/>
             <a:ext cx="11064240" cy="457200"/>
           </a:xfrm>
           <a:prstGeom prst="rect">
@@ -5282,7 +5282,7 @@
         </p:nvSpPr>
         <p:spPr>
           <a:xfrm>
-            <a:off x="1325880" y="36020090"/>
+            <a:off x="1325880" y="36012805"/>
             <a:ext cx="3291840" cy="457200"/>
           </a:xfrm>
           <a:prstGeom prst="rect">
@@ -5324,7 +5324,7 @@
         </p:nvSpPr>
         <p:spPr>
           <a:xfrm>
-            <a:off x="4617720" y="36020090"/>
+            <a:off x="4617720" y="36012805"/>
             <a:ext cx="11064240" cy="457200"/>
           </a:xfrm>
           <a:prstGeom prst="rect">
@@ -5366,7 +5366,7 @@
         </p:nvSpPr>
         <p:spPr>
           <a:xfrm>
-            <a:off x="1325880" y="36449858"/>
+            <a:off x="1325880" y="36442573"/>
             <a:ext cx="3291840" cy="457200"/>
           </a:xfrm>
           <a:prstGeom prst="rect">
@@ -5408,7 +5408,7 @@
         </p:nvSpPr>
         <p:spPr>
           <a:xfrm>
-            <a:off x="4617720" y="36449858"/>
+            <a:off x="4617720" y="36442573"/>
             <a:ext cx="11064240" cy="457200"/>
           </a:xfrm>
           <a:prstGeom prst="rect">
@@ -5450,7 +5450,7 @@
         </p:nvSpPr>
         <p:spPr>
           <a:xfrm>
-            <a:off x="1325880" y="36879626"/>
+            <a:off x="1325880" y="36872341"/>
             <a:ext cx="3291840" cy="457200"/>
           </a:xfrm>
           <a:prstGeom prst="rect">
@@ -5492,7 +5492,7 @@
         </p:nvSpPr>
         <p:spPr>
           <a:xfrm>
-            <a:off x="4617720" y="36879626"/>
+            <a:off x="4617720" y="36872341"/>
             <a:ext cx="11064240" cy="457200"/>
           </a:xfrm>
           <a:prstGeom prst="rect">
@@ -5534,7 +5534,7 @@
         </p:nvSpPr>
         <p:spPr>
           <a:xfrm>
-            <a:off x="1143000" y="37594359"/>
+            <a:off x="1143000" y="37590717"/>
             <a:ext cx="14538960" cy="2171395"/>
           </a:xfrm>
           <a:prstGeom prst="rect">

</xml_diff>

<commit_message>
Poster: redesign draft (no components fig, larger text, 140 vs 500-day sky-map pair, compact Next Steps)
Co-Authored-By: Claude Opus 5.5 <noreply@anthropic.com>

Claude-Session: https://claude.ai/code/session_012rGthNAyzBgnDfYXWSYd8K
</commit_message>
<xml_diff>
--- a/poster/poster_dark.pptx
+++ b/poster/poster_dark.pptx
@@ -3956,7 +3956,7 @@
         <p:spPr>
           <a:xfrm>
             <a:off x="731520" y="7223760"/>
-            <a:ext cx="15361920" cy="15382097"/>
+            <a:ext cx="15361920" cy="11025627"/>
           </a:xfrm>
           <a:prstGeom prst="rect">
             <a:avLst/>
@@ -4088,7 +4088,7 @@
         <p:spPr>
           <a:xfrm>
             <a:off x="1143000" y="8595360"/>
-            <a:ext cx="14538960" cy="1909876"/>
+            <a:ext cx="14538960" cy="2173224"/>
           </a:xfrm>
           <a:prstGeom prst="rect">
             <a:avLst/>
@@ -4115,7 +4115,7 @@
               <a:buChar char="•"/>
             </a:pPr>
             <a:r>
-              <a:rPr sz="2600" b="1">
+              <a:rPr sz="3000" b="1">
                 <a:solidFill>
                   <a:srgbClr val="EEF3F8"/>
                 </a:solidFill>
@@ -4124,7 +4124,7 @@
               <a:t>SPHEREx: </a:t>
             </a:r>
             <a:r>
-              <a:rPr sz="2600" b="0">
+              <a:rPr sz="3000" b="0">
                 <a:solidFill>
                   <a:srgbClr val="EEF3F8"/>
                 </a:solidFill>
@@ -4133,7 +4133,7 @@
               <a:t>NASA space telescope (launched March 2025) mapping the </a:t>
             </a:r>
             <a:r>
-              <a:rPr sz="2600" b="1">
+              <a:rPr sz="3000" b="1">
                 <a:solidFill>
                   <a:srgbClr val="EEF3F8"/>
                 </a:solidFill>
@@ -4142,7 +4142,7 @@
               <a:t>entire sky in infrared</a:t>
             </a:r>
             <a:r>
-              <a:rPr sz="2600" b="0">
+              <a:rPr sz="3000" b="0">
                 <a:solidFill>
                   <a:srgbClr val="EEF3F8"/>
                 </a:solidFill>
@@ -4166,7 +4166,7 @@
               <a:buChar char="•"/>
             </a:pPr>
             <a:r>
-              <a:rPr sz="2600" b="1">
+              <a:rPr sz="3000" b="1">
                 <a:solidFill>
                   <a:srgbClr val="EEF3F8"/>
                 </a:solidFill>
@@ -4175,7 +4175,7 @@
               <a:t>Science: </a:t>
             </a:r>
             <a:r>
-              <a:rPr sz="2600" b="0">
+              <a:rPr sz="3000" b="0">
                 <a:solidFill>
                   <a:srgbClr val="EEF3F8"/>
                 </a:solidFill>
@@ -4194,8 +4194,8 @@
         </p:nvSpPr>
         <p:spPr>
           <a:xfrm>
-            <a:off x="1143000" y="10596676"/>
-            <a:ext cx="7705648" cy="5066385"/>
+            <a:off x="1143000" y="10860024"/>
+            <a:ext cx="7269480" cy="6712305"/>
           </a:xfrm>
           <a:prstGeom prst="rect">
             <a:avLst/>
@@ -4220,7 +4220,7 @@
               </a:spcAft>
             </a:pPr>
             <a:r>
-              <a:rPr sz="2600" b="1">
+              <a:rPr sz="3000" b="1">
                 <a:solidFill>
                   <a:srgbClr val="5FB0FF"/>
                 </a:solidFill>
@@ -4244,7 +4244,7 @@
               <a:buChar char="•"/>
             </a:pPr>
             <a:r>
-              <a:rPr sz="2400" b="0">
+              <a:rPr sz="2800" b="0">
                 <a:solidFill>
                   <a:srgbClr val="EEF3F8"/>
                 </a:solidFill>
@@ -4268,7 +4268,7 @@
               <a:buChar char="•"/>
             </a:pPr>
             <a:r>
-              <a:rPr sz="2400" b="0">
+              <a:rPr sz="2800" b="0">
                 <a:solidFill>
                   <a:srgbClr val="EEF3F8"/>
                 </a:solidFill>
@@ -4292,7 +4292,7 @@
               <a:buChar char="•"/>
             </a:pPr>
             <a:r>
-              <a:rPr sz="2400" b="0">
+              <a:rPr sz="2800" b="0">
                 <a:solidFill>
                   <a:srgbClr val="EEF3F8"/>
                 </a:solidFill>
@@ -4301,7 +4301,7 @@
               <a:t>Changes with pointing and Earth's place in orbit → </a:t>
             </a:r>
             <a:r>
-              <a:rPr sz="2400" b="1">
+              <a:rPr sz="2800" b="1">
                 <a:solidFill>
                   <a:srgbClr val="EEF3F8"/>
                 </a:solidFill>
@@ -4323,7 +4323,7 @@
               </a:spcAft>
             </a:pPr>
             <a:r>
-              <a:rPr sz="2600" b="1">
+              <a:rPr sz="3000" b="1">
                 <a:solidFill>
                   <a:srgbClr val="5FB0FF"/>
                 </a:solidFill>
@@ -4347,16 +4347,16 @@
               <a:buChar char="•"/>
             </a:pPr>
             <a:r>
-              <a:rPr sz="2400" b="0">
+              <a:rPr sz="2800" b="0">
                 <a:solidFill>
                   <a:srgbClr val="EEF3F8"/>
                 </a:solidFill>
                 <a:latin typeface="Arial"/>
               </a:rPr>
-              <a:t>Standard dust model from NASA's COBE (Fig. 2); </a:t>
-            </a:r>
-            <a:r>
-              <a:rPr sz="2400" b="1">
+              <a:t>Standard dust model from NASA's COBE; </a:t>
+            </a:r>
+            <a:r>
+              <a:rPr sz="2800" b="1">
                 <a:solidFill>
                   <a:srgbClr val="EEF3F8"/>
                 </a:solidFill>
@@ -4365,7 +4365,7 @@
               <a:t>ZodiPy</a:t>
             </a:r>
             <a:r>
-              <a:rPr sz="2400" b="0">
+              <a:rPr sz="2800" b="0">
                 <a:solidFill>
                   <a:srgbClr val="EEF3F8"/>
                 </a:solidFill>
@@ -4392,8 +4392,8 @@
         </p:blipFill>
         <p:spPr>
           <a:xfrm>
-            <a:off x="9122968" y="10870996"/>
-            <a:ext cx="6558991" cy="3935394"/>
+            <a:off x="8686800" y="11134344"/>
+            <a:ext cx="6995160" cy="4197096"/>
           </a:xfrm>
           <a:prstGeom prst="rect">
             <a:avLst/>
@@ -4408,8 +4408,8 @@
         </p:nvSpPr>
         <p:spPr>
           <a:xfrm>
-            <a:off x="9122968" y="14897831"/>
-            <a:ext cx="6558991" cy="1453896"/>
+            <a:off x="8686800" y="15422880"/>
+            <a:ext cx="6995160" cy="1709928"/>
           </a:xfrm>
           <a:prstGeom prst="rect">
             <a:avLst/>
@@ -4431,7 +4431,7 @@
               </a:spcAft>
             </a:pPr>
             <a:r>
-              <a:rPr sz="2200" b="1">
+              <a:rPr sz="2600" b="1">
                 <a:solidFill>
                   <a:srgbClr val="A9B6C6"/>
                 </a:solidFill>
@@ -4440,7 +4440,7 @@
               <a:t>Figure 1. </a:t>
             </a:r>
             <a:r>
-              <a:rPr sz="2200" b="0">
+              <a:rPr sz="2600" b="0">
                 <a:solidFill>
                   <a:srgbClr val="A9B6C6"/>
                 </a:solidFill>
@@ -4451,91 +4451,16 @@
           </a:p>
         </p:txBody>
       </p:sp>
-      <p:pic>
-        <p:nvPicPr>
-          <p:cNvPr id="17" name="Picture 16" descr="components_dark.png"/>
-          <p:cNvPicPr>
-            <a:picLocks noChangeAspect="1"/>
-          </p:cNvPicPr>
-          <p:nvPr/>
-        </p:nvPicPr>
-        <p:blipFill>
-          <a:blip r:embed="rId5"/>
-          <a:stretch>
-            <a:fillRect/>
-          </a:stretch>
-        </p:blipFill>
-        <p:spPr>
-          <a:xfrm>
-            <a:off x="2160727" y="16488887"/>
-            <a:ext cx="12503505" cy="5001402"/>
-          </a:xfrm>
-          <a:prstGeom prst="rect">
-            <a:avLst/>
-          </a:prstGeom>
-        </p:spPr>
-      </p:pic>
-      <p:sp>
-        <p:nvSpPr>
-          <p:cNvPr id="18" name="TextBox 17"/>
-          <p:cNvSpPr txBox="1"/>
-          <p:nvPr/>
-        </p:nvSpPr>
-        <p:spPr>
-          <a:xfrm>
-            <a:off x="1143000" y="21581729"/>
-            <a:ext cx="14538960" cy="749808"/>
-          </a:xfrm>
-          <a:prstGeom prst="rect">
-            <a:avLst/>
-          </a:prstGeom>
-          <a:noFill/>
-        </p:spPr>
-        <p:txBody>
-          <a:bodyPr wrap="square" anchor="t" lIns="45720" rIns="45720" tIns="18288" bIns="18288">
-            <a:spAutoFit/>
-          </a:bodyPr>
-          <a:lstStyle/>
-          <a:p>
-            <a:pPr algn="l">
-              <a:lnSpc>
-                <a:spcPct val="105000"/>
-              </a:lnSpc>
-              <a:spcAft>
-                <a:spcPts val="0"/>
-              </a:spcAft>
-            </a:pPr>
-            <a:r>
-              <a:rPr sz="2200" b="1">
-                <a:solidFill>
-                  <a:srgbClr val="A9B6C6"/>
-                </a:solidFill>
-                <a:latin typeface="Arial"/>
-              </a:rPr>
-              <a:t>Figure 2. </a:t>
-            </a:r>
-            <a:r>
-              <a:rPr sz="2200" b="0">
-                <a:solidFill>
-                  <a:srgbClr val="A9B6C6"/>
-                </a:solidFill>
-                <a:latin typeface="Arial"/>
-              </a:rPr>
-              <a:t>What makes up the zodiacal light SPHEREx sees (Kelsall model): a smooth cloud (88–95%) plus dust bands, a ring around the Sun, and a cloud trailing Earth, strongest when looking behind Earth.</a:t>
-            </a:r>
-          </a:p>
-        </p:txBody>
-      </p:sp>
-      <p:sp>
-        <p:nvSpPr>
-          <p:cNvPr id="19" name="Rectangle 18"/>
+      <p:sp>
+        <p:nvSpPr>
+          <p:cNvPr id="17" name="Rectangle 16"/>
           <p:cNvSpPr/>
           <p:nvPr/>
         </p:nvSpPr>
         <p:spPr>
           <a:xfrm>
-            <a:off x="731520" y="23017337"/>
-            <a:ext cx="15361920" cy="3399885"/>
+            <a:off x="731520" y="18660867"/>
+            <a:ext cx="15361920" cy="3713927"/>
           </a:xfrm>
           <a:prstGeom prst="rect">
             <a:avLst/>
@@ -4574,14 +4499,14 @@
       </p:sp>
       <p:sp>
         <p:nvSpPr>
-          <p:cNvPr id="20" name="TextBox 19"/>
+          <p:cNvPr id="18" name="TextBox 17"/>
           <p:cNvSpPr txBox="1"/>
           <p:nvPr/>
         </p:nvSpPr>
         <p:spPr>
           <a:xfrm>
-            <a:off x="1143000" y="23218505"/>
-            <a:ext cx="7040880" cy="2776118"/>
+            <a:off x="1143000" y="18862035"/>
+            <a:ext cx="7040880" cy="3072384"/>
           </a:xfrm>
           <a:prstGeom prst="rect">
             <a:avLst/>
@@ -4606,7 +4531,7 @@
               </a:spcAft>
             </a:pPr>
             <a:r>
-              <a:rPr sz="2700" b="1">
+              <a:rPr sz="3000" b="1">
                 <a:solidFill>
                   <a:srgbClr val="5FB0FF"/>
                 </a:solidFill>
@@ -4630,7 +4555,7 @@
               <a:buChar char="•"/>
             </a:pPr>
             <a:r>
-              <a:rPr sz="2500" b="0">
+              <a:rPr sz="2800" b="0">
                 <a:solidFill>
                   <a:srgbClr val="EEF3F8"/>
                 </a:solidFill>
@@ -4643,14 +4568,14 @@
       </p:sp>
       <p:sp>
         <p:nvSpPr>
-          <p:cNvPr id="21" name="TextBox 20"/>
+          <p:cNvPr id="19" name="TextBox 18"/>
           <p:cNvSpPr txBox="1"/>
           <p:nvPr/>
         </p:nvSpPr>
         <p:spPr>
           <a:xfrm>
-            <a:off x="8641080" y="23218505"/>
-            <a:ext cx="7040880" cy="2364638"/>
+            <a:off x="8641080" y="18862035"/>
+            <a:ext cx="7040880" cy="2611526"/>
           </a:xfrm>
           <a:prstGeom prst="rect">
             <a:avLst/>
@@ -4675,7 +4600,7 @@
               </a:spcAft>
             </a:pPr>
             <a:r>
-              <a:rPr sz="2700" b="1">
+              <a:rPr sz="3000" b="1">
                 <a:solidFill>
                   <a:srgbClr val="5FB0FF"/>
                 </a:solidFill>
@@ -4699,7 +4624,7 @@
               <a:buChar char="•"/>
             </a:pPr>
             <a:r>
-              <a:rPr sz="2500" b="0">
+              <a:rPr sz="2800" b="0">
                 <a:solidFill>
                   <a:srgbClr val="EEF3F8"/>
                 </a:solidFill>
@@ -4708,7 +4633,7 @@
               <a:t>A </a:t>
             </a:r>
             <a:r>
-              <a:rPr sz="2500" b="1">
+              <a:rPr sz="2800" b="1">
                 <a:solidFill>
                   <a:srgbClr val="EEF3F8"/>
                 </a:solidFill>
@@ -4717,7 +4642,7 @@
               <a:t>geometrically constrained</a:t>
             </a:r>
             <a:r>
-              <a:rPr sz="2500" b="0">
+              <a:rPr sz="2800" b="0">
                 <a:solidFill>
                   <a:srgbClr val="EEF3F8"/>
                 </a:solidFill>
@@ -4726,7 +4651,7 @@
               <a:t> neural network that learns zodiacal light from SPHEREx data and </a:t>
             </a:r>
             <a:r>
-              <a:rPr sz="2500" b="1">
+              <a:rPr sz="2800" b="1">
                 <a:solidFill>
                   <a:srgbClr val="EEF3F8"/>
                 </a:solidFill>
@@ -4735,7 +4660,7 @@
               <a:t>outperforms the Kelsall model</a:t>
             </a:r>
             <a:r>
-              <a:rPr sz="2500" b="0">
+              <a:rPr sz="2800" b="0">
                 <a:solidFill>
                   <a:srgbClr val="EEF3F8"/>
                 </a:solidFill>
@@ -4748,14 +4673,14 @@
       </p:sp>
       <p:sp>
         <p:nvSpPr>
-          <p:cNvPr id="22" name="Rectangle 21"/>
+          <p:cNvPr id="20" name="Rectangle 19"/>
           <p:cNvSpPr/>
           <p:nvPr/>
         </p:nvSpPr>
         <p:spPr>
           <a:xfrm>
-            <a:off x="731520" y="26828703"/>
-            <a:ext cx="15361920" cy="13404896"/>
+            <a:off x="731520" y="22786274"/>
+            <a:ext cx="15361920" cy="17447325"/>
           </a:xfrm>
           <a:prstGeom prst="rect">
             <a:avLst/>
@@ -4794,13 +4719,13 @@
       </p:sp>
       <p:sp>
         <p:nvSpPr>
-          <p:cNvPr id="23" name="Rectangle 22"/>
+          <p:cNvPr id="21" name="Rectangle 20"/>
           <p:cNvSpPr/>
           <p:nvPr/>
         </p:nvSpPr>
         <p:spPr>
           <a:xfrm>
-            <a:off x="731520" y="26828703"/>
+            <a:off x="731520" y="22786274"/>
             <a:ext cx="15361920" cy="1051560"/>
           </a:xfrm>
           <a:prstGeom prst="rect">
@@ -4838,13 +4763,13 @@
       </p:sp>
       <p:sp>
         <p:nvSpPr>
-          <p:cNvPr id="24" name="TextBox 23"/>
+          <p:cNvPr id="22" name="TextBox 21"/>
           <p:cNvSpPr txBox="1"/>
           <p:nvPr/>
         </p:nvSpPr>
         <p:spPr>
           <a:xfrm>
-            <a:off x="731520" y="26828703"/>
+            <a:off x="731520" y="22786274"/>
             <a:ext cx="15361920" cy="1051560"/>
           </a:xfrm>
           <a:prstGeom prst="rect">
@@ -4880,14 +4805,14 @@
       </p:sp>
       <p:sp>
         <p:nvSpPr>
-          <p:cNvPr id="25" name="TextBox 24"/>
+          <p:cNvPr id="23" name="TextBox 22"/>
           <p:cNvSpPr txBox="1"/>
           <p:nvPr/>
         </p:nvSpPr>
         <p:spPr>
           <a:xfrm>
-            <a:off x="1143000" y="29082481"/>
-            <a:ext cx="7181258" cy="3263798"/>
+            <a:off x="1143000" y="24837124"/>
+            <a:ext cx="6122822" cy="4531156"/>
           </a:xfrm>
           <a:prstGeom prst="rect">
             <a:avLst/>
@@ -4912,7 +4837,7 @@
               </a:spcAft>
             </a:pPr>
             <a:r>
-              <a:rPr sz="2700" b="1">
+              <a:rPr sz="3000" b="1">
                 <a:solidFill>
                   <a:srgbClr val="5FB0FF"/>
                 </a:solidFill>
@@ -4936,7 +4861,7 @@
               <a:buChar char="•"/>
             </a:pPr>
             <a:r>
-              <a:rPr sz="2500" b="0">
+              <a:rPr sz="2800" b="0">
                 <a:solidFill>
                   <a:srgbClr val="EEF3F8"/>
                 </a:solidFill>
@@ -4945,7 +4870,7 @@
               <a:t>No dates or sky coordinates: only </a:t>
             </a:r>
             <a:r>
-              <a:rPr sz="2500" b="1">
+              <a:rPr sz="2800" b="1">
                 <a:solidFill>
                   <a:srgbClr val="EEF3F8"/>
                 </a:solidFill>
@@ -4954,13 +4879,13 @@
               <a:t>9 numbers describing the viewing geometry</a:t>
             </a:r>
             <a:r>
-              <a:rPr sz="2500" b="0">
+              <a:rPr sz="2800" b="0">
                 <a:solidFill>
                   <a:srgbClr val="EEF3F8"/>
                 </a:solidFill>
                 <a:latin typeface="Arial"/>
               </a:rPr>
-              <a:t> (Fig. 3), dot products of the pointing vector n</a:t>
+              <a:t> (Fig. 2), dot products of the pointing vector n</a:t>
             </a:r>
           </a:p>
           <a:p>
@@ -4978,7 +4903,7 @@
               <a:buChar char="•"/>
             </a:pPr>
             <a:r>
-              <a:rPr sz="2500" b="0">
+              <a:rPr sz="2800" b="0">
                 <a:solidFill>
                   <a:srgbClr val="EEF3F8"/>
                 </a:solidFill>
@@ -4991,22 +4916,22 @@
       </p:sp>
       <p:pic>
         <p:nvPicPr>
-          <p:cNvPr id="26" name="Picture 25" descr="geometry_dark.png"/>
+          <p:cNvPr id="24" name="Picture 23" descr="geometry_dark.png"/>
           <p:cNvPicPr>
             <a:picLocks noChangeAspect="1"/>
           </p:cNvPicPr>
           <p:nvPr/>
         </p:nvPicPr>
         <p:blipFill>
-          <a:blip r:embed="rId6"/>
+          <a:blip r:embed="rId5"/>
           <a:stretch>
             <a:fillRect/>
           </a:stretch>
         </p:blipFill>
         <p:spPr>
           <a:xfrm>
-            <a:off x="8598578" y="28306030"/>
-            <a:ext cx="7083381" cy="4816699"/>
+            <a:off x="7540142" y="24334485"/>
+            <a:ext cx="8141817" cy="5536435"/>
           </a:xfrm>
           <a:prstGeom prst="rect">
             <a:avLst/>
@@ -5015,14 +4940,14 @@
       </p:pic>
       <p:sp>
         <p:nvSpPr>
-          <p:cNvPr id="27" name="TextBox 26"/>
+          <p:cNvPr id="25" name="TextBox 24"/>
           <p:cNvSpPr txBox="1"/>
           <p:nvPr/>
         </p:nvSpPr>
         <p:spPr>
           <a:xfrm>
-            <a:off x="1143000" y="33214170"/>
-            <a:ext cx="14538960" cy="1101852"/>
+            <a:off x="1143000" y="29962361"/>
+            <a:ext cx="14538960" cy="1709928"/>
           </a:xfrm>
           <a:prstGeom prst="rect">
             <a:avLst/>
@@ -5044,16 +4969,16 @@
               </a:spcAft>
             </a:pPr>
             <a:r>
-              <a:rPr sz="2200" b="1">
+              <a:rPr sz="2600" b="1">
                 <a:solidFill>
                   <a:srgbClr val="A9B6C6"/>
                 </a:solidFill>
                 <a:latin typeface="Arial"/>
               </a:rPr>
-              <a:t>Figure 3. </a:t>
-            </a:r>
-            <a:r>
-              <a:rPr sz="2200" b="0">
+              <a:t>Figure 2. </a:t>
+            </a:r>
+            <a:r>
+              <a:rPr sz="2600" b="0">
                 <a:solidFill>
                   <a:srgbClr val="A9B6C6"/>
                 </a:solidFill>
@@ -5066,14 +4991,14 @@
       </p:sp>
       <p:sp>
         <p:nvSpPr>
-          <p:cNvPr id="28" name="TextBox 27"/>
+          <p:cNvPr id="26" name="TextBox 25"/>
           <p:cNvSpPr txBox="1"/>
           <p:nvPr/>
         </p:nvSpPr>
         <p:spPr>
           <a:xfrm>
-            <a:off x="1143000" y="34604629"/>
-            <a:ext cx="14538960" cy="548640"/>
+            <a:off x="1143000" y="32031779"/>
+            <a:ext cx="14538960" cy="594360"/>
           </a:xfrm>
           <a:prstGeom prst="rect">
             <a:avLst/>
@@ -5095,7 +5020,7 @@
               </a:spcAft>
             </a:pPr>
             <a:r>
-              <a:rPr sz="2800" b="1">
+              <a:rPr sz="3200" b="1">
                 <a:solidFill>
                   <a:srgbClr val="5FB0FF"/>
                 </a:solidFill>
@@ -5108,14 +5033,14 @@
       </p:sp>
       <p:sp>
         <p:nvSpPr>
-          <p:cNvPr id="29" name="TextBox 28"/>
+          <p:cNvPr id="27" name="TextBox 26"/>
           <p:cNvSpPr txBox="1"/>
           <p:nvPr/>
         </p:nvSpPr>
         <p:spPr>
           <a:xfrm>
-            <a:off x="1325880" y="35153269"/>
-            <a:ext cx="3291840" cy="457200"/>
+            <a:off x="1325880" y="32653571"/>
+            <a:ext cx="3657600" cy="512064"/>
           </a:xfrm>
           <a:prstGeom prst="rect">
             <a:avLst/>
@@ -5137,7 +5062,7 @@
               </a:spcAft>
             </a:pPr>
             <a:r>
-              <a:rPr sz="2400" b="1">
+              <a:rPr sz="2800" b="1">
                 <a:solidFill>
                   <a:srgbClr val="5FB0FF"/>
                 </a:solidFill>
@@ -5150,14 +5075,14 @@
       </p:sp>
       <p:sp>
         <p:nvSpPr>
-          <p:cNvPr id="30" name="TextBox 29"/>
+          <p:cNvPr id="28" name="TextBox 27"/>
           <p:cNvSpPr txBox="1"/>
           <p:nvPr/>
         </p:nvSpPr>
         <p:spPr>
           <a:xfrm>
-            <a:off x="4617720" y="35153269"/>
-            <a:ext cx="11064240" cy="457200"/>
+            <a:off x="4983480" y="32653571"/>
+            <a:ext cx="10698480" cy="512064"/>
           </a:xfrm>
           <a:prstGeom prst="rect">
             <a:avLst/>
@@ -5179,7 +5104,7 @@
               </a:spcAft>
             </a:pPr>
             <a:r>
-              <a:rPr sz="2400" b="0">
+              <a:rPr sz="2600" b="0">
                 <a:solidFill>
                   <a:srgbClr val="EEF3F8"/>
                 </a:solidFill>
@@ -5192,14 +5117,14 @@
       </p:sp>
       <p:sp>
         <p:nvSpPr>
-          <p:cNvPr id="31" name="TextBox 30"/>
+          <p:cNvPr id="29" name="TextBox 28"/>
           <p:cNvSpPr txBox="1"/>
           <p:nvPr/>
         </p:nvSpPr>
         <p:spPr>
           <a:xfrm>
-            <a:off x="1325880" y="35583037"/>
-            <a:ext cx="3291840" cy="457200"/>
+            <a:off x="1325880" y="33165635"/>
+            <a:ext cx="3657600" cy="512064"/>
           </a:xfrm>
           <a:prstGeom prst="rect">
             <a:avLst/>
@@ -5221,7 +5146,7 @@
               </a:spcAft>
             </a:pPr>
             <a:r>
-              <a:rPr sz="2400" b="1">
+              <a:rPr sz="2800" b="1">
                 <a:solidFill>
                   <a:srgbClr val="5FB0FF"/>
                 </a:solidFill>
@@ -5234,14 +5159,14 @@
       </p:sp>
       <p:sp>
         <p:nvSpPr>
-          <p:cNvPr id="32" name="TextBox 31"/>
+          <p:cNvPr id="30" name="TextBox 29"/>
           <p:cNvSpPr txBox="1"/>
           <p:nvPr/>
         </p:nvSpPr>
         <p:spPr>
           <a:xfrm>
-            <a:off x="4617720" y="35583037"/>
-            <a:ext cx="11064240" cy="457200"/>
+            <a:off x="4983480" y="33165635"/>
+            <a:ext cx="10698480" cy="512064"/>
           </a:xfrm>
           <a:prstGeom prst="rect">
             <a:avLst/>
@@ -5263,7 +5188,7 @@
               </a:spcAft>
             </a:pPr>
             <a:r>
-              <a:rPr sz="2400" b="0">
+              <a:rPr sz="2600" b="0">
                 <a:solidFill>
                   <a:srgbClr val="EEF3F8"/>
                 </a:solidFill>
@@ -5276,14 +5201,14 @@
       </p:sp>
       <p:sp>
         <p:nvSpPr>
-          <p:cNvPr id="33" name="TextBox 32"/>
+          <p:cNvPr id="31" name="TextBox 30"/>
           <p:cNvSpPr txBox="1"/>
           <p:nvPr/>
         </p:nvSpPr>
         <p:spPr>
           <a:xfrm>
-            <a:off x="1325880" y="36012805"/>
-            <a:ext cx="3291840" cy="457200"/>
+            <a:off x="1325880" y="33677699"/>
+            <a:ext cx="3657600" cy="512064"/>
           </a:xfrm>
           <a:prstGeom prst="rect">
             <a:avLst/>
@@ -5305,7 +5230,7 @@
               </a:spcAft>
             </a:pPr>
             <a:r>
-              <a:rPr sz="2400" b="1">
+              <a:rPr sz="2800" b="1">
                 <a:solidFill>
                   <a:srgbClr val="5FB0FF"/>
                 </a:solidFill>
@@ -5318,14 +5243,14 @@
       </p:sp>
       <p:sp>
         <p:nvSpPr>
-          <p:cNvPr id="34" name="TextBox 33"/>
+          <p:cNvPr id="32" name="TextBox 31"/>
           <p:cNvSpPr txBox="1"/>
           <p:nvPr/>
         </p:nvSpPr>
         <p:spPr>
           <a:xfrm>
-            <a:off x="4617720" y="36012805"/>
-            <a:ext cx="11064240" cy="457200"/>
+            <a:off x="4983480" y="33677699"/>
+            <a:ext cx="10698480" cy="512064"/>
           </a:xfrm>
           <a:prstGeom prst="rect">
             <a:avLst/>
@@ -5347,7 +5272,7 @@
               </a:spcAft>
             </a:pPr>
             <a:r>
-              <a:rPr sz="2400" b="0">
+              <a:rPr sz="2600" b="0">
                 <a:solidFill>
                   <a:srgbClr val="EEF3F8"/>
                 </a:solidFill>
@@ -5360,14 +5285,14 @@
       </p:sp>
       <p:sp>
         <p:nvSpPr>
-          <p:cNvPr id="35" name="TextBox 34"/>
+          <p:cNvPr id="33" name="TextBox 32"/>
           <p:cNvSpPr txBox="1"/>
           <p:nvPr/>
         </p:nvSpPr>
         <p:spPr>
           <a:xfrm>
-            <a:off x="1325880" y="36442573"/>
-            <a:ext cx="3291840" cy="457200"/>
+            <a:off x="1325880" y="34189763"/>
+            <a:ext cx="3657600" cy="512064"/>
           </a:xfrm>
           <a:prstGeom prst="rect">
             <a:avLst/>
@@ -5389,7 +5314,7 @@
               </a:spcAft>
             </a:pPr>
             <a:r>
-              <a:rPr sz="2400" b="1">
+              <a:rPr sz="2800" b="1">
                 <a:solidFill>
                   <a:srgbClr val="5FB0FF"/>
                 </a:solidFill>
@@ -5402,14 +5327,14 @@
       </p:sp>
       <p:sp>
         <p:nvSpPr>
-          <p:cNvPr id="36" name="TextBox 35"/>
+          <p:cNvPr id="34" name="TextBox 33"/>
           <p:cNvSpPr txBox="1"/>
           <p:nvPr/>
         </p:nvSpPr>
         <p:spPr>
           <a:xfrm>
-            <a:off x="4617720" y="36442573"/>
-            <a:ext cx="11064240" cy="457200"/>
+            <a:off x="4983480" y="34189763"/>
+            <a:ext cx="10698480" cy="512064"/>
           </a:xfrm>
           <a:prstGeom prst="rect">
             <a:avLst/>
@@ -5431,7 +5356,7 @@
               </a:spcAft>
             </a:pPr>
             <a:r>
-              <a:rPr sz="2400" b="0">
+              <a:rPr sz="2600" b="0">
                 <a:solidFill>
                   <a:srgbClr val="EEF3F8"/>
                 </a:solidFill>
@@ -5444,14 +5369,14 @@
       </p:sp>
       <p:sp>
         <p:nvSpPr>
-          <p:cNvPr id="37" name="TextBox 36"/>
+          <p:cNvPr id="35" name="TextBox 34"/>
           <p:cNvSpPr txBox="1"/>
           <p:nvPr/>
         </p:nvSpPr>
         <p:spPr>
           <a:xfrm>
-            <a:off x="1325880" y="36872341"/>
-            <a:ext cx="3291840" cy="457200"/>
+            <a:off x="1325880" y="34701827"/>
+            <a:ext cx="3657600" cy="512064"/>
           </a:xfrm>
           <a:prstGeom prst="rect">
             <a:avLst/>
@@ -5473,7 +5398,7 @@
               </a:spcAft>
             </a:pPr>
             <a:r>
-              <a:rPr sz="2400" b="1">
+              <a:rPr sz="2800" b="1">
                 <a:solidFill>
                   <a:srgbClr val="5FB0FF"/>
                 </a:solidFill>
@@ -5486,14 +5411,14 @@
       </p:sp>
       <p:sp>
         <p:nvSpPr>
-          <p:cNvPr id="38" name="TextBox 37"/>
+          <p:cNvPr id="36" name="TextBox 35"/>
           <p:cNvSpPr txBox="1"/>
           <p:nvPr/>
         </p:nvSpPr>
         <p:spPr>
           <a:xfrm>
-            <a:off x="4617720" y="36872341"/>
-            <a:ext cx="11064240" cy="457200"/>
+            <a:off x="4983480" y="34701827"/>
+            <a:ext cx="10698480" cy="512064"/>
           </a:xfrm>
           <a:prstGeom prst="rect">
             <a:avLst/>
@@ -5515,7 +5440,7 @@
               </a:spcAft>
             </a:pPr>
             <a:r>
-              <a:rPr sz="2400" b="0">
+              <a:rPr sz="2600" b="0">
                 <a:solidFill>
                   <a:srgbClr val="EEF3F8"/>
                 </a:solidFill>
@@ -5528,14 +5453,14 @@
       </p:sp>
       <p:sp>
         <p:nvSpPr>
-          <p:cNvPr id="39" name="TextBox 38"/>
+          <p:cNvPr id="37" name="TextBox 36"/>
           <p:cNvSpPr txBox="1"/>
           <p:nvPr/>
         </p:nvSpPr>
         <p:spPr>
           <a:xfrm>
-            <a:off x="1143000" y="37590717"/>
-            <a:ext cx="14538960" cy="2171395"/>
+            <a:off x="1143000" y="35573381"/>
+            <a:ext cx="6995160" cy="3148583"/>
           </a:xfrm>
           <a:prstGeom prst="rect">
             <a:avLst/>
@@ -5560,7 +5485,7 @@
               </a:spcAft>
             </a:pPr>
             <a:r>
-              <a:rPr sz="2800" b="1">
+              <a:rPr sz="3000" b="1">
                 <a:solidFill>
                   <a:srgbClr val="5FB0FF"/>
                 </a:solidFill>
@@ -5584,7 +5509,7 @@
               <a:buChar char="•"/>
             </a:pPr>
             <a:r>
-              <a:rPr sz="2600" b="0">
+              <a:rPr sz="2800" b="0">
                 <a:solidFill>
                   <a:srgbClr val="EEF3F8"/>
                 </a:solidFill>
@@ -5608,7 +5533,7 @@
               <a:buChar char="•"/>
             </a:pPr>
             <a:r>
-              <a:rPr sz="2600" b="0">
+              <a:rPr sz="2800" b="0">
                 <a:solidFill>
                   <a:srgbClr val="EEF3F8"/>
                 </a:solidFill>
@@ -5617,37 +5542,79 @@
               <a:t>Tested on whole months and sky regions they never saw</a:t>
             </a:r>
           </a:p>
-          <a:p>
-            <a:pPr algn="l" marL="384048" indent="-384048">
+        </p:txBody>
+      </p:sp>
+      <p:pic>
+        <p:nvPicPr>
+          <p:cNvPr id="38" name="Picture 37" descr="training_dark.png"/>
+          <p:cNvPicPr>
+            <a:picLocks noChangeAspect="1"/>
+          </p:cNvPicPr>
+          <p:nvPr/>
+        </p:nvPicPr>
+        <p:blipFill>
+          <a:blip r:embed="rId6"/>
+          <a:stretch>
+            <a:fillRect/>
+          </a:stretch>
+        </p:blipFill>
+        <p:spPr>
+          <a:xfrm>
+            <a:off x="8412480" y="35573381"/>
+            <a:ext cx="7269480" cy="3004718"/>
+          </a:xfrm>
+          <a:prstGeom prst="rect">
+            <a:avLst/>
+          </a:prstGeom>
+        </p:spPr>
+      </p:pic>
+      <p:sp>
+        <p:nvSpPr>
+          <p:cNvPr id="39" name="TextBox 38"/>
+          <p:cNvSpPr txBox="1"/>
+          <p:nvPr/>
+        </p:nvSpPr>
+        <p:spPr>
+          <a:xfrm>
+            <a:off x="1143000" y="38813405"/>
+            <a:ext cx="14538960" cy="877824"/>
+          </a:xfrm>
+          <a:prstGeom prst="rect">
+            <a:avLst/>
+          </a:prstGeom>
+          <a:noFill/>
+        </p:spPr>
+        <p:txBody>
+          <a:bodyPr wrap="square" anchor="t" lIns="45720" rIns="45720" tIns="18288" bIns="18288">
+            <a:spAutoFit/>
+          </a:bodyPr>
+          <a:lstStyle/>
+          <a:p>
+            <a:pPr algn="l">
               <a:lnSpc>
-                <a:spcPct val="108000"/>
+                <a:spcPct val="105000"/>
               </a:lnSpc>
               <a:spcAft>
-                <a:spcPts val="600"/>
+                <a:spcPts val="0"/>
               </a:spcAft>
-              <a:buClr>
-                <a:srgbClr val="FF6F91"/>
-              </a:buClr>
-              <a:buFont typeface="Arial"/>
-              <a:buChar char="•"/>
             </a:pPr>
             <a:r>
               <a:rPr sz="2600" b="1">
                 <a:solidFill>
-                  <a:srgbClr val="EEF3F8"/>
-                </a:solidFill>
-                <a:latin typeface="Arial"/>
-              </a:rPr>
-              <a:t>Lesson: </a:t>
+                  <a:srgbClr val="A9B6C6"/>
+                </a:solidFill>
+                <a:latin typeface="Arial"/>
+              </a:rPr>
+              <a:t>Figure 3. </a:t>
             </a:r>
             <a:r>
               <a:rPr sz="2600" b="0">
                 <a:solidFill>
-                  <a:srgbClr val="EEF3F8"/>
-                </a:solidFill>
-                <a:latin typeface="Arial"/>
-              </a:rPr>
-              <a:t>adding the time of year (sin λ⊕, cos λ⊕) cut the errors ~40–65×</a:t>
+                  <a:srgbClr val="A9B6C6"/>
+                </a:solidFill>
+                <a:latin typeface="Arial"/>
+              </a:rPr>
+              <a:t>Error during training: 5 networks (thin), average (thick). The error on withheld months levels off and never rises: no overfitting.</a:t>
             </a:r>
           </a:p>
         </p:txBody>
@@ -5661,7 +5628,7 @@
         <p:spPr>
           <a:xfrm>
             <a:off x="16824960" y="7223760"/>
-            <a:ext cx="15361920" cy="26517600"/>
+            <a:ext cx="15361920" cy="27889200"/>
           </a:xfrm>
           <a:prstGeom prst="rect">
             <a:avLst/>
@@ -5903,7 +5870,7 @@
               </a:spcAft>
             </a:pPr>
             <a:r>
-              <a:rPr sz="2300" b="0">
+              <a:rPr sz="2600" b="0">
                 <a:solidFill>
                   <a:srgbClr val="EEF3F8"/>
                 </a:solidFill>
@@ -5922,7 +5889,7 @@
               </a:spcAft>
             </a:pPr>
             <a:r>
-              <a:rPr sz="2300" b="0">
+              <a:rPr sz="2600" b="0">
                 <a:solidFill>
                   <a:srgbClr val="EEF3F8"/>
                 </a:solidFill>
@@ -6052,7 +6019,7 @@
               </a:spcAft>
             </a:pPr>
             <a:r>
-              <a:rPr sz="2300" b="0">
+              <a:rPr sz="2600" b="0">
                 <a:solidFill>
                   <a:srgbClr val="EEF3F8"/>
                 </a:solidFill>
@@ -6071,7 +6038,7 @@
               </a:spcAft>
             </a:pPr>
             <a:r>
-              <a:rPr sz="2300" b="0">
+              <a:rPr sz="2600" b="0">
                 <a:solidFill>
                   <a:srgbClr val="EEF3F8"/>
                 </a:solidFill>
@@ -6201,7 +6168,7 @@
               </a:spcAft>
             </a:pPr>
             <a:r>
-              <a:rPr sz="2300" b="0">
+              <a:rPr sz="2600" b="0">
                 <a:solidFill>
                   <a:srgbClr val="EEF3F8"/>
                 </a:solidFill>
@@ -6220,7 +6187,7 @@
               </a:spcAft>
             </a:pPr>
             <a:r>
-              <a:rPr sz="2300" b="0">
+              <a:rPr sz="2600" b="0">
                 <a:solidFill>
                   <a:srgbClr val="EEF3F8"/>
                 </a:solidFill>
@@ -6247,8 +6214,8 @@
         </p:blipFill>
         <p:spPr>
           <a:xfrm>
-            <a:off x="19717904" y="11178540"/>
-            <a:ext cx="9576031" cy="4788015"/>
+            <a:off x="17963388" y="11229487"/>
+            <a:ext cx="13085064" cy="6542532"/>
           </a:xfrm>
           <a:prstGeom prst="rect">
             <a:avLst/>
@@ -6263,8 +6230,8 @@
         </p:nvSpPr>
         <p:spPr>
           <a:xfrm>
-            <a:off x="17236440" y="16057995"/>
-            <a:ext cx="14538960" cy="749808"/>
+            <a:off x="17236440" y="17863459"/>
+            <a:ext cx="14538960" cy="1293876"/>
           </a:xfrm>
           <a:prstGeom prst="rect">
             <a:avLst/>
@@ -6286,7 +6253,7 @@
               </a:spcAft>
             </a:pPr>
             <a:r>
-              <a:rPr sz="2200" b="1">
+              <a:rPr sz="2600" b="1">
                 <a:solidFill>
                   <a:srgbClr val="A9B6C6"/>
                 </a:solidFill>
@@ -6295,7 +6262,7 @@
               <a:t>Figure 4. </a:t>
             </a:r>
             <a:r>
-              <a:rPr sz="2200" b="0">
+              <a:rPr sz="2600" b="0">
                 <a:solidFill>
                   <a:srgbClr val="A9B6C6"/>
                 </a:solidFill>
@@ -6308,7 +6275,7 @@
       </p:sp>
       <p:pic>
         <p:nvPicPr>
-          <p:cNvPr id="54" name="Picture 53" descr="training_dark.png"/>
+          <p:cNvPr id="54" name="Picture 53" descr="shifts_dark.png"/>
           <p:cNvPicPr>
             <a:picLocks noChangeAspect="1"/>
           </p:cNvPicPr>
@@ -6322,8 +6289,8 @@
         </p:blipFill>
         <p:spPr>
           <a:xfrm>
-            <a:off x="20196705" y="16922103"/>
-            <a:ext cx="8618428" cy="3562283"/>
+            <a:off x="18326862" y="19322582"/>
+            <a:ext cx="12358116" cy="5561152"/>
           </a:xfrm>
           <a:prstGeom prst="rect">
             <a:avLst/>
@@ -6338,8 +6305,8 @@
         </p:nvSpPr>
         <p:spPr>
           <a:xfrm>
-            <a:off x="17236440" y="20575827"/>
-            <a:ext cx="14538960" cy="749808"/>
+            <a:off x="17236440" y="24975174"/>
+            <a:ext cx="14538960" cy="1293876"/>
           </a:xfrm>
           <a:prstGeom prst="rect">
             <a:avLst/>
@@ -6361,7 +6328,7 @@
               </a:spcAft>
             </a:pPr>
             <a:r>
-              <a:rPr sz="2200" b="1">
+              <a:rPr sz="2600" b="1">
                 <a:solidFill>
                   <a:srgbClr val="A9B6C6"/>
                 </a:solidFill>
@@ -6370,102 +6337,27 @@
               <a:t>Figure 5. </a:t>
             </a:r>
             <a:r>
-              <a:rPr sz="2200" b="0">
+              <a:rPr sz="2600" b="0">
                 <a:solidFill>
                   <a:srgbClr val="A9B6C6"/>
                 </a:solidFill>
                 <a:latin typeface="Arial"/>
               </a:rPr>
-              <a:t>Error during training: 5 networks (thin), average (thick). The error on withheld months levels off and never rises: no overfitting.</a:t>
-            </a:r>
-          </a:p>
-        </p:txBody>
-      </p:sp>
-      <p:pic>
-        <p:nvPicPr>
-          <p:cNvPr id="56" name="Picture 55" descr="shifts_dark.png"/>
-          <p:cNvPicPr>
-            <a:picLocks noChangeAspect="1"/>
-          </p:cNvPicPr>
-          <p:nvPr/>
-        </p:nvPicPr>
-        <p:blipFill>
-          <a:blip r:embed="rId9"/>
-          <a:stretch>
-            <a:fillRect/>
-          </a:stretch>
-        </p:blipFill>
-        <p:spPr>
-          <a:xfrm>
-            <a:off x="19717904" y="21439935"/>
-            <a:ext cx="9576031" cy="4309214"/>
-          </a:xfrm>
-          <a:prstGeom prst="rect">
-            <a:avLst/>
-          </a:prstGeom>
-        </p:spPr>
-      </p:pic>
-      <p:sp>
-        <p:nvSpPr>
-          <p:cNvPr id="57" name="TextBox 56"/>
+              <a:t>Six versions of the test, sliding the withheld months 10 days at a time: all reach 0.015–0.03% (red). Predicting past the start/end of the data (orange) is harder: fine for ~10 days, then errors grow.</a:t>
+            </a:r>
+          </a:p>
+        </p:txBody>
+      </p:sp>
+      <p:sp>
+        <p:nvSpPr>
+          <p:cNvPr id="56" name="TextBox 55"/>
           <p:cNvSpPr txBox="1"/>
           <p:nvPr/>
         </p:nvSpPr>
         <p:spPr>
           <a:xfrm>
-            <a:off x="17236440" y="25840589"/>
-            <a:ext cx="14538960" cy="749808"/>
-          </a:xfrm>
-          <a:prstGeom prst="rect">
-            <a:avLst/>
-          </a:prstGeom>
-          <a:noFill/>
-        </p:spPr>
-        <p:txBody>
-          <a:bodyPr wrap="square" anchor="t" lIns="45720" rIns="45720" tIns="18288" bIns="18288">
-            <a:spAutoFit/>
-          </a:bodyPr>
-          <a:lstStyle/>
-          <a:p>
-            <a:pPr algn="l">
-              <a:lnSpc>
-                <a:spcPct val="105000"/>
-              </a:lnSpc>
-              <a:spcAft>
-                <a:spcPts val="0"/>
-              </a:spcAft>
-            </a:pPr>
-            <a:r>
-              <a:rPr sz="2200" b="1">
-                <a:solidFill>
-                  <a:srgbClr val="A9B6C6"/>
-                </a:solidFill>
-                <a:latin typeface="Arial"/>
-              </a:rPr>
-              <a:t>Figure 6. </a:t>
-            </a:r>
-            <a:r>
-              <a:rPr sz="2200" b="0">
-                <a:solidFill>
-                  <a:srgbClr val="A9B6C6"/>
-                </a:solidFill>
-                <a:latin typeface="Arial"/>
-              </a:rPr>
-              <a:t>Six versions of the test, sliding the withheld months 10 days at a time: all reach 0.015–0.03% (red). Predicting past the start/end of the data (orange) is harder: fine for ~10 days, then errors grow.</a:t>
-            </a:r>
-          </a:p>
-        </p:txBody>
-      </p:sp>
-      <p:sp>
-        <p:nvSpPr>
-          <p:cNvPr id="58" name="TextBox 57"/>
-          <p:cNvSpPr txBox="1"/>
-          <p:nvPr/>
-        </p:nvSpPr>
-        <p:spPr>
-          <a:xfrm>
-            <a:off x="17236440" y="26704697"/>
-            <a:ext cx="14538960" cy="977798"/>
+            <a:off x="17236440" y="26434298"/>
+            <a:ext cx="14538960" cy="2173224"/>
           </a:xfrm>
           <a:prstGeom prst="rect">
             <a:avLst/>
@@ -6492,7 +6384,7 @@
               <a:buChar char="•"/>
             </a:pPr>
             <a:r>
-              <a:rPr sz="2600" b="1">
+              <a:rPr sz="3000" b="1">
                 <a:solidFill>
                   <a:srgbClr val="EEF3F8"/>
                 </a:solidFill>
@@ -6501,16 +6393,16 @@
               <a:t>Largest errors </a:t>
             </a:r>
             <a:r>
-              <a:rPr sz="2600" b="0">
+              <a:rPr sz="3000" b="0">
                 <a:solidFill>
                   <a:srgbClr val="EEF3F8"/>
                 </a:solidFill>
                 <a:latin typeface="Arial"/>
               </a:rPr>
-              <a:t>along the plane of the planets, where the dust bands are (0.08%); </a:t>
-            </a:r>
-            <a:r>
-              <a:rPr sz="2600" b="1">
+              <a:t>along the plane of the planets, where the dust bands are; </a:t>
+            </a:r>
+            <a:r>
+              <a:rPr sz="3000" b="1">
                 <a:solidFill>
                   <a:srgbClr val="EEF3F8"/>
                 </a:solidFill>
@@ -6519,35 +6411,68 @@
               <a:t>smallest </a:t>
             </a:r>
             <a:r>
-              <a:rPr sz="2600" b="0">
+              <a:rPr sz="3000" b="0">
                 <a:solidFill>
                   <a:srgbClr val="EEF3F8"/>
                 </a:solidFill>
                 <a:latin typeface="Arial"/>
               </a:rPr>
-              <a:t>toward the poles (0.013%; Fig. 7)</a:t>
+              <a:t>toward the poles (Fig. 6)</a:t>
+            </a:r>
+          </a:p>
+          <a:p>
+            <a:pPr algn="l" marL="384048" indent="-384048">
+              <a:lnSpc>
+                <a:spcPct val="108000"/>
+              </a:lnSpc>
+              <a:spcAft>
+                <a:spcPts val="600"/>
+              </a:spcAft>
+              <a:buClr>
+                <a:srgbClr val="FF6F91"/>
+              </a:buClr>
+              <a:buFont typeface="Arial"/>
+              <a:buChar char="•"/>
+            </a:pPr>
+            <a:r>
+              <a:rPr sz="3000" b="1">
+                <a:solidFill>
+                  <a:srgbClr val="EEF3F8"/>
+                </a:solidFill>
+                <a:latin typeface="Arial"/>
+              </a:rPr>
+              <a:t>More data: </a:t>
+            </a:r>
+            <a:r>
+              <a:rPr sz="3000" b="0">
+                <a:solidFill>
+                  <a:srgbClr val="EEF3F8"/>
+                </a:solidFill>
+                <a:latin typeface="Arial"/>
+              </a:rPr>
+              <a:t>with all 500 days the whole sky is tested and the plane-of-the-planets error drops (0.083% → 0.063%)</a:t>
             </a:r>
           </a:p>
         </p:txBody>
       </p:sp>
       <p:pic>
         <p:nvPicPr>
-          <p:cNvPr id="59" name="Picture 58" descr="skyerror_dark.png"/>
+          <p:cNvPr id="57" name="Picture 56" descr="skyerror_pair_dark.png"/>
           <p:cNvPicPr>
             <a:picLocks noChangeAspect="1"/>
           </p:cNvPicPr>
           <p:nvPr/>
         </p:nvPicPr>
         <p:blipFill>
-          <a:blip r:embed="rId10"/>
+          <a:blip r:embed="rId9"/>
           <a:stretch>
             <a:fillRect/>
           </a:stretch>
         </p:blipFill>
         <p:spPr>
           <a:xfrm>
-            <a:off x="19717904" y="27796796"/>
-            <a:ext cx="9576031" cy="4851855"/>
+            <a:off x="17236440" y="28772769"/>
+            <a:ext cx="14538960" cy="4652467"/>
           </a:xfrm>
           <a:prstGeom prst="rect">
             <a:avLst/>
@@ -6556,14 +6481,14 @@
       </p:pic>
       <p:sp>
         <p:nvSpPr>
-          <p:cNvPr id="60" name="TextBox 59"/>
+          <p:cNvPr id="58" name="TextBox 57"/>
           <p:cNvSpPr txBox="1"/>
           <p:nvPr/>
         </p:nvSpPr>
         <p:spPr>
           <a:xfrm>
-            <a:off x="17236440" y="32740092"/>
-            <a:ext cx="14538960" cy="749808"/>
+            <a:off x="17236440" y="33516676"/>
+            <a:ext cx="14538960" cy="1293876"/>
           </a:xfrm>
           <a:prstGeom prst="rect">
             <a:avLst/>
@@ -6585,36 +6510,36 @@
               </a:spcAft>
             </a:pPr>
             <a:r>
-              <a:rPr sz="2200" b="1">
+              <a:rPr sz="2600" b="1">
                 <a:solidFill>
                   <a:srgbClr val="A9B6C6"/>
                 </a:solidFill>
                 <a:latin typeface="Arial"/>
               </a:rPr>
-              <a:t>Figure 7. </a:t>
-            </a:r>
-            <a:r>
-              <a:rPr sz="2200" b="0">
+              <a:t>Figure 6. </a:t>
+            </a:r>
+            <a:r>
+              <a:rPr sz="2600" b="0">
                 <a:solidFill>
                   <a:srgbClr val="A9B6C6"/>
                 </a:solidFill>
                 <a:latin typeface="Arial"/>
               </a:rPr>
-              <a:t>Error on pointings the network never saw, across the whole sky. Each pointing is drawn 3.5° wide, about SPHEREx's view. Grey: not tested.</a:t>
-            </a:r>
-          </a:p>
-        </p:txBody>
-      </p:sp>
-      <p:sp>
-        <p:nvSpPr>
-          <p:cNvPr id="61" name="Rectangle 60"/>
+              <a:t>Error on pointings the network never saw, across the sky (3.5° patches, about SPHEREx's view). Left: the first 140 days. Right: all 500 days now available (that model also uses Jupiter's direction, n·J). Grey: not tested.</a:t>
+            </a:r>
+          </a:p>
+        </p:txBody>
+      </p:sp>
+      <p:sp>
+        <p:nvSpPr>
+          <p:cNvPr id="59" name="Rectangle 58"/>
           <p:cNvSpPr/>
           <p:nvPr/>
         </p:nvSpPr>
         <p:spPr>
           <a:xfrm>
-            <a:off x="16824960" y="34152840"/>
-            <a:ext cx="15361920" cy="6080759"/>
+            <a:off x="16824960" y="35524440"/>
+            <a:ext cx="15361920" cy="4709159"/>
           </a:xfrm>
           <a:prstGeom prst="rect">
             <a:avLst/>
@@ -6653,13 +6578,13 @@
       </p:sp>
       <p:sp>
         <p:nvSpPr>
-          <p:cNvPr id="62" name="Rectangle 61"/>
+          <p:cNvPr id="60" name="Rectangle 59"/>
           <p:cNvSpPr/>
           <p:nvPr/>
         </p:nvSpPr>
         <p:spPr>
           <a:xfrm>
-            <a:off x="16824960" y="34152840"/>
+            <a:off x="16824960" y="35524440"/>
             <a:ext cx="15361920" cy="914400"/>
           </a:xfrm>
           <a:prstGeom prst="rect">
@@ -6697,13 +6622,13 @@
       </p:sp>
       <p:sp>
         <p:nvSpPr>
-          <p:cNvPr id="63" name="TextBox 62"/>
+          <p:cNvPr id="61" name="TextBox 60"/>
           <p:cNvSpPr txBox="1"/>
           <p:nvPr/>
         </p:nvSpPr>
         <p:spPr>
           <a:xfrm>
-            <a:off x="16824960" y="34152840"/>
+            <a:off x="16824960" y="35524440"/>
             <a:ext cx="15361920" cy="914400"/>
           </a:xfrm>
           <a:prstGeom prst="rect">
@@ -6739,18 +6664,18 @@
       </p:sp>
       <p:sp>
         <p:nvSpPr>
-          <p:cNvPr id="64" name="Rounded Rectangle 63"/>
+          <p:cNvPr id="62" name="Rounded Rectangle 61"/>
           <p:cNvSpPr/>
           <p:nvPr/>
         </p:nvSpPr>
         <p:spPr>
           <a:xfrm>
-            <a:off x="17236440" y="35387280"/>
-            <a:ext cx="14538960" cy="914400"/>
+            <a:off x="17236440" y="36758880"/>
+            <a:ext cx="6995160" cy="1280159"/>
           </a:xfrm>
           <a:prstGeom prst="roundRect">
             <a:avLst>
-              <a:gd name="adj" fmla="val 15000"/>
+              <a:gd name="adj" fmla="val 12000"/>
             </a:avLst>
           </a:prstGeom>
           <a:solidFill>
@@ -6787,14 +6712,14 @@
       </p:sp>
       <p:sp>
         <p:nvSpPr>
-          <p:cNvPr id="65" name="TextBox 64"/>
+          <p:cNvPr id="63" name="TextBox 62"/>
           <p:cNvSpPr txBox="1"/>
           <p:nvPr/>
         </p:nvSpPr>
         <p:spPr>
           <a:xfrm>
-            <a:off x="17465040" y="35387280"/>
-            <a:ext cx="3931920" cy="914400"/>
+            <a:off x="17419320" y="36832032"/>
+            <a:ext cx="6629400" cy="1133855"/>
           </a:xfrm>
           <a:prstGeom prst="rect">
             <a:avLst/>
@@ -6812,17 +6737,17 @@
                 <a:spcPct val="100000"/>
               </a:lnSpc>
               <a:spcAft>
-                <a:spcPts val="0"/>
+                <a:spcPts val="200"/>
               </a:spcAft>
             </a:pPr>
             <a:r>
               <a:rPr sz="2200" b="1">
                 <a:solidFill>
-                  <a:srgbClr val="66BB6A"/>
-                </a:solidFill>
-                <a:latin typeface="Arial"/>
-              </a:rPr>
-              <a:t>✓ DONE</a:t>
+                  <a:srgbClr val="EEF3F8"/>
+                </a:solidFill>
+                <a:latin typeface="Arial"/>
+              </a:rPr>
+              <a:t>✓ DONE: Validate</a:t>
             </a:r>
           </a:p>
           <a:p>
@@ -6831,75 +6756,33 @@
                 <a:spcPct val="100000"/>
               </a:lnSpc>
               <a:spcAft>
-                <a:spcPts val="0"/>
+                <a:spcPts val="200"/>
               </a:spcAft>
             </a:pPr>
             <a:r>
-              <a:rPr sz="2200" b="1">
-                <a:solidFill>
-                  <a:srgbClr val="66BB6A"/>
-                </a:solidFill>
-                <a:latin typeface="Arial"/>
-              </a:rPr>
-              <a:t>Validate</a:t>
-            </a:r>
-          </a:p>
-        </p:txBody>
-      </p:sp>
-      <p:sp>
-        <p:nvSpPr>
-          <p:cNvPr id="66" name="TextBox 65"/>
-          <p:cNvSpPr txBox="1"/>
-          <p:nvPr/>
-        </p:nvSpPr>
-        <p:spPr>
-          <a:xfrm>
-            <a:off x="21442680" y="35387280"/>
-            <a:ext cx="10104120" cy="914400"/>
-          </a:xfrm>
-          <a:prstGeom prst="rect">
-            <a:avLst/>
-          </a:prstGeom>
-          <a:noFill/>
-        </p:spPr>
-        <p:txBody>
-          <a:bodyPr wrap="square" anchor="ctr" lIns="45720" rIns="45720" tIns="18288" bIns="18288">
-            <a:spAutoFit/>
-          </a:bodyPr>
-          <a:lstStyle/>
-          <a:p>
-            <a:pPr algn="l">
-              <a:lnSpc>
-                <a:spcPct val="100000"/>
-              </a:lnSpc>
-              <a:spcAft>
-                <a:spcPts val="0"/>
-              </a:spcAft>
-            </a:pPr>
-            <a:r>
-              <a:rPr sz="2300" b="0">
+              <a:rPr sz="2200" b="0">
                 <a:solidFill>
                   <a:srgbClr val="EEF3F8"/>
                 </a:solidFill>
                 <a:latin typeface="Arial"/>
               </a:rPr>
-              <a:t>Learn ZodiPy's simulated sky from geometry alone; test on unseen months and sky regions</a:t>
-            </a:r>
-          </a:p>
-        </p:txBody>
-      </p:sp>
-      <p:sp>
-        <p:nvSpPr>
-          <p:cNvPr id="67" name="Down Arrow 66"/>
+              <a:t>Learn ZodiPy's simulated sky from geometry alone</a:t>
+            </a:r>
+          </a:p>
+        </p:txBody>
+      </p:sp>
+      <p:sp>
+        <p:nvSpPr>
+          <p:cNvPr id="64" name="Right Arrow 63"/>
           <p:cNvSpPr/>
           <p:nvPr/>
         </p:nvSpPr>
         <p:spPr>
           <a:xfrm>
-            <a:off x="24231600" y="36329112"/>
-            <a:ext cx="548640" cy="164592"/>
-          </a:xfrm>
-          <a:prstGeom prst="downArrow">
+            <a:off x="24323040" y="37216080"/>
+            <a:ext cx="365759" cy="365760"/>
+          </a:xfrm>
+          <a:prstGeom prst="rightArrow">
             <a:avLst/>
           </a:prstGeom>
           <a:solidFill>
@@ -6934,18 +6817,18 @@
       </p:sp>
       <p:sp>
         <p:nvSpPr>
-          <p:cNvPr id="68" name="Rounded Rectangle 67"/>
+          <p:cNvPr id="65" name="Rounded Rectangle 64"/>
           <p:cNvSpPr/>
           <p:nvPr/>
         </p:nvSpPr>
         <p:spPr>
           <a:xfrm>
-            <a:off x="17236440" y="36521136"/>
-            <a:ext cx="14538960" cy="914400"/>
+            <a:off x="24780240" y="36758880"/>
+            <a:ext cx="6995160" cy="1280159"/>
           </a:xfrm>
           <a:prstGeom prst="roundRect">
             <a:avLst>
-              <a:gd name="adj" fmla="val 15000"/>
+              <a:gd name="adj" fmla="val 12000"/>
             </a:avLst>
           </a:prstGeom>
           <a:solidFill>
@@ -6982,14 +6865,14 @@
       </p:sp>
       <p:sp>
         <p:nvSpPr>
-          <p:cNvPr id="69" name="TextBox 68"/>
+          <p:cNvPr id="66" name="TextBox 65"/>
           <p:cNvSpPr txBox="1"/>
           <p:nvPr/>
         </p:nvSpPr>
         <p:spPr>
           <a:xfrm>
-            <a:off x="17465040" y="36521136"/>
-            <a:ext cx="3931920" cy="914400"/>
+            <a:off x="24963120" y="36832032"/>
+            <a:ext cx="6629400" cy="1133855"/>
           </a:xfrm>
           <a:prstGeom prst="rect">
             <a:avLst/>
@@ -7007,17 +6890,17 @@
                 <a:spcPct val="100000"/>
               </a:lnSpc>
               <a:spcAft>
-                <a:spcPts val="0"/>
+                <a:spcPts val="200"/>
               </a:spcAft>
             </a:pPr>
             <a:r>
               <a:rPr sz="2200" b="1">
                 <a:solidFill>
-                  <a:srgbClr val="FFB000"/>
-                </a:solidFill>
-                <a:latin typeface="Arial"/>
-              </a:rPr>
-              <a:t>IN PROGRESS</a:t>
+                  <a:srgbClr val="EEF3F8"/>
+                </a:solidFill>
+                <a:latin typeface="Arial"/>
+              </a:rPr>
+              <a:t>IN PROGRESS: Refine</a:t>
             </a:r>
           </a:p>
           <a:p>
@@ -7026,82 +6909,44 @@
                 <a:spcPct val="100000"/>
               </a:lnSpc>
               <a:spcAft>
-                <a:spcPts val="0"/>
+                <a:spcPts val="200"/>
               </a:spcAft>
             </a:pPr>
             <a:r>
-              <a:rPr sz="2200" b="1">
-                <a:solidFill>
-                  <a:srgbClr val="FFB000"/>
-                </a:solidFill>
-                <a:latin typeface="Arial"/>
-              </a:rPr>
-              <a:t>Refine</a:t>
-            </a:r>
-          </a:p>
-        </p:txBody>
-      </p:sp>
-      <p:sp>
-        <p:nvSpPr>
-          <p:cNvPr id="70" name="TextBox 69"/>
-          <p:cNvSpPr txBox="1"/>
-          <p:nvPr/>
-        </p:nvSpPr>
-        <p:spPr>
-          <a:xfrm>
-            <a:off x="21442680" y="36521136"/>
-            <a:ext cx="10104120" cy="914400"/>
-          </a:xfrm>
-          <a:prstGeom prst="rect">
-            <a:avLst/>
-          </a:prstGeom>
-          <a:noFill/>
-        </p:spPr>
-        <p:txBody>
-          <a:bodyPr wrap="square" anchor="ctr" lIns="45720" rIns="45720" tIns="18288" bIns="18288">
-            <a:spAutoFit/>
-          </a:bodyPr>
-          <a:lstStyle/>
-          <a:p>
-            <a:pPr algn="l">
-              <a:lnSpc>
-                <a:spcPct val="100000"/>
-              </a:lnSpc>
-              <a:spcAft>
-                <a:spcPts val="0"/>
-              </a:spcAft>
-            </a:pPr>
-            <a:r>
-              <a:rPr sz="2300" b="0">
+              <a:rPr sz="2200" b="0">
                 <a:solidFill>
                   <a:srgbClr val="EEF3F8"/>
                 </a:solidFill>
                 <a:latin typeface="Arial"/>
               </a:rPr>
-              <a:t>Longer training; all SPHEREx wavelengths (a first 1.25–5 μm version: ~0.1% error)</a:t>
-            </a:r>
-          </a:p>
-        </p:txBody>
-      </p:sp>
-      <p:sp>
-        <p:nvSpPr>
-          <p:cNvPr id="71" name="Down Arrow 70"/>
+              <a:t>More data (500 days), longer training, Jupiter's direction</a:t>
+            </a:r>
+          </a:p>
+        </p:txBody>
+      </p:sp>
+      <p:sp>
+        <p:nvSpPr>
+          <p:cNvPr id="67" name="Rounded Rectangle 66"/>
           <p:cNvSpPr/>
           <p:nvPr/>
         </p:nvSpPr>
         <p:spPr>
           <a:xfrm>
-            <a:off x="24231600" y="37462968"/>
-            <a:ext cx="548640" cy="164592"/>
-          </a:xfrm>
-          <a:prstGeom prst="downArrow">
-            <a:avLst/>
+            <a:off x="17236440" y="38267640"/>
+            <a:ext cx="6995160" cy="1280159"/>
+          </a:xfrm>
+          <a:prstGeom prst="roundRect">
+            <a:avLst>
+              <a:gd name="adj" fmla="val 12000"/>
+            </a:avLst>
           </a:prstGeom>
           <a:solidFill>
-            <a:srgbClr val="FF6F91"/>
+            <a:srgbClr val="16304F"/>
           </a:solidFill>
-          <a:ln>
-            <a:noFill/>
+          <a:ln w="63500">
+            <a:solidFill>
+              <a:srgbClr val="A9B6C6"/>
+            </a:solidFill>
           </a:ln>
           <a:effectLst/>
         </p:spPr>
@@ -7129,27 +6974,84 @@
       </p:sp>
       <p:sp>
         <p:nvSpPr>
-          <p:cNvPr id="72" name="Rounded Rectangle 71"/>
+          <p:cNvPr id="68" name="TextBox 67"/>
+          <p:cNvSpPr txBox="1"/>
+          <p:nvPr/>
+        </p:nvSpPr>
+        <p:spPr>
+          <a:xfrm>
+            <a:off x="17419320" y="38340792"/>
+            <a:ext cx="6629400" cy="1133855"/>
+          </a:xfrm>
+          <a:prstGeom prst="rect">
+            <a:avLst/>
+          </a:prstGeom>
+          <a:noFill/>
+        </p:spPr>
+        <p:txBody>
+          <a:bodyPr wrap="square" anchor="ctr" lIns="45720" rIns="45720" tIns="18288" bIns="18288">
+            <a:spAutoFit/>
+          </a:bodyPr>
+          <a:lstStyle/>
+          <a:p>
+            <a:pPr algn="l">
+              <a:lnSpc>
+                <a:spcPct val="100000"/>
+              </a:lnSpc>
+              <a:spcAft>
+                <a:spcPts val="200"/>
+              </a:spcAft>
+            </a:pPr>
+            <a:r>
+              <a:rPr sz="2200" b="1">
+                <a:solidFill>
+                  <a:srgbClr val="EEF3F8"/>
+                </a:solidFill>
+                <a:latin typeface="Arial"/>
+              </a:rPr>
+              <a:t>NEXT: Scale up</a:t>
+            </a:r>
+          </a:p>
+          <a:p>
+            <a:pPr algn="l">
+              <a:lnSpc>
+                <a:spcPct val="100000"/>
+              </a:lnSpc>
+              <a:spcAft>
+                <a:spcPts val="200"/>
+              </a:spcAft>
+            </a:pPr>
+            <a:r>
+              <a:rPr sz="2200" b="0">
+                <a:solidFill>
+                  <a:srgbClr val="EEF3F8"/>
+                </a:solidFill>
+                <a:latin typeface="Arial"/>
+              </a:rPr>
+              <a:t>Move training to a computing cluster</a:t>
+            </a:r>
+          </a:p>
+        </p:txBody>
+      </p:sp>
+      <p:sp>
+        <p:nvSpPr>
+          <p:cNvPr id="69" name="Right Arrow 68"/>
           <p:cNvSpPr/>
           <p:nvPr/>
         </p:nvSpPr>
         <p:spPr>
           <a:xfrm>
-            <a:off x="17236440" y="37654992"/>
-            <a:ext cx="14538960" cy="914400"/>
-          </a:xfrm>
-          <a:prstGeom prst="roundRect">
-            <a:avLst>
-              <a:gd name="adj" fmla="val 15000"/>
-            </a:avLst>
+            <a:off x="24323040" y="38724839"/>
+            <a:ext cx="365759" cy="365760"/>
+          </a:xfrm>
+          <a:prstGeom prst="rightArrow">
+            <a:avLst/>
           </a:prstGeom>
           <a:solidFill>
-            <a:srgbClr val="16304F"/>
+            <a:srgbClr val="FF6F91"/>
           </a:solidFill>
-          <a:ln w="63500">
-            <a:solidFill>
-              <a:srgbClr val="A9B6C6"/>
-            </a:solidFill>
+          <a:ln>
+            <a:noFill/>
           </a:ln>
           <a:effectLst/>
         </p:spPr>
@@ -7177,126 +7079,27 @@
       </p:sp>
       <p:sp>
         <p:nvSpPr>
-          <p:cNvPr id="73" name="TextBox 72"/>
-          <p:cNvSpPr txBox="1"/>
-          <p:nvPr/>
-        </p:nvSpPr>
-        <p:spPr>
-          <a:xfrm>
-            <a:off x="17465040" y="37654992"/>
-            <a:ext cx="3931920" cy="914400"/>
-          </a:xfrm>
-          <a:prstGeom prst="rect">
-            <a:avLst/>
-          </a:prstGeom>
-          <a:noFill/>
-        </p:spPr>
-        <p:txBody>
-          <a:bodyPr wrap="square" anchor="ctr" lIns="45720" rIns="45720" tIns="18288" bIns="18288">
-            <a:spAutoFit/>
-          </a:bodyPr>
-          <a:lstStyle/>
-          <a:p>
-            <a:pPr algn="l">
-              <a:lnSpc>
-                <a:spcPct val="100000"/>
-              </a:lnSpc>
-              <a:spcAft>
-                <a:spcPts val="0"/>
-              </a:spcAft>
-            </a:pPr>
-            <a:r>
-              <a:rPr sz="2200" b="1">
-                <a:solidFill>
-                  <a:srgbClr val="A9B6C6"/>
-                </a:solidFill>
-                <a:latin typeface="Arial"/>
-              </a:rPr>
-              <a:t>NEXT</a:t>
-            </a:r>
-          </a:p>
-          <a:p>
-            <a:pPr algn="l">
-              <a:lnSpc>
-                <a:spcPct val="100000"/>
-              </a:lnSpc>
-              <a:spcAft>
-                <a:spcPts val="0"/>
-              </a:spcAft>
-            </a:pPr>
-            <a:r>
-              <a:rPr sz="2200" b="1">
-                <a:solidFill>
-                  <a:srgbClr val="A9B6C6"/>
-                </a:solidFill>
-                <a:latin typeface="Arial"/>
-              </a:rPr>
-              <a:t>Scale up</a:t>
-            </a:r>
-          </a:p>
-        </p:txBody>
-      </p:sp>
-      <p:sp>
-        <p:nvSpPr>
-          <p:cNvPr id="74" name="TextBox 73"/>
-          <p:cNvSpPr txBox="1"/>
-          <p:nvPr/>
-        </p:nvSpPr>
-        <p:spPr>
-          <a:xfrm>
-            <a:off x="21442680" y="37654992"/>
-            <a:ext cx="10104120" cy="914400"/>
-          </a:xfrm>
-          <a:prstGeom prst="rect">
-            <a:avLst/>
-          </a:prstGeom>
-          <a:noFill/>
-        </p:spPr>
-        <p:txBody>
-          <a:bodyPr wrap="square" anchor="ctr" lIns="45720" rIns="45720" tIns="18288" bIns="18288">
-            <a:spAutoFit/>
-          </a:bodyPr>
-          <a:lstStyle/>
-          <a:p>
-            <a:pPr algn="l">
-              <a:lnSpc>
-                <a:spcPct val="100000"/>
-              </a:lnSpc>
-              <a:spcAft>
-                <a:spcPts val="0"/>
-              </a:spcAft>
-            </a:pPr>
-            <a:r>
-              <a:rPr sz="2300" b="0">
-                <a:solidFill>
-                  <a:srgbClr val="EEF3F8"/>
-                </a:solidFill>
-                <a:latin typeface="Arial"/>
-              </a:rPr>
-              <a:t>Move training to a computing cluster</a:t>
-            </a:r>
-          </a:p>
-        </p:txBody>
-      </p:sp>
-      <p:sp>
-        <p:nvSpPr>
-          <p:cNvPr id="75" name="Down Arrow 74"/>
+          <p:cNvPr id="70" name="Rounded Rectangle 69"/>
           <p:cNvSpPr/>
           <p:nvPr/>
         </p:nvSpPr>
         <p:spPr>
           <a:xfrm>
-            <a:off x="24231600" y="38596824"/>
-            <a:ext cx="548640" cy="164592"/>
-          </a:xfrm>
-          <a:prstGeom prst="downArrow">
-            <a:avLst/>
+            <a:off x="24780240" y="38267640"/>
+            <a:ext cx="6995160" cy="1280159"/>
+          </a:xfrm>
+          <a:prstGeom prst="roundRect">
+            <a:avLst>
+              <a:gd name="adj" fmla="val 12000"/>
+            </a:avLst>
           </a:prstGeom>
           <a:solidFill>
-            <a:srgbClr val="FF6F91"/>
+            <a:srgbClr val="16304F"/>
           </a:solidFill>
-          <a:ln>
-            <a:noFill/>
+          <a:ln w="63500">
+            <a:solidFill>
+              <a:srgbClr val="A9B6C6"/>
+            </a:solidFill>
           </a:ln>
           <a:effectLst/>
         </p:spPr>
@@ -7324,26 +7127,127 @@
       </p:sp>
       <p:sp>
         <p:nvSpPr>
-          <p:cNvPr id="76" name="Rounded Rectangle 75"/>
+          <p:cNvPr id="71" name="TextBox 70"/>
+          <p:cNvSpPr txBox="1"/>
+          <p:nvPr/>
+        </p:nvSpPr>
+        <p:spPr>
+          <a:xfrm>
+            <a:off x="24963120" y="38340792"/>
+            <a:ext cx="6629400" cy="1133855"/>
+          </a:xfrm>
+          <a:prstGeom prst="rect">
+            <a:avLst/>
+          </a:prstGeom>
+          <a:noFill/>
+        </p:spPr>
+        <p:txBody>
+          <a:bodyPr wrap="square" anchor="ctr" lIns="45720" rIns="45720" tIns="18288" bIns="18288">
+            <a:spAutoFit/>
+          </a:bodyPr>
+          <a:lstStyle/>
+          <a:p>
+            <a:pPr algn="l">
+              <a:lnSpc>
+                <a:spcPct val="100000"/>
+              </a:lnSpc>
+              <a:spcAft>
+                <a:spcPts val="200"/>
+              </a:spcAft>
+            </a:pPr>
+            <a:r>
+              <a:rPr sz="2200" b="1">
+                <a:solidFill>
+                  <a:srgbClr val="EEF3F8"/>
+                </a:solidFill>
+                <a:latin typeface="Arial"/>
+              </a:rPr>
+              <a:t>NEXT: Real data</a:t>
+            </a:r>
+          </a:p>
+          <a:p>
+            <a:pPr algn="l">
+              <a:lnSpc>
+                <a:spcPct val="100000"/>
+              </a:lnSpc>
+              <a:spcAft>
+                <a:spcPts val="200"/>
+              </a:spcAft>
+            </a:pPr>
+            <a:r>
+              <a:rPr sz="2200" b="0">
+                <a:solidFill>
+                  <a:srgbClr val="EEF3F8"/>
+                </a:solidFill>
+                <a:latin typeface="Arial"/>
+              </a:rPr>
+              <a:t>Train on real SPHEREx images; compare with Kelsall</a:t>
+            </a:r>
+          </a:p>
+        </p:txBody>
+      </p:sp>
+      <p:sp>
+        <p:nvSpPr>
+          <p:cNvPr id="72" name="TextBox 71"/>
+          <p:cNvSpPr txBox="1"/>
+          <p:nvPr/>
+        </p:nvSpPr>
+        <p:spPr>
+          <a:xfrm>
+            <a:off x="17236440" y="39684960"/>
+            <a:ext cx="14538960" cy="411480"/>
+          </a:xfrm>
+          <a:prstGeom prst="rect">
+            <a:avLst/>
+          </a:prstGeom>
+          <a:noFill/>
+        </p:spPr>
+        <p:txBody>
+          <a:bodyPr wrap="square" anchor="t" lIns="45720" rIns="45720" tIns="18288" bIns="18288">
+            <a:spAutoFit/>
+          </a:bodyPr>
+          <a:lstStyle/>
+          <a:p>
+            <a:pPr algn="ctr">
+              <a:lnSpc>
+                <a:spcPct val="112000"/>
+              </a:lnSpc>
+              <a:spcAft>
+                <a:spcPts val="0"/>
+              </a:spcAft>
+            </a:pPr>
+            <a:r>
+              <a:rPr sz="2200" b="0">
+                <a:solidFill>
+                  <a:srgbClr val="A9B6C6"/>
+                </a:solidFill>
+                <a:latin typeface="Arial"/>
+              </a:rPr>
+              <a:t>All results so far are preliminary and use simulated data.</a:t>
+            </a:r>
+          </a:p>
+        </p:txBody>
+      </p:sp>
+      <p:sp>
+        <p:nvSpPr>
+          <p:cNvPr id="73" name="Rectangle 72"/>
           <p:cNvSpPr/>
           <p:nvPr/>
         </p:nvSpPr>
         <p:spPr>
           <a:xfrm>
-            <a:off x="17236440" y="38788848"/>
-            <a:ext cx="14538960" cy="914400"/>
-          </a:xfrm>
-          <a:prstGeom prst="roundRect">
-            <a:avLst>
-              <a:gd name="adj" fmla="val 15000"/>
-            </a:avLst>
+            <a:off x="731520" y="40599360"/>
+            <a:ext cx="15361920" cy="2834640"/>
+          </a:xfrm>
+          <a:prstGeom prst="rect">
+            <a:avLst/>
           </a:prstGeom>
           <a:solidFill>
-            <a:srgbClr val="16304F"/>
+            <a:srgbClr val="0F2036"/>
           </a:solidFill>
-          <a:ln w="63500">
+          <a:ln w="38100">
             <a:solidFill>
-              <a:srgbClr val="A9B6C6"/>
+              <a:srgbClr val="2D5A94"/>
             </a:solidFill>
           </a:ln>
           <a:effectLst/>
@@ -7372,170 +7276,23 @@
       </p:sp>
       <p:sp>
         <p:nvSpPr>
-          <p:cNvPr id="77" name="TextBox 76"/>
-          <p:cNvSpPr txBox="1"/>
+          <p:cNvPr id="74" name="Rectangle 73"/>
+          <p:cNvSpPr/>
           <p:nvPr/>
         </p:nvSpPr>
         <p:spPr>
           <a:xfrm>
-            <a:off x="17465040" y="38788848"/>
-            <a:ext cx="3931920" cy="914400"/>
+            <a:off x="731520" y="40599360"/>
+            <a:ext cx="15361920" cy="777240"/>
           </a:xfrm>
           <a:prstGeom prst="rect">
             <a:avLst/>
           </a:prstGeom>
-          <a:noFill/>
-        </p:spPr>
-        <p:txBody>
-          <a:bodyPr wrap="square" anchor="ctr" lIns="45720" rIns="45720" tIns="18288" bIns="18288">
-            <a:spAutoFit/>
-          </a:bodyPr>
-          <a:lstStyle/>
-          <a:p>
-            <a:pPr algn="l">
-              <a:lnSpc>
-                <a:spcPct val="100000"/>
-              </a:lnSpc>
-              <a:spcAft>
-                <a:spcPts val="0"/>
-              </a:spcAft>
-            </a:pPr>
-            <a:r>
-              <a:rPr sz="2200" b="1">
-                <a:solidFill>
-                  <a:srgbClr val="A9B6C6"/>
-                </a:solidFill>
-                <a:latin typeface="Arial"/>
-              </a:rPr>
-              <a:t>NEXT</a:t>
-            </a:r>
-          </a:p>
-          <a:p>
-            <a:pPr algn="l">
-              <a:lnSpc>
-                <a:spcPct val="100000"/>
-              </a:lnSpc>
-              <a:spcAft>
-                <a:spcPts val="0"/>
-              </a:spcAft>
-            </a:pPr>
-            <a:r>
-              <a:rPr sz="2200" b="1">
-                <a:solidFill>
-                  <a:srgbClr val="A9B6C6"/>
-                </a:solidFill>
-                <a:latin typeface="Arial"/>
-              </a:rPr>
-              <a:t>Real data</a:t>
-            </a:r>
-          </a:p>
-        </p:txBody>
-      </p:sp>
-      <p:sp>
-        <p:nvSpPr>
-          <p:cNvPr id="78" name="TextBox 77"/>
-          <p:cNvSpPr txBox="1"/>
-          <p:nvPr/>
-        </p:nvSpPr>
-        <p:spPr>
-          <a:xfrm>
-            <a:off x="21442680" y="38788848"/>
-            <a:ext cx="10104120" cy="914400"/>
-          </a:xfrm>
-          <a:prstGeom prst="rect">
-            <a:avLst/>
-          </a:prstGeom>
-          <a:noFill/>
-        </p:spPr>
-        <p:txBody>
-          <a:bodyPr wrap="square" anchor="ctr" lIns="45720" rIns="45720" tIns="18288" bIns="18288">
-            <a:spAutoFit/>
-          </a:bodyPr>
-          <a:lstStyle/>
-          <a:p>
-            <a:pPr algn="l">
-              <a:lnSpc>
-                <a:spcPct val="100000"/>
-              </a:lnSpc>
-              <a:spcAft>
-                <a:spcPts val="0"/>
-              </a:spcAft>
-            </a:pPr>
-            <a:r>
-              <a:rPr sz="2300" b="0">
-                <a:solidFill>
-                  <a:srgbClr val="EEF3F8"/>
-                </a:solidFill>
-                <a:latin typeface="Arial"/>
-              </a:rPr>
-              <a:t>Train on real SPHEREx images and compare with the Kelsall model</a:t>
-            </a:r>
-          </a:p>
-        </p:txBody>
-      </p:sp>
-      <p:sp>
-        <p:nvSpPr>
-          <p:cNvPr id="79" name="TextBox 78"/>
-          <p:cNvSpPr txBox="1"/>
-          <p:nvPr/>
-        </p:nvSpPr>
-        <p:spPr>
-          <a:xfrm>
-            <a:off x="17236440" y="39776400"/>
-            <a:ext cx="14538960" cy="457200"/>
-          </a:xfrm>
-          <a:prstGeom prst="rect">
-            <a:avLst/>
-          </a:prstGeom>
-          <a:noFill/>
-        </p:spPr>
-        <p:txBody>
-          <a:bodyPr wrap="square" anchor="t" lIns="45720" rIns="45720" tIns="18288" bIns="18288">
-            <a:spAutoFit/>
-          </a:bodyPr>
-          <a:lstStyle/>
-          <a:p>
-            <a:pPr algn="ctr">
-              <a:lnSpc>
-                <a:spcPct val="112000"/>
-              </a:lnSpc>
-              <a:spcAft>
-                <a:spcPts val="0"/>
-              </a:spcAft>
-            </a:pPr>
-            <a:r>
-              <a:rPr sz="2100" b="0">
-                <a:solidFill>
-                  <a:srgbClr val="A9B6C6"/>
-                </a:solidFill>
-                <a:latin typeface="Arial"/>
-              </a:rPr>
-              <a:t>All results so far are preliminary and use simulated data.</a:t>
-            </a:r>
-          </a:p>
-        </p:txBody>
-      </p:sp>
-      <p:sp>
-        <p:nvSpPr>
-          <p:cNvPr id="80" name="Rectangle 79"/>
-          <p:cNvSpPr/>
-          <p:nvPr/>
-        </p:nvSpPr>
-        <p:spPr>
-          <a:xfrm>
-            <a:off x="731520" y="40599360"/>
-            <a:ext cx="15361920" cy="2834640"/>
-          </a:xfrm>
-          <a:prstGeom prst="rect">
-            <a:avLst/>
-          </a:prstGeom>
           <a:solidFill>
-            <a:srgbClr val="0F2036"/>
+            <a:srgbClr val="1E3557"/>
           </a:solidFill>
-          <a:ln w="38100">
-            <a:solidFill>
-              <a:srgbClr val="2D5A94"/>
-            </a:solidFill>
+          <a:ln>
+            <a:noFill/>
           </a:ln>
           <a:effectLst/>
         </p:spPr>
@@ -7563,23 +7320,133 @@
       </p:sp>
       <p:sp>
         <p:nvSpPr>
-          <p:cNvPr id="81" name="Rectangle 80"/>
+          <p:cNvPr id="75" name="TextBox 74"/>
+          <p:cNvSpPr txBox="1"/>
+          <p:nvPr/>
+        </p:nvSpPr>
+        <p:spPr>
+          <a:xfrm>
+            <a:off x="731520" y="40599360"/>
+            <a:ext cx="15361920" cy="777240"/>
+          </a:xfrm>
+          <a:prstGeom prst="rect">
+            <a:avLst/>
+          </a:prstGeom>
+          <a:noFill/>
+        </p:spPr>
+        <p:txBody>
+          <a:bodyPr wrap="square" anchor="ctr" lIns="45720" rIns="45720" tIns="18288" bIns="18288">
+            <a:spAutoFit/>
+          </a:bodyPr>
+          <a:lstStyle/>
+          <a:p>
+            <a:pPr algn="ctr">
+              <a:lnSpc>
+                <a:spcPct val="112000"/>
+              </a:lnSpc>
+              <a:spcAft>
+                <a:spcPts val="0"/>
+              </a:spcAft>
+            </a:pPr>
+            <a:r>
+              <a:rPr sz="4000" b="1">
+                <a:solidFill>
+                  <a:srgbClr val="FFFFFF"/>
+                </a:solidFill>
+                <a:latin typeface="Arial"/>
+              </a:rPr>
+              <a:t>Acknowledgements</a:t>
+            </a:r>
+          </a:p>
+        </p:txBody>
+      </p:sp>
+      <p:pic>
+        <p:nvPicPr>
+          <p:cNvPr id="76" name="Picture 75" descr="logo_nsf.png"/>
+          <p:cNvPicPr>
+            <a:picLocks noChangeAspect="1"/>
+          </p:cNvPicPr>
+          <p:nvPr/>
+        </p:nvPicPr>
+        <p:blipFill>
+          <a:blip r:embed="rId10"/>
+          <a:stretch>
+            <a:fillRect/>
+          </a:stretch>
+        </p:blipFill>
+        <p:spPr>
+          <a:xfrm>
+            <a:off x="14036040" y="41559480"/>
+            <a:ext cx="1640792" cy="1645919"/>
+          </a:xfrm>
+          <a:prstGeom prst="rect">
+            <a:avLst/>
+          </a:prstGeom>
+        </p:spPr>
+      </p:pic>
+      <p:sp>
+        <p:nvSpPr>
+          <p:cNvPr id="77" name="TextBox 76"/>
+          <p:cNvSpPr txBox="1"/>
+          <p:nvPr/>
+        </p:nvSpPr>
+        <p:spPr>
+          <a:xfrm>
+            <a:off x="1143000" y="41513760"/>
+            <a:ext cx="12618720" cy="1828799"/>
+          </a:xfrm>
+          <a:prstGeom prst="rect">
+            <a:avLst/>
+          </a:prstGeom>
+          <a:noFill/>
+        </p:spPr>
+        <p:txBody>
+          <a:bodyPr wrap="square" anchor="t" lIns="45720" rIns="45720" tIns="18288" bIns="18288">
+            <a:spAutoFit/>
+          </a:bodyPr>
+          <a:lstStyle/>
+          <a:p>
+            <a:pPr algn="l">
+              <a:lnSpc>
+                <a:spcPct val="105000"/>
+              </a:lnSpc>
+              <a:spcAft>
+                <a:spcPts val="1000"/>
+              </a:spcAft>
+            </a:pPr>
+            <a:r>
+              <a:rPr sz="2400" b="0">
+                <a:solidFill>
+                  <a:srgbClr val="EEF3F8"/>
+                </a:solidFill>
+                <a:latin typeface="Arial"/>
+              </a:rPr>
+              <a:t>This research is supported by a URS grant at New Mexico State University, funded by the National Science Foundation (NSF). Thank you to Dr. Andrew Saydjari for mentorship, and to the developers of ZodiPy and Flux.jl.</a:t>
+            </a:r>
+          </a:p>
+        </p:txBody>
+      </p:sp>
+      <p:sp>
+        <p:nvSpPr>
+          <p:cNvPr id="78" name="Rectangle 77"/>
           <p:cNvSpPr/>
           <p:nvPr/>
         </p:nvSpPr>
         <p:spPr>
           <a:xfrm>
-            <a:off x="731520" y="40599360"/>
-            <a:ext cx="15361920" cy="777240"/>
+            <a:off x="16824960" y="40599360"/>
+            <a:ext cx="15361920" cy="2834640"/>
           </a:xfrm>
           <a:prstGeom prst="rect">
             <a:avLst/>
           </a:prstGeom>
           <a:solidFill>
-            <a:srgbClr val="1E3557"/>
+            <a:srgbClr val="0F2036"/>
           </a:solidFill>
-          <a:ln>
-            <a:noFill/>
+          <a:ln w="38100">
+            <a:solidFill>
+              <a:srgbClr val="2D5A94"/>
+            </a:solidFill>
           </a:ln>
           <a:effectLst/>
         </p:spPr>
@@ -7607,133 +7474,23 @@
       </p:sp>
       <p:sp>
         <p:nvSpPr>
-          <p:cNvPr id="82" name="TextBox 81"/>
-          <p:cNvSpPr txBox="1"/>
+          <p:cNvPr id="79" name="Rectangle 78"/>
+          <p:cNvSpPr/>
           <p:nvPr/>
         </p:nvSpPr>
         <p:spPr>
           <a:xfrm>
-            <a:off x="731520" y="40599360"/>
+            <a:off x="16824960" y="40599360"/>
             <a:ext cx="15361920" cy="777240"/>
           </a:xfrm>
           <a:prstGeom prst="rect">
             <a:avLst/>
           </a:prstGeom>
-          <a:noFill/>
-        </p:spPr>
-        <p:txBody>
-          <a:bodyPr wrap="square" anchor="ctr" lIns="45720" rIns="45720" tIns="18288" bIns="18288">
-            <a:spAutoFit/>
-          </a:bodyPr>
-          <a:lstStyle/>
-          <a:p>
-            <a:pPr algn="ctr">
-              <a:lnSpc>
-                <a:spcPct val="112000"/>
-              </a:lnSpc>
-              <a:spcAft>
-                <a:spcPts val="0"/>
-              </a:spcAft>
-            </a:pPr>
-            <a:r>
-              <a:rPr sz="4000" b="1">
-                <a:solidFill>
-                  <a:srgbClr val="FFFFFF"/>
-                </a:solidFill>
-                <a:latin typeface="Arial"/>
-              </a:rPr>
-              <a:t>Acknowledgements</a:t>
-            </a:r>
-          </a:p>
-        </p:txBody>
-      </p:sp>
-      <p:pic>
-        <p:nvPicPr>
-          <p:cNvPr id="83" name="Picture 82" descr="logo_nsf.png"/>
-          <p:cNvPicPr>
-            <a:picLocks noChangeAspect="1"/>
-          </p:cNvPicPr>
-          <p:nvPr/>
-        </p:nvPicPr>
-        <p:blipFill>
-          <a:blip r:embed="rId11"/>
-          <a:stretch>
-            <a:fillRect/>
-          </a:stretch>
-        </p:blipFill>
-        <p:spPr>
-          <a:xfrm>
-            <a:off x="14036040" y="41559480"/>
-            <a:ext cx="1640792" cy="1645919"/>
-          </a:xfrm>
-          <a:prstGeom prst="rect">
-            <a:avLst/>
-          </a:prstGeom>
-        </p:spPr>
-      </p:pic>
-      <p:sp>
-        <p:nvSpPr>
-          <p:cNvPr id="84" name="TextBox 83"/>
-          <p:cNvSpPr txBox="1"/>
-          <p:nvPr/>
-        </p:nvSpPr>
-        <p:spPr>
-          <a:xfrm>
-            <a:off x="1143000" y="41513760"/>
-            <a:ext cx="12618720" cy="1828799"/>
-          </a:xfrm>
-          <a:prstGeom prst="rect">
-            <a:avLst/>
-          </a:prstGeom>
-          <a:noFill/>
-        </p:spPr>
-        <p:txBody>
-          <a:bodyPr wrap="square" anchor="t" lIns="45720" rIns="45720" tIns="18288" bIns="18288">
-            <a:spAutoFit/>
-          </a:bodyPr>
-          <a:lstStyle/>
-          <a:p>
-            <a:pPr algn="l">
-              <a:lnSpc>
-                <a:spcPct val="105000"/>
-              </a:lnSpc>
-              <a:spcAft>
-                <a:spcPts val="1000"/>
-              </a:spcAft>
-            </a:pPr>
-            <a:r>
-              <a:rPr sz="2200" b="0">
-                <a:solidFill>
-                  <a:srgbClr val="EEF3F8"/>
-                </a:solidFill>
-                <a:latin typeface="Arial"/>
-              </a:rPr>
-              <a:t>This research is supported by a URS grant at New Mexico State University, funded by the National Science Foundation (NSF). Thank you to Dr. Andrew Saydjari for mentorship, and to the developers of ZodiPy and Flux.jl.</a:t>
-            </a:r>
-          </a:p>
-        </p:txBody>
-      </p:sp>
-      <p:sp>
-        <p:nvSpPr>
-          <p:cNvPr id="85" name="Rectangle 84"/>
-          <p:cNvSpPr/>
-          <p:nvPr/>
-        </p:nvSpPr>
-        <p:spPr>
-          <a:xfrm>
-            <a:off x="16824960" y="40599360"/>
-            <a:ext cx="15361920" cy="2834640"/>
-          </a:xfrm>
-          <a:prstGeom prst="rect">
-            <a:avLst/>
-          </a:prstGeom>
           <a:solidFill>
-            <a:srgbClr val="0F2036"/>
+            <a:srgbClr val="1E3557"/>
           </a:solidFill>
-          <a:ln w="38100">
-            <a:solidFill>
-              <a:srgbClr val="2D5A94"/>
-            </a:solidFill>
+          <a:ln>
+            <a:noFill/>
           </a:ln>
           <a:effectLst/>
         </p:spPr>
@@ -7761,51 +7518,7 @@
       </p:sp>
       <p:sp>
         <p:nvSpPr>
-          <p:cNvPr id="86" name="Rectangle 85"/>
-          <p:cNvSpPr/>
-          <p:nvPr/>
-        </p:nvSpPr>
-        <p:spPr>
-          <a:xfrm>
-            <a:off x="16824960" y="40599360"/>
-            <a:ext cx="15361920" cy="777240"/>
-          </a:xfrm>
-          <a:prstGeom prst="rect">
-            <a:avLst/>
-          </a:prstGeom>
-          <a:solidFill>
-            <a:srgbClr val="1E3557"/>
-          </a:solidFill>
-          <a:ln>
-            <a:noFill/>
-          </a:ln>
-          <a:effectLst/>
-        </p:spPr>
-        <p:style>
-          <a:lnRef idx="1">
-            <a:schemeClr val="accent1"/>
-          </a:lnRef>
-          <a:fillRef idx="3">
-            <a:schemeClr val="accent1"/>
-          </a:fillRef>
-          <a:effectRef idx="2">
-            <a:schemeClr val="accent1"/>
-          </a:effectRef>
-          <a:fontRef idx="minor">
-            <a:schemeClr val="lt1"/>
-          </a:fontRef>
-        </p:style>
-        <p:txBody>
-          <a:bodyPr rtlCol="0" anchor="ctr"/>
-          <a:lstStyle/>
-          <a:p>
-            <a:pPr algn="ctr"/>
-          </a:p>
-        </p:txBody>
-      </p:sp>
-      <p:sp>
-        <p:nvSpPr>
-          <p:cNvPr id="87" name="TextBox 86"/>
+          <p:cNvPr id="80" name="TextBox 79"/>
           <p:cNvSpPr txBox="1"/>
           <p:nvPr/>
         </p:nvSpPr>
@@ -7847,7 +7560,7 @@
       </p:sp>
       <p:sp>
         <p:nvSpPr>
-          <p:cNvPr id="88" name="TextBox 87"/>
+          <p:cNvPr id="81" name="TextBox 80"/>
           <p:cNvSpPr txBox="1"/>
           <p:nvPr/>
         </p:nvSpPr>
@@ -7876,7 +7589,7 @@
               </a:spcAft>
             </a:pPr>
             <a:r>
-              <a:rPr sz="2100" b="0">
+              <a:rPr sz="2300" b="0">
                 <a:solidFill>
                   <a:srgbClr val="EEF3F8"/>
                 </a:solidFill>
@@ -7895,7 +7608,7 @@
               </a:spcAft>
             </a:pPr>
             <a:r>
-              <a:rPr sz="2100" b="0">
+              <a:rPr sz="2300" b="0">
                 <a:solidFill>
                   <a:srgbClr val="EEF3F8"/>
                 </a:solidFill>
@@ -7908,7 +7621,7 @@
       </p:sp>
       <p:sp>
         <p:nvSpPr>
-          <p:cNvPr id="89" name="TextBox 88"/>
+          <p:cNvPr id="82" name="TextBox 81"/>
           <p:cNvSpPr txBox="1"/>
           <p:nvPr/>
         </p:nvSpPr>
@@ -7937,7 +7650,7 @@
               </a:spcAft>
             </a:pPr>
             <a:r>
-              <a:rPr sz="2100" b="0">
+              <a:rPr sz="2300" b="0">
                 <a:solidFill>
                   <a:srgbClr val="EEF3F8"/>
                 </a:solidFill>
@@ -7956,7 +7669,7 @@
               </a:spcAft>
             </a:pPr>
             <a:r>
-              <a:rPr sz="2100" b="0">
+              <a:rPr sz="2300" b="0">
                 <a:solidFill>
                   <a:srgbClr val="EEF3F8"/>
                 </a:solidFill>

</xml_diff>

<commit_message>
Poster: highlight key phrases in colour (mentor's style)
Co-Authored-By: Claude Opus 5.5 <noreply@anthropic.com>

Claude-Session: https://claude.ai/code/session_012rGthNAyzBgnDfYXWSYd8K
</commit_message>
<xml_diff>
--- a/poster/poster_dark.pptx
+++ b/poster/poster_dark.pptx
@@ -4117,25 +4117,25 @@
             <a:r>
               <a:rPr sz="3000" b="1">
                 <a:solidFill>
+                  <a:srgbClr val="FFC861"/>
+                </a:solidFill>
+                <a:latin typeface="Arial"/>
+              </a:rPr>
+              <a:t>SPHEREx: </a:t>
+            </a:r>
+            <a:r>
+              <a:rPr sz="3000" b="0">
+                <a:solidFill>
                   <a:srgbClr val="EEF3F8"/>
                 </a:solidFill>
                 <a:latin typeface="Arial"/>
               </a:rPr>
-              <a:t>SPHEREx: </a:t>
-            </a:r>
-            <a:r>
-              <a:rPr sz="3000" b="0">
-                <a:solidFill>
-                  <a:srgbClr val="EEF3F8"/>
-                </a:solidFill>
-                <a:latin typeface="Arial"/>
-              </a:rPr>
               <a:t>NASA space telescope (launched March 2025) mapping the </a:t>
             </a:r>
             <a:r>
               <a:rPr sz="3000" b="1">
                 <a:solidFill>
-                  <a:srgbClr val="EEF3F8"/>
+                  <a:srgbClr val="FFC861"/>
                 </a:solidFill>
                 <a:latin typeface="Arial"/>
               </a:rPr>
@@ -4168,7 +4168,7 @@
             <a:r>
               <a:rPr sz="3000" b="1">
                 <a:solidFill>
-                  <a:srgbClr val="EEF3F8"/>
+                  <a:srgbClr val="FFC861"/>
                 </a:solidFill>
                 <a:latin typeface="Arial"/>
               </a:rPr>
@@ -4303,7 +4303,7 @@
             <a:r>
               <a:rPr sz="2800" b="1">
                 <a:solidFill>
-                  <a:srgbClr val="EEF3F8"/>
+                  <a:srgbClr val="FFC861"/>
                 </a:solidFill>
                 <a:latin typeface="Arial"/>
               </a:rPr>
@@ -4358,7 +4358,7 @@
             <a:r>
               <a:rPr sz="2800" b="1">
                 <a:solidFill>
-                  <a:srgbClr val="EEF3F8"/>
+                  <a:srgbClr val="FFC861"/>
                 </a:solidFill>
                 <a:latin typeface="Arial"/>
               </a:rPr>
@@ -4635,25 +4635,25 @@
             <a:r>
               <a:rPr sz="2800" b="1">
                 <a:solidFill>
+                  <a:srgbClr val="FFC861"/>
+                </a:solidFill>
+                <a:latin typeface="Arial"/>
+              </a:rPr>
+              <a:t>geometrically constrained</a:t>
+            </a:r>
+            <a:r>
+              <a:rPr sz="2800" b="0">
+                <a:solidFill>
                   <a:srgbClr val="EEF3F8"/>
                 </a:solidFill>
                 <a:latin typeface="Arial"/>
               </a:rPr>
-              <a:t>geometrically constrained</a:t>
-            </a:r>
-            <a:r>
-              <a:rPr sz="2800" b="0">
-                <a:solidFill>
-                  <a:srgbClr val="EEF3F8"/>
-                </a:solidFill>
-                <a:latin typeface="Arial"/>
-              </a:rPr>
               <a:t> neural network that learns zodiacal light from SPHEREx data and </a:t>
             </a:r>
             <a:r>
               <a:rPr sz="2800" b="1">
                 <a:solidFill>
-                  <a:srgbClr val="EEF3F8"/>
+                  <a:srgbClr val="FFC861"/>
                 </a:solidFill>
                 <a:latin typeface="Arial"/>
               </a:rPr>
@@ -4872,7 +4872,7 @@
             <a:r>
               <a:rPr sz="2800" b="1">
                 <a:solidFill>
-                  <a:srgbClr val="EEF3F8"/>
+                  <a:srgbClr val="FFC861"/>
                 </a:solidFill>
                 <a:latin typeface="Arial"/>
               </a:rPr>
@@ -6386,25 +6386,25 @@
             <a:r>
               <a:rPr sz="3000" b="1">
                 <a:solidFill>
+                  <a:srgbClr val="FFC861"/>
+                </a:solidFill>
+                <a:latin typeface="Arial"/>
+              </a:rPr>
+              <a:t>Largest errors </a:t>
+            </a:r>
+            <a:r>
+              <a:rPr sz="3000" b="0">
+                <a:solidFill>
                   <a:srgbClr val="EEF3F8"/>
                 </a:solidFill>
                 <a:latin typeface="Arial"/>
               </a:rPr>
-              <a:t>Largest errors </a:t>
-            </a:r>
-            <a:r>
-              <a:rPr sz="3000" b="0">
-                <a:solidFill>
-                  <a:srgbClr val="EEF3F8"/>
-                </a:solidFill>
-                <a:latin typeface="Arial"/>
-              </a:rPr>
               <a:t>along the plane of the planets, where the dust bands are; </a:t>
             </a:r>
             <a:r>
               <a:rPr sz="3000" b="1">
                 <a:solidFill>
-                  <a:srgbClr val="EEF3F8"/>
+                  <a:srgbClr val="FFC861"/>
                 </a:solidFill>
                 <a:latin typeface="Arial"/>
               </a:rPr>
@@ -6437,7 +6437,7 @@
             <a:r>
               <a:rPr sz="3000" b="1">
                 <a:solidFill>
-                  <a:srgbClr val="EEF3F8"/>
+                  <a:srgbClr val="FFC861"/>
                 </a:solidFill>
                 <a:latin typeface="Arial"/>
               </a:rPr>

</xml_diff>

<commit_message>
Poster: Fig. 6 caption notes that n.J helps the 500-day model tell the two years apart
Co-Authored-By: Claude Opus 5.5 <noreply@anthropic.com>

Claude-Session: https://claude.ai/code/session_012rGthNAyzBgnDfYXWSYd8K
</commit_message>
<xml_diff>
--- a/poster/poster_dark.pptx
+++ b/poster/poster_dark.pptx
@@ -6214,8 +6214,8 @@
         </p:blipFill>
         <p:spPr>
           <a:xfrm>
-            <a:off x="17963388" y="11229487"/>
-            <a:ext cx="13085064" cy="6542532"/>
+            <a:off x="18017448" y="11173968"/>
+            <a:ext cx="12976942" cy="6488471"/>
           </a:xfrm>
           <a:prstGeom prst="rect">
             <a:avLst/>
@@ -6230,7 +6230,7 @@
         </p:nvSpPr>
         <p:spPr>
           <a:xfrm>
-            <a:off x="17236440" y="17863459"/>
+            <a:off x="17236440" y="17753879"/>
             <a:ext cx="14538960" cy="1293876"/>
           </a:xfrm>
           <a:prstGeom prst="rect">
@@ -6289,8 +6289,8 @@
         </p:blipFill>
         <p:spPr>
           <a:xfrm>
-            <a:off x="18326862" y="19322582"/>
-            <a:ext cx="12358116" cy="5561152"/>
+            <a:off x="18377919" y="19157483"/>
+            <a:ext cx="12256001" cy="5515200"/>
           </a:xfrm>
           <a:prstGeom prst="rect">
             <a:avLst/>
@@ -6305,7 +6305,7 @@
         </p:nvSpPr>
         <p:spPr>
           <a:xfrm>
-            <a:off x="17236440" y="24975174"/>
+            <a:off x="17236440" y="24764123"/>
             <a:ext cx="14538960" cy="1293876"/>
           </a:xfrm>
           <a:prstGeom prst="rect">
@@ -6356,7 +6356,7 @@
         </p:nvSpPr>
         <p:spPr>
           <a:xfrm>
-            <a:off x="17236440" y="26434298"/>
+            <a:off x="17236440" y="26167727"/>
             <a:ext cx="14538960" cy="2173224"/>
           </a:xfrm>
           <a:prstGeom prst="rect">
@@ -6471,8 +6471,8 @@
         </p:blipFill>
         <p:spPr>
           <a:xfrm>
-            <a:off x="17236440" y="28772769"/>
-            <a:ext cx="14538960" cy="4652467"/>
+            <a:off x="17296507" y="28450679"/>
+            <a:ext cx="14418825" cy="4614024"/>
           </a:xfrm>
           <a:prstGeom prst="rect">
             <a:avLst/>
@@ -6487,8 +6487,8 @@
         </p:nvSpPr>
         <p:spPr>
           <a:xfrm>
-            <a:off x="17236440" y="33516676"/>
-            <a:ext cx="14538960" cy="1293876"/>
+            <a:off x="17236440" y="33156144"/>
+            <a:ext cx="14538960" cy="1709928"/>
           </a:xfrm>
           <a:prstGeom prst="rect">
             <a:avLst/>
@@ -6525,7 +6525,7 @@
                 </a:solidFill>
                 <a:latin typeface="Arial"/>
               </a:rPr>
-              <a:t>Error on pointings the network never saw, across the sky (3.5° patches, about SPHEREx's view). Left: the first 140 days. Right: all 500 days now available (that model also uses Jupiter's direction, n·J). Grey: not tested.</a:t>
+              <a:t>Error on pointings the network never saw, across the sky (3.5° patches, about SPHEREx's view). Left: the first 140 days. Right: all 500 days now available; with more than a year of data, Jupiter's direction (n·J) also helps the network tell the two years apart. Grey: not tested.</a:t>
             </a:r>
           </a:p>
         </p:txBody>

</xml_diff>

<commit_message>
Notebook 10212026 (heliocentric 500-day map, Jupiter null test); poster review fixes (Fig. 2 ẑ note, training bullet, notes)
Co-Authored-By: Claude Opus 5.5 <noreply@anthropic.com>

Claude-Session: https://claude.ai/code/session_012rGthNAyzBgnDfYXWSYd8K
</commit_message>
<xml_diff>
--- a/poster/poster_dark.pptx
+++ b/poster/poster_dark.pptx
@@ -507,32 +507,37 @@
           </a:p>
           <a:p>
             <a:r>
-              <a:t>- Problem statement: 'physics models such as Kelsall's were fit to older data and leave errors behind' -- right framing?</a:t>
-            </a:r>
-          </a:p>
-          <a:p>
-            <a:r>
               <a:t>- Acknowledgment: exact name of the URS grant/program and the NSF award number (if one should be listed).</a:t>
             </a:r>
           </a:p>
           <a:p>
             <a:r>
-              <a:t>- Fig. 3: Jupiter and the Moon are drawn for context; the poster's model inputs are n.S n.z n.E n.vS n.vE n.x_E n.y_E sin/cos(lambda_E) (no Jupiter, no Moon).</a:t>
-            </a:r>
-          </a:p>
-          <a:p>
-            <a:r>
-              <a:t>Numbers (poster v6): 5-network ensemble, 64-64-32-16 gelu (4 hidden layers), 750 epochs (round 21, z115_m750_shift*).</a:t>
-            </a:r>
-          </a:p>
-          <a:p>
-            <a:r>
-              <a:t>- Fig. 2 (poster/data_components.jl): ZodiPy components per pointing as % of the total. Smooth cloud 90.1% (|b|&lt;5) to</a:t>
-            </a:r>
-          </a:p>
-          <a:p>
-            <a:r>
-              <a:t>  94.8% (&gt;60 deg); behind Earth (n.vE&lt;-0.5, |b|&lt;15) the trailing cloud is 7.0% vs 1.1% ahead.</a:t>
+              <a:t>Numbers: 5-network ensemble, 64-64-32-16 gelu (4 hidden layers), one-cycle LR (peak 1e-3), 750 epochs (round 21,</a:t>
+            </a:r>
+          </a:p>
+          <a:p>
+            <a:r>
+              <a:t>z115_m750_shift*), 140-day corrected data (ZODI_DATA=z115). Errors are relative to ZodiPy (the Kelsall model), not the real sky.</a:t>
+            </a:r>
+          </a:p>
+          <a:p>
+            <a:r>
+              <a:t>- Fig. 2: Jupiter and the Moon are tracked for real data; the poster model's 9 inputs are n.S n.z n.E n.vS n.vE n.x_E n.y_E</a:t>
+            </a:r>
+          </a:p>
+          <a:p>
+            <a:r>
+              <a:t>  sin/cos(lambda_E) (no Jupiter, no Moon). x_E, y_E = ecliptic x, y rotated by Earth's longitude lambda_E.</a:t>
+            </a:r>
+          </a:p>
+          <a:p>
+            <a:r>
+              <a:t>- Fig. 3 (poster/data_training.jl): epoch-averaged MSE (mean of 10 in-epoch evaluations), poster split; final mean</a:t>
+            </a:r>
+          </a:p>
+          <a:p>
+            <a:r>
+              <a:t>  train/test MSE 2.5e-8 / 1.2e-7 (MJy/sr)^2.</a:t>
             </a:r>
           </a:p>
           <a:p>
@@ -542,72 +547,47 @@
           </a:p>
           <a:p>
             <a:r>
-              <a:t>  43%): median 0.018%, p95 0.069%, 97.5% within 0.1%. (100 epochs: 0.026%, 0.10%, 94.8%.)</a:t>
-            </a:r>
-          </a:p>
-          <a:p>
-            <a:r>
-              <a:t>  Errors are relative to ZodiPy (the Kelsall model), not the real sky.</a:t>
-            </a:r>
-          </a:p>
-          <a:p>
-            <a:r>
-              <a:t>- Fig. 5 (poster/data_training.jl): epoch-averaged MSE (mean of 10 in-epoch evaluations) on the training data and the</a:t>
-            </a:r>
-          </a:p>
-          <a:p>
-            <a:r>
-              <a:t>  withheld months; final mean train/test MSE 2.5e-8 / 1.2e-7 (MJy/sr)^2.</a:t>
-            </a:r>
-          </a:p>
-          <a:p>
-            <a:r>
-              <a:t>- Fig. 6: the 30-day split slid by 0, 10, ..., 50 days, 5 seeds each, 750 epochs. Red = withheld windows with training</a:t>
-            </a:r>
-          </a:p>
-          <a:p>
-            <a:r>
-              <a:t>  data before and after (interpolation): 0.015-0.030%. Orange = windows at the mission's start/end (extrapolation in</a:t>
-            </a:r>
-          </a:p>
-          <a:p>
-            <a:r>
-              <a:t>  time): 10 days 0.016-0.023%, 20-30 days 0.07-0.09% median.</a:t>
-            </a:r>
-          </a:p>
-          <a:p>
-            <a:r>
-              <a:t>- Fig. 7 (poster/data_skyerror.jl): red (interior) windows only, 364,797 pointings (86%), each averaged over the versions</a:t>
-            </a:r>
-          </a:p>
-          <a:p>
-            <a:r>
-              <a:t>  that withheld it: median 0.016%, p95 0.063%; within 2 deg of the ecliptic 0.083%, above 60 deg 0.0125%. Map: each</a:t>
-            </a:r>
-          </a:p>
-          <a:p>
-            <a:r>
-              <a:t>  boresight spread over a disc on a 1-deg grid (radius 1.75 deg = 3.5-deg patches, or 3.5 deg = the 7-deg blend);</a:t>
-            </a:r>
-          </a:p>
-          <a:p>
-            <a:r>
-              <a:t>  boresights lie on scan circles a few degrees apart, so without spreading thin pole-to-pole gaps appear.</a:t>
-            </a:r>
-          </a:p>
-          <a:p>
-            <a:r>
-              <a:t>- Earth-trailing cloud (mentor's test, 10182026 notebook): stacking residuals along the ahead/behind-Earth angle and the</a:t>
-            </a:r>
-          </a:p>
-          <a:p>
-            <a:r>
-              <a:t>  angle to the cloud's centre shows no leftover cloud signal; fitted missing fraction 0.06 +/- 0.09% (|b|&lt;15, 750 ep).</a:t>
-            </a:r>
-          </a:p>
-          <a:p>
-            <a:r>
-              <a:t>- Multi-wavelength (Refine step): round-15 'ep300' ensemble, 30-day blocks, 1.25-5.0 um, ~0.1% median (poster/data_spectra.jl).</a:t>
+              <a:t>  43%): median 0.018%, p95 0.069%, 97.5% within 0.1%.</a:t>
+            </a:r>
+          </a:p>
+          <a:p>
+            <a:r>
+              <a:t>- Fig. 5: the 30-day split slid by 0, 10, ..., 50 days, 5 seeds each. Red = withheld windows with training data before and</a:t>
+            </a:r>
+          </a:p>
+          <a:p>
+            <a:r>
+              <a:t>  after: 0.015-0.030%. Orange = windows at the mission's start/end (extrapolation in time): 0.016-0.09%.</a:t>
+            </a:r>
+          </a:p>
+          <a:p>
+            <a:r>
+              <a:t>- Fig. 6 (poster/data_skyerror.jl, sweeps/r24_data.jl): between-month windows, each pointing averaged over the versions</a:t>
+            </a:r>
+          </a:p>
+          <a:p>
+            <a:r>
+              <a:t>  that withheld it; 3.5-deg patches. Left (140 d): median 0.016%, p95 0.063%, within 2 deg of the ecliptic 0.083%.</a:t>
+            </a:r>
+          </a:p>
+          <a:p>
+            <a:r>
+              <a:t>  Right (500 d, poster model + n.J, 500 epochs, round 24): median 0.016%, p95 0.053%, ecliptic 0.064%.</a:t>
+            </a:r>
+          </a:p>
+          <a:p>
+            <a:r>
+              <a:t>  If asked about n.J: on 500 days it stood in for the Sun's wobble about the barycentre (inputs were barycentric);</a:t>
+            </a:r>
+          </a:p>
+          <a:p>
+            <a:r>
+              <a:t>  with heliocentric inputs and no n.J the 500-day ecliptic error is 0.048% (round 27/28, not shown).</a:t>
+            </a:r>
+          </a:p>
+          <a:p>
+            <a:r>
+              <a:t>- Earth-trailing cloud (mentor's tests): the network reproduces Kelsall's ring + trailing blob to 0.002% of the total.</a:t>
             </a:r>
           </a:p>
           <a:p/>
@@ -4811,7 +4791,7 @@
         </p:nvSpPr>
         <p:spPr>
           <a:xfrm>
-            <a:off x="1143000" y="24837124"/>
+            <a:off x="1143000" y="24843394"/>
             <a:ext cx="6122822" cy="4531156"/>
           </a:xfrm>
           <a:prstGeom prst="rect">
@@ -4930,7 +4910,7 @@
         </p:blipFill>
         <p:spPr>
           <a:xfrm>
-            <a:off x="7540142" y="24334485"/>
+            <a:off x="7540142" y="24340754"/>
             <a:ext cx="8141817" cy="5536435"/>
           </a:xfrm>
           <a:prstGeom prst="rect">
@@ -4946,7 +4926,7 @@
         </p:nvSpPr>
         <p:spPr>
           <a:xfrm>
-            <a:off x="1143000" y="29962361"/>
+            <a:off x="1143000" y="29968630"/>
             <a:ext cx="14538960" cy="1709928"/>
           </a:xfrm>
           <a:prstGeom prst="rect">
@@ -4997,7 +4977,7 @@
         </p:nvSpPr>
         <p:spPr>
           <a:xfrm>
-            <a:off x="1143000" y="32031779"/>
+            <a:off x="1143000" y="32083914"/>
             <a:ext cx="14538960" cy="594360"/>
           </a:xfrm>
           <a:prstGeom prst="rect">
@@ -5039,7 +5019,7 @@
         </p:nvSpPr>
         <p:spPr>
           <a:xfrm>
-            <a:off x="1325880" y="32653571"/>
+            <a:off x="1325880" y="32705706"/>
             <a:ext cx="3657600" cy="512064"/>
           </a:xfrm>
           <a:prstGeom prst="rect">
@@ -5081,7 +5061,7 @@
         </p:nvSpPr>
         <p:spPr>
           <a:xfrm>
-            <a:off x="4983480" y="32653571"/>
+            <a:off x="4983480" y="32705706"/>
             <a:ext cx="10698480" cy="512064"/>
           </a:xfrm>
           <a:prstGeom prst="rect">
@@ -5123,7 +5103,7 @@
         </p:nvSpPr>
         <p:spPr>
           <a:xfrm>
-            <a:off x="1325880" y="33165635"/>
+            <a:off x="1325880" y="33217770"/>
             <a:ext cx="3657600" cy="512064"/>
           </a:xfrm>
           <a:prstGeom prst="rect">
@@ -5165,7 +5145,7 @@
         </p:nvSpPr>
         <p:spPr>
           <a:xfrm>
-            <a:off x="4983480" y="33165635"/>
+            <a:off x="4983480" y="33217770"/>
             <a:ext cx="10698480" cy="512064"/>
           </a:xfrm>
           <a:prstGeom prst="rect">
@@ -5207,7 +5187,7 @@
         </p:nvSpPr>
         <p:spPr>
           <a:xfrm>
-            <a:off x="1325880" y="33677699"/>
+            <a:off x="1325880" y="33729834"/>
             <a:ext cx="3657600" cy="512064"/>
           </a:xfrm>
           <a:prstGeom prst="rect">
@@ -5249,7 +5229,7 @@
         </p:nvSpPr>
         <p:spPr>
           <a:xfrm>
-            <a:off x="4983480" y="33677699"/>
+            <a:off x="4983480" y="33729834"/>
             <a:ext cx="10698480" cy="512064"/>
           </a:xfrm>
           <a:prstGeom prst="rect">
@@ -5291,7 +5271,7 @@
         </p:nvSpPr>
         <p:spPr>
           <a:xfrm>
-            <a:off x="1325880" y="34189763"/>
+            <a:off x="1325880" y="34241898"/>
             <a:ext cx="3657600" cy="512064"/>
           </a:xfrm>
           <a:prstGeom prst="rect">
@@ -5333,7 +5313,7 @@
         </p:nvSpPr>
         <p:spPr>
           <a:xfrm>
-            <a:off x="4983480" y="34189763"/>
+            <a:off x="4983480" y="34241898"/>
             <a:ext cx="10698480" cy="512064"/>
           </a:xfrm>
           <a:prstGeom prst="rect">
@@ -5375,7 +5355,7 @@
         </p:nvSpPr>
         <p:spPr>
           <a:xfrm>
-            <a:off x="1325880" y="34701827"/>
+            <a:off x="1325880" y="34753962"/>
             <a:ext cx="3657600" cy="512064"/>
           </a:xfrm>
           <a:prstGeom prst="rect">
@@ -5417,7 +5397,7 @@
         </p:nvSpPr>
         <p:spPr>
           <a:xfrm>
-            <a:off x="4983480" y="34701827"/>
+            <a:off x="4983480" y="34753962"/>
             <a:ext cx="10698480" cy="512064"/>
           </a:xfrm>
           <a:prstGeom prst="rect">
@@ -5459,8 +5439,8 @@
         </p:nvSpPr>
         <p:spPr>
           <a:xfrm>
-            <a:off x="1143000" y="35573381"/>
-            <a:ext cx="6995160" cy="3148583"/>
+            <a:off x="1143000" y="35829878"/>
+            <a:ext cx="6995160" cy="2687726"/>
           </a:xfrm>
           <a:prstGeom prst="rect">
             <a:avLst/>
@@ -5539,7 +5519,7 @@
                 </a:solidFill>
                 <a:latin typeface="Arial"/>
               </a:rPr>
-              <a:t>Tested on whole months and sky regions they never saw</a:t>
+              <a:t>Tested on whole months they never saw</a:t>
             </a:r>
           </a:p>
         </p:txBody>
@@ -5560,7 +5540,7 @@
         </p:blipFill>
         <p:spPr>
           <a:xfrm>
-            <a:off x="8412480" y="35573381"/>
+            <a:off x="8412480" y="35671382"/>
             <a:ext cx="7269480" cy="3004718"/>
           </a:xfrm>
           <a:prstGeom prst="rect">
@@ -5576,7 +5556,7 @@
         </p:nvSpPr>
         <p:spPr>
           <a:xfrm>
-            <a:off x="1143000" y="38813405"/>
+            <a:off x="1143000" y="38767540"/>
             <a:ext cx="14538960" cy="877824"/>
           </a:xfrm>
           <a:prstGeom prst="rect">

</xml_diff>